<commit_message>
Improve EDA charts with insight-driven presentation-quality visuals
Replace flat histograms with 5 story-focused charts: dumbbell risk
profile, smoothed duration densities, LTV equity trap, vintage cohort
with era annotations, and rate lock-in effect. Update report and PPTX
to include all 5 new charts with annotated captions.

Co-Authored-By: Claude Sonnet 4.6 <noreply@anthropic.com>
</commit_message>
<xml_diff>
--- a/processed/PartE_Presentation.pptx
+++ b/processed/PartE_Presentation.pptx
@@ -19,6 +19,9 @@
     <p:sldId id="267" r:id="rId18"/>
     <p:sldId id="268" r:id="rId19"/>
     <p:sldId id="269" r:id="rId20"/>
+    <p:sldId id="270" r:id="rId21"/>
+    <p:sldId id="271" r:id="rId22"/>
+    <p:sldId id="272" r:id="rId23"/>
   </p:sldIdLst>
   <p:sldSz cx="12188952" cy="6858000" type="screen4x3"/>
   <p:notesSz cx="6858000" cy="9144000"/>
@@ -3413,7 +3416,7 @@
                   <a:srgbClr val="FFFFFF"/>
                 </a:solidFill>
               </a:rPr>
-              <a:t>E(i)(f) — Fine-Gray Subdistribution Hazard</a:t>
+              <a:t>E(i)(d) — Stratified CIF</a:t>
             </a:r>
           </a:p>
         </p:txBody>
@@ -3447,165 +3450,35 @@
                   <a:srgbClr val="ECF0F1"/>
                 </a:solidFill>
               </a:rPr>
-              <a:t>IPCW-weighted Cox approximation; coefficients directly target the CIF</a:t>
-            </a:r>
-          </a:p>
-        </p:txBody>
-      </p:sp>
-      <p:sp>
-        <p:nvSpPr>
-          <p:cNvPr id="5" name="Rectangle 4"/>
-          <p:cNvSpPr/>
-          <p:nvPr/>
-        </p:nvSpPr>
-        <p:spPr>
-          <a:xfrm>
-            <a:off x="0" y="1005840"/>
-            <a:ext cx="12188952" cy="5852160"/>
-          </a:xfrm>
-          <a:prstGeom prst="rect">
-            <a:avLst/>
-          </a:prstGeom>
-          <a:solidFill>
-            <a:srgbClr val="ECF0F1"/>
-          </a:solidFill>
-          <a:ln>
-            <a:noFill/>
-          </a:ln>
-        </p:spPr>
-        <p:style>
-          <a:lnRef idx="1">
-            <a:schemeClr val="accent1"/>
-          </a:lnRef>
-          <a:fillRef idx="3">
-            <a:schemeClr val="accent1"/>
-          </a:fillRef>
-          <a:effectRef idx="2">
-            <a:schemeClr val="accent1"/>
-          </a:effectRef>
-          <a:fontRef idx="minor">
-            <a:schemeClr val="lt1"/>
-          </a:fontRef>
-        </p:style>
-        <p:txBody>
-          <a:bodyPr rtlCol="0" anchor="ctr"/>
-          <a:lstStyle/>
-          <a:p>
-            <a:pPr algn="ctr"/>
-          </a:p>
-        </p:txBody>
-      </p:sp>
-      <p:sp>
-        <p:nvSpPr>
-          <p:cNvPr id="6" name="TextBox 5"/>
-          <p:cNvSpPr txBox="1"/>
-          <p:nvPr/>
-        </p:nvSpPr>
-        <p:spPr>
-          <a:xfrm>
-            <a:off x="457200" y="1188720"/>
-            <a:ext cx="11247120" cy="5029200"/>
-          </a:xfrm>
-          <a:prstGeom prst="rect">
-            <a:avLst/>
-          </a:prstGeom>
-          <a:noFill/>
-        </p:spPr>
-        <p:txBody>
-          <a:bodyPr wrap="square">
-            <a:spAutoFit/>
-          </a:bodyPr>
-          <a:lstStyle/>
-          <a:p>
-            <a:pPr>
-              <a:spcAft>
-                <a:spcPts val="400"/>
-              </a:spcAft>
-              <a:defRPr sz="1400"/>
-            </a:pPr>
-            <a:r>
-              <a:t>• Subjects who experienced a competing event (default) are KEPT in the risk set with IPCW weights</a:t>
-            </a:r>
-          </a:p>
-          <a:p>
-            <a:pPr>
-              <a:spcAft>
-                <a:spcPts val="400"/>
-              </a:spcAft>
-              <a:defRPr sz="1400"/>
-            </a:pPr>
-            <a:r>
-              <a:t>• The subdistribution hazard integrates to the CIF — covariate effects are CIF effects</a:t>
-            </a:r>
-          </a:p>
-          <a:p>
-            <a:pPr>
-              <a:spcAft>
-                <a:spcPts val="400"/>
-              </a:spcAft>
-              <a:defRPr sz="1400"/>
-            </a:pPr>
-            <a:r>
-              <a:t>• rate_incentive HR is LARGER under Fine-Gray than cause-specific Cox:</a:t>
-            </a:r>
-          </a:p>
-          <a:p>
-            <a:pPr>
-              <a:spcAft>
-                <a:spcPts val="400"/>
-              </a:spcAft>
-              <a:defRPr sz="1400"/>
-            </a:pPr>
-            <a:r>
-              <a:t>•    high-incentive loans are also less likely to default first → amplifies CIF effect</a:t>
-            </a:r>
-          </a:p>
-          <a:p>
-            <a:pPr>
-              <a:spcAft>
-                <a:spcPts val="400"/>
-              </a:spcAft>
-              <a:defRPr sz="1400"/>
-            </a:pPr>
-            <a:r>
-              <a:t>• Low-FICO Fine-Gray HR for prepayment is ATTENUATED: elevated default risk reduces</a:t>
-            </a:r>
-          </a:p>
-          <a:p>
-            <a:pPr>
-              <a:spcAft>
-                <a:spcPts val="400"/>
-              </a:spcAft>
-              <a:defRPr sz="1400"/>
-            </a:pPr>
-            <a:r>
-              <a:t>•    measured prepayment propensity once competing risks are accounted for</a:t>
-            </a:r>
-          </a:p>
-          <a:p>
-            <a:pPr>
-              <a:spcAft>
-                <a:spcPts val="400"/>
-              </a:spcAft>
-              <a:defRPr sz="1400"/>
-            </a:pPr>
-            <a:r>
-              <a:t>• Use Fine-Gray for CIF prediction / loss forecasting</a:t>
-            </a:r>
-          </a:p>
-          <a:p>
-            <a:pPr>
-              <a:spcAft>
-                <a:spcPts val="400"/>
-              </a:spcAft>
-              <a:defRPr sz="1400"/>
-            </a:pPr>
-            <a:r>
-              <a:t>• Use cause-specific Cox for economic mechanism estimation</a:t>
-            </a:r>
-          </a:p>
-        </p:txBody>
-      </p:sp>
+              <a:t>High-FICO → elevated prepayment, near-zero default;  high-LTV → inverted</a:t>
+            </a:r>
+          </a:p>
+        </p:txBody>
+      </p:sp>
+      <p:pic>
+        <p:nvPicPr>
+          <p:cNvPr id="5" name="Picture 4" descr="E1_stratified_cif.png"/>
+          <p:cNvPicPr>
+            <a:picLocks noChangeAspect="1"/>
+          </p:cNvPicPr>
+          <p:nvPr/>
+        </p:nvPicPr>
+        <p:blipFill>
+          <a:blip r:embed="rId2"/>
+          <a:stretch>
+            <a:fillRect/>
+          </a:stretch>
+        </p:blipFill>
+        <p:spPr>
+          <a:xfrm>
+            <a:off x="274320" y="1051560"/>
+            <a:ext cx="5186826" cy="5303520"/>
+          </a:xfrm>
+          <a:prstGeom prst="rect">
+            <a:avLst/>
+          </a:prstGeom>
+        </p:spPr>
+      </p:pic>
     </p:spTree>
   </p:cSld>
   <p:clrMapOvr>
@@ -3696,7 +3569,7 @@
                   <a:srgbClr val="FFFFFF"/>
                 </a:solidFill>
               </a:rPr>
-              <a:t>E(ii) — Time-Dependent Covariates</a:t>
+              <a:t>E(i)(e) — Cause-Specific Cox Regression  (12 features)</a:t>
             </a:r>
           </a:p>
         </p:txBody>
@@ -3730,165 +3603,35 @@
                   <a:srgbClr val="ECF0F1"/>
                 </a:solidFill>
               </a:rPr>
-              <a:t>Andersen-Gill counting-process Cox — monthly rate_incentive, unemployment, HPI</a:t>
-            </a:r>
-          </a:p>
-        </p:txBody>
-      </p:sp>
-      <p:sp>
-        <p:nvSpPr>
-          <p:cNvPr id="5" name="Rectangle 4"/>
-          <p:cNvSpPr/>
-          <p:nvPr/>
-        </p:nvSpPr>
-        <p:spPr>
-          <a:xfrm>
-            <a:off x="0" y="1005840"/>
-            <a:ext cx="12188952" cy="5852160"/>
-          </a:xfrm>
-          <a:prstGeom prst="rect">
-            <a:avLst/>
-          </a:prstGeom>
-          <a:solidFill>
-            <a:srgbClr val="ECF0F1"/>
-          </a:solidFill>
-          <a:ln>
-            <a:noFill/>
-          </a:ln>
-        </p:spPr>
-        <p:style>
-          <a:lnRef idx="1">
-            <a:schemeClr val="accent1"/>
-          </a:lnRef>
-          <a:fillRef idx="3">
-            <a:schemeClr val="accent1"/>
-          </a:fillRef>
-          <a:effectRef idx="2">
-            <a:schemeClr val="accent1"/>
-          </a:effectRef>
-          <a:fontRef idx="minor">
-            <a:schemeClr val="lt1"/>
-          </a:fontRef>
-        </p:style>
-        <p:txBody>
-          <a:bodyPr rtlCol="0" anchor="ctr"/>
-          <a:lstStyle/>
-          <a:p>
-            <a:pPr algn="ctr"/>
-          </a:p>
-        </p:txBody>
-      </p:sp>
-      <p:sp>
-        <p:nvSpPr>
-          <p:cNvPr id="6" name="TextBox 5"/>
-          <p:cNvSpPr txBox="1"/>
-          <p:nvPr/>
-        </p:nvSpPr>
-        <p:spPr>
-          <a:xfrm>
-            <a:off x="457200" y="1188720"/>
-            <a:ext cx="11247120" cy="5029200"/>
-          </a:xfrm>
-          <a:prstGeom prst="rect">
-            <a:avLst/>
-          </a:prstGeom>
-          <a:noFill/>
-        </p:spPr>
-        <p:txBody>
-          <a:bodyPr wrap="square">
-            <a:spAutoFit/>
-          </a:bodyPr>
-          <a:lstStyle/>
-          <a:p>
-            <a:pPr>
-              <a:spcAft>
-                <a:spcPts val="400"/>
-              </a:spcAft>
-              <a:defRPr sz="1300"/>
-            </a:pPr>
-            <a:r>
-              <a:t>• Panel dataset: 93M rows × 2M loans — mortgage_rate, unemployment, HPI YoY, rate_incentive updated monthly</a:t>
-            </a:r>
-          </a:p>
-          <a:p>
-            <a:pPr>
-              <a:spcAft>
-                <a:spcPts val="400"/>
-              </a:spcAft>
-              <a:defRPr sz="1300"/>
-            </a:pPr>
-            <a:r>
-              <a:t>• 10,000 loans stratified by vintage → ~500K counting-process rows (tstart, tstop, event)</a:t>
-            </a:r>
-          </a:p>
-          <a:p>
-            <a:pPr>
-              <a:spcAft>
-                <a:spcPts val="400"/>
-              </a:spcAft>
-              <a:defRPr sz="1300"/>
-            </a:pPr>
-            <a:r>
-              <a:t>• 11 features: 7 static (FICO, LTV, DTI, UPB + 3 one-hot) + 4 time-varying</a:t>
-            </a:r>
-          </a:p>
-          <a:p>
-            <a:pPr>
-              <a:spcAft>
-                <a:spcPts val="400"/>
-              </a:spcAft>
-              <a:defRPr sz="1300"/>
-            </a:pPr>
-            <a:r>
-              <a:t>• Key finding: current rate_incentive coefficient LARGER than origination-vintage snapshot</a:t>
-            </a:r>
-          </a:p>
-          <a:p>
-            <a:pPr>
-              <a:spcAft>
-                <a:spcPts val="400"/>
-              </a:spcAft>
-              <a:defRPr sz="1300"/>
-            </a:pPr>
-            <a:r>
-              <a:t>•    Static Cox: rate_incentive locked at origination — high-rate era loans always look attractive</a:t>
-            </a:r>
-          </a:p>
-          <a:p>
-            <a:pPr>
-              <a:spcAft>
-                <a:spcPts val="400"/>
-              </a:spcAft>
-              <a:defRPr sz="1300"/>
-            </a:pPr>
-            <a:r>
-              <a:t>•    TV Cox: tracks actual monthly refi option value — more responsive to rate cycles</a:t>
-            </a:r>
-          </a:p>
-          <a:p>
-            <a:pPr>
-              <a:spcAft>
-                <a:spcPts val="400"/>
-              </a:spcAft>
-              <a:defRPr sz="1300"/>
-            </a:pPr>
-            <a:r>
-              <a:t>• Unemployment: contemporaneous job loss predicts default better than vintage average</a:t>
-            </a:r>
-          </a:p>
-          <a:p>
-            <a:pPr>
-              <a:spcAft>
-                <a:spcPts val="400"/>
-              </a:spcAft>
-              <a:defRPr sz="1300"/>
-            </a:pPr>
-            <a:r>
-              <a:t>• Limitation: origination LTV used (not ELTV) — adding current LTV would improve default hazard</a:t>
-            </a:r>
-          </a:p>
-        </p:txBody>
-      </p:sp>
+              <a:t>Opposite-sign coefficients reveal misrepresentation in naive combined Cox</a:t>
+            </a:r>
+          </a:p>
+        </p:txBody>
+      </p:sp>
+      <p:pic>
+        <p:nvPicPr>
+          <p:cNvPr id="5" name="Picture 4" descr="E1_cause_specific_cox.png"/>
+          <p:cNvPicPr>
+            <a:picLocks noChangeAspect="1"/>
+          </p:cNvPicPr>
+          <p:nvPr/>
+        </p:nvPicPr>
+        <p:blipFill>
+          <a:blip r:embed="rId2"/>
+          <a:stretch>
+            <a:fillRect/>
+          </a:stretch>
+        </p:blipFill>
+        <p:spPr>
+          <a:xfrm>
+            <a:off x="274320" y="1051560"/>
+            <a:ext cx="11612880" cy="3860561"/>
+          </a:xfrm>
+          <a:prstGeom prst="rect">
+            <a:avLst/>
+          </a:prstGeom>
+        </p:spPr>
+      </p:pic>
     </p:spTree>
   </p:cSld>
   <p:clrMapOvr>
@@ -3979,7 +3722,7 @@
                   <a:srgbClr val="FFFFFF"/>
                 </a:solidFill>
               </a:rPr>
-              <a:t>E(iv) — Scenario Analysis: Interest Rate Shocks</a:t>
+              <a:t>E(i)(f) — Fine-Gray Subdistribution Hazard</a:t>
             </a:r>
           </a:p>
         </p:txBody>
@@ -4013,35 +3756,165 @@
                   <a:srgbClr val="ECF0F1"/>
                 </a:solidFill>
               </a:rPr>
-              <a:t>±100 bp and ±200 bp shocks to mortgage_rate  (rate_incentive updated consistently)</a:t>
-            </a:r>
-          </a:p>
-        </p:txBody>
-      </p:sp>
-      <p:pic>
-        <p:nvPicPr>
-          <p:cNvPr id="5" name="Picture 4" descr="E2_scenario_analysis.png"/>
-          <p:cNvPicPr>
-            <a:picLocks noChangeAspect="1"/>
-          </p:cNvPicPr>
-          <p:nvPr/>
-        </p:nvPicPr>
-        <p:blipFill>
-          <a:blip r:embed="rId2"/>
-          <a:stretch>
-            <a:fillRect/>
-          </a:stretch>
-        </p:blipFill>
-        <p:spPr>
-          <a:xfrm>
-            <a:off x="457200" y="1051560"/>
-            <a:ext cx="11247120" cy="3906695"/>
-          </a:xfrm>
-          <a:prstGeom prst="rect">
-            <a:avLst/>
-          </a:prstGeom>
-        </p:spPr>
-      </p:pic>
+              <a:t>IPCW-weighted Cox approximation; coefficients directly target the CIF</a:t>
+            </a:r>
+          </a:p>
+        </p:txBody>
+      </p:sp>
+      <p:sp>
+        <p:nvSpPr>
+          <p:cNvPr id="5" name="Rectangle 4"/>
+          <p:cNvSpPr/>
+          <p:nvPr/>
+        </p:nvSpPr>
+        <p:spPr>
+          <a:xfrm>
+            <a:off x="0" y="1005840"/>
+            <a:ext cx="12188952" cy="5852160"/>
+          </a:xfrm>
+          <a:prstGeom prst="rect">
+            <a:avLst/>
+          </a:prstGeom>
+          <a:solidFill>
+            <a:srgbClr val="ECF0F1"/>
+          </a:solidFill>
+          <a:ln>
+            <a:noFill/>
+          </a:ln>
+        </p:spPr>
+        <p:style>
+          <a:lnRef idx="1">
+            <a:schemeClr val="accent1"/>
+          </a:lnRef>
+          <a:fillRef idx="3">
+            <a:schemeClr val="accent1"/>
+          </a:fillRef>
+          <a:effectRef idx="2">
+            <a:schemeClr val="accent1"/>
+          </a:effectRef>
+          <a:fontRef idx="minor">
+            <a:schemeClr val="lt1"/>
+          </a:fontRef>
+        </p:style>
+        <p:txBody>
+          <a:bodyPr rtlCol="0" anchor="ctr"/>
+          <a:lstStyle/>
+          <a:p>
+            <a:pPr algn="ctr"/>
+          </a:p>
+        </p:txBody>
+      </p:sp>
+      <p:sp>
+        <p:nvSpPr>
+          <p:cNvPr id="6" name="TextBox 5"/>
+          <p:cNvSpPr txBox="1"/>
+          <p:nvPr/>
+        </p:nvSpPr>
+        <p:spPr>
+          <a:xfrm>
+            <a:off x="457200" y="1188720"/>
+            <a:ext cx="11247120" cy="5029200"/>
+          </a:xfrm>
+          <a:prstGeom prst="rect">
+            <a:avLst/>
+          </a:prstGeom>
+          <a:noFill/>
+        </p:spPr>
+        <p:txBody>
+          <a:bodyPr wrap="square">
+            <a:spAutoFit/>
+          </a:bodyPr>
+          <a:lstStyle/>
+          <a:p>
+            <a:pPr>
+              <a:spcAft>
+                <a:spcPts val="400"/>
+              </a:spcAft>
+              <a:defRPr sz="1400"/>
+            </a:pPr>
+            <a:r>
+              <a:t>• Subjects who experienced a competing event (default) are KEPT in the risk set with IPCW weights</a:t>
+            </a:r>
+          </a:p>
+          <a:p>
+            <a:pPr>
+              <a:spcAft>
+                <a:spcPts val="400"/>
+              </a:spcAft>
+              <a:defRPr sz="1400"/>
+            </a:pPr>
+            <a:r>
+              <a:t>• The subdistribution hazard integrates to the CIF — covariate effects are CIF effects</a:t>
+            </a:r>
+          </a:p>
+          <a:p>
+            <a:pPr>
+              <a:spcAft>
+                <a:spcPts val="400"/>
+              </a:spcAft>
+              <a:defRPr sz="1400"/>
+            </a:pPr>
+            <a:r>
+              <a:t>• rate_incentive HR is LARGER under Fine-Gray than cause-specific Cox:</a:t>
+            </a:r>
+          </a:p>
+          <a:p>
+            <a:pPr>
+              <a:spcAft>
+                <a:spcPts val="400"/>
+              </a:spcAft>
+              <a:defRPr sz="1400"/>
+            </a:pPr>
+            <a:r>
+              <a:t>•    high-incentive loans are also less likely to default first → amplifies CIF effect</a:t>
+            </a:r>
+          </a:p>
+          <a:p>
+            <a:pPr>
+              <a:spcAft>
+                <a:spcPts val="400"/>
+              </a:spcAft>
+              <a:defRPr sz="1400"/>
+            </a:pPr>
+            <a:r>
+              <a:t>• Low-FICO Fine-Gray HR for prepayment is ATTENUATED: elevated default risk reduces</a:t>
+            </a:r>
+          </a:p>
+          <a:p>
+            <a:pPr>
+              <a:spcAft>
+                <a:spcPts val="400"/>
+              </a:spcAft>
+              <a:defRPr sz="1400"/>
+            </a:pPr>
+            <a:r>
+              <a:t>•    measured prepayment propensity once competing risks are accounted for</a:t>
+            </a:r>
+          </a:p>
+          <a:p>
+            <a:pPr>
+              <a:spcAft>
+                <a:spcPts val="400"/>
+              </a:spcAft>
+              <a:defRPr sz="1400"/>
+            </a:pPr>
+            <a:r>
+              <a:t>• Use Fine-Gray for CIF prediction / loss forecasting</a:t>
+            </a:r>
+          </a:p>
+          <a:p>
+            <a:pPr>
+              <a:spcAft>
+                <a:spcPts val="400"/>
+              </a:spcAft>
+              <a:defRPr sz="1400"/>
+            </a:pPr>
+            <a:r>
+              <a:t>• Use cause-specific Cox for economic mechanism estimation</a:t>
+            </a:r>
+          </a:p>
+        </p:txBody>
+      </p:sp>
     </p:spTree>
   </p:cSld>
   <p:clrMapOvr>
@@ -4132,14 +4005,48 @@
                   <a:srgbClr val="FFFFFF"/>
                 </a:solidFill>
               </a:rPr>
-              <a:t>E(iv) — Scenario Analysis: Interpretation</a:t>
-            </a:r>
-          </a:p>
-        </p:txBody>
-      </p:sp>
-      <p:sp>
-        <p:nvSpPr>
-          <p:cNvPr id="4" name="Rectangle 3"/>
+              <a:t>E(ii) — Time-Dependent Covariates</a:t>
+            </a:r>
+          </a:p>
+        </p:txBody>
+      </p:sp>
+      <p:sp>
+        <p:nvSpPr>
+          <p:cNvPr id="4" name="TextBox 3"/>
+          <p:cNvSpPr txBox="1"/>
+          <p:nvPr/>
+        </p:nvSpPr>
+        <p:spPr>
+          <a:xfrm>
+            <a:off x="274320" y="566928"/>
+            <a:ext cx="10058400" cy="365760"/>
+          </a:xfrm>
+          <a:prstGeom prst="rect">
+            <a:avLst/>
+          </a:prstGeom>
+          <a:noFill/>
+        </p:spPr>
+        <p:txBody>
+          <a:bodyPr wrap="square">
+            <a:spAutoFit/>
+          </a:bodyPr>
+          <a:lstStyle/>
+          <a:p>
+            <a:pPr algn="l"/>
+            <a:r>
+              <a:rPr sz="1400" b="0">
+                <a:solidFill>
+                  <a:srgbClr val="ECF0F1"/>
+                </a:solidFill>
+              </a:rPr>
+              <a:t>Andersen-Gill counting-process Cox — monthly rate_incentive, unemployment, HPI</a:t>
+            </a:r>
+          </a:p>
+        </p:txBody>
+      </p:sp>
+      <p:sp>
+        <p:nvSpPr>
+          <p:cNvPr id="5" name="Rectangle 4"/>
           <p:cNvSpPr/>
           <p:nvPr/>
         </p:nvSpPr>
@@ -4182,7 +4089,7 @@
       </p:sp>
       <p:sp>
         <p:nvSpPr>
-          <p:cNvPr id="5" name="TextBox 4"/>
+          <p:cNvPr id="6" name="TextBox 5"/>
           <p:cNvSpPr txBox="1"/>
           <p:nvPr/>
         </p:nvSpPr>
@@ -4206,10 +4113,10 @@
               <a:spcAft>
                 <a:spcPts val="400"/>
               </a:spcAft>
-              <a:defRPr sz="1500"/>
+              <a:defRPr sz="1300"/>
             </a:pPr>
             <a:r>
-              <a:t>• XGBoost: clear monotone CONVEX response — rate cuts raise prepayment probability more than rate rises suppress it</a:t>
+              <a:t>• Panel dataset: 93M rows × 2M loans — mortgage_rate, unemployment, HPI YoY, rate_incentive updated monthly</a:t>
             </a:r>
           </a:p>
           <a:p>
@@ -4217,10 +4124,10 @@
               <a:spcAft>
                 <a:spcPts val="400"/>
               </a:spcAft>
-              <a:defRPr sz="1500"/>
+              <a:defRPr sz="1300"/>
             </a:pPr>
             <a:r>
-              <a:t>• Deep Cox: monotone but smoother — log-hazard is a less non-linear function of rate_incentive</a:t>
+              <a:t>• 10,000 loans stratified by vintage → ~500K counting-process rows (tstart, tstop, event)</a:t>
             </a:r>
           </a:p>
           <a:p>
@@ -4228,10 +4135,10 @@
               <a:spcAft>
                 <a:spcPts val="400"/>
               </a:spcAft>
-              <a:defRPr sz="1500"/>
+              <a:defRPr sz="1300"/>
             </a:pPr>
             <a:r>
-              <a:t>• Asymmetry (−200 bp effect &gt; +200 bp effect) reflects the BURNOUT effect:</a:t>
+              <a:t>• 11 features: 7 static (FICO, LTV, DTI, UPB + 3 one-hot) + 4 time-varying</a:t>
             </a:r>
           </a:p>
           <a:p>
@@ -4239,10 +4146,10 @@
               <a:spcAft>
                 <a:spcPts val="400"/>
               </a:spcAft>
-              <a:defRPr sz="1500"/>
+              <a:defRPr sz="1300"/>
             </a:pPr>
             <a:r>
-              <a:t>•    most rate-sensitive borrowers have already prepaid → muted upside response to cuts</a:t>
+              <a:t>• Key finding: current rate_incentive coefficient LARGER than origination-vintage snapshot</a:t>
             </a:r>
           </a:p>
           <a:p>
@@ -4250,10 +4157,10 @@
               <a:spcAft>
                 <a:spcPts val="400"/>
               </a:spcAft>
-              <a:defRPr sz="1500"/>
+              <a:defRPr sz="1300"/>
             </a:pPr>
             <a:r>
-              <a:t>• Both models agree on direction → robustness of rate-incentive channel across architectures</a:t>
+              <a:t>•    Static Cox: rate_incentive locked at origination — high-rate era loans always look attractive</a:t>
             </a:r>
           </a:p>
           <a:p>
@@ -4261,10 +4168,10 @@
               <a:spcAft>
                 <a:spcPts val="400"/>
               </a:spcAft>
-              <a:defRPr sz="1500"/>
+              <a:defRPr sz="1300"/>
             </a:pPr>
             <a:r>
-              <a:t>• Implication for MBS pricing: prepayment option has POSITIVE CONVEXITY —</a:t>
+              <a:t>•    TV Cox: tracks actual monthly refi option value — more responsive to rate cycles</a:t>
             </a:r>
           </a:p>
           <a:p>
@@ -4272,10 +4179,21 @@
               <a:spcAft>
                 <a:spcPts val="400"/>
               </a:spcAft>
-              <a:defRPr sz="1500"/>
+              <a:defRPr sz="1300"/>
             </a:pPr>
             <a:r>
-              <a:t>•    rate decline creates more prepayment than rate rise suppresses it</a:t>
+              <a:t>• Unemployment: contemporaneous job loss predicts default better than vintage average</a:t>
+            </a:r>
+          </a:p>
+          <a:p>
+            <a:pPr>
+              <a:spcAft>
+                <a:spcPts val="400"/>
+              </a:spcAft>
+              <a:defRPr sz="1300"/>
+            </a:pPr>
+            <a:r>
+              <a:t>• Limitation: origination LTV used (not ELTV) — adding current LTV would improve default hazard</a:t>
             </a:r>
           </a:p>
         </p:txBody>
@@ -4370,6 +4288,540 @@
                   <a:srgbClr val="FFFFFF"/>
                 </a:solidFill>
               </a:rPr>
+              <a:t>E(ii) — TV Cox Results</a:t>
+            </a:r>
+          </a:p>
+        </p:txBody>
+      </p:sp>
+      <p:pic>
+        <p:nvPicPr>
+          <p:cNvPr id="4" name="Picture 3" descr="Eii_tv_cox_forest.png"/>
+          <p:cNvPicPr>
+            <a:picLocks noChangeAspect="1"/>
+          </p:cNvPicPr>
+          <p:nvPr/>
+        </p:nvPicPr>
+        <p:blipFill>
+          <a:blip r:embed="rId2"/>
+          <a:stretch>
+            <a:fillRect/>
+          </a:stretch>
+        </p:blipFill>
+        <p:spPr>
+          <a:xfrm>
+            <a:off x="137160" y="1051560"/>
+            <a:ext cx="7132320" cy="3013704"/>
+          </a:xfrm>
+          <a:prstGeom prst="rect">
+            <a:avLst/>
+          </a:prstGeom>
+        </p:spPr>
+      </p:pic>
+      <p:pic>
+        <p:nvPicPr>
+          <p:cNvPr id="5" name="Picture 4" descr="Eii_static_vs_tv.png"/>
+          <p:cNvPicPr>
+            <a:picLocks noChangeAspect="1"/>
+          </p:cNvPicPr>
+          <p:nvPr/>
+        </p:nvPicPr>
+        <p:blipFill>
+          <a:blip r:embed="rId3"/>
+          <a:stretch>
+            <a:fillRect/>
+          </a:stretch>
+        </p:blipFill>
+        <p:spPr>
+          <a:xfrm>
+            <a:off x="7406640" y="1051560"/>
+            <a:ext cx="4572000" cy="2247385"/>
+          </a:xfrm>
+          <a:prstGeom prst="rect">
+            <a:avLst/>
+          </a:prstGeom>
+        </p:spPr>
+      </p:pic>
+    </p:spTree>
+  </p:cSld>
+  <p:clrMapOvr>
+    <a:masterClrMapping/>
+  </p:clrMapOvr>
+</p:sld>
+</file>
+
+<file path=ppt/slides/slide15.xml><?xml version="1.0" encoding="utf-8"?>
+<p:sld xmlns:a="http://schemas.openxmlformats.org/drawingml/2006/main" xmlns:p="http://schemas.openxmlformats.org/presentationml/2006/main" xmlns:r="http://schemas.openxmlformats.org/officeDocument/2006/relationships">
+  <p:cSld>
+    <p:spTree>
+      <p:nvGrpSpPr>
+        <p:cNvPr id="1" name=""/>
+        <p:cNvGrpSpPr/>
+        <p:nvPr/>
+      </p:nvGrpSpPr>
+      <p:grpSpPr/>
+      <p:sp>
+        <p:nvSpPr>
+          <p:cNvPr id="2" name="Rectangle 1"/>
+          <p:cNvSpPr/>
+          <p:nvPr/>
+        </p:nvSpPr>
+        <p:spPr>
+          <a:xfrm>
+            <a:off x="0" y="0"/>
+            <a:ext cx="12188952" cy="1005840"/>
+          </a:xfrm>
+          <a:prstGeom prst="rect">
+            <a:avLst/>
+          </a:prstGeom>
+          <a:solidFill>
+            <a:srgbClr val="2C3E50"/>
+          </a:solidFill>
+          <a:ln>
+            <a:noFill/>
+          </a:ln>
+        </p:spPr>
+        <p:style>
+          <a:lnRef idx="1">
+            <a:schemeClr val="accent1"/>
+          </a:lnRef>
+          <a:fillRef idx="3">
+            <a:schemeClr val="accent1"/>
+          </a:fillRef>
+          <a:effectRef idx="2">
+            <a:schemeClr val="accent1"/>
+          </a:effectRef>
+          <a:fontRef idx="minor">
+            <a:schemeClr val="lt1"/>
+          </a:fontRef>
+        </p:style>
+        <p:txBody>
+          <a:bodyPr rtlCol="0" anchor="ctr"/>
+          <a:lstStyle/>
+          <a:p>
+            <a:pPr algn="ctr"/>
+          </a:p>
+        </p:txBody>
+      </p:sp>
+      <p:sp>
+        <p:nvSpPr>
+          <p:cNvPr id="3" name="TextBox 2"/>
+          <p:cNvSpPr txBox="1"/>
+          <p:nvPr/>
+        </p:nvSpPr>
+        <p:spPr>
+          <a:xfrm>
+            <a:off x="274320" y="73152"/>
+            <a:ext cx="10058400" cy="502920"/>
+          </a:xfrm>
+          <a:prstGeom prst="rect">
+            <a:avLst/>
+          </a:prstGeom>
+          <a:noFill/>
+        </p:spPr>
+        <p:txBody>
+          <a:bodyPr wrap="square">
+            <a:spAutoFit/>
+          </a:bodyPr>
+          <a:lstStyle/>
+          <a:p>
+            <a:pPr algn="l"/>
+            <a:r>
+              <a:rPr sz="2600" b="1">
+                <a:solidFill>
+                  <a:srgbClr val="FFFFFF"/>
+                </a:solidFill>
+              </a:rPr>
+              <a:t>E(iv) — Scenario Analysis: Interest Rate Shocks</a:t>
+            </a:r>
+          </a:p>
+        </p:txBody>
+      </p:sp>
+      <p:sp>
+        <p:nvSpPr>
+          <p:cNvPr id="4" name="TextBox 3"/>
+          <p:cNvSpPr txBox="1"/>
+          <p:nvPr/>
+        </p:nvSpPr>
+        <p:spPr>
+          <a:xfrm>
+            <a:off x="274320" y="566928"/>
+            <a:ext cx="10058400" cy="365760"/>
+          </a:xfrm>
+          <a:prstGeom prst="rect">
+            <a:avLst/>
+          </a:prstGeom>
+          <a:noFill/>
+        </p:spPr>
+        <p:txBody>
+          <a:bodyPr wrap="square">
+            <a:spAutoFit/>
+          </a:bodyPr>
+          <a:lstStyle/>
+          <a:p>
+            <a:pPr algn="l"/>
+            <a:r>
+              <a:rPr sz="1400" b="0">
+                <a:solidFill>
+                  <a:srgbClr val="ECF0F1"/>
+                </a:solidFill>
+              </a:rPr>
+              <a:t>±100 bp and ±200 bp shocks to mortgage_rate  (rate_incentive updated consistently)</a:t>
+            </a:r>
+          </a:p>
+        </p:txBody>
+      </p:sp>
+      <p:pic>
+        <p:nvPicPr>
+          <p:cNvPr id="5" name="Picture 4" descr="E2_scenario_analysis.png"/>
+          <p:cNvPicPr>
+            <a:picLocks noChangeAspect="1"/>
+          </p:cNvPicPr>
+          <p:nvPr/>
+        </p:nvPicPr>
+        <p:blipFill>
+          <a:blip r:embed="rId2"/>
+          <a:stretch>
+            <a:fillRect/>
+          </a:stretch>
+        </p:blipFill>
+        <p:spPr>
+          <a:xfrm>
+            <a:off x="457200" y="1051560"/>
+            <a:ext cx="11247120" cy="3906695"/>
+          </a:xfrm>
+          <a:prstGeom prst="rect">
+            <a:avLst/>
+          </a:prstGeom>
+        </p:spPr>
+      </p:pic>
+    </p:spTree>
+  </p:cSld>
+  <p:clrMapOvr>
+    <a:masterClrMapping/>
+  </p:clrMapOvr>
+</p:sld>
+</file>
+
+<file path=ppt/slides/slide16.xml><?xml version="1.0" encoding="utf-8"?>
+<p:sld xmlns:a="http://schemas.openxmlformats.org/drawingml/2006/main" xmlns:p="http://schemas.openxmlformats.org/presentationml/2006/main" xmlns:r="http://schemas.openxmlformats.org/officeDocument/2006/relationships">
+  <p:cSld>
+    <p:spTree>
+      <p:nvGrpSpPr>
+        <p:cNvPr id="1" name=""/>
+        <p:cNvGrpSpPr/>
+        <p:nvPr/>
+      </p:nvGrpSpPr>
+      <p:grpSpPr/>
+      <p:sp>
+        <p:nvSpPr>
+          <p:cNvPr id="2" name="Rectangle 1"/>
+          <p:cNvSpPr/>
+          <p:nvPr/>
+        </p:nvSpPr>
+        <p:spPr>
+          <a:xfrm>
+            <a:off x="0" y="0"/>
+            <a:ext cx="12188952" cy="1005840"/>
+          </a:xfrm>
+          <a:prstGeom prst="rect">
+            <a:avLst/>
+          </a:prstGeom>
+          <a:solidFill>
+            <a:srgbClr val="2C3E50"/>
+          </a:solidFill>
+          <a:ln>
+            <a:noFill/>
+          </a:ln>
+        </p:spPr>
+        <p:style>
+          <a:lnRef idx="1">
+            <a:schemeClr val="accent1"/>
+          </a:lnRef>
+          <a:fillRef idx="3">
+            <a:schemeClr val="accent1"/>
+          </a:fillRef>
+          <a:effectRef idx="2">
+            <a:schemeClr val="accent1"/>
+          </a:effectRef>
+          <a:fontRef idx="minor">
+            <a:schemeClr val="lt1"/>
+          </a:fontRef>
+        </p:style>
+        <p:txBody>
+          <a:bodyPr rtlCol="0" anchor="ctr"/>
+          <a:lstStyle/>
+          <a:p>
+            <a:pPr algn="ctr"/>
+          </a:p>
+        </p:txBody>
+      </p:sp>
+      <p:sp>
+        <p:nvSpPr>
+          <p:cNvPr id="3" name="TextBox 2"/>
+          <p:cNvSpPr txBox="1"/>
+          <p:nvPr/>
+        </p:nvSpPr>
+        <p:spPr>
+          <a:xfrm>
+            <a:off x="274320" y="73152"/>
+            <a:ext cx="10058400" cy="502920"/>
+          </a:xfrm>
+          <a:prstGeom prst="rect">
+            <a:avLst/>
+          </a:prstGeom>
+          <a:noFill/>
+        </p:spPr>
+        <p:txBody>
+          <a:bodyPr wrap="square">
+            <a:spAutoFit/>
+          </a:bodyPr>
+          <a:lstStyle/>
+          <a:p>
+            <a:pPr algn="l"/>
+            <a:r>
+              <a:rPr sz="2600" b="1">
+                <a:solidFill>
+                  <a:srgbClr val="FFFFFF"/>
+                </a:solidFill>
+              </a:rPr>
+              <a:t>E(iv) — Scenario Analysis: Interpretation</a:t>
+            </a:r>
+          </a:p>
+        </p:txBody>
+      </p:sp>
+      <p:sp>
+        <p:nvSpPr>
+          <p:cNvPr id="4" name="Rectangle 3"/>
+          <p:cNvSpPr/>
+          <p:nvPr/>
+        </p:nvSpPr>
+        <p:spPr>
+          <a:xfrm>
+            <a:off x="0" y="1005840"/>
+            <a:ext cx="12188952" cy="5852160"/>
+          </a:xfrm>
+          <a:prstGeom prst="rect">
+            <a:avLst/>
+          </a:prstGeom>
+          <a:solidFill>
+            <a:srgbClr val="ECF0F1"/>
+          </a:solidFill>
+          <a:ln>
+            <a:noFill/>
+          </a:ln>
+        </p:spPr>
+        <p:style>
+          <a:lnRef idx="1">
+            <a:schemeClr val="accent1"/>
+          </a:lnRef>
+          <a:fillRef idx="3">
+            <a:schemeClr val="accent1"/>
+          </a:fillRef>
+          <a:effectRef idx="2">
+            <a:schemeClr val="accent1"/>
+          </a:effectRef>
+          <a:fontRef idx="minor">
+            <a:schemeClr val="lt1"/>
+          </a:fontRef>
+        </p:style>
+        <p:txBody>
+          <a:bodyPr rtlCol="0" anchor="ctr"/>
+          <a:lstStyle/>
+          <a:p>
+            <a:pPr algn="ctr"/>
+          </a:p>
+        </p:txBody>
+      </p:sp>
+      <p:sp>
+        <p:nvSpPr>
+          <p:cNvPr id="5" name="TextBox 4"/>
+          <p:cNvSpPr txBox="1"/>
+          <p:nvPr/>
+        </p:nvSpPr>
+        <p:spPr>
+          <a:xfrm>
+            <a:off x="457200" y="1188720"/>
+            <a:ext cx="11247120" cy="5029200"/>
+          </a:xfrm>
+          <a:prstGeom prst="rect">
+            <a:avLst/>
+          </a:prstGeom>
+          <a:noFill/>
+        </p:spPr>
+        <p:txBody>
+          <a:bodyPr wrap="square">
+            <a:spAutoFit/>
+          </a:bodyPr>
+          <a:lstStyle/>
+          <a:p>
+            <a:pPr>
+              <a:spcAft>
+                <a:spcPts val="400"/>
+              </a:spcAft>
+              <a:defRPr sz="1500"/>
+            </a:pPr>
+            <a:r>
+              <a:t>• XGBoost: clear monotone CONVEX response — rate cuts raise prepayment probability more than rate rises suppress it</a:t>
+            </a:r>
+          </a:p>
+          <a:p>
+            <a:pPr>
+              <a:spcAft>
+                <a:spcPts val="400"/>
+              </a:spcAft>
+              <a:defRPr sz="1500"/>
+            </a:pPr>
+            <a:r>
+              <a:t>• Deep Cox: monotone but smoother — log-hazard is a less non-linear function of rate_incentive</a:t>
+            </a:r>
+          </a:p>
+          <a:p>
+            <a:pPr>
+              <a:spcAft>
+                <a:spcPts val="400"/>
+              </a:spcAft>
+              <a:defRPr sz="1500"/>
+            </a:pPr>
+            <a:r>
+              <a:t>• Asymmetry (−200 bp effect &gt; +200 bp effect) reflects the BURNOUT effect:</a:t>
+            </a:r>
+          </a:p>
+          <a:p>
+            <a:pPr>
+              <a:spcAft>
+                <a:spcPts val="400"/>
+              </a:spcAft>
+              <a:defRPr sz="1500"/>
+            </a:pPr>
+            <a:r>
+              <a:t>•    most rate-sensitive borrowers have already prepaid → muted upside response to cuts</a:t>
+            </a:r>
+          </a:p>
+          <a:p>
+            <a:pPr>
+              <a:spcAft>
+                <a:spcPts val="400"/>
+              </a:spcAft>
+              <a:defRPr sz="1500"/>
+            </a:pPr>
+            <a:r>
+              <a:t>• Both models agree on direction → robustness of rate-incentive channel across architectures</a:t>
+            </a:r>
+          </a:p>
+          <a:p>
+            <a:pPr>
+              <a:spcAft>
+                <a:spcPts val="400"/>
+              </a:spcAft>
+              <a:defRPr sz="1500"/>
+            </a:pPr>
+            <a:r>
+              <a:t>• Implication for MBS pricing: prepayment option has POSITIVE CONVEXITY —</a:t>
+            </a:r>
+          </a:p>
+          <a:p>
+            <a:pPr>
+              <a:spcAft>
+                <a:spcPts val="400"/>
+              </a:spcAft>
+              <a:defRPr sz="1500"/>
+            </a:pPr>
+            <a:r>
+              <a:t>•    rate decline creates more prepayment than rate rise suppresses it</a:t>
+            </a:r>
+          </a:p>
+        </p:txBody>
+      </p:sp>
+    </p:spTree>
+  </p:cSld>
+  <p:clrMapOvr>
+    <a:masterClrMapping/>
+  </p:clrMapOvr>
+</p:sld>
+</file>
+
+<file path=ppt/slides/slide17.xml><?xml version="1.0" encoding="utf-8"?>
+<p:sld xmlns:a="http://schemas.openxmlformats.org/drawingml/2006/main" xmlns:p="http://schemas.openxmlformats.org/presentationml/2006/main" xmlns:r="http://schemas.openxmlformats.org/officeDocument/2006/relationships">
+  <p:cSld>
+    <p:spTree>
+      <p:nvGrpSpPr>
+        <p:cNvPr id="1" name=""/>
+        <p:cNvGrpSpPr/>
+        <p:nvPr/>
+      </p:nvGrpSpPr>
+      <p:grpSpPr/>
+      <p:sp>
+        <p:nvSpPr>
+          <p:cNvPr id="2" name="Rectangle 1"/>
+          <p:cNvSpPr/>
+          <p:nvPr/>
+        </p:nvSpPr>
+        <p:spPr>
+          <a:xfrm>
+            <a:off x="0" y="0"/>
+            <a:ext cx="12188952" cy="1005840"/>
+          </a:xfrm>
+          <a:prstGeom prst="rect">
+            <a:avLst/>
+          </a:prstGeom>
+          <a:solidFill>
+            <a:srgbClr val="2C3E50"/>
+          </a:solidFill>
+          <a:ln>
+            <a:noFill/>
+          </a:ln>
+        </p:spPr>
+        <p:style>
+          <a:lnRef idx="1">
+            <a:schemeClr val="accent1"/>
+          </a:lnRef>
+          <a:fillRef idx="3">
+            <a:schemeClr val="accent1"/>
+          </a:fillRef>
+          <a:effectRef idx="2">
+            <a:schemeClr val="accent1"/>
+          </a:effectRef>
+          <a:fontRef idx="minor">
+            <a:schemeClr val="lt1"/>
+          </a:fontRef>
+        </p:style>
+        <p:txBody>
+          <a:bodyPr rtlCol="0" anchor="ctr"/>
+          <a:lstStyle/>
+          <a:p>
+            <a:pPr algn="ctr"/>
+          </a:p>
+        </p:txBody>
+      </p:sp>
+      <p:sp>
+        <p:nvSpPr>
+          <p:cNvPr id="3" name="TextBox 2"/>
+          <p:cNvSpPr txBox="1"/>
+          <p:nvPr/>
+        </p:nvSpPr>
+        <p:spPr>
+          <a:xfrm>
+            <a:off x="274320" y="73152"/>
+            <a:ext cx="10058400" cy="502920"/>
+          </a:xfrm>
+          <a:prstGeom prst="rect">
+            <a:avLst/>
+          </a:prstGeom>
+          <a:noFill/>
+        </p:spPr>
+        <p:txBody>
+          <a:bodyPr wrap="square">
+            <a:spAutoFit/>
+          </a:bodyPr>
+          <a:lstStyle/>
+          <a:p>
+            <a:pPr algn="l"/>
+            <a:r>
+              <a:rPr sz="2600" b="1">
+                <a:solidFill>
+                  <a:srgbClr val="FFFFFF"/>
+                </a:solidFill>
+              </a:rPr>
               <a:t>Summary</a:t>
             </a:r>
           </a:p>
@@ -5762,7 +6214,7 @@
                   <a:srgbClr val="FFFFFF"/>
                 </a:solidFill>
               </a:rPr>
-              <a:t>E(i)(a) — EDA: Full 34M-Loan Dataset</a:t>
+              <a:t>E(i)(a) — EDA: Defaulted Borrowers Are Riskier on Every Dimension</a:t>
             </a:r>
           </a:p>
         </p:txBody>
@@ -5796,14 +6248,14 @@
                   <a:srgbClr val="ECF0F1"/>
                 </a:solidFill>
               </a:rPr>
-              <a:t>Freddie Mac FRM-360, 1999–2023</a:t>
+              <a:t>FICO 44 pts lower · LTV 8.6 pp higher · DTI 4.6 pp higher · Rate 0.85 pp higher</a:t>
             </a:r>
           </a:p>
         </p:txBody>
       </p:sp>
       <p:pic>
         <p:nvPicPr>
-          <p:cNvPr id="5" name="Picture 4" descr="E1_eda_duration.png"/>
+          <p:cNvPr id="5" name="Picture 4" descr="E1_eda_profile.png"/>
           <p:cNvPicPr>
             <a:picLocks noChangeAspect="1"/>
           </p:cNvPicPr>
@@ -5817,8 +6269,8 @@
         </p:blipFill>
         <p:spPr>
           <a:xfrm>
-            <a:off x="137160" y="1097280"/>
-            <a:ext cx="11887200" cy="3196144"/>
+            <a:off x="457200" y="1097280"/>
+            <a:ext cx="11247120" cy="4968424"/>
           </a:xfrm>
           <a:prstGeom prst="rect">
             <a:avLst/>
@@ -5915,14 +6367,48 @@
                   <a:srgbClr val="FFFFFF"/>
                 </a:solidFill>
               </a:rPr>
-              <a:t>E(i)(a) — EDA: Covariate Profiles &amp; Loan Categories</a:t>
+              <a:t>E(i)(a) — EDA: Different Timescales, Different Mechanisms</a:t>
+            </a:r>
+          </a:p>
+        </p:txBody>
+      </p:sp>
+      <p:sp>
+        <p:nvSpPr>
+          <p:cNvPr id="4" name="TextBox 3"/>
+          <p:cNvSpPr txBox="1"/>
+          <p:nvPr/>
+        </p:nvSpPr>
+        <p:spPr>
+          <a:xfrm>
+            <a:off x="274320" y="566928"/>
+            <a:ext cx="10058400" cy="365760"/>
+          </a:xfrm>
+          <a:prstGeom prst="rect">
+            <a:avLst/>
+          </a:prstGeom>
+          <a:noFill/>
+        </p:spPr>
+        <p:txBody>
+          <a:bodyPr wrap="square">
+            <a:spAutoFit/>
+          </a:bodyPr>
+          <a:lstStyle/>
+          <a:p>
+            <a:pPr algn="l"/>
+            <a:r>
+              <a:rPr sz="1400" b="0">
+                <a:solidFill>
+                  <a:srgbClr val="ECF0F1"/>
+                </a:solidFill>
+              </a:rPr>
+              <a:t>Prepayment = rate-option exercise (~40 mo median)  |  Default = financial stress (30–80 mo)</a:t>
             </a:r>
           </a:p>
         </p:txBody>
       </p:sp>
       <p:pic>
         <p:nvPicPr>
-          <p:cNvPr id="4" name="Picture 3" descr="E1_eda_covariates.png"/>
+          <p:cNvPr id="5" name="Picture 4" descr="E1_eda_duration.png"/>
           <p:cNvPicPr>
             <a:picLocks noChangeAspect="1"/>
           </p:cNvPicPr>
@@ -5936,32 +6422,8 @@
         </p:blipFill>
         <p:spPr>
           <a:xfrm>
-            <a:off x="137160" y="1051560"/>
-            <a:ext cx="7132320" cy="2031941"/>
-          </a:xfrm>
-          <a:prstGeom prst="rect">
-            <a:avLst/>
-          </a:prstGeom>
-        </p:spPr>
-      </p:pic>
-      <p:pic>
-        <p:nvPicPr>
-          <p:cNvPr id="5" name="Picture 4" descr="E1_eda_categorical.png"/>
-          <p:cNvPicPr>
-            <a:picLocks noChangeAspect="1"/>
-          </p:cNvPicPr>
-          <p:nvPr/>
-        </p:nvPicPr>
-        <p:blipFill>
-          <a:blip r:embed="rId3"/>
-          <a:stretch>
-            <a:fillRect/>
-          </a:stretch>
-        </p:blipFill>
-        <p:spPr>
-          <a:xfrm>
-            <a:off x="7406640" y="1051560"/>
-            <a:ext cx="4572000" cy="1404223"/>
+            <a:off x="137160" y="1097280"/>
+            <a:ext cx="11887200" cy="5099710"/>
           </a:xfrm>
           <a:prstGeom prst="rect">
             <a:avLst/>
@@ -6058,7 +6520,7 @@
                   <a:srgbClr val="FFFFFF"/>
                 </a:solidFill>
               </a:rPr>
-              <a:t>E(i)(a) — EDA: Vintage Cohort Analysis</a:t>
+              <a:t>E(i)(a) — EDA: The Equity Trap &amp; Rate Lock-In Effect</a:t>
             </a:r>
           </a:p>
         </p:txBody>
@@ -6092,14 +6554,14 @@
                   <a:srgbClr val="ECF0F1"/>
                 </a:solidFill>
               </a:rPr>
-              <a:t>2006–2008 vintages: peak default 8–12%; post-2012: near-zero default</a:t>
+              <a:t>High LTV removes refi escape · Active loans at 4.4% cannot refinance into 7%+ market</a:t>
             </a:r>
           </a:p>
         </p:txBody>
       </p:sp>
       <p:pic>
         <p:nvPicPr>
-          <p:cNvPr id="5" name="Picture 4" descr="E1_eda_vintage.png"/>
+          <p:cNvPr id="5" name="Picture 4" descr="E1_eda_ltv_trap.png"/>
           <p:cNvPicPr>
             <a:picLocks noChangeAspect="1"/>
           </p:cNvPicPr>
@@ -6113,8 +6575,32 @@
         </p:blipFill>
         <p:spPr>
           <a:xfrm>
-            <a:off x="457200" y="1097280"/>
-            <a:ext cx="11247120" cy="3200356"/>
+            <a:off x="137160" y="1097280"/>
+            <a:ext cx="5943600" cy="2807590"/>
+          </a:xfrm>
+          <a:prstGeom prst="rect">
+            <a:avLst/>
+          </a:prstGeom>
+        </p:spPr>
+      </p:pic>
+      <p:pic>
+        <p:nvPicPr>
+          <p:cNvPr id="6" name="Picture 5" descr="E1_eda_rate_lockin.png"/>
+          <p:cNvPicPr>
+            <a:picLocks noChangeAspect="1"/>
+          </p:cNvPicPr>
+          <p:nvPr/>
+        </p:nvPicPr>
+        <p:blipFill>
+          <a:blip r:embed="rId3"/>
+          <a:stretch>
+            <a:fillRect/>
+          </a:stretch>
+        </p:blipFill>
+        <p:spPr>
+          <a:xfrm>
+            <a:off x="6217920" y="1097280"/>
+            <a:ext cx="5760720" cy="2471398"/>
           </a:xfrm>
           <a:prstGeom prst="rect">
             <a:avLst/>
@@ -6211,7 +6697,7 @@
                   <a:srgbClr val="FFFFFF"/>
                 </a:solidFill>
               </a:rPr>
-              <a:t>E(i)(b) — Aalen-Johansen CIF</a:t>
+              <a:t>E(i)(a) — EDA: GFC Vintages Carry Concentrated Default Risk</a:t>
             </a:r>
           </a:p>
         </p:txBody>
@@ -6245,14 +6731,14 @@
                   <a:srgbClr val="ECF0F1"/>
                 </a:solidFill>
               </a:rPr>
-              <a:t>Correct competing-risks treatment; 10-yr prepay ≈ 45%,  default ≈ 2%</a:t>
+              <a:t>2007 cohort = 6× long-run avg default rate · Post-2013 near-zero · Post-2020 rate-locked</a:t>
             </a:r>
           </a:p>
         </p:txBody>
       </p:sp>
       <p:pic>
         <p:nvPicPr>
-          <p:cNvPr id="5" name="Picture 4" descr="E1_competing_risks_cif.png"/>
+          <p:cNvPr id="5" name="Picture 4" descr="E1_eda_vintage.png"/>
           <p:cNvPicPr>
             <a:picLocks noChangeAspect="1"/>
           </p:cNvPicPr>
@@ -6266,8 +6752,8 @@
         </p:blipFill>
         <p:spPr>
           <a:xfrm>
-            <a:off x="1371600" y="1097280"/>
-            <a:ext cx="9144000" cy="5034337"/>
+            <a:off x="137160" y="1097280"/>
+            <a:ext cx="11887200" cy="4059952"/>
           </a:xfrm>
           <a:prstGeom prst="rect">
             <a:avLst/>
@@ -6364,48 +6850,14 @@
                   <a:srgbClr val="FFFFFF"/>
                 </a:solidFill>
               </a:rPr>
-              <a:t>E(i)(c) — KM vs AJ: Bias from Ignoring Competing Events</a:t>
-            </a:r>
-          </a:p>
-        </p:txBody>
-      </p:sp>
-      <p:sp>
-        <p:nvSpPr>
-          <p:cNvPr id="4" name="TextBox 3"/>
-          <p:cNvSpPr txBox="1"/>
-          <p:nvPr/>
-        </p:nvSpPr>
-        <p:spPr>
-          <a:xfrm>
-            <a:off x="274320" y="566928"/>
-            <a:ext cx="10058400" cy="365760"/>
-          </a:xfrm>
-          <a:prstGeom prst="rect">
-            <a:avLst/>
-          </a:prstGeom>
-          <a:noFill/>
-        </p:spPr>
-        <p:txBody>
-          <a:bodyPr wrap="square">
-            <a:spAutoFit/>
-          </a:bodyPr>
-          <a:lstStyle/>
-          <a:p>
-            <a:pPr algn="l"/>
-            <a:r>
-              <a:rPr sz="1400" b="0">
-                <a:solidFill>
-                  <a:srgbClr val="ECF0F1"/>
-                </a:solidFill>
-              </a:rPr>
-              <a:t>KM over-estimates prepayment CIF by treating defaults as independent censorings</a:t>
+              <a:t>E(i)(a) — EDA: Covariate Profiles &amp; Loan Categories</a:t>
             </a:r>
           </a:p>
         </p:txBody>
       </p:sp>
       <p:pic>
         <p:nvPicPr>
-          <p:cNvPr id="5" name="Picture 4" descr="E1_km_vs_aj_bias.png"/>
+          <p:cNvPr id="4" name="Picture 3" descr="E1_eda_covariates.png"/>
           <p:cNvPicPr>
             <a:picLocks noChangeAspect="1"/>
           </p:cNvPicPr>
@@ -6419,70 +6871,38 @@
         </p:blipFill>
         <p:spPr>
           <a:xfrm>
-            <a:off x="457200" y="1097280"/>
-            <a:ext cx="11247120" cy="3402930"/>
+            <a:off x="137160" y="1051560"/>
+            <a:ext cx="7132320" cy="2038539"/>
           </a:xfrm>
           <a:prstGeom prst="rect">
             <a:avLst/>
           </a:prstGeom>
         </p:spPr>
       </p:pic>
-      <p:sp>
-        <p:nvSpPr>
-          <p:cNvPr id="6" name="TextBox 5"/>
-          <p:cNvSpPr txBox="1"/>
-          <p:nvPr/>
-        </p:nvSpPr>
-        <p:spPr>
-          <a:xfrm>
-            <a:off x="8686800" y="4754880"/>
-            <a:ext cx="3200400" cy="1371600"/>
-          </a:xfrm>
-          <a:prstGeom prst="rect">
-            <a:avLst/>
-          </a:prstGeom>
-          <a:noFill/>
-        </p:spPr>
-        <p:txBody>
-          <a:bodyPr wrap="square">
-            <a:spAutoFit/>
-          </a:bodyPr>
-          <a:lstStyle/>
-          <a:p>
-            <a:pPr>
-              <a:spcAft>
-                <a:spcPts val="400"/>
-              </a:spcAft>
-              <a:defRPr sz="1300"/>
-            </a:pPr>
-            <a:r>
-              <a:t>• 5 yr: +0.45 pp</a:t>
-            </a:r>
-          </a:p>
-          <a:p>
-            <a:pPr>
-              <a:spcAft>
-                <a:spcPts val="400"/>
-              </a:spcAft>
-              <a:defRPr sz="1300"/>
-            </a:pPr>
-            <a:r>
-              <a:t>• 10 yr: +1.31 pp</a:t>
-            </a:r>
-          </a:p>
-          <a:p>
-            <a:pPr>
-              <a:spcAft>
-                <a:spcPts val="400"/>
-              </a:spcAft>
-              <a:defRPr sz="1300"/>
-            </a:pPr>
-            <a:r>
-              <a:t>• 20 yr: +2.23 pp</a:t>
-            </a:r>
-          </a:p>
-        </p:txBody>
-      </p:sp>
+      <p:pic>
+        <p:nvPicPr>
+          <p:cNvPr id="5" name="Picture 4" descr="E1_eda_categorical.png"/>
+          <p:cNvPicPr>
+            <a:picLocks noChangeAspect="1"/>
+          </p:cNvPicPr>
+          <p:nvPr/>
+        </p:nvPicPr>
+        <p:blipFill>
+          <a:blip r:embed="rId3"/>
+          <a:stretch>
+            <a:fillRect/>
+          </a:stretch>
+        </p:blipFill>
+        <p:spPr>
+          <a:xfrm>
+            <a:off x="7406640" y="1051560"/>
+            <a:ext cx="4572000" cy="1404586"/>
+          </a:xfrm>
+          <a:prstGeom prst="rect">
+            <a:avLst/>
+          </a:prstGeom>
+        </p:spPr>
+      </p:pic>
     </p:spTree>
   </p:cSld>
   <p:clrMapOvr>
@@ -6573,7 +6993,7 @@
                   <a:srgbClr val="FFFFFF"/>
                 </a:solidFill>
               </a:rPr>
-              <a:t>E(i)(d) — Stratified CIF</a:t>
+              <a:t>E(i)(b) — Aalen-Johansen CIF</a:t>
             </a:r>
           </a:p>
         </p:txBody>
@@ -6607,14 +7027,14 @@
                   <a:srgbClr val="ECF0F1"/>
                 </a:solidFill>
               </a:rPr>
-              <a:t>High-FICO → elevated prepayment, near-zero default;  high-LTV → inverted</a:t>
+              <a:t>Correct competing-risks treatment; 10-yr prepay ≈ 45%,  default ≈ 2%</a:t>
             </a:r>
           </a:p>
         </p:txBody>
       </p:sp>
       <p:pic>
         <p:nvPicPr>
-          <p:cNvPr id="5" name="Picture 4" descr="E1_stratified_cif.png"/>
+          <p:cNvPr id="5" name="Picture 4" descr="E1_competing_risks_cif.png"/>
           <p:cNvPicPr>
             <a:picLocks noChangeAspect="1"/>
           </p:cNvPicPr>
@@ -6628,8 +7048,8 @@
         </p:blipFill>
         <p:spPr>
           <a:xfrm>
-            <a:off x="274320" y="1051560"/>
-            <a:ext cx="5186826" cy="5303520"/>
+            <a:off x="1371600" y="1097280"/>
+            <a:ext cx="9144000" cy="5034337"/>
           </a:xfrm>
           <a:prstGeom prst="rect">
             <a:avLst/>
@@ -6726,7 +7146,7 @@
                   <a:srgbClr val="FFFFFF"/>
                 </a:solidFill>
               </a:rPr>
-              <a:t>E(i)(e) — Cause-Specific Cox Regression  (12 features)</a:t>
+              <a:t>E(i)(c) — KM vs AJ: Bias from Ignoring Competing Events</a:t>
             </a:r>
           </a:p>
         </p:txBody>
@@ -6760,14 +7180,14 @@
                   <a:srgbClr val="ECF0F1"/>
                 </a:solidFill>
               </a:rPr>
-              <a:t>Opposite-sign coefficients reveal misrepresentation in naive combined Cox</a:t>
+              <a:t>KM over-estimates prepayment CIF by treating defaults as independent censorings</a:t>
             </a:r>
           </a:p>
         </p:txBody>
       </p:sp>
       <p:pic>
         <p:nvPicPr>
-          <p:cNvPr id="5" name="Picture 4" descr="E1_cause_specific_cox.png"/>
+          <p:cNvPr id="5" name="Picture 4" descr="E1_km_vs_aj_bias.png"/>
           <p:cNvPicPr>
             <a:picLocks noChangeAspect="1"/>
           </p:cNvPicPr>
@@ -6781,14 +7201,70 @@
         </p:blipFill>
         <p:spPr>
           <a:xfrm>
-            <a:off x="274320" y="1051560"/>
-            <a:ext cx="10715275" cy="5303520"/>
+            <a:off x="457200" y="1097280"/>
+            <a:ext cx="11247120" cy="3402930"/>
           </a:xfrm>
           <a:prstGeom prst="rect">
             <a:avLst/>
           </a:prstGeom>
         </p:spPr>
       </p:pic>
+      <p:sp>
+        <p:nvSpPr>
+          <p:cNvPr id="6" name="TextBox 5"/>
+          <p:cNvSpPr txBox="1"/>
+          <p:nvPr/>
+        </p:nvSpPr>
+        <p:spPr>
+          <a:xfrm>
+            <a:off x="8686800" y="4754880"/>
+            <a:ext cx="3200400" cy="1371600"/>
+          </a:xfrm>
+          <a:prstGeom prst="rect">
+            <a:avLst/>
+          </a:prstGeom>
+          <a:noFill/>
+        </p:spPr>
+        <p:txBody>
+          <a:bodyPr wrap="square">
+            <a:spAutoFit/>
+          </a:bodyPr>
+          <a:lstStyle/>
+          <a:p>
+            <a:pPr>
+              <a:spcAft>
+                <a:spcPts val="400"/>
+              </a:spcAft>
+              <a:defRPr sz="1300"/>
+            </a:pPr>
+            <a:r>
+              <a:t>• 5 yr: +0.45 pp</a:t>
+            </a:r>
+          </a:p>
+          <a:p>
+            <a:pPr>
+              <a:spcAft>
+                <a:spcPts val="400"/>
+              </a:spcAft>
+              <a:defRPr sz="1300"/>
+            </a:pPr>
+            <a:r>
+              <a:t>• 10 yr: +1.31 pp</a:t>
+            </a:r>
+          </a:p>
+          <a:p>
+            <a:pPr>
+              <a:spcAft>
+                <a:spcPts val="400"/>
+              </a:spcAft>
+              <a:defRPr sz="1300"/>
+            </a:pPr>
+            <a:r>
+              <a:t>• 20 yr: +2.23 pp</a:t>
+            </a:r>
+          </a:p>
+        </p:txBody>
+      </p:sp>
     </p:spTree>
   </p:cSld>
   <p:clrMapOvr>

</xml_diff>

<commit_message>
Improve AJ CIF chart: CI bands, still-active curve, inset, burnout annotation
Add 95% confidence bands, a "Still Active" residual curve, year markers
with CIF values at 5/10/20yr, burnout inflection annotation, and a zoomed
default-CIF inset panel. Fixes attribute name to confidence_interval_
_cumulative_density_. Results: 10-yr prepay 83.3%, default 2.23%, still
active 14.5%.

Co-Authored-By: Claude Sonnet 4.6 <noreply@anthropic.com>
</commit_message>
<xml_diff>
--- a/processed/PartE_Presentation.pptx
+++ b/processed/PartE_Presentation.pptx
@@ -6896,7 +6896,7 @@
         <p:spPr>
           <a:xfrm>
             <a:off x="7406640" y="1051560"/>
-            <a:ext cx="4572000" cy="1404586"/>
+            <a:ext cx="4572000" cy="1404223"/>
           </a:xfrm>
           <a:prstGeom prst="rect">
             <a:avLst/>
@@ -7049,7 +7049,7 @@
         <p:spPr>
           <a:xfrm>
             <a:off x="1371600" y="1097280"/>
-            <a:ext cx="9144000" cy="5034337"/>
+            <a:ext cx="9144000" cy="4149378"/>
           </a:xfrm>
           <a:prstGeom prst="rect">
             <a:avLst/>

</xml_diff>

<commit_message>
Restore original EDA graphs; add hazard intensity analysis
Revert E1(a) EDA cells to original histograms, box plots, and vintage
charts. Add two new cells with cause-specific Nelson-Aalen hazard plots:
overall prepayment vs default h(t), and stratified by FICO, LTV,
origination rate, and vintage era.

Co-Authored-By: Claude Sonnet 4.6 <noreply@anthropic.com>
</commit_message>
<xml_diff>
--- a/processed/PartE_Presentation.pptx
+++ b/processed/PartE_Presentation.pptx
@@ -21,7 +21,6 @@
     <p:sldId id="269" r:id="rId20"/>
     <p:sldId id="270" r:id="rId21"/>
     <p:sldId id="271" r:id="rId22"/>
-    <p:sldId id="272" r:id="rId23"/>
   </p:sldIdLst>
   <p:sldSz cx="12188952" cy="6858000" type="screen4x3"/>
   <p:notesSz cx="6858000" cy="9144000"/>
@@ -3416,7 +3415,7 @@
                   <a:srgbClr val="FFFFFF"/>
                 </a:solidFill>
               </a:rPr>
-              <a:t>E(i)(d) — Stratified CIF</a:t>
+              <a:t>E(i)(e) — Cause-Specific Cox Regression  (12 features)</a:t>
             </a:r>
           </a:p>
         </p:txBody>
@@ -3450,14 +3449,14 @@
                   <a:srgbClr val="ECF0F1"/>
                 </a:solidFill>
               </a:rPr>
-              <a:t>High-FICO → elevated prepayment, near-zero default;  high-LTV → inverted</a:t>
+              <a:t>Opposite-sign coefficients reveal misrepresentation in naive combined Cox</a:t>
             </a:r>
           </a:p>
         </p:txBody>
       </p:sp>
       <p:pic>
         <p:nvPicPr>
-          <p:cNvPr id="5" name="Picture 4" descr="E1_stratified_cif.png"/>
+          <p:cNvPr id="5" name="Picture 4" descr="E1_cause_specific_cox.png"/>
           <p:cNvPicPr>
             <a:picLocks noChangeAspect="1"/>
           </p:cNvPicPr>
@@ -3472,7 +3471,7 @@
         <p:spPr>
           <a:xfrm>
             <a:off x="274320" y="1051560"/>
-            <a:ext cx="5186826" cy="5303520"/>
+            <a:ext cx="11612880" cy="3860561"/>
           </a:xfrm>
           <a:prstGeom prst="rect">
             <a:avLst/>
@@ -3569,7 +3568,7 @@
                   <a:srgbClr val="FFFFFF"/>
                 </a:solidFill>
               </a:rPr>
-              <a:t>E(i)(e) — Cause-Specific Cox Regression  (12 features)</a:t>
+              <a:t>E(i)(f) — Fine-Gray Subdistribution Hazard</a:t>
             </a:r>
           </a:p>
         </p:txBody>
@@ -3603,35 +3602,165 @@
                   <a:srgbClr val="ECF0F1"/>
                 </a:solidFill>
               </a:rPr>
-              <a:t>Opposite-sign coefficients reveal misrepresentation in naive combined Cox</a:t>
-            </a:r>
-          </a:p>
-        </p:txBody>
-      </p:sp>
-      <p:pic>
-        <p:nvPicPr>
-          <p:cNvPr id="5" name="Picture 4" descr="E1_cause_specific_cox.png"/>
-          <p:cNvPicPr>
-            <a:picLocks noChangeAspect="1"/>
-          </p:cNvPicPr>
-          <p:nvPr/>
-        </p:nvPicPr>
-        <p:blipFill>
-          <a:blip r:embed="rId2"/>
-          <a:stretch>
-            <a:fillRect/>
-          </a:stretch>
-        </p:blipFill>
-        <p:spPr>
-          <a:xfrm>
-            <a:off x="274320" y="1051560"/>
-            <a:ext cx="11612880" cy="3860561"/>
-          </a:xfrm>
-          <a:prstGeom prst="rect">
-            <a:avLst/>
-          </a:prstGeom>
-        </p:spPr>
-      </p:pic>
+              <a:t>IPCW-weighted Cox approximation; coefficients directly target the CIF</a:t>
+            </a:r>
+          </a:p>
+        </p:txBody>
+      </p:sp>
+      <p:sp>
+        <p:nvSpPr>
+          <p:cNvPr id="5" name="Rectangle 4"/>
+          <p:cNvSpPr/>
+          <p:nvPr/>
+        </p:nvSpPr>
+        <p:spPr>
+          <a:xfrm>
+            <a:off x="0" y="1005840"/>
+            <a:ext cx="12188952" cy="5852160"/>
+          </a:xfrm>
+          <a:prstGeom prst="rect">
+            <a:avLst/>
+          </a:prstGeom>
+          <a:solidFill>
+            <a:srgbClr val="ECF0F1"/>
+          </a:solidFill>
+          <a:ln>
+            <a:noFill/>
+          </a:ln>
+        </p:spPr>
+        <p:style>
+          <a:lnRef idx="1">
+            <a:schemeClr val="accent1"/>
+          </a:lnRef>
+          <a:fillRef idx="3">
+            <a:schemeClr val="accent1"/>
+          </a:fillRef>
+          <a:effectRef idx="2">
+            <a:schemeClr val="accent1"/>
+          </a:effectRef>
+          <a:fontRef idx="minor">
+            <a:schemeClr val="lt1"/>
+          </a:fontRef>
+        </p:style>
+        <p:txBody>
+          <a:bodyPr rtlCol="0" anchor="ctr"/>
+          <a:lstStyle/>
+          <a:p>
+            <a:pPr algn="ctr"/>
+          </a:p>
+        </p:txBody>
+      </p:sp>
+      <p:sp>
+        <p:nvSpPr>
+          <p:cNvPr id="6" name="TextBox 5"/>
+          <p:cNvSpPr txBox="1"/>
+          <p:nvPr/>
+        </p:nvSpPr>
+        <p:spPr>
+          <a:xfrm>
+            <a:off x="457200" y="1188720"/>
+            <a:ext cx="11247120" cy="5029200"/>
+          </a:xfrm>
+          <a:prstGeom prst="rect">
+            <a:avLst/>
+          </a:prstGeom>
+          <a:noFill/>
+        </p:spPr>
+        <p:txBody>
+          <a:bodyPr wrap="square">
+            <a:spAutoFit/>
+          </a:bodyPr>
+          <a:lstStyle/>
+          <a:p>
+            <a:pPr>
+              <a:spcAft>
+                <a:spcPts val="400"/>
+              </a:spcAft>
+              <a:defRPr sz="1400"/>
+            </a:pPr>
+            <a:r>
+              <a:t>• Subjects who experienced a competing event (default) are KEPT in the risk set with IPCW weights</a:t>
+            </a:r>
+          </a:p>
+          <a:p>
+            <a:pPr>
+              <a:spcAft>
+                <a:spcPts val="400"/>
+              </a:spcAft>
+              <a:defRPr sz="1400"/>
+            </a:pPr>
+            <a:r>
+              <a:t>• The subdistribution hazard integrates to the CIF — covariate effects are CIF effects</a:t>
+            </a:r>
+          </a:p>
+          <a:p>
+            <a:pPr>
+              <a:spcAft>
+                <a:spcPts val="400"/>
+              </a:spcAft>
+              <a:defRPr sz="1400"/>
+            </a:pPr>
+            <a:r>
+              <a:t>• rate_incentive HR is LARGER under Fine-Gray than cause-specific Cox:</a:t>
+            </a:r>
+          </a:p>
+          <a:p>
+            <a:pPr>
+              <a:spcAft>
+                <a:spcPts val="400"/>
+              </a:spcAft>
+              <a:defRPr sz="1400"/>
+            </a:pPr>
+            <a:r>
+              <a:t>•    high-incentive loans are also less likely to default first → amplifies CIF effect</a:t>
+            </a:r>
+          </a:p>
+          <a:p>
+            <a:pPr>
+              <a:spcAft>
+                <a:spcPts val="400"/>
+              </a:spcAft>
+              <a:defRPr sz="1400"/>
+            </a:pPr>
+            <a:r>
+              <a:t>• Low-FICO Fine-Gray HR for prepayment is ATTENUATED: elevated default risk reduces</a:t>
+            </a:r>
+          </a:p>
+          <a:p>
+            <a:pPr>
+              <a:spcAft>
+                <a:spcPts val="400"/>
+              </a:spcAft>
+              <a:defRPr sz="1400"/>
+            </a:pPr>
+            <a:r>
+              <a:t>•    measured prepayment propensity once competing risks are accounted for</a:t>
+            </a:r>
+          </a:p>
+          <a:p>
+            <a:pPr>
+              <a:spcAft>
+                <a:spcPts val="400"/>
+              </a:spcAft>
+              <a:defRPr sz="1400"/>
+            </a:pPr>
+            <a:r>
+              <a:t>• Use Fine-Gray for CIF prediction / loss forecasting</a:t>
+            </a:r>
+          </a:p>
+          <a:p>
+            <a:pPr>
+              <a:spcAft>
+                <a:spcPts val="400"/>
+              </a:spcAft>
+              <a:defRPr sz="1400"/>
+            </a:pPr>
+            <a:r>
+              <a:t>• Use cause-specific Cox for economic mechanism estimation</a:t>
+            </a:r>
+          </a:p>
+        </p:txBody>
+      </p:sp>
     </p:spTree>
   </p:cSld>
   <p:clrMapOvr>
@@ -3722,7 +3851,7 @@
                   <a:srgbClr val="FFFFFF"/>
                 </a:solidFill>
               </a:rPr>
-              <a:t>E(i)(f) — Fine-Gray Subdistribution Hazard</a:t>
+              <a:t>E(ii) — Time-Dependent Covariates</a:t>
             </a:r>
           </a:p>
         </p:txBody>
@@ -3756,7 +3885,7 @@
                   <a:srgbClr val="ECF0F1"/>
                 </a:solidFill>
               </a:rPr>
-              <a:t>IPCW-weighted Cox approximation; coefficients directly target the CIF</a:t>
+              <a:t>Andersen-Gill counting-process Cox — monthly rate_incentive, unemployment, HPI</a:t>
             </a:r>
           </a:p>
         </p:txBody>
@@ -3830,10 +3959,10 @@
               <a:spcAft>
                 <a:spcPts val="400"/>
               </a:spcAft>
-              <a:defRPr sz="1400"/>
+              <a:defRPr sz="1300"/>
             </a:pPr>
             <a:r>
-              <a:t>• Subjects who experienced a competing event (default) are KEPT in the risk set with IPCW weights</a:t>
+              <a:t>• Panel dataset: 93M rows × 2M loans — mortgage_rate, unemployment, HPI YoY, rate_incentive updated monthly</a:t>
             </a:r>
           </a:p>
           <a:p>
@@ -3841,10 +3970,10 @@
               <a:spcAft>
                 <a:spcPts val="400"/>
               </a:spcAft>
-              <a:defRPr sz="1400"/>
+              <a:defRPr sz="1300"/>
             </a:pPr>
             <a:r>
-              <a:t>• The subdistribution hazard integrates to the CIF — covariate effects are CIF effects</a:t>
+              <a:t>• 10,000 loans stratified by vintage → ~500K counting-process rows (tstart, tstop, event)</a:t>
             </a:r>
           </a:p>
           <a:p>
@@ -3852,10 +3981,10 @@
               <a:spcAft>
                 <a:spcPts val="400"/>
               </a:spcAft>
-              <a:defRPr sz="1400"/>
+              <a:defRPr sz="1300"/>
             </a:pPr>
             <a:r>
-              <a:t>• rate_incentive HR is LARGER under Fine-Gray than cause-specific Cox:</a:t>
+              <a:t>• 11 features: 7 static (FICO, LTV, DTI, UPB + 3 one-hot) + 4 time-varying</a:t>
             </a:r>
           </a:p>
           <a:p>
@@ -3863,10 +3992,10 @@
               <a:spcAft>
                 <a:spcPts val="400"/>
               </a:spcAft>
-              <a:defRPr sz="1400"/>
+              <a:defRPr sz="1300"/>
             </a:pPr>
             <a:r>
-              <a:t>•    high-incentive loans are also less likely to default first → amplifies CIF effect</a:t>
+              <a:t>• Key finding: current rate_incentive coefficient LARGER than origination-vintage snapshot</a:t>
             </a:r>
           </a:p>
           <a:p>
@@ -3874,10 +4003,10 @@
               <a:spcAft>
                 <a:spcPts val="400"/>
               </a:spcAft>
-              <a:defRPr sz="1400"/>
+              <a:defRPr sz="1300"/>
             </a:pPr>
             <a:r>
-              <a:t>• Low-FICO Fine-Gray HR for prepayment is ATTENUATED: elevated default risk reduces</a:t>
+              <a:t>•    Static Cox: rate_incentive locked at origination — high-rate era loans always look attractive</a:t>
             </a:r>
           </a:p>
           <a:p>
@@ -3885,10 +4014,10 @@
               <a:spcAft>
                 <a:spcPts val="400"/>
               </a:spcAft>
-              <a:defRPr sz="1400"/>
+              <a:defRPr sz="1300"/>
             </a:pPr>
             <a:r>
-              <a:t>•    measured prepayment propensity once competing risks are accounted for</a:t>
+              <a:t>•    TV Cox: tracks actual monthly refi option value — more responsive to rate cycles</a:t>
             </a:r>
           </a:p>
           <a:p>
@@ -3896,10 +4025,10 @@
               <a:spcAft>
                 <a:spcPts val="400"/>
               </a:spcAft>
-              <a:defRPr sz="1400"/>
+              <a:defRPr sz="1300"/>
             </a:pPr>
             <a:r>
-              <a:t>• Use Fine-Gray for CIF prediction / loss forecasting</a:t>
+              <a:t>• Unemployment: contemporaneous job loss predicts default better than vintage average</a:t>
             </a:r>
           </a:p>
           <a:p>
@@ -3907,10 +4036,10 @@
               <a:spcAft>
                 <a:spcPts val="400"/>
               </a:spcAft>
-              <a:defRPr sz="1400"/>
+              <a:defRPr sz="1300"/>
             </a:pPr>
             <a:r>
-              <a:t>• Use cause-specific Cox for economic mechanism estimation</a:t>
+              <a:t>• Limitation: origination LTV used (not ELTV) — adding current LTV would improve default hazard</a:t>
             </a:r>
           </a:p>
         </p:txBody>
@@ -4005,199 +4134,59 @@
                   <a:srgbClr val="FFFFFF"/>
                 </a:solidFill>
               </a:rPr>
-              <a:t>E(ii) — Time-Dependent Covariates</a:t>
-            </a:r>
-          </a:p>
-        </p:txBody>
-      </p:sp>
-      <p:sp>
-        <p:nvSpPr>
-          <p:cNvPr id="4" name="TextBox 3"/>
-          <p:cNvSpPr txBox="1"/>
-          <p:nvPr/>
-        </p:nvSpPr>
-        <p:spPr>
-          <a:xfrm>
-            <a:off x="274320" y="566928"/>
-            <a:ext cx="10058400" cy="365760"/>
-          </a:xfrm>
-          <a:prstGeom prst="rect">
-            <a:avLst/>
-          </a:prstGeom>
-          <a:noFill/>
-        </p:spPr>
-        <p:txBody>
-          <a:bodyPr wrap="square">
-            <a:spAutoFit/>
-          </a:bodyPr>
-          <a:lstStyle/>
-          <a:p>
-            <a:pPr algn="l"/>
-            <a:r>
-              <a:rPr sz="1400" b="0">
-                <a:solidFill>
-                  <a:srgbClr val="ECF0F1"/>
-                </a:solidFill>
-              </a:rPr>
-              <a:t>Andersen-Gill counting-process Cox — monthly rate_incentive, unemployment, HPI</a:t>
-            </a:r>
-          </a:p>
-        </p:txBody>
-      </p:sp>
-      <p:sp>
-        <p:nvSpPr>
-          <p:cNvPr id="5" name="Rectangle 4"/>
-          <p:cNvSpPr/>
-          <p:nvPr/>
-        </p:nvSpPr>
-        <p:spPr>
-          <a:xfrm>
-            <a:off x="0" y="1005840"/>
-            <a:ext cx="12188952" cy="5852160"/>
-          </a:xfrm>
-          <a:prstGeom prst="rect">
-            <a:avLst/>
-          </a:prstGeom>
-          <a:solidFill>
-            <a:srgbClr val="ECF0F1"/>
-          </a:solidFill>
-          <a:ln>
-            <a:noFill/>
-          </a:ln>
-        </p:spPr>
-        <p:style>
-          <a:lnRef idx="1">
-            <a:schemeClr val="accent1"/>
-          </a:lnRef>
-          <a:fillRef idx="3">
-            <a:schemeClr val="accent1"/>
-          </a:fillRef>
-          <a:effectRef idx="2">
-            <a:schemeClr val="accent1"/>
-          </a:effectRef>
-          <a:fontRef idx="minor">
-            <a:schemeClr val="lt1"/>
-          </a:fontRef>
-        </p:style>
-        <p:txBody>
-          <a:bodyPr rtlCol="0" anchor="ctr"/>
-          <a:lstStyle/>
-          <a:p>
-            <a:pPr algn="ctr"/>
-          </a:p>
-        </p:txBody>
-      </p:sp>
-      <p:sp>
-        <p:nvSpPr>
-          <p:cNvPr id="6" name="TextBox 5"/>
-          <p:cNvSpPr txBox="1"/>
-          <p:nvPr/>
-        </p:nvSpPr>
-        <p:spPr>
-          <a:xfrm>
-            <a:off x="457200" y="1188720"/>
-            <a:ext cx="11247120" cy="5029200"/>
-          </a:xfrm>
-          <a:prstGeom prst="rect">
-            <a:avLst/>
-          </a:prstGeom>
-          <a:noFill/>
-        </p:spPr>
-        <p:txBody>
-          <a:bodyPr wrap="square">
-            <a:spAutoFit/>
-          </a:bodyPr>
-          <a:lstStyle/>
-          <a:p>
-            <a:pPr>
-              <a:spcAft>
-                <a:spcPts val="400"/>
-              </a:spcAft>
-              <a:defRPr sz="1300"/>
-            </a:pPr>
-            <a:r>
-              <a:t>• Panel dataset: 93M rows × 2M loans — mortgage_rate, unemployment, HPI YoY, rate_incentive updated monthly</a:t>
-            </a:r>
-          </a:p>
-          <a:p>
-            <a:pPr>
-              <a:spcAft>
-                <a:spcPts val="400"/>
-              </a:spcAft>
-              <a:defRPr sz="1300"/>
-            </a:pPr>
-            <a:r>
-              <a:t>• 10,000 loans stratified by vintage → ~500K counting-process rows (tstart, tstop, event)</a:t>
-            </a:r>
-          </a:p>
-          <a:p>
-            <a:pPr>
-              <a:spcAft>
-                <a:spcPts val="400"/>
-              </a:spcAft>
-              <a:defRPr sz="1300"/>
-            </a:pPr>
-            <a:r>
-              <a:t>• 11 features: 7 static (FICO, LTV, DTI, UPB + 3 one-hot) + 4 time-varying</a:t>
-            </a:r>
-          </a:p>
-          <a:p>
-            <a:pPr>
-              <a:spcAft>
-                <a:spcPts val="400"/>
-              </a:spcAft>
-              <a:defRPr sz="1300"/>
-            </a:pPr>
-            <a:r>
-              <a:t>• Key finding: current rate_incentive coefficient LARGER than origination-vintage snapshot</a:t>
-            </a:r>
-          </a:p>
-          <a:p>
-            <a:pPr>
-              <a:spcAft>
-                <a:spcPts val="400"/>
-              </a:spcAft>
-              <a:defRPr sz="1300"/>
-            </a:pPr>
-            <a:r>
-              <a:t>•    Static Cox: rate_incentive locked at origination — high-rate era loans always look attractive</a:t>
-            </a:r>
-          </a:p>
-          <a:p>
-            <a:pPr>
-              <a:spcAft>
-                <a:spcPts val="400"/>
-              </a:spcAft>
-              <a:defRPr sz="1300"/>
-            </a:pPr>
-            <a:r>
-              <a:t>•    TV Cox: tracks actual monthly refi option value — more responsive to rate cycles</a:t>
-            </a:r>
-          </a:p>
-          <a:p>
-            <a:pPr>
-              <a:spcAft>
-                <a:spcPts val="400"/>
-              </a:spcAft>
-              <a:defRPr sz="1300"/>
-            </a:pPr>
-            <a:r>
-              <a:t>• Unemployment: contemporaneous job loss predicts default better than vintage average</a:t>
-            </a:r>
-          </a:p>
-          <a:p>
-            <a:pPr>
-              <a:spcAft>
-                <a:spcPts val="400"/>
-              </a:spcAft>
-              <a:defRPr sz="1300"/>
-            </a:pPr>
-            <a:r>
-              <a:t>• Limitation: origination LTV used (not ELTV) — adding current LTV would improve default hazard</a:t>
-            </a:r>
-          </a:p>
-        </p:txBody>
-      </p:sp>
+              <a:t>E(ii) — TV Cox Results</a:t>
+            </a:r>
+          </a:p>
+        </p:txBody>
+      </p:sp>
+      <p:pic>
+        <p:nvPicPr>
+          <p:cNvPr id="4" name="Picture 3" descr="Eii_tv_cox_forest.png"/>
+          <p:cNvPicPr>
+            <a:picLocks noChangeAspect="1"/>
+          </p:cNvPicPr>
+          <p:nvPr/>
+        </p:nvPicPr>
+        <p:blipFill>
+          <a:blip r:embed="rId2"/>
+          <a:stretch>
+            <a:fillRect/>
+          </a:stretch>
+        </p:blipFill>
+        <p:spPr>
+          <a:xfrm>
+            <a:off x="137160" y="1051560"/>
+            <a:ext cx="7132320" cy="3013704"/>
+          </a:xfrm>
+          <a:prstGeom prst="rect">
+            <a:avLst/>
+          </a:prstGeom>
+        </p:spPr>
+      </p:pic>
+      <p:pic>
+        <p:nvPicPr>
+          <p:cNvPr id="5" name="Picture 4" descr="Eii_static_vs_tv.png"/>
+          <p:cNvPicPr>
+            <a:picLocks noChangeAspect="1"/>
+          </p:cNvPicPr>
+          <p:nvPr/>
+        </p:nvPicPr>
+        <p:blipFill>
+          <a:blip r:embed="rId3"/>
+          <a:stretch>
+            <a:fillRect/>
+          </a:stretch>
+        </p:blipFill>
+        <p:spPr>
+          <a:xfrm>
+            <a:off x="7406640" y="1051560"/>
+            <a:ext cx="4572000" cy="2247385"/>
+          </a:xfrm>
+          <a:prstGeom prst="rect">
+            <a:avLst/>
+          </a:prstGeom>
+        </p:spPr>
+      </p:pic>
     </p:spTree>
   </p:cSld>
   <p:clrMapOvr>
@@ -4288,14 +4277,48 @@
                   <a:srgbClr val="FFFFFF"/>
                 </a:solidFill>
               </a:rPr>
-              <a:t>E(ii) — TV Cox Results</a:t>
+              <a:t>E(iv) — Scenario Analysis: Interest Rate Shocks</a:t>
+            </a:r>
+          </a:p>
+        </p:txBody>
+      </p:sp>
+      <p:sp>
+        <p:nvSpPr>
+          <p:cNvPr id="4" name="TextBox 3"/>
+          <p:cNvSpPr txBox="1"/>
+          <p:nvPr/>
+        </p:nvSpPr>
+        <p:spPr>
+          <a:xfrm>
+            <a:off x="274320" y="566928"/>
+            <a:ext cx="10058400" cy="365760"/>
+          </a:xfrm>
+          <a:prstGeom prst="rect">
+            <a:avLst/>
+          </a:prstGeom>
+          <a:noFill/>
+        </p:spPr>
+        <p:txBody>
+          <a:bodyPr wrap="square">
+            <a:spAutoFit/>
+          </a:bodyPr>
+          <a:lstStyle/>
+          <a:p>
+            <a:pPr algn="l"/>
+            <a:r>
+              <a:rPr sz="1400" b="0">
+                <a:solidFill>
+                  <a:srgbClr val="ECF0F1"/>
+                </a:solidFill>
+              </a:rPr>
+              <a:t>±100 bp and ±200 bp shocks to mortgage_rate  (rate_incentive updated consistently)</a:t>
             </a:r>
           </a:p>
         </p:txBody>
       </p:sp>
       <p:pic>
         <p:nvPicPr>
-          <p:cNvPr id="4" name="Picture 3" descr="Eii_tv_cox_forest.png"/>
+          <p:cNvPr id="5" name="Picture 4" descr="E2_scenario_analysis.png"/>
           <p:cNvPicPr>
             <a:picLocks noChangeAspect="1"/>
           </p:cNvPicPr>
@@ -4309,32 +4332,8 @@
         </p:blipFill>
         <p:spPr>
           <a:xfrm>
-            <a:off x="137160" y="1051560"/>
-            <a:ext cx="7132320" cy="3013704"/>
-          </a:xfrm>
-          <a:prstGeom prst="rect">
-            <a:avLst/>
-          </a:prstGeom>
-        </p:spPr>
-      </p:pic>
-      <p:pic>
-        <p:nvPicPr>
-          <p:cNvPr id="5" name="Picture 4" descr="Eii_static_vs_tv.png"/>
-          <p:cNvPicPr>
-            <a:picLocks noChangeAspect="1"/>
-          </p:cNvPicPr>
-          <p:nvPr/>
-        </p:nvPicPr>
-        <p:blipFill>
-          <a:blip r:embed="rId3"/>
-          <a:stretch>
-            <a:fillRect/>
-          </a:stretch>
-        </p:blipFill>
-        <p:spPr>
-          <a:xfrm>
-            <a:off x="7406640" y="1051560"/>
-            <a:ext cx="4572000" cy="2247385"/>
+            <a:off x="457200" y="1051560"/>
+            <a:ext cx="11247120" cy="3906695"/>
           </a:xfrm>
           <a:prstGeom prst="rect">
             <a:avLst/>
@@ -4431,21 +4430,64 @@
                   <a:srgbClr val="FFFFFF"/>
                 </a:solidFill>
               </a:rPr>
-              <a:t>E(iv) — Scenario Analysis: Interest Rate Shocks</a:t>
-            </a:r>
-          </a:p>
-        </p:txBody>
-      </p:sp>
-      <p:sp>
-        <p:nvSpPr>
-          <p:cNvPr id="4" name="TextBox 3"/>
+              <a:t>E(iv) — Scenario Analysis: Interpretation</a:t>
+            </a:r>
+          </a:p>
+        </p:txBody>
+      </p:sp>
+      <p:sp>
+        <p:nvSpPr>
+          <p:cNvPr id="4" name="Rectangle 3"/>
+          <p:cNvSpPr/>
+          <p:nvPr/>
+        </p:nvSpPr>
+        <p:spPr>
+          <a:xfrm>
+            <a:off x="0" y="1005840"/>
+            <a:ext cx="12188952" cy="5852160"/>
+          </a:xfrm>
+          <a:prstGeom prst="rect">
+            <a:avLst/>
+          </a:prstGeom>
+          <a:solidFill>
+            <a:srgbClr val="ECF0F1"/>
+          </a:solidFill>
+          <a:ln>
+            <a:noFill/>
+          </a:ln>
+        </p:spPr>
+        <p:style>
+          <a:lnRef idx="1">
+            <a:schemeClr val="accent1"/>
+          </a:lnRef>
+          <a:fillRef idx="3">
+            <a:schemeClr val="accent1"/>
+          </a:fillRef>
+          <a:effectRef idx="2">
+            <a:schemeClr val="accent1"/>
+          </a:effectRef>
+          <a:fontRef idx="minor">
+            <a:schemeClr val="lt1"/>
+          </a:fontRef>
+        </p:style>
+        <p:txBody>
+          <a:bodyPr rtlCol="0" anchor="ctr"/>
+          <a:lstStyle/>
+          <a:p>
+            <a:pPr algn="ctr"/>
+          </a:p>
+        </p:txBody>
+      </p:sp>
+      <p:sp>
+        <p:nvSpPr>
+          <p:cNvPr id="5" name="TextBox 4"/>
           <p:cNvSpPr txBox="1"/>
           <p:nvPr/>
         </p:nvSpPr>
         <p:spPr>
           <a:xfrm>
-            <a:off x="274320" y="566928"/>
-            <a:ext cx="10058400" cy="365760"/>
+            <a:off x="457200" y="1188720"/>
+            <a:ext cx="11247120" cy="5029200"/>
           </a:xfrm>
           <a:prstGeom prst="rect">
             <a:avLst/>
@@ -4458,42 +4500,84 @@
           </a:bodyPr>
           <a:lstStyle/>
           <a:p>
-            <a:pPr algn="l"/>
-            <a:r>
-              <a:rPr sz="1400" b="0">
-                <a:solidFill>
-                  <a:srgbClr val="ECF0F1"/>
-                </a:solidFill>
-              </a:rPr>
-              <a:t>±100 bp and ±200 bp shocks to mortgage_rate  (rate_incentive updated consistently)</a:t>
-            </a:r>
-          </a:p>
-        </p:txBody>
-      </p:sp>
-      <p:pic>
-        <p:nvPicPr>
-          <p:cNvPr id="5" name="Picture 4" descr="E2_scenario_analysis.png"/>
-          <p:cNvPicPr>
-            <a:picLocks noChangeAspect="1"/>
-          </p:cNvPicPr>
-          <p:nvPr/>
-        </p:nvPicPr>
-        <p:blipFill>
-          <a:blip r:embed="rId2"/>
-          <a:stretch>
-            <a:fillRect/>
-          </a:stretch>
-        </p:blipFill>
-        <p:spPr>
-          <a:xfrm>
-            <a:off x="457200" y="1051560"/>
-            <a:ext cx="11247120" cy="3906695"/>
-          </a:xfrm>
-          <a:prstGeom prst="rect">
-            <a:avLst/>
-          </a:prstGeom>
-        </p:spPr>
-      </p:pic>
+            <a:pPr>
+              <a:spcAft>
+                <a:spcPts val="400"/>
+              </a:spcAft>
+              <a:defRPr sz="1500"/>
+            </a:pPr>
+            <a:r>
+              <a:t>• XGBoost: clear monotone CONVEX response — rate cuts raise prepayment probability more than rate rises suppress it</a:t>
+            </a:r>
+          </a:p>
+          <a:p>
+            <a:pPr>
+              <a:spcAft>
+                <a:spcPts val="400"/>
+              </a:spcAft>
+              <a:defRPr sz="1500"/>
+            </a:pPr>
+            <a:r>
+              <a:t>• Deep Cox: monotone but smoother — log-hazard is a less non-linear function of rate_incentive</a:t>
+            </a:r>
+          </a:p>
+          <a:p>
+            <a:pPr>
+              <a:spcAft>
+                <a:spcPts val="400"/>
+              </a:spcAft>
+              <a:defRPr sz="1500"/>
+            </a:pPr>
+            <a:r>
+              <a:t>• Asymmetry (−200 bp effect &gt; +200 bp effect) reflects the BURNOUT effect:</a:t>
+            </a:r>
+          </a:p>
+          <a:p>
+            <a:pPr>
+              <a:spcAft>
+                <a:spcPts val="400"/>
+              </a:spcAft>
+              <a:defRPr sz="1500"/>
+            </a:pPr>
+            <a:r>
+              <a:t>•    most rate-sensitive borrowers have already prepaid → muted upside response to cuts</a:t>
+            </a:r>
+          </a:p>
+          <a:p>
+            <a:pPr>
+              <a:spcAft>
+                <a:spcPts val="400"/>
+              </a:spcAft>
+              <a:defRPr sz="1500"/>
+            </a:pPr>
+            <a:r>
+              <a:t>• Both models agree on direction → robustness of rate-incentive channel across architectures</a:t>
+            </a:r>
+          </a:p>
+          <a:p>
+            <a:pPr>
+              <a:spcAft>
+                <a:spcPts val="400"/>
+              </a:spcAft>
+              <a:defRPr sz="1500"/>
+            </a:pPr>
+            <a:r>
+              <a:t>• Implication for MBS pricing: prepayment option has POSITIVE CONVEXITY —</a:t>
+            </a:r>
+          </a:p>
+          <a:p>
+            <a:pPr>
+              <a:spcAft>
+                <a:spcPts val="400"/>
+              </a:spcAft>
+              <a:defRPr sz="1500"/>
+            </a:pPr>
+            <a:r>
+              <a:t>•    rate decline creates more prepayment than rate rise suppresses it</a:t>
+            </a:r>
+          </a:p>
+        </p:txBody>
+      </p:sp>
     </p:spTree>
   </p:cSld>
   <p:clrMapOvr>
@@ -4584,244 +4668,6 @@
                   <a:srgbClr val="FFFFFF"/>
                 </a:solidFill>
               </a:rPr>
-              <a:t>E(iv) — Scenario Analysis: Interpretation</a:t>
-            </a:r>
-          </a:p>
-        </p:txBody>
-      </p:sp>
-      <p:sp>
-        <p:nvSpPr>
-          <p:cNvPr id="4" name="Rectangle 3"/>
-          <p:cNvSpPr/>
-          <p:nvPr/>
-        </p:nvSpPr>
-        <p:spPr>
-          <a:xfrm>
-            <a:off x="0" y="1005840"/>
-            <a:ext cx="12188952" cy="5852160"/>
-          </a:xfrm>
-          <a:prstGeom prst="rect">
-            <a:avLst/>
-          </a:prstGeom>
-          <a:solidFill>
-            <a:srgbClr val="ECF0F1"/>
-          </a:solidFill>
-          <a:ln>
-            <a:noFill/>
-          </a:ln>
-        </p:spPr>
-        <p:style>
-          <a:lnRef idx="1">
-            <a:schemeClr val="accent1"/>
-          </a:lnRef>
-          <a:fillRef idx="3">
-            <a:schemeClr val="accent1"/>
-          </a:fillRef>
-          <a:effectRef idx="2">
-            <a:schemeClr val="accent1"/>
-          </a:effectRef>
-          <a:fontRef idx="minor">
-            <a:schemeClr val="lt1"/>
-          </a:fontRef>
-        </p:style>
-        <p:txBody>
-          <a:bodyPr rtlCol="0" anchor="ctr"/>
-          <a:lstStyle/>
-          <a:p>
-            <a:pPr algn="ctr"/>
-          </a:p>
-        </p:txBody>
-      </p:sp>
-      <p:sp>
-        <p:nvSpPr>
-          <p:cNvPr id="5" name="TextBox 4"/>
-          <p:cNvSpPr txBox="1"/>
-          <p:nvPr/>
-        </p:nvSpPr>
-        <p:spPr>
-          <a:xfrm>
-            <a:off x="457200" y="1188720"/>
-            <a:ext cx="11247120" cy="5029200"/>
-          </a:xfrm>
-          <a:prstGeom prst="rect">
-            <a:avLst/>
-          </a:prstGeom>
-          <a:noFill/>
-        </p:spPr>
-        <p:txBody>
-          <a:bodyPr wrap="square">
-            <a:spAutoFit/>
-          </a:bodyPr>
-          <a:lstStyle/>
-          <a:p>
-            <a:pPr>
-              <a:spcAft>
-                <a:spcPts val="400"/>
-              </a:spcAft>
-              <a:defRPr sz="1500"/>
-            </a:pPr>
-            <a:r>
-              <a:t>• XGBoost: clear monotone CONVEX response — rate cuts raise prepayment probability more than rate rises suppress it</a:t>
-            </a:r>
-          </a:p>
-          <a:p>
-            <a:pPr>
-              <a:spcAft>
-                <a:spcPts val="400"/>
-              </a:spcAft>
-              <a:defRPr sz="1500"/>
-            </a:pPr>
-            <a:r>
-              <a:t>• Deep Cox: monotone but smoother — log-hazard is a less non-linear function of rate_incentive</a:t>
-            </a:r>
-          </a:p>
-          <a:p>
-            <a:pPr>
-              <a:spcAft>
-                <a:spcPts val="400"/>
-              </a:spcAft>
-              <a:defRPr sz="1500"/>
-            </a:pPr>
-            <a:r>
-              <a:t>• Asymmetry (−200 bp effect &gt; +200 bp effect) reflects the BURNOUT effect:</a:t>
-            </a:r>
-          </a:p>
-          <a:p>
-            <a:pPr>
-              <a:spcAft>
-                <a:spcPts val="400"/>
-              </a:spcAft>
-              <a:defRPr sz="1500"/>
-            </a:pPr>
-            <a:r>
-              <a:t>•    most rate-sensitive borrowers have already prepaid → muted upside response to cuts</a:t>
-            </a:r>
-          </a:p>
-          <a:p>
-            <a:pPr>
-              <a:spcAft>
-                <a:spcPts val="400"/>
-              </a:spcAft>
-              <a:defRPr sz="1500"/>
-            </a:pPr>
-            <a:r>
-              <a:t>• Both models agree on direction → robustness of rate-incentive channel across architectures</a:t>
-            </a:r>
-          </a:p>
-          <a:p>
-            <a:pPr>
-              <a:spcAft>
-                <a:spcPts val="400"/>
-              </a:spcAft>
-              <a:defRPr sz="1500"/>
-            </a:pPr>
-            <a:r>
-              <a:t>• Implication for MBS pricing: prepayment option has POSITIVE CONVEXITY —</a:t>
-            </a:r>
-          </a:p>
-          <a:p>
-            <a:pPr>
-              <a:spcAft>
-                <a:spcPts val="400"/>
-              </a:spcAft>
-              <a:defRPr sz="1500"/>
-            </a:pPr>
-            <a:r>
-              <a:t>•    rate decline creates more prepayment than rate rise suppresses it</a:t>
-            </a:r>
-          </a:p>
-        </p:txBody>
-      </p:sp>
-    </p:spTree>
-  </p:cSld>
-  <p:clrMapOvr>
-    <a:masterClrMapping/>
-  </p:clrMapOvr>
-</p:sld>
-</file>
-
-<file path=ppt/slides/slide17.xml><?xml version="1.0" encoding="utf-8"?>
-<p:sld xmlns:a="http://schemas.openxmlformats.org/drawingml/2006/main" xmlns:p="http://schemas.openxmlformats.org/presentationml/2006/main" xmlns:r="http://schemas.openxmlformats.org/officeDocument/2006/relationships">
-  <p:cSld>
-    <p:spTree>
-      <p:nvGrpSpPr>
-        <p:cNvPr id="1" name=""/>
-        <p:cNvGrpSpPr/>
-        <p:nvPr/>
-      </p:nvGrpSpPr>
-      <p:grpSpPr/>
-      <p:sp>
-        <p:nvSpPr>
-          <p:cNvPr id="2" name="Rectangle 1"/>
-          <p:cNvSpPr/>
-          <p:nvPr/>
-        </p:nvSpPr>
-        <p:spPr>
-          <a:xfrm>
-            <a:off x="0" y="0"/>
-            <a:ext cx="12188952" cy="1005840"/>
-          </a:xfrm>
-          <a:prstGeom prst="rect">
-            <a:avLst/>
-          </a:prstGeom>
-          <a:solidFill>
-            <a:srgbClr val="2C3E50"/>
-          </a:solidFill>
-          <a:ln>
-            <a:noFill/>
-          </a:ln>
-        </p:spPr>
-        <p:style>
-          <a:lnRef idx="1">
-            <a:schemeClr val="accent1"/>
-          </a:lnRef>
-          <a:fillRef idx="3">
-            <a:schemeClr val="accent1"/>
-          </a:fillRef>
-          <a:effectRef idx="2">
-            <a:schemeClr val="accent1"/>
-          </a:effectRef>
-          <a:fontRef idx="minor">
-            <a:schemeClr val="lt1"/>
-          </a:fontRef>
-        </p:style>
-        <p:txBody>
-          <a:bodyPr rtlCol="0" anchor="ctr"/>
-          <a:lstStyle/>
-          <a:p>
-            <a:pPr algn="ctr"/>
-          </a:p>
-        </p:txBody>
-      </p:sp>
-      <p:sp>
-        <p:nvSpPr>
-          <p:cNvPr id="3" name="TextBox 2"/>
-          <p:cNvSpPr txBox="1"/>
-          <p:nvPr/>
-        </p:nvSpPr>
-        <p:spPr>
-          <a:xfrm>
-            <a:off x="274320" y="73152"/>
-            <a:ext cx="10058400" cy="502920"/>
-          </a:xfrm>
-          <a:prstGeom prst="rect">
-            <a:avLst/>
-          </a:prstGeom>
-          <a:noFill/>
-        </p:spPr>
-        <p:txBody>
-          <a:bodyPr wrap="square">
-            <a:spAutoFit/>
-          </a:bodyPr>
-          <a:lstStyle/>
-          <a:p>
-            <a:pPr algn="l"/>
-            <a:r>
-              <a:rPr sz="2600" b="1">
-                <a:solidFill>
-                  <a:srgbClr val="FFFFFF"/>
-                </a:solidFill>
-              </a:rPr>
               <a:t>Summary</a:t>
             </a:r>
           </a:p>
@@ -6214,7 +6060,7 @@
                   <a:srgbClr val="FFFFFF"/>
                 </a:solidFill>
               </a:rPr>
-              <a:t>E(i)(a) — EDA: Defaulted Borrowers Are Riskier on Every Dimension</a:t>
+              <a:t>E(i)(a) — EDA: Duration Distributions &amp; Covariate Profiles</a:t>
             </a:r>
           </a:p>
         </p:txBody>
@@ -6248,14 +6094,14 @@
                   <a:srgbClr val="ECF0F1"/>
                 </a:solidFill>
               </a:rPr>
-              <a:t>FICO 44 pts lower · LTV 8.6 pp higher · DTI 4.6 pp higher · Rate 0.85 pp higher</a:t>
+              <a:t>Prepaid: median ~40 mo  |  Defaulted: median ~55 mo  |  full 34M-loan dataset</a:t>
             </a:r>
           </a:p>
         </p:txBody>
       </p:sp>
       <p:pic>
         <p:nvPicPr>
-          <p:cNvPr id="5" name="Picture 4" descr="E1_eda_profile.png"/>
+          <p:cNvPr id="5" name="Picture 4" descr="E1_eda_duration.png"/>
           <p:cNvPicPr>
             <a:picLocks noChangeAspect="1"/>
           </p:cNvPicPr>
@@ -6269,8 +6115,8 @@
         </p:blipFill>
         <p:spPr>
           <a:xfrm>
-            <a:off x="457200" y="1097280"/>
-            <a:ext cx="11247120" cy="4968424"/>
+            <a:off x="137160" y="1051560"/>
+            <a:ext cx="11887200" cy="5099710"/>
           </a:xfrm>
           <a:prstGeom prst="rect">
             <a:avLst/>
@@ -6367,48 +6213,14 @@
                   <a:srgbClr val="FFFFFF"/>
                 </a:solidFill>
               </a:rPr>
-              <a:t>E(i)(a) — EDA: Different Timescales, Different Mechanisms</a:t>
-            </a:r>
-          </a:p>
-        </p:txBody>
-      </p:sp>
-      <p:sp>
-        <p:nvSpPr>
-          <p:cNvPr id="4" name="TextBox 3"/>
-          <p:cNvSpPr txBox="1"/>
-          <p:nvPr/>
-        </p:nvSpPr>
-        <p:spPr>
-          <a:xfrm>
-            <a:off x="274320" y="566928"/>
-            <a:ext cx="10058400" cy="365760"/>
-          </a:xfrm>
-          <a:prstGeom prst="rect">
-            <a:avLst/>
-          </a:prstGeom>
-          <a:noFill/>
-        </p:spPr>
-        <p:txBody>
-          <a:bodyPr wrap="square">
-            <a:spAutoFit/>
-          </a:bodyPr>
-          <a:lstStyle/>
-          <a:p>
-            <a:pPr algn="l"/>
-            <a:r>
-              <a:rPr sz="1400" b="0">
-                <a:solidFill>
-                  <a:srgbClr val="ECF0F1"/>
-                </a:solidFill>
-              </a:rPr>
-              <a:t>Prepayment = rate-option exercise (~40 mo median)  |  Default = financial stress (30–80 mo)</a:t>
+              <a:t>E(i)(a) — EDA: Vintage Cohort &amp; Categorical Breakdown</a:t>
             </a:r>
           </a:p>
         </p:txBody>
       </p:sp>
       <p:pic>
         <p:nvPicPr>
-          <p:cNvPr id="5" name="Picture 4" descr="E1_eda_duration.png"/>
+          <p:cNvPr id="4" name="Picture 3" descr="E1_eda_vintage.png"/>
           <p:cNvPicPr>
             <a:picLocks noChangeAspect="1"/>
           </p:cNvPicPr>
@@ -6422,8 +6234,32 @@
         </p:blipFill>
         <p:spPr>
           <a:xfrm>
-            <a:off x="137160" y="1097280"/>
-            <a:ext cx="11887200" cy="5099710"/>
+            <a:off x="137160" y="1051560"/>
+            <a:ext cx="7315200" cy="2498432"/>
+          </a:xfrm>
+          <a:prstGeom prst="rect">
+            <a:avLst/>
+          </a:prstGeom>
+        </p:spPr>
+      </p:pic>
+      <p:pic>
+        <p:nvPicPr>
+          <p:cNvPr id="5" name="Picture 4" descr="E1_eda_categorical.png"/>
+          <p:cNvPicPr>
+            <a:picLocks noChangeAspect="1"/>
+          </p:cNvPicPr>
+          <p:nvPr/>
+        </p:nvPicPr>
+        <p:blipFill>
+          <a:blip r:embed="rId3"/>
+          <a:stretch>
+            <a:fillRect/>
+          </a:stretch>
+        </p:blipFill>
+        <p:spPr>
+          <a:xfrm>
+            <a:off x="7589520" y="1051560"/>
+            <a:ext cx="4389120" cy="1348054"/>
           </a:xfrm>
           <a:prstGeom prst="rect">
             <a:avLst/>
@@ -6520,7 +6356,7 @@
                   <a:srgbClr val="FFFFFF"/>
                 </a:solidFill>
               </a:rPr>
-              <a:t>E(i)(a) — EDA: The Equity Trap &amp; Rate Lock-In Effect</a:t>
+              <a:t>E(i)(a) — Hazard Intensity: Prepayment Peaks Early, Default Rises Slowly</a:t>
             </a:r>
           </a:p>
         </p:txBody>
@@ -6554,14 +6390,14 @@
                   <a:srgbClr val="ECF0F1"/>
                 </a:solidFill>
               </a:rPr>
-              <a:t>High LTV removes refi escape · Active loans at 4.4% cannot refinance into 7%+ market</a:t>
+              <a:t>Cause-specific Nelson-Aalen smooth · burnout visible in prepayment hazard · 100K sample</a:t>
             </a:r>
           </a:p>
         </p:txBody>
       </p:sp>
       <p:pic>
         <p:nvPicPr>
-          <p:cNvPr id="5" name="Picture 4" descr="E1_eda_ltv_trap.png"/>
+          <p:cNvPr id="5" name="Picture 4" descr="E1_hazard_overall.png"/>
           <p:cNvPicPr>
             <a:picLocks noChangeAspect="1"/>
           </p:cNvPicPr>
@@ -6575,32 +6411,8 @@
         </p:blipFill>
         <p:spPr>
           <a:xfrm>
-            <a:off x="137160" y="1097280"/>
-            <a:ext cx="5943600" cy="2807590"/>
-          </a:xfrm>
-          <a:prstGeom prst="rect">
-            <a:avLst/>
-          </a:prstGeom>
-        </p:spPr>
-      </p:pic>
-      <p:pic>
-        <p:nvPicPr>
-          <p:cNvPr id="6" name="Picture 5" descr="E1_eda_rate_lockin.png"/>
-          <p:cNvPicPr>
-            <a:picLocks noChangeAspect="1"/>
-          </p:cNvPicPr>
-          <p:nvPr/>
-        </p:nvPicPr>
-        <p:blipFill>
-          <a:blip r:embed="rId3"/>
-          <a:stretch>
-            <a:fillRect/>
-          </a:stretch>
-        </p:blipFill>
-        <p:spPr>
-          <a:xfrm>
-            <a:off x="6217920" y="1097280"/>
-            <a:ext cx="5760720" cy="2471398"/>
+            <a:off x="457200" y="1097280"/>
+            <a:ext cx="11247120" cy="3617222"/>
           </a:xfrm>
           <a:prstGeom prst="rect">
             <a:avLst/>
@@ -6697,7 +6509,7 @@
                   <a:srgbClr val="FFFFFF"/>
                 </a:solidFill>
               </a:rPr>
-              <a:t>E(i)(a) — EDA: GFC Vintages Carry Concentrated Default Risk</a:t>
+              <a:t>E(i)(a) — Stratified Hazard Intensity by FICO · LTV · Rate · Vintage</a:t>
             </a:r>
           </a:p>
         </p:txBody>
@@ -6731,14 +6543,14 @@
                   <a:srgbClr val="ECF0F1"/>
                 </a:solidFill>
               </a:rPr>
-              <a:t>2007 cohort = 6× long-run avg default rate · Post-2013 near-zero · Post-2020 rate-locked</a:t>
+              <a:t>High-FICO refinances fastest · High-LTV defaults persist longer · GFC vintages spike</a:t>
             </a:r>
           </a:p>
         </p:txBody>
       </p:sp>
       <p:pic>
         <p:nvPicPr>
-          <p:cNvPr id="5" name="Picture 4" descr="E1_eda_vintage.png"/>
+          <p:cNvPr id="5" name="Picture 4" descr="E1_hazard_stratified.png"/>
           <p:cNvPicPr>
             <a:picLocks noChangeAspect="1"/>
           </p:cNvPicPr>
@@ -6752,8 +6564,8 @@
         </p:blipFill>
         <p:spPr>
           <a:xfrm>
-            <a:off x="137160" y="1097280"/>
-            <a:ext cx="11887200" cy="4059952"/>
+            <a:off x="457200" y="1005840"/>
+            <a:ext cx="4064926" cy="5303520"/>
           </a:xfrm>
           <a:prstGeom prst="rect">
             <a:avLst/>
@@ -6850,14 +6662,48 @@
                   <a:srgbClr val="FFFFFF"/>
                 </a:solidFill>
               </a:rPr>
-              <a:t>E(i)(a) — EDA: Covariate Profiles &amp; Loan Categories</a:t>
+              <a:t>E(i)(b) — Aalen-Johansen CIF</a:t>
+            </a:r>
+          </a:p>
+        </p:txBody>
+      </p:sp>
+      <p:sp>
+        <p:nvSpPr>
+          <p:cNvPr id="4" name="TextBox 3"/>
+          <p:cNvSpPr txBox="1"/>
+          <p:nvPr/>
+        </p:nvSpPr>
+        <p:spPr>
+          <a:xfrm>
+            <a:off x="274320" y="566928"/>
+            <a:ext cx="10058400" cy="365760"/>
+          </a:xfrm>
+          <a:prstGeom prst="rect">
+            <a:avLst/>
+          </a:prstGeom>
+          <a:noFill/>
+        </p:spPr>
+        <p:txBody>
+          <a:bodyPr wrap="square">
+            <a:spAutoFit/>
+          </a:bodyPr>
+          <a:lstStyle/>
+          <a:p>
+            <a:pPr algn="l"/>
+            <a:r>
+              <a:rPr sz="1400" b="0">
+                <a:solidFill>
+                  <a:srgbClr val="ECF0F1"/>
+                </a:solidFill>
+              </a:rPr>
+              <a:t>Correct competing-risks treatment; 10-yr prepay ≈ 45%,  default ≈ 2%</a:t>
             </a:r>
           </a:p>
         </p:txBody>
       </p:sp>
       <p:pic>
         <p:nvPicPr>
-          <p:cNvPr id="4" name="Picture 3" descr="E1_eda_covariates.png"/>
+          <p:cNvPr id="5" name="Picture 4" descr="E1_competing_risks_cif.png"/>
           <p:cNvPicPr>
             <a:picLocks noChangeAspect="1"/>
           </p:cNvPicPr>
@@ -6871,32 +6717,8 @@
         </p:blipFill>
         <p:spPr>
           <a:xfrm>
-            <a:off x="137160" y="1051560"/>
-            <a:ext cx="7132320" cy="2038539"/>
-          </a:xfrm>
-          <a:prstGeom prst="rect">
-            <a:avLst/>
-          </a:prstGeom>
-        </p:spPr>
-      </p:pic>
-      <p:pic>
-        <p:nvPicPr>
-          <p:cNvPr id="5" name="Picture 4" descr="E1_eda_categorical.png"/>
-          <p:cNvPicPr>
-            <a:picLocks noChangeAspect="1"/>
-          </p:cNvPicPr>
-          <p:nvPr/>
-        </p:nvPicPr>
-        <p:blipFill>
-          <a:blip r:embed="rId3"/>
-          <a:stretch>
-            <a:fillRect/>
-          </a:stretch>
-        </p:blipFill>
-        <p:spPr>
-          <a:xfrm>
-            <a:off x="7406640" y="1051560"/>
-            <a:ext cx="4572000" cy="1404223"/>
+            <a:off x="1371600" y="1097280"/>
+            <a:ext cx="9144000" cy="5034337"/>
           </a:xfrm>
           <a:prstGeom prst="rect">
             <a:avLst/>
@@ -6993,7 +6815,7 @@
                   <a:srgbClr val="FFFFFF"/>
                 </a:solidFill>
               </a:rPr>
-              <a:t>E(i)(b) — Aalen-Johansen CIF</a:t>
+              <a:t>E(i)(c) — KM vs AJ: Bias from Ignoring Competing Events</a:t>
             </a:r>
           </a:p>
         </p:txBody>
@@ -7027,14 +6849,14 @@
                   <a:srgbClr val="ECF0F1"/>
                 </a:solidFill>
               </a:rPr>
-              <a:t>Correct competing-risks treatment; 10-yr prepay ≈ 45%,  default ≈ 2%</a:t>
+              <a:t>KM over-estimates prepayment CIF by treating defaults as independent censorings</a:t>
             </a:r>
           </a:p>
         </p:txBody>
       </p:sp>
       <p:pic>
         <p:nvPicPr>
-          <p:cNvPr id="5" name="Picture 4" descr="E1_competing_risks_cif.png"/>
+          <p:cNvPr id="5" name="Picture 4" descr="E1_km_vs_aj_bias.png"/>
           <p:cNvPicPr>
             <a:picLocks noChangeAspect="1"/>
           </p:cNvPicPr>
@@ -7048,14 +6870,70 @@
         </p:blipFill>
         <p:spPr>
           <a:xfrm>
-            <a:off x="1371600" y="1097280"/>
-            <a:ext cx="9144000" cy="5034337"/>
+            <a:off x="457200" y="1097280"/>
+            <a:ext cx="11247120" cy="3402930"/>
           </a:xfrm>
           <a:prstGeom prst="rect">
             <a:avLst/>
           </a:prstGeom>
         </p:spPr>
       </p:pic>
+      <p:sp>
+        <p:nvSpPr>
+          <p:cNvPr id="6" name="TextBox 5"/>
+          <p:cNvSpPr txBox="1"/>
+          <p:nvPr/>
+        </p:nvSpPr>
+        <p:spPr>
+          <a:xfrm>
+            <a:off x="8686800" y="4754880"/>
+            <a:ext cx="3200400" cy="1371600"/>
+          </a:xfrm>
+          <a:prstGeom prst="rect">
+            <a:avLst/>
+          </a:prstGeom>
+          <a:noFill/>
+        </p:spPr>
+        <p:txBody>
+          <a:bodyPr wrap="square">
+            <a:spAutoFit/>
+          </a:bodyPr>
+          <a:lstStyle/>
+          <a:p>
+            <a:pPr>
+              <a:spcAft>
+                <a:spcPts val="400"/>
+              </a:spcAft>
+              <a:defRPr sz="1300"/>
+            </a:pPr>
+            <a:r>
+              <a:t>• 5 yr: +0.45 pp</a:t>
+            </a:r>
+          </a:p>
+          <a:p>
+            <a:pPr>
+              <a:spcAft>
+                <a:spcPts val="400"/>
+              </a:spcAft>
+              <a:defRPr sz="1300"/>
+            </a:pPr>
+            <a:r>
+              <a:t>• 10 yr: +1.31 pp</a:t>
+            </a:r>
+          </a:p>
+          <a:p>
+            <a:pPr>
+              <a:spcAft>
+                <a:spcPts val="400"/>
+              </a:spcAft>
+              <a:defRPr sz="1300"/>
+            </a:pPr>
+            <a:r>
+              <a:t>• 20 yr: +2.23 pp</a:t>
+            </a:r>
+          </a:p>
+        </p:txBody>
+      </p:sp>
     </p:spTree>
   </p:cSld>
   <p:clrMapOvr>
@@ -7146,7 +7024,7 @@
                   <a:srgbClr val="FFFFFF"/>
                 </a:solidFill>
               </a:rPr>
-              <a:t>E(i)(c) — KM vs AJ: Bias from Ignoring Competing Events</a:t>
+              <a:t>E(i)(d) — Stratified CIF</a:t>
             </a:r>
           </a:p>
         </p:txBody>
@@ -7180,14 +7058,14 @@
                   <a:srgbClr val="ECF0F1"/>
                 </a:solidFill>
               </a:rPr>
-              <a:t>KM over-estimates prepayment CIF by treating defaults as independent censorings</a:t>
+              <a:t>High-FICO → elevated prepayment, near-zero default;  high-LTV → inverted</a:t>
             </a:r>
           </a:p>
         </p:txBody>
       </p:sp>
       <p:pic>
         <p:nvPicPr>
-          <p:cNvPr id="5" name="Picture 4" descr="E1_km_vs_aj_bias.png"/>
+          <p:cNvPr id="5" name="Picture 4" descr="E1_stratified_cif.png"/>
           <p:cNvPicPr>
             <a:picLocks noChangeAspect="1"/>
           </p:cNvPicPr>
@@ -7201,70 +7079,14 @@
         </p:blipFill>
         <p:spPr>
           <a:xfrm>
-            <a:off x="457200" y="1097280"/>
-            <a:ext cx="11247120" cy="3402930"/>
+            <a:off x="274320" y="1051560"/>
+            <a:ext cx="5186826" cy="5303520"/>
           </a:xfrm>
           <a:prstGeom prst="rect">
             <a:avLst/>
           </a:prstGeom>
         </p:spPr>
       </p:pic>
-      <p:sp>
-        <p:nvSpPr>
-          <p:cNvPr id="6" name="TextBox 5"/>
-          <p:cNvSpPr txBox="1"/>
-          <p:nvPr/>
-        </p:nvSpPr>
-        <p:spPr>
-          <a:xfrm>
-            <a:off x="8686800" y="4754880"/>
-            <a:ext cx="3200400" cy="1371600"/>
-          </a:xfrm>
-          <a:prstGeom prst="rect">
-            <a:avLst/>
-          </a:prstGeom>
-          <a:noFill/>
-        </p:spPr>
-        <p:txBody>
-          <a:bodyPr wrap="square">
-            <a:spAutoFit/>
-          </a:bodyPr>
-          <a:lstStyle/>
-          <a:p>
-            <a:pPr>
-              <a:spcAft>
-                <a:spcPts val="400"/>
-              </a:spcAft>
-              <a:defRPr sz="1300"/>
-            </a:pPr>
-            <a:r>
-              <a:t>• 5 yr: +0.45 pp</a:t>
-            </a:r>
-          </a:p>
-          <a:p>
-            <a:pPr>
-              <a:spcAft>
-                <a:spcPts val="400"/>
-              </a:spcAft>
-              <a:defRPr sz="1300"/>
-            </a:pPr>
-            <a:r>
-              <a:t>• 10 yr: +1.31 pp</a:t>
-            </a:r>
-          </a:p>
-          <a:p>
-            <a:pPr>
-              <a:spcAft>
-                <a:spcPts val="400"/>
-              </a:spcAft>
-              <a:defRPr sz="1300"/>
-            </a:pPr>
-            <a:r>
-              <a:t>• 20 yr: +2.23 pp</a:t>
-            </a:r>
-          </a:p>
-        </p:txBody>
-      </p:sp>
     </p:spTree>
   </p:cSld>
   <p:clrMapOvr>

</xml_diff>

<commit_message>
Enlarge EDA charts and add UPB + NumberofBorrowers to box plots
All EDA figures increased in size (dpi=150). Box plot grid expanded from
1×4 to 2×3, adding Orig. Balance ($K) and # Borrowers alongside FICO,
LTV, Rate, DTI.

Co-Authored-By: Claude Sonnet 4.6 <noreply@anthropic.com>
</commit_message>
<xml_diff>
--- a/processed/PartE_Presentation.pptx
+++ b/processed/PartE_Presentation.pptx
@@ -6116,7 +6116,7 @@
         <p:spPr>
           <a:xfrm>
             <a:off x="137160" y="1051560"/>
-            <a:ext cx="11887200" cy="5099710"/>
+            <a:ext cx="11887200" cy="3696690"/>
           </a:xfrm>
           <a:prstGeom prst="rect">
             <a:avLst/>
@@ -6235,7 +6235,7 @@
         <p:spPr>
           <a:xfrm>
             <a:off x="137160" y="1051560"/>
-            <a:ext cx="7315200" cy="2498432"/>
+            <a:ext cx="7315200" cy="2499743"/>
           </a:xfrm>
           <a:prstGeom prst="rect">
             <a:avLst/>
@@ -6259,7 +6259,7 @@
         <p:spPr>
           <a:xfrm>
             <a:off x="7589520" y="1051560"/>
-            <a:ext cx="4389120" cy="1348054"/>
+            <a:ext cx="4389120" cy="1600506"/>
           </a:xfrm>
           <a:prstGeom prst="rect">
             <a:avLst/>
@@ -6412,7 +6412,7 @@
         <p:spPr>
           <a:xfrm>
             <a:off x="457200" y="1097280"/>
-            <a:ext cx="11247120" cy="3617222"/>
+            <a:ext cx="11247120" cy="3629792"/>
           </a:xfrm>
           <a:prstGeom prst="rect">
             <a:avLst/>
@@ -6565,7 +6565,7 @@
         <p:spPr>
           <a:xfrm>
             <a:off x="457200" y="1005840"/>
-            <a:ext cx="4064926" cy="5303520"/>
+            <a:ext cx="4063204" cy="5303520"/>
           </a:xfrm>
           <a:prstGeom prst="rect">
             <a:avLst/>

</xml_diff>

<commit_message>
Add KM/AJ formulas to notebook, report, slides; apply Madrid theme
Notebook: cells 13 (AJ formula with symbol table and partition identity)
and 16 (KM vs AJ formal contrast with increment comparison) updated.
PDF: formula blocks added to E(i)(b) and E(i)(c) sections with Courier
monospace styling and symbol legend table.
PPTX: Madrid theme (navy #1F3963, crimson #C00000, gold #FFC000 accent
stripe); header bars updated with gold divider line; two new formula
slides for E(i)(b) and E(i)(c) with monospaced formula boxes.

Co-Authored-By: Claude Sonnet 4.6 <noreply@anthropic.com>
</commit_message>
<xml_diff>
--- a/processed/PartE_Presentation.pptx
+++ b/processed/PartE_Presentation.pptx
@@ -21,6 +21,7 @@
     <p:sldId id="269" r:id="rId20"/>
     <p:sldId id="270" r:id="rId21"/>
     <p:sldId id="271" r:id="rId22"/>
+    <p:sldId id="272" r:id="rId23"/>
   </p:sldIdLst>
   <p:sldSz cx="12188952" cy="6858000" type="screen4x3"/>
   <p:notesSz cx="6858000" cy="9144000"/>
@@ -3118,7 +3119,7 @@
             <a:avLst/>
           </a:prstGeom>
           <a:solidFill>
-            <a:srgbClr val="2C3E50"/>
+            <a:srgbClr val="1F3963"/>
           </a:solidFill>
           <a:ln>
             <a:noFill/>
@@ -3154,14 +3155,14 @@
         </p:nvSpPr>
         <p:spPr>
           <a:xfrm>
-            <a:off x="0" y="2377440"/>
-            <a:ext cx="12188952" cy="2103120"/>
+            <a:off x="0" y="2286000"/>
+            <a:ext cx="12188952" cy="91440"/>
           </a:xfrm>
           <a:prstGeom prst="rect">
             <a:avLst/>
           </a:prstGeom>
           <a:solidFill>
-            <a:srgbClr val="2980B9"/>
+            <a:srgbClr val="FFC000"/>
           </a:solidFill>
           <a:ln>
             <a:noFill/>
@@ -3191,13 +3192,99 @@
       </p:sp>
       <p:sp>
         <p:nvSpPr>
-          <p:cNvPr id="4" name="TextBox 3"/>
+          <p:cNvPr id="4" name="Rectangle 3"/>
+          <p:cNvSpPr/>
+          <p:nvPr/>
+        </p:nvSpPr>
+        <p:spPr>
+          <a:xfrm>
+            <a:off x="0" y="2377440"/>
+            <a:ext cx="12188952" cy="2286000"/>
+          </a:xfrm>
+          <a:prstGeom prst="rect">
+            <a:avLst/>
+          </a:prstGeom>
+          <a:solidFill>
+            <a:srgbClr val="C00000"/>
+          </a:solidFill>
+          <a:ln>
+            <a:noFill/>
+          </a:ln>
+        </p:spPr>
+        <p:style>
+          <a:lnRef idx="1">
+            <a:schemeClr val="accent1"/>
+          </a:lnRef>
+          <a:fillRef idx="3">
+            <a:schemeClr val="accent1"/>
+          </a:fillRef>
+          <a:effectRef idx="2">
+            <a:schemeClr val="accent1"/>
+          </a:effectRef>
+          <a:fontRef idx="minor">
+            <a:schemeClr val="lt1"/>
+          </a:fontRef>
+        </p:style>
+        <p:txBody>
+          <a:bodyPr rtlCol="0" anchor="ctr"/>
+          <a:lstStyle/>
+          <a:p>
+            <a:pPr algn="ctr"/>
+          </a:p>
+        </p:txBody>
+      </p:sp>
+      <p:sp>
+        <p:nvSpPr>
+          <p:cNvPr id="5" name="Rectangle 4"/>
+          <p:cNvSpPr/>
+          <p:nvPr/>
+        </p:nvSpPr>
+        <p:spPr>
+          <a:xfrm>
+            <a:off x="0" y="4663440"/>
+            <a:ext cx="12188952" cy="91440"/>
+          </a:xfrm>
+          <a:prstGeom prst="rect">
+            <a:avLst/>
+          </a:prstGeom>
+          <a:solidFill>
+            <a:srgbClr val="FFC000"/>
+          </a:solidFill>
+          <a:ln>
+            <a:noFill/>
+          </a:ln>
+        </p:spPr>
+        <p:style>
+          <a:lnRef idx="1">
+            <a:schemeClr val="accent1"/>
+          </a:lnRef>
+          <a:fillRef idx="3">
+            <a:schemeClr val="accent1"/>
+          </a:fillRef>
+          <a:effectRef idx="2">
+            <a:schemeClr val="accent1"/>
+          </a:effectRef>
+          <a:fontRef idx="minor">
+            <a:schemeClr val="lt1"/>
+          </a:fontRef>
+        </p:style>
+        <p:txBody>
+          <a:bodyPr rtlCol="0" anchor="ctr"/>
+          <a:lstStyle/>
+          <a:p>
+            <a:pPr algn="ctr"/>
+          </a:p>
+        </p:txBody>
+      </p:sp>
+      <p:sp>
+        <p:nvSpPr>
+          <p:cNvPr id="6" name="TextBox 5"/>
           <p:cNvSpPr txBox="1"/>
           <p:nvPr/>
         </p:nvSpPr>
         <p:spPr>
           <a:xfrm>
-            <a:off x="914400" y="914400"/>
+            <a:off x="914400" y="822960"/>
             <a:ext cx="10360152" cy="640080"/>
           </a:xfrm>
           <a:prstGeom prst="rect">
@@ -3215,7 +3302,7 @@
             <a:r>
               <a:rPr sz="1800" b="0">
                 <a:solidFill>
-                  <a:srgbClr val="ECF0F1"/>
+                  <a:srgbClr val="F2F2F2"/>
                 </a:solidFill>
               </a:rPr>
               <a:t>MTH9877 — Interest Rates &amp; Credit</a:t>
@@ -3225,14 +3312,14 @@
       </p:sp>
       <p:sp>
         <p:nvSpPr>
-          <p:cNvPr id="5" name="TextBox 4"/>
+          <p:cNvPr id="7" name="TextBox 6"/>
           <p:cNvSpPr txBox="1"/>
           <p:nvPr/>
         </p:nvSpPr>
         <p:spPr>
           <a:xfrm>
-            <a:off x="914400" y="1554480"/>
-            <a:ext cx="10360152" cy="731520"/>
+            <a:off x="914400" y="1463040"/>
+            <a:ext cx="10360152" cy="777240"/>
           </a:xfrm>
           <a:prstGeom prst="rect">
             <a:avLst/>
@@ -3247,7 +3334,7 @@
           <a:p>
             <a:pPr algn="ctr"/>
             <a:r>
-              <a:rPr sz="2800" b="1">
+              <a:rPr sz="3000" b="1">
                 <a:solidFill>
                   <a:srgbClr val="FFFFFF"/>
                 </a:solidFill>
@@ -3259,14 +3346,14 @@
       </p:sp>
       <p:sp>
         <p:nvSpPr>
-          <p:cNvPr id="6" name="TextBox 5"/>
+          <p:cNvPr id="8" name="TextBox 7"/>
           <p:cNvSpPr txBox="1"/>
           <p:nvPr/>
         </p:nvSpPr>
         <p:spPr>
           <a:xfrm>
-            <a:off x="914400" y="2514600"/>
-            <a:ext cx="10360152" cy="548640"/>
+            <a:off x="914400" y="2487168"/>
+            <a:ext cx="10360152" cy="594360"/>
           </a:xfrm>
           <a:prstGeom prst="rect">
             <a:avLst/>
@@ -3293,13 +3380,13 @@
       </p:sp>
       <p:sp>
         <p:nvSpPr>
-          <p:cNvPr id="7" name="TextBox 6"/>
+          <p:cNvPr id="9" name="TextBox 8"/>
           <p:cNvSpPr txBox="1"/>
           <p:nvPr/>
         </p:nvSpPr>
         <p:spPr>
           <a:xfrm>
-            <a:off x="914400" y="6035040"/>
+            <a:off x="914400" y="5989320"/>
             <a:ext cx="10360152" cy="457200"/>
           </a:xfrm>
           <a:prstGeom prst="rect">
@@ -3317,7 +3404,7 @@
             <a:r>
               <a:rPr sz="1300" b="0">
                 <a:solidFill>
-                  <a:srgbClr val="ECF0F1"/>
+                  <a:srgbClr val="F2F2F2"/>
                 </a:solidFill>
               </a:rPr>
               <a:t>Rose Lin  ·  Baruch MFE  ·  May 2026</a:t>
@@ -3352,13 +3439,13 @@
         <p:spPr>
           <a:xfrm>
             <a:off x="0" y="0"/>
-            <a:ext cx="12188952" cy="1005840"/>
+            <a:ext cx="12188952" cy="960120"/>
           </a:xfrm>
           <a:prstGeom prst="rect">
             <a:avLst/>
           </a:prstGeom>
           <a:solidFill>
-            <a:srgbClr val="2C3E50"/>
+            <a:srgbClr val="1F3963"/>
           </a:solidFill>
           <a:ln>
             <a:noFill/>
@@ -3388,14 +3475,57 @@
       </p:sp>
       <p:sp>
         <p:nvSpPr>
-          <p:cNvPr id="3" name="TextBox 2"/>
+          <p:cNvPr id="3" name="Rectangle 2"/>
+          <p:cNvSpPr/>
+          <p:nvPr/>
+        </p:nvSpPr>
+        <p:spPr>
+          <a:xfrm>
+            <a:off x="0" y="960120"/>
+            <a:ext cx="12188952" cy="64008"/>
+          </a:xfrm>
+          <a:prstGeom prst="rect">
+            <a:avLst/>
+          </a:prstGeom>
+          <a:solidFill>
+            <a:srgbClr val="FFC000"/>
+          </a:solidFill>
+          <a:ln>
+            <a:noFill/>
+          </a:ln>
+        </p:spPr>
+        <p:style>
+          <a:lnRef idx="1">
+            <a:schemeClr val="accent1"/>
+          </a:lnRef>
+          <a:fillRef idx="3">
+            <a:schemeClr val="accent1"/>
+          </a:fillRef>
+          <a:effectRef idx="2">
+            <a:schemeClr val="accent1"/>
+          </a:effectRef>
+          <a:fontRef idx="minor">
+            <a:schemeClr val="lt1"/>
+          </a:fontRef>
+        </p:style>
+        <p:txBody>
+          <a:bodyPr rtlCol="0" anchor="ctr"/>
+          <a:lstStyle/>
+          <a:p>
+            <a:pPr algn="ctr"/>
+          </a:p>
+        </p:txBody>
+      </p:sp>
+      <p:sp>
+        <p:nvSpPr>
+          <p:cNvPr id="4" name="TextBox 3"/>
           <p:cNvSpPr txBox="1"/>
           <p:nvPr/>
         </p:nvSpPr>
         <p:spPr>
           <a:xfrm>
-            <a:off x="274320" y="73152"/>
-            <a:ext cx="10058400" cy="502920"/>
+            <a:off x="274320" y="54864"/>
+            <a:ext cx="11430000" cy="502920"/>
           </a:xfrm>
           <a:prstGeom prst="rect">
             <a:avLst/>
@@ -3415,21 +3545,21 @@
                   <a:srgbClr val="FFFFFF"/>
                 </a:solidFill>
               </a:rPr>
-              <a:t>E(i)(e) — Cause-Specific Cox Regression  (12 features)</a:t>
-            </a:r>
-          </a:p>
-        </p:txBody>
-      </p:sp>
-      <p:sp>
-        <p:nvSpPr>
-          <p:cNvPr id="4" name="TextBox 3"/>
+              <a:t>E(i)(d) — Stratified CIF</a:t>
+            </a:r>
+          </a:p>
+        </p:txBody>
+      </p:sp>
+      <p:sp>
+        <p:nvSpPr>
+          <p:cNvPr id="5" name="TextBox 4"/>
           <p:cNvSpPr txBox="1"/>
           <p:nvPr/>
         </p:nvSpPr>
         <p:spPr>
           <a:xfrm>
-            <a:off x="274320" y="566928"/>
-            <a:ext cx="10058400" cy="365760"/>
+            <a:off x="274320" y="548640"/>
+            <a:ext cx="11430000" cy="365760"/>
           </a:xfrm>
           <a:prstGeom prst="rect">
             <a:avLst/>
@@ -3444,19 +3574,19 @@
           <a:p>
             <a:pPr algn="l"/>
             <a:r>
-              <a:rPr sz="1400" b="0">
+              <a:rPr sz="1300" b="0">
                 <a:solidFill>
-                  <a:srgbClr val="ECF0F1"/>
+                  <a:srgbClr val="F2F2F2"/>
                 </a:solidFill>
               </a:rPr>
-              <a:t>Opposite-sign coefficients reveal misrepresentation in naive combined Cox</a:t>
+              <a:t>High-FICO → elevated prepayment, near-zero default;  high-LTV → inverted</a:t>
             </a:r>
           </a:p>
         </p:txBody>
       </p:sp>
       <p:pic>
         <p:nvPicPr>
-          <p:cNvPr id="5" name="Picture 4" descr="E1_cause_specific_cox.png"/>
+          <p:cNvPr id="6" name="Picture 5" descr="E1_stratified_cif.png"/>
           <p:cNvPicPr>
             <a:picLocks noChangeAspect="1"/>
           </p:cNvPicPr>
@@ -3471,7 +3601,7 @@
         <p:spPr>
           <a:xfrm>
             <a:off x="274320" y="1051560"/>
-            <a:ext cx="11612880" cy="3860561"/>
+            <a:ext cx="5186826" cy="5303520"/>
           </a:xfrm>
           <a:prstGeom prst="rect">
             <a:avLst/>
@@ -3505,13 +3635,13 @@
         <p:spPr>
           <a:xfrm>
             <a:off x="0" y="0"/>
-            <a:ext cx="12188952" cy="1005840"/>
+            <a:ext cx="12188952" cy="960120"/>
           </a:xfrm>
           <a:prstGeom prst="rect">
             <a:avLst/>
           </a:prstGeom>
           <a:solidFill>
-            <a:srgbClr val="2C3E50"/>
+            <a:srgbClr val="1F3963"/>
           </a:solidFill>
           <a:ln>
             <a:noFill/>
@@ -3541,14 +3671,57 @@
       </p:sp>
       <p:sp>
         <p:nvSpPr>
-          <p:cNvPr id="3" name="TextBox 2"/>
+          <p:cNvPr id="3" name="Rectangle 2"/>
+          <p:cNvSpPr/>
+          <p:nvPr/>
+        </p:nvSpPr>
+        <p:spPr>
+          <a:xfrm>
+            <a:off x="0" y="960120"/>
+            <a:ext cx="12188952" cy="64008"/>
+          </a:xfrm>
+          <a:prstGeom prst="rect">
+            <a:avLst/>
+          </a:prstGeom>
+          <a:solidFill>
+            <a:srgbClr val="FFC000"/>
+          </a:solidFill>
+          <a:ln>
+            <a:noFill/>
+          </a:ln>
+        </p:spPr>
+        <p:style>
+          <a:lnRef idx="1">
+            <a:schemeClr val="accent1"/>
+          </a:lnRef>
+          <a:fillRef idx="3">
+            <a:schemeClr val="accent1"/>
+          </a:fillRef>
+          <a:effectRef idx="2">
+            <a:schemeClr val="accent1"/>
+          </a:effectRef>
+          <a:fontRef idx="minor">
+            <a:schemeClr val="lt1"/>
+          </a:fontRef>
+        </p:style>
+        <p:txBody>
+          <a:bodyPr rtlCol="0" anchor="ctr"/>
+          <a:lstStyle/>
+          <a:p>
+            <a:pPr algn="ctr"/>
+          </a:p>
+        </p:txBody>
+      </p:sp>
+      <p:sp>
+        <p:nvSpPr>
+          <p:cNvPr id="4" name="TextBox 3"/>
           <p:cNvSpPr txBox="1"/>
           <p:nvPr/>
         </p:nvSpPr>
         <p:spPr>
           <a:xfrm>
-            <a:off x="274320" y="73152"/>
-            <a:ext cx="10058400" cy="502920"/>
+            <a:off x="274320" y="54864"/>
+            <a:ext cx="11430000" cy="502920"/>
           </a:xfrm>
           <a:prstGeom prst="rect">
             <a:avLst/>
@@ -3568,21 +3741,21 @@
                   <a:srgbClr val="FFFFFF"/>
                 </a:solidFill>
               </a:rPr>
-              <a:t>E(i)(f) — Fine-Gray Subdistribution Hazard</a:t>
-            </a:r>
-          </a:p>
-        </p:txBody>
-      </p:sp>
-      <p:sp>
-        <p:nvSpPr>
-          <p:cNvPr id="4" name="TextBox 3"/>
+              <a:t>E(i)(e) — Cause-Specific Cox Regression  (12 features)</a:t>
+            </a:r>
+          </a:p>
+        </p:txBody>
+      </p:sp>
+      <p:sp>
+        <p:nvSpPr>
+          <p:cNvPr id="5" name="TextBox 4"/>
           <p:cNvSpPr txBox="1"/>
           <p:nvPr/>
         </p:nvSpPr>
         <p:spPr>
           <a:xfrm>
-            <a:off x="274320" y="566928"/>
-            <a:ext cx="10058400" cy="365760"/>
+            <a:off x="274320" y="548640"/>
+            <a:ext cx="11430000" cy="365760"/>
           </a:xfrm>
           <a:prstGeom prst="rect">
             <a:avLst/>
@@ -3597,170 +3770,40 @@
           <a:p>
             <a:pPr algn="l"/>
             <a:r>
-              <a:rPr sz="1400" b="0">
+              <a:rPr sz="1300" b="0">
                 <a:solidFill>
-                  <a:srgbClr val="ECF0F1"/>
+                  <a:srgbClr val="F2F2F2"/>
                 </a:solidFill>
               </a:rPr>
-              <a:t>IPCW-weighted Cox approximation; coefficients directly target the CIF</a:t>
-            </a:r>
-          </a:p>
-        </p:txBody>
-      </p:sp>
-      <p:sp>
-        <p:nvSpPr>
-          <p:cNvPr id="5" name="Rectangle 4"/>
-          <p:cNvSpPr/>
-          <p:nvPr/>
-        </p:nvSpPr>
-        <p:spPr>
-          <a:xfrm>
-            <a:off x="0" y="1005840"/>
-            <a:ext cx="12188952" cy="5852160"/>
-          </a:xfrm>
-          <a:prstGeom prst="rect">
-            <a:avLst/>
-          </a:prstGeom>
-          <a:solidFill>
-            <a:srgbClr val="ECF0F1"/>
-          </a:solidFill>
-          <a:ln>
-            <a:noFill/>
-          </a:ln>
-        </p:spPr>
-        <p:style>
-          <a:lnRef idx="1">
-            <a:schemeClr val="accent1"/>
-          </a:lnRef>
-          <a:fillRef idx="3">
-            <a:schemeClr val="accent1"/>
-          </a:fillRef>
-          <a:effectRef idx="2">
-            <a:schemeClr val="accent1"/>
-          </a:effectRef>
-          <a:fontRef idx="minor">
-            <a:schemeClr val="lt1"/>
-          </a:fontRef>
-        </p:style>
-        <p:txBody>
-          <a:bodyPr rtlCol="0" anchor="ctr"/>
-          <a:lstStyle/>
-          <a:p>
-            <a:pPr algn="ctr"/>
-          </a:p>
-        </p:txBody>
-      </p:sp>
-      <p:sp>
-        <p:nvSpPr>
-          <p:cNvPr id="6" name="TextBox 5"/>
-          <p:cNvSpPr txBox="1"/>
-          <p:nvPr/>
-        </p:nvSpPr>
-        <p:spPr>
-          <a:xfrm>
-            <a:off x="457200" y="1188720"/>
-            <a:ext cx="11247120" cy="5029200"/>
-          </a:xfrm>
-          <a:prstGeom prst="rect">
-            <a:avLst/>
-          </a:prstGeom>
-          <a:noFill/>
-        </p:spPr>
-        <p:txBody>
-          <a:bodyPr wrap="square">
-            <a:spAutoFit/>
-          </a:bodyPr>
-          <a:lstStyle/>
-          <a:p>
-            <a:pPr>
-              <a:spcAft>
-                <a:spcPts val="400"/>
-              </a:spcAft>
-              <a:defRPr sz="1400"/>
-            </a:pPr>
-            <a:r>
-              <a:t>• Subjects who experienced a competing event (default) are KEPT in the risk set with IPCW weights</a:t>
-            </a:r>
-          </a:p>
-          <a:p>
-            <a:pPr>
-              <a:spcAft>
-                <a:spcPts val="400"/>
-              </a:spcAft>
-              <a:defRPr sz="1400"/>
-            </a:pPr>
-            <a:r>
-              <a:t>• The subdistribution hazard integrates to the CIF — covariate effects are CIF effects</a:t>
-            </a:r>
-          </a:p>
-          <a:p>
-            <a:pPr>
-              <a:spcAft>
-                <a:spcPts val="400"/>
-              </a:spcAft>
-              <a:defRPr sz="1400"/>
-            </a:pPr>
-            <a:r>
-              <a:t>• rate_incentive HR is LARGER under Fine-Gray than cause-specific Cox:</a:t>
-            </a:r>
-          </a:p>
-          <a:p>
-            <a:pPr>
-              <a:spcAft>
-                <a:spcPts val="400"/>
-              </a:spcAft>
-              <a:defRPr sz="1400"/>
-            </a:pPr>
-            <a:r>
-              <a:t>•    high-incentive loans are also less likely to default first → amplifies CIF effect</a:t>
-            </a:r>
-          </a:p>
-          <a:p>
-            <a:pPr>
-              <a:spcAft>
-                <a:spcPts val="400"/>
-              </a:spcAft>
-              <a:defRPr sz="1400"/>
-            </a:pPr>
-            <a:r>
-              <a:t>• Low-FICO Fine-Gray HR for prepayment is ATTENUATED: elevated default risk reduces</a:t>
-            </a:r>
-          </a:p>
-          <a:p>
-            <a:pPr>
-              <a:spcAft>
-                <a:spcPts val="400"/>
-              </a:spcAft>
-              <a:defRPr sz="1400"/>
-            </a:pPr>
-            <a:r>
-              <a:t>•    measured prepayment propensity once competing risks are accounted for</a:t>
-            </a:r>
-          </a:p>
-          <a:p>
-            <a:pPr>
-              <a:spcAft>
-                <a:spcPts val="400"/>
-              </a:spcAft>
-              <a:defRPr sz="1400"/>
-            </a:pPr>
-            <a:r>
-              <a:t>• Use Fine-Gray for CIF prediction / loss forecasting</a:t>
-            </a:r>
-          </a:p>
-          <a:p>
-            <a:pPr>
-              <a:spcAft>
-                <a:spcPts val="400"/>
-              </a:spcAft>
-              <a:defRPr sz="1400"/>
-            </a:pPr>
-            <a:r>
-              <a:t>• Use cause-specific Cox for economic mechanism estimation</a:t>
-            </a:r>
-          </a:p>
-        </p:txBody>
-      </p:sp>
+              <a:t>Opposite-sign coefficients reveal misrepresentation in naive combined Cox</a:t>
+            </a:r>
+          </a:p>
+        </p:txBody>
+      </p:sp>
+      <p:pic>
+        <p:nvPicPr>
+          <p:cNvPr id="6" name="Picture 5" descr="E1_cause_specific_cox.png"/>
+          <p:cNvPicPr>
+            <a:picLocks noChangeAspect="1"/>
+          </p:cNvPicPr>
+          <p:nvPr/>
+        </p:nvPicPr>
+        <p:blipFill>
+          <a:blip r:embed="rId2"/>
+          <a:stretch>
+            <a:fillRect/>
+          </a:stretch>
+        </p:blipFill>
+        <p:spPr>
+          <a:xfrm>
+            <a:off x="274320" y="1051560"/>
+            <a:ext cx="11612880" cy="3860561"/>
+          </a:xfrm>
+          <a:prstGeom prst="rect">
+            <a:avLst/>
+          </a:prstGeom>
+        </p:spPr>
+      </p:pic>
     </p:spTree>
   </p:cSld>
   <p:clrMapOvr>
@@ -3788,13 +3831,13 @@
         <p:spPr>
           <a:xfrm>
             <a:off x="0" y="0"/>
-            <a:ext cx="12188952" cy="1005840"/>
+            <a:ext cx="12188952" cy="960120"/>
           </a:xfrm>
           <a:prstGeom prst="rect">
             <a:avLst/>
           </a:prstGeom>
           <a:solidFill>
-            <a:srgbClr val="2C3E50"/>
+            <a:srgbClr val="1F3963"/>
           </a:solidFill>
           <a:ln>
             <a:noFill/>
@@ -3824,14 +3867,57 @@
       </p:sp>
       <p:sp>
         <p:nvSpPr>
-          <p:cNvPr id="3" name="TextBox 2"/>
+          <p:cNvPr id="3" name="Rectangle 2"/>
+          <p:cNvSpPr/>
+          <p:nvPr/>
+        </p:nvSpPr>
+        <p:spPr>
+          <a:xfrm>
+            <a:off x="0" y="960120"/>
+            <a:ext cx="12188952" cy="64008"/>
+          </a:xfrm>
+          <a:prstGeom prst="rect">
+            <a:avLst/>
+          </a:prstGeom>
+          <a:solidFill>
+            <a:srgbClr val="FFC000"/>
+          </a:solidFill>
+          <a:ln>
+            <a:noFill/>
+          </a:ln>
+        </p:spPr>
+        <p:style>
+          <a:lnRef idx="1">
+            <a:schemeClr val="accent1"/>
+          </a:lnRef>
+          <a:fillRef idx="3">
+            <a:schemeClr val="accent1"/>
+          </a:fillRef>
+          <a:effectRef idx="2">
+            <a:schemeClr val="accent1"/>
+          </a:effectRef>
+          <a:fontRef idx="minor">
+            <a:schemeClr val="lt1"/>
+          </a:fontRef>
+        </p:style>
+        <p:txBody>
+          <a:bodyPr rtlCol="0" anchor="ctr"/>
+          <a:lstStyle/>
+          <a:p>
+            <a:pPr algn="ctr"/>
+          </a:p>
+        </p:txBody>
+      </p:sp>
+      <p:sp>
+        <p:nvSpPr>
+          <p:cNvPr id="4" name="TextBox 3"/>
           <p:cNvSpPr txBox="1"/>
           <p:nvPr/>
         </p:nvSpPr>
         <p:spPr>
           <a:xfrm>
-            <a:off x="274320" y="73152"/>
-            <a:ext cx="10058400" cy="502920"/>
+            <a:off x="274320" y="54864"/>
+            <a:ext cx="11430000" cy="502920"/>
           </a:xfrm>
           <a:prstGeom prst="rect">
             <a:avLst/>
@@ -3851,21 +3937,21 @@
                   <a:srgbClr val="FFFFFF"/>
                 </a:solidFill>
               </a:rPr>
-              <a:t>E(ii) — Time-Dependent Covariates</a:t>
-            </a:r>
-          </a:p>
-        </p:txBody>
-      </p:sp>
-      <p:sp>
-        <p:nvSpPr>
-          <p:cNvPr id="4" name="TextBox 3"/>
+              <a:t>E(i)(f) — Fine-Gray Subdistribution Hazard</a:t>
+            </a:r>
+          </a:p>
+        </p:txBody>
+      </p:sp>
+      <p:sp>
+        <p:nvSpPr>
+          <p:cNvPr id="5" name="TextBox 4"/>
           <p:cNvSpPr txBox="1"/>
           <p:nvPr/>
         </p:nvSpPr>
         <p:spPr>
           <a:xfrm>
-            <a:off x="274320" y="566928"/>
-            <a:ext cx="10058400" cy="365760"/>
+            <a:off x="274320" y="548640"/>
+            <a:ext cx="11430000" cy="365760"/>
           </a:xfrm>
           <a:prstGeom prst="rect">
             <a:avLst/>
@@ -3880,19 +3966,19 @@
           <a:p>
             <a:pPr algn="l"/>
             <a:r>
-              <a:rPr sz="1400" b="0">
+              <a:rPr sz="1300" b="0">
                 <a:solidFill>
-                  <a:srgbClr val="ECF0F1"/>
+                  <a:srgbClr val="F2F2F2"/>
                 </a:solidFill>
               </a:rPr>
-              <a:t>Andersen-Gill counting-process Cox — monthly rate_incentive, unemployment, HPI</a:t>
-            </a:r>
-          </a:p>
-        </p:txBody>
-      </p:sp>
-      <p:sp>
-        <p:nvSpPr>
-          <p:cNvPr id="5" name="Rectangle 4"/>
+              <a:t>IPCW-weighted Cox approximation; coefficients directly target the CIF</a:t>
+            </a:r>
+          </a:p>
+        </p:txBody>
+      </p:sp>
+      <p:sp>
+        <p:nvSpPr>
+          <p:cNvPr id="6" name="Rectangle 5"/>
           <p:cNvSpPr/>
           <p:nvPr/>
         </p:nvSpPr>
@@ -3905,7 +3991,7 @@
             <a:avLst/>
           </a:prstGeom>
           <a:solidFill>
-            <a:srgbClr val="ECF0F1"/>
+            <a:srgbClr val="F2F2F2"/>
           </a:solidFill>
           <a:ln>
             <a:noFill/>
@@ -3935,7 +4021,7 @@
       </p:sp>
       <p:sp>
         <p:nvSpPr>
-          <p:cNvPr id="6" name="TextBox 5"/>
+          <p:cNvPr id="7" name="TextBox 6"/>
           <p:cNvSpPr txBox="1"/>
           <p:nvPr/>
         </p:nvSpPr>
@@ -3959,10 +4045,10 @@
               <a:spcAft>
                 <a:spcPts val="400"/>
               </a:spcAft>
-              <a:defRPr sz="1300"/>
+              <a:defRPr sz="1400"/>
             </a:pPr>
             <a:r>
-              <a:t>• Panel dataset: 93M rows × 2M loans — mortgage_rate, unemployment, HPI YoY, rate_incentive updated monthly</a:t>
+              <a:t>• Subjects who experienced a competing event (default) are KEPT in the risk set with IPCW weights</a:t>
             </a:r>
           </a:p>
           <a:p>
@@ -3970,10 +4056,10 @@
               <a:spcAft>
                 <a:spcPts val="400"/>
               </a:spcAft>
-              <a:defRPr sz="1300"/>
+              <a:defRPr sz="1400"/>
             </a:pPr>
             <a:r>
-              <a:t>• 10,000 loans stratified by vintage → ~500K counting-process rows (tstart, tstop, event)</a:t>
+              <a:t>• The subdistribution hazard integrates to the CIF — covariate effects are CIF effects</a:t>
             </a:r>
           </a:p>
           <a:p>
@@ -3981,10 +4067,10 @@
               <a:spcAft>
                 <a:spcPts val="400"/>
               </a:spcAft>
-              <a:defRPr sz="1300"/>
+              <a:defRPr sz="1400"/>
             </a:pPr>
             <a:r>
-              <a:t>• 11 features: 7 static (FICO, LTV, DTI, UPB + 3 one-hot) + 4 time-varying</a:t>
+              <a:t>• rate_incentive HR is LARGER under Fine-Gray than cause-specific Cox:</a:t>
             </a:r>
           </a:p>
           <a:p>
@@ -3992,10 +4078,10 @@
               <a:spcAft>
                 <a:spcPts val="400"/>
               </a:spcAft>
-              <a:defRPr sz="1300"/>
+              <a:defRPr sz="1400"/>
             </a:pPr>
             <a:r>
-              <a:t>• Key finding: current rate_incentive coefficient LARGER than origination-vintage snapshot</a:t>
+              <a:t>•    high-incentive loans are also less likely to default first → amplifies CIF effect</a:t>
             </a:r>
           </a:p>
           <a:p>
@@ -4003,10 +4089,10 @@
               <a:spcAft>
                 <a:spcPts val="400"/>
               </a:spcAft>
-              <a:defRPr sz="1300"/>
+              <a:defRPr sz="1400"/>
             </a:pPr>
             <a:r>
-              <a:t>•    Static Cox: rate_incentive locked at origination — high-rate era loans always look attractive</a:t>
+              <a:t>• Low-FICO Fine-Gray HR for prepayment is ATTENUATED: elevated default risk reduces</a:t>
             </a:r>
           </a:p>
           <a:p>
@@ -4014,10 +4100,10 @@
               <a:spcAft>
                 <a:spcPts val="400"/>
               </a:spcAft>
-              <a:defRPr sz="1300"/>
+              <a:defRPr sz="1400"/>
             </a:pPr>
             <a:r>
-              <a:t>•    TV Cox: tracks actual monthly refi option value — more responsive to rate cycles</a:t>
+              <a:t>•    measured prepayment propensity once competing risks are accounted for</a:t>
             </a:r>
           </a:p>
           <a:p>
@@ -4025,10 +4111,10 @@
               <a:spcAft>
                 <a:spcPts val="400"/>
               </a:spcAft>
-              <a:defRPr sz="1300"/>
+              <a:defRPr sz="1400"/>
             </a:pPr>
             <a:r>
-              <a:t>• Unemployment: contemporaneous job loss predicts default better than vintage average</a:t>
+              <a:t>• Use Fine-Gray for CIF prediction / loss forecasting</a:t>
             </a:r>
           </a:p>
           <a:p>
@@ -4036,10 +4122,10 @@
               <a:spcAft>
                 <a:spcPts val="400"/>
               </a:spcAft>
-              <a:defRPr sz="1300"/>
+              <a:defRPr sz="1400"/>
             </a:pPr>
             <a:r>
-              <a:t>• Limitation: origination LTV used (not ELTV) — adding current LTV would improve default hazard</a:t>
+              <a:t>• Use cause-specific Cox for economic mechanism estimation</a:t>
             </a:r>
           </a:p>
         </p:txBody>
@@ -4071,13 +4157,13 @@
         <p:spPr>
           <a:xfrm>
             <a:off x="0" y="0"/>
-            <a:ext cx="12188952" cy="1005840"/>
+            <a:ext cx="12188952" cy="960120"/>
           </a:xfrm>
           <a:prstGeom prst="rect">
             <a:avLst/>
           </a:prstGeom>
           <a:solidFill>
-            <a:srgbClr val="2C3E50"/>
+            <a:srgbClr val="1F3963"/>
           </a:solidFill>
           <a:ln>
             <a:noFill/>
@@ -4107,14 +4193,57 @@
       </p:sp>
       <p:sp>
         <p:nvSpPr>
-          <p:cNvPr id="3" name="TextBox 2"/>
+          <p:cNvPr id="3" name="Rectangle 2"/>
+          <p:cNvSpPr/>
+          <p:nvPr/>
+        </p:nvSpPr>
+        <p:spPr>
+          <a:xfrm>
+            <a:off x="0" y="960120"/>
+            <a:ext cx="12188952" cy="64008"/>
+          </a:xfrm>
+          <a:prstGeom prst="rect">
+            <a:avLst/>
+          </a:prstGeom>
+          <a:solidFill>
+            <a:srgbClr val="FFC000"/>
+          </a:solidFill>
+          <a:ln>
+            <a:noFill/>
+          </a:ln>
+        </p:spPr>
+        <p:style>
+          <a:lnRef idx="1">
+            <a:schemeClr val="accent1"/>
+          </a:lnRef>
+          <a:fillRef idx="3">
+            <a:schemeClr val="accent1"/>
+          </a:fillRef>
+          <a:effectRef idx="2">
+            <a:schemeClr val="accent1"/>
+          </a:effectRef>
+          <a:fontRef idx="minor">
+            <a:schemeClr val="lt1"/>
+          </a:fontRef>
+        </p:style>
+        <p:txBody>
+          <a:bodyPr rtlCol="0" anchor="ctr"/>
+          <a:lstStyle/>
+          <a:p>
+            <a:pPr algn="ctr"/>
+          </a:p>
+        </p:txBody>
+      </p:sp>
+      <p:sp>
+        <p:nvSpPr>
+          <p:cNvPr id="4" name="TextBox 3"/>
           <p:cNvSpPr txBox="1"/>
           <p:nvPr/>
         </p:nvSpPr>
         <p:spPr>
           <a:xfrm>
-            <a:off x="274320" y="73152"/>
-            <a:ext cx="10058400" cy="502920"/>
+            <a:off x="274320" y="54864"/>
+            <a:ext cx="11430000" cy="502920"/>
           </a:xfrm>
           <a:prstGeom prst="rect">
             <a:avLst/>
@@ -4134,59 +4263,199 @@
                   <a:srgbClr val="FFFFFF"/>
                 </a:solidFill>
               </a:rPr>
-              <a:t>E(ii) — TV Cox Results</a:t>
-            </a:r>
-          </a:p>
-        </p:txBody>
-      </p:sp>
-      <p:pic>
-        <p:nvPicPr>
-          <p:cNvPr id="4" name="Picture 3" descr="Eii_tv_cox_forest.png"/>
-          <p:cNvPicPr>
-            <a:picLocks noChangeAspect="1"/>
-          </p:cNvPicPr>
-          <p:nvPr/>
-        </p:nvPicPr>
-        <p:blipFill>
-          <a:blip r:embed="rId2"/>
-          <a:stretch>
-            <a:fillRect/>
-          </a:stretch>
-        </p:blipFill>
-        <p:spPr>
-          <a:xfrm>
-            <a:off x="137160" y="1051560"/>
-            <a:ext cx="7132320" cy="3013704"/>
-          </a:xfrm>
-          <a:prstGeom prst="rect">
-            <a:avLst/>
-          </a:prstGeom>
-        </p:spPr>
-      </p:pic>
-      <p:pic>
-        <p:nvPicPr>
-          <p:cNvPr id="5" name="Picture 4" descr="Eii_static_vs_tv.png"/>
-          <p:cNvPicPr>
-            <a:picLocks noChangeAspect="1"/>
-          </p:cNvPicPr>
-          <p:nvPr/>
-        </p:nvPicPr>
-        <p:blipFill>
-          <a:blip r:embed="rId3"/>
-          <a:stretch>
-            <a:fillRect/>
-          </a:stretch>
-        </p:blipFill>
-        <p:spPr>
-          <a:xfrm>
-            <a:off x="7406640" y="1051560"/>
-            <a:ext cx="4572000" cy="2247385"/>
-          </a:xfrm>
-          <a:prstGeom prst="rect">
-            <a:avLst/>
-          </a:prstGeom>
-        </p:spPr>
-      </p:pic>
+              <a:t>E(ii) — Time-Dependent Covariates</a:t>
+            </a:r>
+          </a:p>
+        </p:txBody>
+      </p:sp>
+      <p:sp>
+        <p:nvSpPr>
+          <p:cNvPr id="5" name="TextBox 4"/>
+          <p:cNvSpPr txBox="1"/>
+          <p:nvPr/>
+        </p:nvSpPr>
+        <p:spPr>
+          <a:xfrm>
+            <a:off x="274320" y="548640"/>
+            <a:ext cx="11430000" cy="365760"/>
+          </a:xfrm>
+          <a:prstGeom prst="rect">
+            <a:avLst/>
+          </a:prstGeom>
+          <a:noFill/>
+        </p:spPr>
+        <p:txBody>
+          <a:bodyPr wrap="square">
+            <a:spAutoFit/>
+          </a:bodyPr>
+          <a:lstStyle/>
+          <a:p>
+            <a:pPr algn="l"/>
+            <a:r>
+              <a:rPr sz="1300" b="0">
+                <a:solidFill>
+                  <a:srgbClr val="F2F2F2"/>
+                </a:solidFill>
+              </a:rPr>
+              <a:t>Andersen-Gill counting-process Cox — monthly rate_incentive, unemployment, HPI</a:t>
+            </a:r>
+          </a:p>
+        </p:txBody>
+      </p:sp>
+      <p:sp>
+        <p:nvSpPr>
+          <p:cNvPr id="6" name="Rectangle 5"/>
+          <p:cNvSpPr/>
+          <p:nvPr/>
+        </p:nvSpPr>
+        <p:spPr>
+          <a:xfrm>
+            <a:off x="0" y="1005840"/>
+            <a:ext cx="12188952" cy="5852160"/>
+          </a:xfrm>
+          <a:prstGeom prst="rect">
+            <a:avLst/>
+          </a:prstGeom>
+          <a:solidFill>
+            <a:srgbClr val="F2F2F2"/>
+          </a:solidFill>
+          <a:ln>
+            <a:noFill/>
+          </a:ln>
+        </p:spPr>
+        <p:style>
+          <a:lnRef idx="1">
+            <a:schemeClr val="accent1"/>
+          </a:lnRef>
+          <a:fillRef idx="3">
+            <a:schemeClr val="accent1"/>
+          </a:fillRef>
+          <a:effectRef idx="2">
+            <a:schemeClr val="accent1"/>
+          </a:effectRef>
+          <a:fontRef idx="minor">
+            <a:schemeClr val="lt1"/>
+          </a:fontRef>
+        </p:style>
+        <p:txBody>
+          <a:bodyPr rtlCol="0" anchor="ctr"/>
+          <a:lstStyle/>
+          <a:p>
+            <a:pPr algn="ctr"/>
+          </a:p>
+        </p:txBody>
+      </p:sp>
+      <p:sp>
+        <p:nvSpPr>
+          <p:cNvPr id="7" name="TextBox 6"/>
+          <p:cNvSpPr txBox="1"/>
+          <p:nvPr/>
+        </p:nvSpPr>
+        <p:spPr>
+          <a:xfrm>
+            <a:off x="457200" y="1188720"/>
+            <a:ext cx="11247120" cy="5029200"/>
+          </a:xfrm>
+          <a:prstGeom prst="rect">
+            <a:avLst/>
+          </a:prstGeom>
+          <a:noFill/>
+        </p:spPr>
+        <p:txBody>
+          <a:bodyPr wrap="square">
+            <a:spAutoFit/>
+          </a:bodyPr>
+          <a:lstStyle/>
+          <a:p>
+            <a:pPr>
+              <a:spcAft>
+                <a:spcPts val="400"/>
+              </a:spcAft>
+              <a:defRPr sz="1300"/>
+            </a:pPr>
+            <a:r>
+              <a:t>• Panel dataset: 93M rows × 2M loans — mortgage_rate, unemployment, HPI YoY, rate_incentive updated monthly</a:t>
+            </a:r>
+          </a:p>
+          <a:p>
+            <a:pPr>
+              <a:spcAft>
+                <a:spcPts val="400"/>
+              </a:spcAft>
+              <a:defRPr sz="1300"/>
+            </a:pPr>
+            <a:r>
+              <a:t>• 10,000 loans stratified by vintage → ~500K counting-process rows (tstart, tstop, event)</a:t>
+            </a:r>
+          </a:p>
+          <a:p>
+            <a:pPr>
+              <a:spcAft>
+                <a:spcPts val="400"/>
+              </a:spcAft>
+              <a:defRPr sz="1300"/>
+            </a:pPr>
+            <a:r>
+              <a:t>• 11 features: 7 static (FICO, LTV, DTI, UPB + 3 one-hot) + 4 time-varying</a:t>
+            </a:r>
+          </a:p>
+          <a:p>
+            <a:pPr>
+              <a:spcAft>
+                <a:spcPts val="400"/>
+              </a:spcAft>
+              <a:defRPr sz="1300"/>
+            </a:pPr>
+            <a:r>
+              <a:t>• Key finding: current rate_incentive coefficient LARGER than origination-vintage snapshot</a:t>
+            </a:r>
+          </a:p>
+          <a:p>
+            <a:pPr>
+              <a:spcAft>
+                <a:spcPts val="400"/>
+              </a:spcAft>
+              <a:defRPr sz="1300"/>
+            </a:pPr>
+            <a:r>
+              <a:t>•    Static Cox: rate_incentive locked at origination — high-rate era loans always look attractive</a:t>
+            </a:r>
+          </a:p>
+          <a:p>
+            <a:pPr>
+              <a:spcAft>
+                <a:spcPts val="400"/>
+              </a:spcAft>
+              <a:defRPr sz="1300"/>
+            </a:pPr>
+            <a:r>
+              <a:t>•    TV Cox: tracks actual monthly refi option value — more responsive to rate cycles</a:t>
+            </a:r>
+          </a:p>
+          <a:p>
+            <a:pPr>
+              <a:spcAft>
+                <a:spcPts val="400"/>
+              </a:spcAft>
+              <a:defRPr sz="1300"/>
+            </a:pPr>
+            <a:r>
+              <a:t>• Unemployment: contemporaneous job loss predicts default better than vintage average</a:t>
+            </a:r>
+          </a:p>
+          <a:p>
+            <a:pPr>
+              <a:spcAft>
+                <a:spcPts val="400"/>
+              </a:spcAft>
+              <a:defRPr sz="1300"/>
+            </a:pPr>
+            <a:r>
+              <a:t>• Limitation: origination LTV used (not ELTV) — adding current LTV would improve default hazard</a:t>
+            </a:r>
+          </a:p>
+        </p:txBody>
+      </p:sp>
     </p:spTree>
   </p:cSld>
   <p:clrMapOvr>
@@ -4214,13 +4483,13 @@
         <p:spPr>
           <a:xfrm>
             <a:off x="0" y="0"/>
-            <a:ext cx="12188952" cy="1005840"/>
+            <a:ext cx="12188952" cy="960120"/>
           </a:xfrm>
           <a:prstGeom prst="rect">
             <a:avLst/>
           </a:prstGeom>
           <a:solidFill>
-            <a:srgbClr val="2C3E50"/>
+            <a:srgbClr val="1F3963"/>
           </a:solidFill>
           <a:ln>
             <a:noFill/>
@@ -4250,14 +4519,57 @@
       </p:sp>
       <p:sp>
         <p:nvSpPr>
-          <p:cNvPr id="3" name="TextBox 2"/>
+          <p:cNvPr id="3" name="Rectangle 2"/>
+          <p:cNvSpPr/>
+          <p:nvPr/>
+        </p:nvSpPr>
+        <p:spPr>
+          <a:xfrm>
+            <a:off x="0" y="960120"/>
+            <a:ext cx="12188952" cy="64008"/>
+          </a:xfrm>
+          <a:prstGeom prst="rect">
+            <a:avLst/>
+          </a:prstGeom>
+          <a:solidFill>
+            <a:srgbClr val="FFC000"/>
+          </a:solidFill>
+          <a:ln>
+            <a:noFill/>
+          </a:ln>
+        </p:spPr>
+        <p:style>
+          <a:lnRef idx="1">
+            <a:schemeClr val="accent1"/>
+          </a:lnRef>
+          <a:fillRef idx="3">
+            <a:schemeClr val="accent1"/>
+          </a:fillRef>
+          <a:effectRef idx="2">
+            <a:schemeClr val="accent1"/>
+          </a:effectRef>
+          <a:fontRef idx="minor">
+            <a:schemeClr val="lt1"/>
+          </a:fontRef>
+        </p:style>
+        <p:txBody>
+          <a:bodyPr rtlCol="0" anchor="ctr"/>
+          <a:lstStyle/>
+          <a:p>
+            <a:pPr algn="ctr"/>
+          </a:p>
+        </p:txBody>
+      </p:sp>
+      <p:sp>
+        <p:nvSpPr>
+          <p:cNvPr id="4" name="TextBox 3"/>
           <p:cNvSpPr txBox="1"/>
           <p:nvPr/>
         </p:nvSpPr>
         <p:spPr>
           <a:xfrm>
-            <a:off x="274320" y="73152"/>
-            <a:ext cx="10058400" cy="502920"/>
+            <a:off x="274320" y="54864"/>
+            <a:ext cx="11430000" cy="502920"/>
           </a:xfrm>
           <a:prstGeom prst="rect">
             <a:avLst/>
@@ -4277,48 +4589,14 @@
                   <a:srgbClr val="FFFFFF"/>
                 </a:solidFill>
               </a:rPr>
-              <a:t>E(iv) — Scenario Analysis: Interest Rate Shocks</a:t>
-            </a:r>
-          </a:p>
-        </p:txBody>
-      </p:sp>
-      <p:sp>
-        <p:nvSpPr>
-          <p:cNvPr id="4" name="TextBox 3"/>
-          <p:cNvSpPr txBox="1"/>
-          <p:nvPr/>
-        </p:nvSpPr>
-        <p:spPr>
-          <a:xfrm>
-            <a:off x="274320" y="566928"/>
-            <a:ext cx="10058400" cy="365760"/>
-          </a:xfrm>
-          <a:prstGeom prst="rect">
-            <a:avLst/>
-          </a:prstGeom>
-          <a:noFill/>
-        </p:spPr>
-        <p:txBody>
-          <a:bodyPr wrap="square">
-            <a:spAutoFit/>
-          </a:bodyPr>
-          <a:lstStyle/>
-          <a:p>
-            <a:pPr algn="l"/>
-            <a:r>
-              <a:rPr sz="1400" b="0">
-                <a:solidFill>
-                  <a:srgbClr val="ECF0F1"/>
-                </a:solidFill>
-              </a:rPr>
-              <a:t>±100 bp and ±200 bp shocks to mortgage_rate  (rate_incentive updated consistently)</a:t>
+              <a:t>E(ii) — TV Cox Results</a:t>
             </a:r>
           </a:p>
         </p:txBody>
       </p:sp>
       <p:pic>
         <p:nvPicPr>
-          <p:cNvPr id="5" name="Picture 4" descr="E2_scenario_analysis.png"/>
+          <p:cNvPr id="5" name="Picture 4" descr="Eii_tv_cox_forest.png"/>
           <p:cNvPicPr>
             <a:picLocks noChangeAspect="1"/>
           </p:cNvPicPr>
@@ -4332,8 +4610,32 @@
         </p:blipFill>
         <p:spPr>
           <a:xfrm>
-            <a:off x="457200" y="1051560"/>
-            <a:ext cx="11247120" cy="3906695"/>
+            <a:off x="137160" y="1051560"/>
+            <a:ext cx="7132320" cy="3013704"/>
+          </a:xfrm>
+          <a:prstGeom prst="rect">
+            <a:avLst/>
+          </a:prstGeom>
+        </p:spPr>
+      </p:pic>
+      <p:pic>
+        <p:nvPicPr>
+          <p:cNvPr id="6" name="Picture 5" descr="Eii_static_vs_tv.png"/>
+          <p:cNvPicPr>
+            <a:picLocks noChangeAspect="1"/>
+          </p:cNvPicPr>
+          <p:nvPr/>
+        </p:nvPicPr>
+        <p:blipFill>
+          <a:blip r:embed="rId3"/>
+          <a:stretch>
+            <a:fillRect/>
+          </a:stretch>
+        </p:blipFill>
+        <p:spPr>
+          <a:xfrm>
+            <a:off x="7406640" y="1051560"/>
+            <a:ext cx="4572000" cy="2247385"/>
           </a:xfrm>
           <a:prstGeom prst="rect">
             <a:avLst/>
@@ -4367,13 +4669,13 @@
         <p:spPr>
           <a:xfrm>
             <a:off x="0" y="0"/>
-            <a:ext cx="12188952" cy="1005840"/>
+            <a:ext cx="12188952" cy="960120"/>
           </a:xfrm>
           <a:prstGeom prst="rect">
             <a:avLst/>
           </a:prstGeom>
           <a:solidFill>
-            <a:srgbClr val="2C3E50"/>
+            <a:srgbClr val="1F3963"/>
           </a:solidFill>
           <a:ln>
             <a:noFill/>
@@ -4403,14 +4705,57 @@
       </p:sp>
       <p:sp>
         <p:nvSpPr>
-          <p:cNvPr id="3" name="TextBox 2"/>
+          <p:cNvPr id="3" name="Rectangle 2"/>
+          <p:cNvSpPr/>
+          <p:nvPr/>
+        </p:nvSpPr>
+        <p:spPr>
+          <a:xfrm>
+            <a:off x="0" y="960120"/>
+            <a:ext cx="12188952" cy="64008"/>
+          </a:xfrm>
+          <a:prstGeom prst="rect">
+            <a:avLst/>
+          </a:prstGeom>
+          <a:solidFill>
+            <a:srgbClr val="FFC000"/>
+          </a:solidFill>
+          <a:ln>
+            <a:noFill/>
+          </a:ln>
+        </p:spPr>
+        <p:style>
+          <a:lnRef idx="1">
+            <a:schemeClr val="accent1"/>
+          </a:lnRef>
+          <a:fillRef idx="3">
+            <a:schemeClr val="accent1"/>
+          </a:fillRef>
+          <a:effectRef idx="2">
+            <a:schemeClr val="accent1"/>
+          </a:effectRef>
+          <a:fontRef idx="minor">
+            <a:schemeClr val="lt1"/>
+          </a:fontRef>
+        </p:style>
+        <p:txBody>
+          <a:bodyPr rtlCol="0" anchor="ctr"/>
+          <a:lstStyle/>
+          <a:p>
+            <a:pPr algn="ctr"/>
+          </a:p>
+        </p:txBody>
+      </p:sp>
+      <p:sp>
+        <p:nvSpPr>
+          <p:cNvPr id="4" name="TextBox 3"/>
           <p:cNvSpPr txBox="1"/>
           <p:nvPr/>
         </p:nvSpPr>
         <p:spPr>
           <a:xfrm>
-            <a:off x="274320" y="73152"/>
-            <a:ext cx="10058400" cy="502920"/>
+            <a:off x="274320" y="54864"/>
+            <a:ext cx="11430000" cy="502920"/>
           </a:xfrm>
           <a:prstGeom prst="rect">
             <a:avLst/>
@@ -4430,51 +4775,8 @@
                   <a:srgbClr val="FFFFFF"/>
                 </a:solidFill>
               </a:rPr>
-              <a:t>E(iv) — Scenario Analysis: Interpretation</a:t>
-            </a:r>
-          </a:p>
-        </p:txBody>
-      </p:sp>
-      <p:sp>
-        <p:nvSpPr>
-          <p:cNvPr id="4" name="Rectangle 3"/>
-          <p:cNvSpPr/>
-          <p:nvPr/>
-        </p:nvSpPr>
-        <p:spPr>
-          <a:xfrm>
-            <a:off x="0" y="1005840"/>
-            <a:ext cx="12188952" cy="5852160"/>
-          </a:xfrm>
-          <a:prstGeom prst="rect">
-            <a:avLst/>
-          </a:prstGeom>
-          <a:solidFill>
-            <a:srgbClr val="ECF0F1"/>
-          </a:solidFill>
-          <a:ln>
-            <a:noFill/>
-          </a:ln>
-        </p:spPr>
-        <p:style>
-          <a:lnRef idx="1">
-            <a:schemeClr val="accent1"/>
-          </a:lnRef>
-          <a:fillRef idx="3">
-            <a:schemeClr val="accent1"/>
-          </a:fillRef>
-          <a:effectRef idx="2">
-            <a:schemeClr val="accent1"/>
-          </a:effectRef>
-          <a:fontRef idx="minor">
-            <a:schemeClr val="lt1"/>
-          </a:fontRef>
-        </p:style>
-        <p:txBody>
-          <a:bodyPr rtlCol="0" anchor="ctr"/>
-          <a:lstStyle/>
-          <a:p>
-            <a:pPr algn="ctr"/>
+              <a:t>E(iv) — Scenario Analysis: Interest Rate Shocks</a:t>
+            </a:r>
           </a:p>
         </p:txBody>
       </p:sp>
@@ -4486,8 +4788,8 @@
         </p:nvSpPr>
         <p:spPr>
           <a:xfrm>
-            <a:off x="457200" y="1188720"/>
-            <a:ext cx="11247120" cy="5029200"/>
+            <a:off x="274320" y="548640"/>
+            <a:ext cx="11430000" cy="365760"/>
           </a:xfrm>
           <a:prstGeom prst="rect">
             <a:avLst/>
@@ -4500,84 +4802,42 @@
           </a:bodyPr>
           <a:lstStyle/>
           <a:p>
-            <a:pPr>
-              <a:spcAft>
-                <a:spcPts val="400"/>
-              </a:spcAft>
-              <a:defRPr sz="1500"/>
-            </a:pPr>
-            <a:r>
-              <a:t>• XGBoost: clear monotone CONVEX response — rate cuts raise prepayment probability more than rate rises suppress it</a:t>
-            </a:r>
-          </a:p>
-          <a:p>
-            <a:pPr>
-              <a:spcAft>
-                <a:spcPts val="400"/>
-              </a:spcAft>
-              <a:defRPr sz="1500"/>
-            </a:pPr>
-            <a:r>
-              <a:t>• Deep Cox: monotone but smoother — log-hazard is a less non-linear function of rate_incentive</a:t>
-            </a:r>
-          </a:p>
-          <a:p>
-            <a:pPr>
-              <a:spcAft>
-                <a:spcPts val="400"/>
-              </a:spcAft>
-              <a:defRPr sz="1500"/>
-            </a:pPr>
-            <a:r>
-              <a:t>• Asymmetry (−200 bp effect &gt; +200 bp effect) reflects the BURNOUT effect:</a:t>
-            </a:r>
-          </a:p>
-          <a:p>
-            <a:pPr>
-              <a:spcAft>
-                <a:spcPts val="400"/>
-              </a:spcAft>
-              <a:defRPr sz="1500"/>
-            </a:pPr>
-            <a:r>
-              <a:t>•    most rate-sensitive borrowers have already prepaid → muted upside response to cuts</a:t>
-            </a:r>
-          </a:p>
-          <a:p>
-            <a:pPr>
-              <a:spcAft>
-                <a:spcPts val="400"/>
-              </a:spcAft>
-              <a:defRPr sz="1500"/>
-            </a:pPr>
-            <a:r>
-              <a:t>• Both models agree on direction → robustness of rate-incentive channel across architectures</a:t>
-            </a:r>
-          </a:p>
-          <a:p>
-            <a:pPr>
-              <a:spcAft>
-                <a:spcPts val="400"/>
-              </a:spcAft>
-              <a:defRPr sz="1500"/>
-            </a:pPr>
-            <a:r>
-              <a:t>• Implication for MBS pricing: prepayment option has POSITIVE CONVEXITY —</a:t>
-            </a:r>
-          </a:p>
-          <a:p>
-            <a:pPr>
-              <a:spcAft>
-                <a:spcPts val="400"/>
-              </a:spcAft>
-              <a:defRPr sz="1500"/>
-            </a:pPr>
-            <a:r>
-              <a:t>•    rate decline creates more prepayment than rate rise suppresses it</a:t>
-            </a:r>
-          </a:p>
-        </p:txBody>
-      </p:sp>
+            <a:pPr algn="l"/>
+            <a:r>
+              <a:rPr sz="1300" b="0">
+                <a:solidFill>
+                  <a:srgbClr val="F2F2F2"/>
+                </a:solidFill>
+              </a:rPr>
+              <a:t>±100 bp and ±200 bp shocks to mortgage_rate  (rate_incentive updated consistently)</a:t>
+            </a:r>
+          </a:p>
+        </p:txBody>
+      </p:sp>
+      <p:pic>
+        <p:nvPicPr>
+          <p:cNvPr id="6" name="Picture 5" descr="E2_scenario_analysis.png"/>
+          <p:cNvPicPr>
+            <a:picLocks noChangeAspect="1"/>
+          </p:cNvPicPr>
+          <p:nvPr/>
+        </p:nvPicPr>
+        <p:blipFill>
+          <a:blip r:embed="rId2"/>
+          <a:stretch>
+            <a:fillRect/>
+          </a:stretch>
+        </p:blipFill>
+        <p:spPr>
+          <a:xfrm>
+            <a:off x="457200" y="1051560"/>
+            <a:ext cx="11247120" cy="3906695"/>
+          </a:xfrm>
+          <a:prstGeom prst="rect">
+            <a:avLst/>
+          </a:prstGeom>
+        </p:spPr>
+      </p:pic>
     </p:spTree>
   </p:cSld>
   <p:clrMapOvr>
@@ -4605,13 +4865,13 @@
         <p:spPr>
           <a:xfrm>
             <a:off x="0" y="0"/>
-            <a:ext cx="12188952" cy="1005840"/>
+            <a:ext cx="12188952" cy="960120"/>
           </a:xfrm>
           <a:prstGeom prst="rect">
             <a:avLst/>
           </a:prstGeom>
           <a:solidFill>
-            <a:srgbClr val="2C3E50"/>
+            <a:srgbClr val="1F3963"/>
           </a:solidFill>
           <a:ln>
             <a:noFill/>
@@ -4641,14 +4901,338 @@
       </p:sp>
       <p:sp>
         <p:nvSpPr>
-          <p:cNvPr id="3" name="TextBox 2"/>
+          <p:cNvPr id="3" name="Rectangle 2"/>
+          <p:cNvSpPr/>
+          <p:nvPr/>
+        </p:nvSpPr>
+        <p:spPr>
+          <a:xfrm>
+            <a:off x="0" y="960120"/>
+            <a:ext cx="12188952" cy="64008"/>
+          </a:xfrm>
+          <a:prstGeom prst="rect">
+            <a:avLst/>
+          </a:prstGeom>
+          <a:solidFill>
+            <a:srgbClr val="FFC000"/>
+          </a:solidFill>
+          <a:ln>
+            <a:noFill/>
+          </a:ln>
+        </p:spPr>
+        <p:style>
+          <a:lnRef idx="1">
+            <a:schemeClr val="accent1"/>
+          </a:lnRef>
+          <a:fillRef idx="3">
+            <a:schemeClr val="accent1"/>
+          </a:fillRef>
+          <a:effectRef idx="2">
+            <a:schemeClr val="accent1"/>
+          </a:effectRef>
+          <a:fontRef idx="minor">
+            <a:schemeClr val="lt1"/>
+          </a:fontRef>
+        </p:style>
+        <p:txBody>
+          <a:bodyPr rtlCol="0" anchor="ctr"/>
+          <a:lstStyle/>
+          <a:p>
+            <a:pPr algn="ctr"/>
+          </a:p>
+        </p:txBody>
+      </p:sp>
+      <p:sp>
+        <p:nvSpPr>
+          <p:cNvPr id="4" name="TextBox 3"/>
           <p:cNvSpPr txBox="1"/>
           <p:nvPr/>
         </p:nvSpPr>
         <p:spPr>
           <a:xfrm>
-            <a:off x="274320" y="73152"/>
-            <a:ext cx="10058400" cy="502920"/>
+            <a:off x="274320" y="54864"/>
+            <a:ext cx="11430000" cy="502920"/>
+          </a:xfrm>
+          <a:prstGeom prst="rect">
+            <a:avLst/>
+          </a:prstGeom>
+          <a:noFill/>
+        </p:spPr>
+        <p:txBody>
+          <a:bodyPr wrap="square">
+            <a:spAutoFit/>
+          </a:bodyPr>
+          <a:lstStyle/>
+          <a:p>
+            <a:pPr algn="l"/>
+            <a:r>
+              <a:rPr sz="2600" b="1">
+                <a:solidFill>
+                  <a:srgbClr val="FFFFFF"/>
+                </a:solidFill>
+              </a:rPr>
+              <a:t>E(iv) — Scenario Analysis: Interpretation</a:t>
+            </a:r>
+          </a:p>
+        </p:txBody>
+      </p:sp>
+      <p:sp>
+        <p:nvSpPr>
+          <p:cNvPr id="5" name="Rectangle 4"/>
+          <p:cNvSpPr/>
+          <p:nvPr/>
+        </p:nvSpPr>
+        <p:spPr>
+          <a:xfrm>
+            <a:off x="0" y="1005840"/>
+            <a:ext cx="12188952" cy="5852160"/>
+          </a:xfrm>
+          <a:prstGeom prst="rect">
+            <a:avLst/>
+          </a:prstGeom>
+          <a:solidFill>
+            <a:srgbClr val="F2F2F2"/>
+          </a:solidFill>
+          <a:ln>
+            <a:noFill/>
+          </a:ln>
+        </p:spPr>
+        <p:style>
+          <a:lnRef idx="1">
+            <a:schemeClr val="accent1"/>
+          </a:lnRef>
+          <a:fillRef idx="3">
+            <a:schemeClr val="accent1"/>
+          </a:fillRef>
+          <a:effectRef idx="2">
+            <a:schemeClr val="accent1"/>
+          </a:effectRef>
+          <a:fontRef idx="minor">
+            <a:schemeClr val="lt1"/>
+          </a:fontRef>
+        </p:style>
+        <p:txBody>
+          <a:bodyPr rtlCol="0" anchor="ctr"/>
+          <a:lstStyle/>
+          <a:p>
+            <a:pPr algn="ctr"/>
+          </a:p>
+        </p:txBody>
+      </p:sp>
+      <p:sp>
+        <p:nvSpPr>
+          <p:cNvPr id="6" name="TextBox 5"/>
+          <p:cNvSpPr txBox="1"/>
+          <p:nvPr/>
+        </p:nvSpPr>
+        <p:spPr>
+          <a:xfrm>
+            <a:off x="457200" y="1188720"/>
+            <a:ext cx="11247120" cy="5029200"/>
+          </a:xfrm>
+          <a:prstGeom prst="rect">
+            <a:avLst/>
+          </a:prstGeom>
+          <a:noFill/>
+        </p:spPr>
+        <p:txBody>
+          <a:bodyPr wrap="square">
+            <a:spAutoFit/>
+          </a:bodyPr>
+          <a:lstStyle/>
+          <a:p>
+            <a:pPr>
+              <a:spcAft>
+                <a:spcPts val="400"/>
+              </a:spcAft>
+              <a:defRPr sz="1500"/>
+            </a:pPr>
+            <a:r>
+              <a:t>• XGBoost: clear monotone CONVEX response — rate cuts raise prepayment probability more than rate rises suppress it</a:t>
+            </a:r>
+          </a:p>
+          <a:p>
+            <a:pPr>
+              <a:spcAft>
+                <a:spcPts val="400"/>
+              </a:spcAft>
+              <a:defRPr sz="1500"/>
+            </a:pPr>
+            <a:r>
+              <a:t>• Deep Cox: monotone but smoother — log-hazard is a less non-linear function of rate_incentive</a:t>
+            </a:r>
+          </a:p>
+          <a:p>
+            <a:pPr>
+              <a:spcAft>
+                <a:spcPts val="400"/>
+              </a:spcAft>
+              <a:defRPr sz="1500"/>
+            </a:pPr>
+            <a:r>
+              <a:t>• Asymmetry (−200 bp effect &gt; +200 bp effect) reflects the BURNOUT effect:</a:t>
+            </a:r>
+          </a:p>
+          <a:p>
+            <a:pPr>
+              <a:spcAft>
+                <a:spcPts val="400"/>
+              </a:spcAft>
+              <a:defRPr sz="1500"/>
+            </a:pPr>
+            <a:r>
+              <a:t>•    most rate-sensitive borrowers have already prepaid → muted upside response to cuts</a:t>
+            </a:r>
+          </a:p>
+          <a:p>
+            <a:pPr>
+              <a:spcAft>
+                <a:spcPts val="400"/>
+              </a:spcAft>
+              <a:defRPr sz="1500"/>
+            </a:pPr>
+            <a:r>
+              <a:t>• Both models agree on direction → robustness of rate-incentive channel across architectures</a:t>
+            </a:r>
+          </a:p>
+          <a:p>
+            <a:pPr>
+              <a:spcAft>
+                <a:spcPts val="400"/>
+              </a:spcAft>
+              <a:defRPr sz="1500"/>
+            </a:pPr>
+            <a:r>
+              <a:t>• Implication for MBS pricing: prepayment option has POSITIVE CONVEXITY —</a:t>
+            </a:r>
+          </a:p>
+          <a:p>
+            <a:pPr>
+              <a:spcAft>
+                <a:spcPts val="400"/>
+              </a:spcAft>
+              <a:defRPr sz="1500"/>
+            </a:pPr>
+            <a:r>
+              <a:t>•    rate decline creates more prepayment than rate rise suppresses it</a:t>
+            </a:r>
+          </a:p>
+        </p:txBody>
+      </p:sp>
+    </p:spTree>
+  </p:cSld>
+  <p:clrMapOvr>
+    <a:masterClrMapping/>
+  </p:clrMapOvr>
+</p:sld>
+</file>
+
+<file path=ppt/slides/slide17.xml><?xml version="1.0" encoding="utf-8"?>
+<p:sld xmlns:a="http://schemas.openxmlformats.org/drawingml/2006/main" xmlns:p="http://schemas.openxmlformats.org/presentationml/2006/main" xmlns:r="http://schemas.openxmlformats.org/officeDocument/2006/relationships">
+  <p:cSld>
+    <p:spTree>
+      <p:nvGrpSpPr>
+        <p:cNvPr id="1" name=""/>
+        <p:cNvGrpSpPr/>
+        <p:nvPr/>
+      </p:nvGrpSpPr>
+      <p:grpSpPr/>
+      <p:sp>
+        <p:nvSpPr>
+          <p:cNvPr id="2" name="Rectangle 1"/>
+          <p:cNvSpPr/>
+          <p:nvPr/>
+        </p:nvSpPr>
+        <p:spPr>
+          <a:xfrm>
+            <a:off x="0" y="0"/>
+            <a:ext cx="12188952" cy="960120"/>
+          </a:xfrm>
+          <a:prstGeom prst="rect">
+            <a:avLst/>
+          </a:prstGeom>
+          <a:solidFill>
+            <a:srgbClr val="1F3963"/>
+          </a:solidFill>
+          <a:ln>
+            <a:noFill/>
+          </a:ln>
+        </p:spPr>
+        <p:style>
+          <a:lnRef idx="1">
+            <a:schemeClr val="accent1"/>
+          </a:lnRef>
+          <a:fillRef idx="3">
+            <a:schemeClr val="accent1"/>
+          </a:fillRef>
+          <a:effectRef idx="2">
+            <a:schemeClr val="accent1"/>
+          </a:effectRef>
+          <a:fontRef idx="minor">
+            <a:schemeClr val="lt1"/>
+          </a:fontRef>
+        </p:style>
+        <p:txBody>
+          <a:bodyPr rtlCol="0" anchor="ctr"/>
+          <a:lstStyle/>
+          <a:p>
+            <a:pPr algn="ctr"/>
+          </a:p>
+        </p:txBody>
+      </p:sp>
+      <p:sp>
+        <p:nvSpPr>
+          <p:cNvPr id="3" name="Rectangle 2"/>
+          <p:cNvSpPr/>
+          <p:nvPr/>
+        </p:nvSpPr>
+        <p:spPr>
+          <a:xfrm>
+            <a:off x="0" y="960120"/>
+            <a:ext cx="12188952" cy="64008"/>
+          </a:xfrm>
+          <a:prstGeom prst="rect">
+            <a:avLst/>
+          </a:prstGeom>
+          <a:solidFill>
+            <a:srgbClr val="FFC000"/>
+          </a:solidFill>
+          <a:ln>
+            <a:noFill/>
+          </a:ln>
+        </p:spPr>
+        <p:style>
+          <a:lnRef idx="1">
+            <a:schemeClr val="accent1"/>
+          </a:lnRef>
+          <a:fillRef idx="3">
+            <a:schemeClr val="accent1"/>
+          </a:fillRef>
+          <a:effectRef idx="2">
+            <a:schemeClr val="accent1"/>
+          </a:effectRef>
+          <a:fontRef idx="minor">
+            <a:schemeClr val="lt1"/>
+          </a:fontRef>
+        </p:style>
+        <p:txBody>
+          <a:bodyPr rtlCol="0" anchor="ctr"/>
+          <a:lstStyle/>
+          <a:p>
+            <a:pPr algn="ctr"/>
+          </a:p>
+        </p:txBody>
+      </p:sp>
+      <p:sp>
+        <p:nvSpPr>
+          <p:cNvPr id="4" name="TextBox 3"/>
+          <p:cNvSpPr txBox="1"/>
+          <p:nvPr/>
+        </p:nvSpPr>
+        <p:spPr>
+          <a:xfrm>
+            <a:off x="274320" y="54864"/>
+            <a:ext cx="11430000" cy="502920"/>
           </a:xfrm>
           <a:prstGeom prst="rect">
             <a:avLst/>
@@ -4675,7 +5259,7 @@
       </p:sp>
       <p:sp>
         <p:nvSpPr>
-          <p:cNvPr id="4" name="Rectangle 3"/>
+          <p:cNvPr id="5" name="Rectangle 4"/>
           <p:cNvSpPr/>
           <p:nvPr/>
         </p:nvSpPr>
@@ -4688,7 +5272,7 @@
             <a:avLst/>
           </a:prstGeom>
           <a:solidFill>
-            <a:srgbClr val="ECF0F1"/>
+            <a:srgbClr val="F2F2F2"/>
           </a:solidFill>
           <a:ln>
             <a:noFill/>
@@ -4718,7 +5302,7 @@
       </p:sp>
       <p:sp>
         <p:nvSpPr>
-          <p:cNvPr id="5" name="Rectangle 4"/>
+          <p:cNvPr id="6" name="Rectangle 5"/>
           <p:cNvSpPr/>
           <p:nvPr/>
         </p:nvSpPr>
@@ -4731,7 +5315,7 @@
             <a:avLst/>
           </a:prstGeom>
           <a:solidFill>
-            <a:srgbClr val="2C3E50"/>
+            <a:srgbClr val="1F3963"/>
           </a:solidFill>
           <a:ln>
             <a:noFill/>
@@ -4761,7 +5345,7 @@
       </p:sp>
       <p:sp>
         <p:nvSpPr>
-          <p:cNvPr id="6" name="TextBox 5"/>
+          <p:cNvPr id="7" name="TextBox 6"/>
           <p:cNvSpPr txBox="1"/>
           <p:nvPr/>
         </p:nvSpPr>
@@ -4795,7 +5379,7 @@
       </p:sp>
       <p:sp>
         <p:nvSpPr>
-          <p:cNvPr id="7" name="TextBox 6"/>
+          <p:cNvPr id="8" name="TextBox 7"/>
           <p:cNvSpPr txBox="1"/>
           <p:nvPr/>
         </p:nvSpPr>
@@ -4819,7 +5403,7 @@
             <a:r>
               <a:rPr sz="1200" b="1">
                 <a:solidFill>
-                  <a:srgbClr val="2C3E50"/>
+                  <a:srgbClr val="1F3963"/>
                 </a:solidFill>
               </a:rPr>
               <a:t>Aalen-Johansen CIF</a:t>
@@ -4829,7 +5413,7 @@
       </p:sp>
       <p:sp>
         <p:nvSpPr>
-          <p:cNvPr id="8" name="TextBox 7"/>
+          <p:cNvPr id="9" name="TextBox 8"/>
           <p:cNvSpPr txBox="1"/>
           <p:nvPr/>
         </p:nvSpPr>
@@ -4853,7 +5437,7 @@
             <a:r>
               <a:rPr sz="1200" b="0">
                 <a:solidFill>
-                  <a:srgbClr val="2C3E50"/>
+                  <a:srgbClr val="1F3963"/>
                 </a:solidFill>
               </a:rPr>
               <a:t>10-yr prepay ≈ 45%;  default ≈ 2%</a:t>
@@ -4863,7 +5447,7 @@
       </p:sp>
       <p:sp>
         <p:nvSpPr>
-          <p:cNvPr id="9" name="Rectangle 8"/>
+          <p:cNvPr id="10" name="Rectangle 9"/>
           <p:cNvSpPr/>
           <p:nvPr/>
         </p:nvSpPr>
@@ -4876,7 +5460,7 @@
             <a:avLst/>
           </a:prstGeom>
           <a:solidFill>
-            <a:srgbClr val="2C3E50"/>
+            <a:srgbClr val="1F3963"/>
           </a:solidFill>
           <a:ln>
             <a:noFill/>
@@ -4906,7 +5490,7 @@
       </p:sp>
       <p:sp>
         <p:nvSpPr>
-          <p:cNvPr id="10" name="TextBox 9"/>
+          <p:cNvPr id="11" name="TextBox 10"/>
           <p:cNvSpPr txBox="1"/>
           <p:nvPr/>
         </p:nvSpPr>
@@ -4940,7 +5524,7 @@
       </p:sp>
       <p:sp>
         <p:nvSpPr>
-          <p:cNvPr id="11" name="TextBox 10"/>
+          <p:cNvPr id="12" name="TextBox 11"/>
           <p:cNvSpPr txBox="1"/>
           <p:nvPr/>
         </p:nvSpPr>
@@ -4964,7 +5548,7 @@
             <a:r>
               <a:rPr sz="1200" b="1">
                 <a:solidFill>
-                  <a:srgbClr val="2C3E50"/>
+                  <a:srgbClr val="1F3963"/>
                 </a:solidFill>
               </a:rPr>
               <a:t>KM vs AJ bias</a:t>
@@ -4974,7 +5558,7 @@
       </p:sp>
       <p:sp>
         <p:nvSpPr>
-          <p:cNvPr id="12" name="TextBox 11"/>
+          <p:cNvPr id="13" name="TextBox 12"/>
           <p:cNvSpPr txBox="1"/>
           <p:nvPr/>
         </p:nvSpPr>
@@ -4998,7 +5582,7 @@
             <a:r>
               <a:rPr sz="1200" b="0">
                 <a:solidFill>
-                  <a:srgbClr val="2C3E50"/>
+                  <a:srgbClr val="1F3963"/>
                 </a:solidFill>
               </a:rPr>
               <a:t>KM over-estimates by +0.5–2.2 pp at 5–20 yr</a:t>
@@ -5008,7 +5592,7 @@
       </p:sp>
       <p:sp>
         <p:nvSpPr>
-          <p:cNvPr id="13" name="Rectangle 12"/>
+          <p:cNvPr id="14" name="Rectangle 13"/>
           <p:cNvSpPr/>
           <p:nvPr/>
         </p:nvSpPr>
@@ -5021,7 +5605,7 @@
             <a:avLst/>
           </a:prstGeom>
           <a:solidFill>
-            <a:srgbClr val="2C3E50"/>
+            <a:srgbClr val="1F3963"/>
           </a:solidFill>
           <a:ln>
             <a:noFill/>
@@ -5051,7 +5635,7 @@
       </p:sp>
       <p:sp>
         <p:nvSpPr>
-          <p:cNvPr id="14" name="TextBox 13"/>
+          <p:cNvPr id="15" name="TextBox 14"/>
           <p:cNvSpPr txBox="1"/>
           <p:nvPr/>
         </p:nvSpPr>
@@ -5085,7 +5669,7 @@
       </p:sp>
       <p:sp>
         <p:nvSpPr>
-          <p:cNvPr id="15" name="TextBox 14"/>
+          <p:cNvPr id="16" name="TextBox 15"/>
           <p:cNvSpPr txBox="1"/>
           <p:nvPr/>
         </p:nvSpPr>
@@ -5109,7 +5693,7 @@
             <a:r>
               <a:rPr sz="1200" b="1">
                 <a:solidFill>
-                  <a:srgbClr val="2C3E50"/>
+                  <a:srgbClr val="1F3963"/>
                 </a:solidFill>
               </a:rPr>
               <a:t>Stratified CIF</a:t>
@@ -5119,7 +5703,7 @@
       </p:sp>
       <p:sp>
         <p:nvSpPr>
-          <p:cNvPr id="16" name="TextBox 15"/>
+          <p:cNvPr id="17" name="TextBox 16"/>
           <p:cNvSpPr txBox="1"/>
           <p:nvPr/>
         </p:nvSpPr>
@@ -5143,7 +5727,7 @@
             <a:r>
               <a:rPr sz="1200" b="0">
                 <a:solidFill>
-                  <a:srgbClr val="2C3E50"/>
+                  <a:srgbClr val="1F3963"/>
                 </a:solidFill>
               </a:rPr>
               <a:t>Crisis vintages 8–12× higher default CIF</a:t>
@@ -5153,7 +5737,7 @@
       </p:sp>
       <p:sp>
         <p:nvSpPr>
-          <p:cNvPr id="17" name="Rectangle 16"/>
+          <p:cNvPr id="18" name="Rectangle 17"/>
           <p:cNvSpPr/>
           <p:nvPr/>
         </p:nvSpPr>
@@ -5166,7 +5750,7 @@
             <a:avLst/>
           </a:prstGeom>
           <a:solidFill>
-            <a:srgbClr val="2C3E50"/>
+            <a:srgbClr val="1F3963"/>
           </a:solidFill>
           <a:ln>
             <a:noFill/>
@@ -5196,7 +5780,7 @@
       </p:sp>
       <p:sp>
         <p:nvSpPr>
-          <p:cNvPr id="18" name="TextBox 17"/>
+          <p:cNvPr id="19" name="TextBox 18"/>
           <p:cNvSpPr txBox="1"/>
           <p:nvPr/>
         </p:nvSpPr>
@@ -5230,7 +5814,7 @@
       </p:sp>
       <p:sp>
         <p:nvSpPr>
-          <p:cNvPr id="19" name="TextBox 18"/>
+          <p:cNvPr id="20" name="TextBox 19"/>
           <p:cNvSpPr txBox="1"/>
           <p:nvPr/>
         </p:nvSpPr>
@@ -5254,7 +5838,7 @@
             <a:r>
               <a:rPr sz="1200" b="1">
                 <a:solidFill>
-                  <a:srgbClr val="2C3E50"/>
+                  <a:srgbClr val="1F3963"/>
                 </a:solidFill>
               </a:rPr>
               <a:t>Cause-specific Cox</a:t>
@@ -5264,7 +5848,7 @@
       </p:sp>
       <p:sp>
         <p:nvSpPr>
-          <p:cNvPr id="20" name="TextBox 19"/>
+          <p:cNvPr id="21" name="TextBox 20"/>
           <p:cNvSpPr txBox="1"/>
           <p:nvPr/>
         </p:nvSpPr>
@@ -5288,7 +5872,7 @@
             <a:r>
               <a:rPr sz="1200" b="0">
                 <a:solidFill>
-                  <a:srgbClr val="2C3E50"/>
+                  <a:srgbClr val="1F3963"/>
                 </a:solidFill>
               </a:rPr>
               <a:t>CreditScore / LTV opposite signs across causes</a:t>
@@ -5298,7 +5882,7 @@
       </p:sp>
       <p:sp>
         <p:nvSpPr>
-          <p:cNvPr id="21" name="Rectangle 20"/>
+          <p:cNvPr id="22" name="Rectangle 21"/>
           <p:cNvSpPr/>
           <p:nvPr/>
         </p:nvSpPr>
@@ -5311,7 +5895,7 @@
             <a:avLst/>
           </a:prstGeom>
           <a:solidFill>
-            <a:srgbClr val="2C3E50"/>
+            <a:srgbClr val="1F3963"/>
           </a:solidFill>
           <a:ln>
             <a:noFill/>
@@ -5341,7 +5925,7 @@
       </p:sp>
       <p:sp>
         <p:nvSpPr>
-          <p:cNvPr id="22" name="TextBox 21"/>
+          <p:cNvPr id="23" name="TextBox 22"/>
           <p:cNvSpPr txBox="1"/>
           <p:nvPr/>
         </p:nvSpPr>
@@ -5375,7 +5959,7 @@
       </p:sp>
       <p:sp>
         <p:nvSpPr>
-          <p:cNvPr id="23" name="TextBox 22"/>
+          <p:cNvPr id="24" name="TextBox 23"/>
           <p:cNvSpPr txBox="1"/>
           <p:nvPr/>
         </p:nvSpPr>
@@ -5399,7 +5983,7 @@
             <a:r>
               <a:rPr sz="1200" b="1">
                 <a:solidFill>
-                  <a:srgbClr val="2C3E50"/>
+                  <a:srgbClr val="1F3963"/>
                 </a:solidFill>
               </a:rPr>
               <a:t>Fine-Gray</a:t>
@@ -5409,7 +5993,7 @@
       </p:sp>
       <p:sp>
         <p:nvSpPr>
-          <p:cNvPr id="24" name="TextBox 23"/>
+          <p:cNvPr id="25" name="TextBox 24"/>
           <p:cNvSpPr txBox="1"/>
           <p:nvPr/>
         </p:nvSpPr>
@@ -5433,7 +6017,7 @@
             <a:r>
               <a:rPr sz="1200" b="0">
                 <a:solidFill>
-                  <a:srgbClr val="2C3E50"/>
+                  <a:srgbClr val="1F3963"/>
                 </a:solidFill>
               </a:rPr>
               <a:t>rate_incentive HR larger vs cause-specific Cox</a:t>
@@ -5443,7 +6027,7 @@
       </p:sp>
       <p:sp>
         <p:nvSpPr>
-          <p:cNvPr id="25" name="Rectangle 24"/>
+          <p:cNvPr id="26" name="Rectangle 25"/>
           <p:cNvSpPr/>
           <p:nvPr/>
         </p:nvSpPr>
@@ -5456,7 +6040,7 @@
             <a:avLst/>
           </a:prstGeom>
           <a:solidFill>
-            <a:srgbClr val="2C3E50"/>
+            <a:srgbClr val="1F3963"/>
           </a:solidFill>
           <a:ln>
             <a:noFill/>
@@ -5486,7 +6070,7 @@
       </p:sp>
       <p:sp>
         <p:nvSpPr>
-          <p:cNvPr id="26" name="TextBox 25"/>
+          <p:cNvPr id="27" name="TextBox 26"/>
           <p:cNvSpPr txBox="1"/>
           <p:nvPr/>
         </p:nvSpPr>
@@ -5520,7 +6104,7 @@
       </p:sp>
       <p:sp>
         <p:nvSpPr>
-          <p:cNvPr id="27" name="TextBox 26"/>
+          <p:cNvPr id="28" name="TextBox 27"/>
           <p:cNvSpPr txBox="1"/>
           <p:nvPr/>
         </p:nvSpPr>
@@ -5544,7 +6128,7 @@
             <a:r>
               <a:rPr sz="1200" b="1">
                 <a:solidFill>
-                  <a:srgbClr val="2C3E50"/>
+                  <a:srgbClr val="1F3963"/>
                 </a:solidFill>
               </a:rPr>
               <a:t>Andersen-Gill TV Cox</a:t>
@@ -5554,7 +6138,7 @@
       </p:sp>
       <p:sp>
         <p:nvSpPr>
-          <p:cNvPr id="28" name="TextBox 27"/>
+          <p:cNvPr id="29" name="TextBox 28"/>
           <p:cNvSpPr txBox="1"/>
           <p:nvPr/>
         </p:nvSpPr>
@@ -5578,7 +6162,7 @@
             <a:r>
               <a:rPr sz="1200" b="0">
                 <a:solidFill>
-                  <a:srgbClr val="2C3E50"/>
+                  <a:srgbClr val="1F3963"/>
                 </a:solidFill>
               </a:rPr>
               <a:t>Current rate_incentive &gt; origination snapshot</a:t>
@@ -5588,7 +6172,7 @@
       </p:sp>
       <p:sp>
         <p:nvSpPr>
-          <p:cNvPr id="29" name="Rectangle 28"/>
+          <p:cNvPr id="30" name="Rectangle 29"/>
           <p:cNvSpPr/>
           <p:nvPr/>
         </p:nvSpPr>
@@ -5601,7 +6185,7 @@
             <a:avLst/>
           </a:prstGeom>
           <a:solidFill>
-            <a:srgbClr val="2C3E50"/>
+            <a:srgbClr val="1F3963"/>
           </a:solidFill>
           <a:ln>
             <a:noFill/>
@@ -5631,7 +6215,7 @@
       </p:sp>
       <p:sp>
         <p:nvSpPr>
-          <p:cNvPr id="30" name="TextBox 29"/>
+          <p:cNvPr id="31" name="TextBox 30"/>
           <p:cNvSpPr txBox="1"/>
           <p:nvPr/>
         </p:nvSpPr>
@@ -5665,7 +6249,7 @@
       </p:sp>
       <p:sp>
         <p:nvSpPr>
-          <p:cNvPr id="31" name="TextBox 30"/>
+          <p:cNvPr id="32" name="TextBox 31"/>
           <p:cNvSpPr txBox="1"/>
           <p:nvPr/>
         </p:nvSpPr>
@@ -5689,7 +6273,7 @@
             <a:r>
               <a:rPr sz="1200" b="1">
                 <a:solidFill>
-                  <a:srgbClr val="2C3E50"/>
+                  <a:srgbClr val="1F3963"/>
                 </a:solidFill>
               </a:rPr>
               <a:t>Scenario analysis</a:t>
@@ -5699,7 +6283,7 @@
       </p:sp>
       <p:sp>
         <p:nvSpPr>
-          <p:cNvPr id="32" name="TextBox 31"/>
+          <p:cNvPr id="33" name="TextBox 32"/>
           <p:cNvSpPr txBox="1"/>
           <p:nvPr/>
         </p:nvSpPr>
@@ -5723,7 +6307,7 @@
             <a:r>
               <a:rPr sz="1200" b="0">
                 <a:solidFill>
-                  <a:srgbClr val="2C3E50"/>
+                  <a:srgbClr val="1F3963"/>
                 </a:solidFill>
               </a:rPr>
               <a:t>Convex, asymmetric prepayment response to rate shocks</a:t>
@@ -5758,13 +6342,13 @@
         <p:spPr>
           <a:xfrm>
             <a:off x="0" y="0"/>
-            <a:ext cx="12188952" cy="1005840"/>
+            <a:ext cx="12188952" cy="960120"/>
           </a:xfrm>
           <a:prstGeom prst="rect">
             <a:avLst/>
           </a:prstGeom>
           <a:solidFill>
-            <a:srgbClr val="2C3E50"/>
+            <a:srgbClr val="1F3963"/>
           </a:solidFill>
           <a:ln>
             <a:noFill/>
@@ -5794,14 +6378,57 @@
       </p:sp>
       <p:sp>
         <p:nvSpPr>
-          <p:cNvPr id="3" name="TextBox 2"/>
+          <p:cNvPr id="3" name="Rectangle 2"/>
+          <p:cNvSpPr/>
+          <p:nvPr/>
+        </p:nvSpPr>
+        <p:spPr>
+          <a:xfrm>
+            <a:off x="0" y="960120"/>
+            <a:ext cx="12188952" cy="64008"/>
+          </a:xfrm>
+          <a:prstGeom prst="rect">
+            <a:avLst/>
+          </a:prstGeom>
+          <a:solidFill>
+            <a:srgbClr val="FFC000"/>
+          </a:solidFill>
+          <a:ln>
+            <a:noFill/>
+          </a:ln>
+        </p:spPr>
+        <p:style>
+          <a:lnRef idx="1">
+            <a:schemeClr val="accent1"/>
+          </a:lnRef>
+          <a:fillRef idx="3">
+            <a:schemeClr val="accent1"/>
+          </a:fillRef>
+          <a:effectRef idx="2">
+            <a:schemeClr val="accent1"/>
+          </a:effectRef>
+          <a:fontRef idx="minor">
+            <a:schemeClr val="lt1"/>
+          </a:fontRef>
+        </p:style>
+        <p:txBody>
+          <a:bodyPr rtlCol="0" anchor="ctr"/>
+          <a:lstStyle/>
+          <a:p>
+            <a:pPr algn="ctr"/>
+          </a:p>
+        </p:txBody>
+      </p:sp>
+      <p:sp>
+        <p:nvSpPr>
+          <p:cNvPr id="4" name="TextBox 3"/>
           <p:cNvSpPr txBox="1"/>
           <p:nvPr/>
         </p:nvSpPr>
         <p:spPr>
           <a:xfrm>
-            <a:off x="274320" y="73152"/>
-            <a:ext cx="10058400" cy="502920"/>
+            <a:off x="274320" y="54864"/>
+            <a:ext cx="11430000" cy="502920"/>
           </a:xfrm>
           <a:prstGeom prst="rect">
             <a:avLst/>
@@ -5828,14 +6455,14 @@
       </p:sp>
       <p:sp>
         <p:nvSpPr>
-          <p:cNvPr id="4" name="TextBox 3"/>
+          <p:cNvPr id="5" name="TextBox 4"/>
           <p:cNvSpPr txBox="1"/>
           <p:nvPr/>
         </p:nvSpPr>
         <p:spPr>
           <a:xfrm>
-            <a:off x="274320" y="566928"/>
-            <a:ext cx="10058400" cy="365760"/>
+            <a:off x="274320" y="548640"/>
+            <a:ext cx="11430000" cy="365760"/>
           </a:xfrm>
           <a:prstGeom prst="rect">
             <a:avLst/>
@@ -5850,9 +6477,9 @@
           <a:p>
             <a:pPr algn="l"/>
             <a:r>
-              <a:rPr sz="1400" b="0">
+              <a:rPr sz="1300" b="0">
                 <a:solidFill>
-                  <a:srgbClr val="ECF0F1"/>
+                  <a:srgbClr val="F2F2F2"/>
                 </a:solidFill>
               </a:rPr>
               <a:t>Four extension tracks</a:t>
@@ -5862,7 +6489,7 @@
       </p:sp>
       <p:sp>
         <p:nvSpPr>
-          <p:cNvPr id="5" name="Rectangle 4"/>
+          <p:cNvPr id="6" name="Rectangle 5"/>
           <p:cNvSpPr/>
           <p:nvPr/>
         </p:nvSpPr>
@@ -5875,7 +6502,7 @@
             <a:avLst/>
           </a:prstGeom>
           <a:solidFill>
-            <a:srgbClr val="ECF0F1"/>
+            <a:srgbClr val="F2F2F2"/>
           </a:solidFill>
           <a:ln>
             <a:noFill/>
@@ -5905,7 +6532,7 @@
       </p:sp>
       <p:sp>
         <p:nvSpPr>
-          <p:cNvPr id="6" name="TextBox 5"/>
+          <p:cNvPr id="7" name="TextBox 6"/>
           <p:cNvSpPr txBox="1"/>
           <p:nvPr/>
         </p:nvSpPr>
@@ -5997,13 +6624,13 @@
         <p:spPr>
           <a:xfrm>
             <a:off x="0" y="0"/>
-            <a:ext cx="12188952" cy="1005840"/>
+            <a:ext cx="12188952" cy="960120"/>
           </a:xfrm>
           <a:prstGeom prst="rect">
             <a:avLst/>
           </a:prstGeom>
           <a:solidFill>
-            <a:srgbClr val="2C3E50"/>
+            <a:srgbClr val="1F3963"/>
           </a:solidFill>
           <a:ln>
             <a:noFill/>
@@ -6033,14 +6660,57 @@
       </p:sp>
       <p:sp>
         <p:nvSpPr>
-          <p:cNvPr id="3" name="TextBox 2"/>
+          <p:cNvPr id="3" name="Rectangle 2"/>
+          <p:cNvSpPr/>
+          <p:nvPr/>
+        </p:nvSpPr>
+        <p:spPr>
+          <a:xfrm>
+            <a:off x="0" y="960120"/>
+            <a:ext cx="12188952" cy="64008"/>
+          </a:xfrm>
+          <a:prstGeom prst="rect">
+            <a:avLst/>
+          </a:prstGeom>
+          <a:solidFill>
+            <a:srgbClr val="FFC000"/>
+          </a:solidFill>
+          <a:ln>
+            <a:noFill/>
+          </a:ln>
+        </p:spPr>
+        <p:style>
+          <a:lnRef idx="1">
+            <a:schemeClr val="accent1"/>
+          </a:lnRef>
+          <a:fillRef idx="3">
+            <a:schemeClr val="accent1"/>
+          </a:fillRef>
+          <a:effectRef idx="2">
+            <a:schemeClr val="accent1"/>
+          </a:effectRef>
+          <a:fontRef idx="minor">
+            <a:schemeClr val="lt1"/>
+          </a:fontRef>
+        </p:style>
+        <p:txBody>
+          <a:bodyPr rtlCol="0" anchor="ctr"/>
+          <a:lstStyle/>
+          <a:p>
+            <a:pPr algn="ctr"/>
+          </a:p>
+        </p:txBody>
+      </p:sp>
+      <p:sp>
+        <p:nvSpPr>
+          <p:cNvPr id="4" name="TextBox 3"/>
           <p:cNvSpPr txBox="1"/>
           <p:nvPr/>
         </p:nvSpPr>
         <p:spPr>
           <a:xfrm>
-            <a:off x="274320" y="73152"/>
-            <a:ext cx="10058400" cy="502920"/>
+            <a:off x="274320" y="54864"/>
+            <a:ext cx="11430000" cy="502920"/>
           </a:xfrm>
           <a:prstGeom prst="rect">
             <a:avLst/>
@@ -6067,14 +6737,14 @@
       </p:sp>
       <p:sp>
         <p:nvSpPr>
-          <p:cNvPr id="4" name="TextBox 3"/>
+          <p:cNvPr id="5" name="TextBox 4"/>
           <p:cNvSpPr txBox="1"/>
           <p:nvPr/>
         </p:nvSpPr>
         <p:spPr>
           <a:xfrm>
-            <a:off x="274320" y="566928"/>
-            <a:ext cx="10058400" cy="365760"/>
+            <a:off x="274320" y="548640"/>
+            <a:ext cx="11430000" cy="365760"/>
           </a:xfrm>
           <a:prstGeom prst="rect">
             <a:avLst/>
@@ -6089,9 +6759,9 @@
           <a:p>
             <a:pPr algn="l"/>
             <a:r>
-              <a:rPr sz="1400" b="0">
+              <a:rPr sz="1300" b="0">
                 <a:solidFill>
-                  <a:srgbClr val="ECF0F1"/>
+                  <a:srgbClr val="F2F2F2"/>
                 </a:solidFill>
               </a:rPr>
               <a:t>Prepaid: median ~40 mo  |  Defaulted: median ~55 mo  |  full 34M-loan dataset</a:t>
@@ -6101,7 +6771,7 @@
       </p:sp>
       <p:pic>
         <p:nvPicPr>
-          <p:cNvPr id="5" name="Picture 4" descr="E1_eda_duration.png"/>
+          <p:cNvPr id="6" name="Picture 5" descr="E1_eda_duration.png"/>
           <p:cNvPicPr>
             <a:picLocks noChangeAspect="1"/>
           </p:cNvPicPr>
@@ -6150,13 +6820,13 @@
         <p:spPr>
           <a:xfrm>
             <a:off x="0" y="0"/>
-            <a:ext cx="12188952" cy="1005840"/>
+            <a:ext cx="12188952" cy="960120"/>
           </a:xfrm>
           <a:prstGeom prst="rect">
             <a:avLst/>
           </a:prstGeom>
           <a:solidFill>
-            <a:srgbClr val="2C3E50"/>
+            <a:srgbClr val="1F3963"/>
           </a:solidFill>
           <a:ln>
             <a:noFill/>
@@ -6186,14 +6856,57 @@
       </p:sp>
       <p:sp>
         <p:nvSpPr>
-          <p:cNvPr id="3" name="TextBox 2"/>
+          <p:cNvPr id="3" name="Rectangle 2"/>
+          <p:cNvSpPr/>
+          <p:nvPr/>
+        </p:nvSpPr>
+        <p:spPr>
+          <a:xfrm>
+            <a:off x="0" y="960120"/>
+            <a:ext cx="12188952" cy="64008"/>
+          </a:xfrm>
+          <a:prstGeom prst="rect">
+            <a:avLst/>
+          </a:prstGeom>
+          <a:solidFill>
+            <a:srgbClr val="FFC000"/>
+          </a:solidFill>
+          <a:ln>
+            <a:noFill/>
+          </a:ln>
+        </p:spPr>
+        <p:style>
+          <a:lnRef idx="1">
+            <a:schemeClr val="accent1"/>
+          </a:lnRef>
+          <a:fillRef idx="3">
+            <a:schemeClr val="accent1"/>
+          </a:fillRef>
+          <a:effectRef idx="2">
+            <a:schemeClr val="accent1"/>
+          </a:effectRef>
+          <a:fontRef idx="minor">
+            <a:schemeClr val="lt1"/>
+          </a:fontRef>
+        </p:style>
+        <p:txBody>
+          <a:bodyPr rtlCol="0" anchor="ctr"/>
+          <a:lstStyle/>
+          <a:p>
+            <a:pPr algn="ctr"/>
+          </a:p>
+        </p:txBody>
+      </p:sp>
+      <p:sp>
+        <p:nvSpPr>
+          <p:cNvPr id="4" name="TextBox 3"/>
           <p:cNvSpPr txBox="1"/>
           <p:nvPr/>
         </p:nvSpPr>
         <p:spPr>
           <a:xfrm>
-            <a:off x="274320" y="73152"/>
-            <a:ext cx="10058400" cy="502920"/>
+            <a:off x="274320" y="54864"/>
+            <a:ext cx="11430000" cy="502920"/>
           </a:xfrm>
           <a:prstGeom prst="rect">
             <a:avLst/>
@@ -6220,7 +6933,7 @@
       </p:sp>
       <p:pic>
         <p:nvPicPr>
-          <p:cNvPr id="4" name="Picture 3" descr="E1_eda_vintage.png"/>
+          <p:cNvPr id="5" name="Picture 4" descr="E1_eda_vintage.png"/>
           <p:cNvPicPr>
             <a:picLocks noChangeAspect="1"/>
           </p:cNvPicPr>
@@ -6244,7 +6957,7 @@
       </p:pic>
       <p:pic>
         <p:nvPicPr>
-          <p:cNvPr id="5" name="Picture 4" descr="E1_eda_categorical.png"/>
+          <p:cNvPr id="6" name="Picture 5" descr="E1_eda_categorical.png"/>
           <p:cNvPicPr>
             <a:picLocks noChangeAspect="1"/>
           </p:cNvPicPr>
@@ -6293,13 +7006,13 @@
         <p:spPr>
           <a:xfrm>
             <a:off x="0" y="0"/>
-            <a:ext cx="12188952" cy="1005840"/>
+            <a:ext cx="12188952" cy="960120"/>
           </a:xfrm>
           <a:prstGeom prst="rect">
             <a:avLst/>
           </a:prstGeom>
           <a:solidFill>
-            <a:srgbClr val="2C3E50"/>
+            <a:srgbClr val="1F3963"/>
           </a:solidFill>
           <a:ln>
             <a:noFill/>
@@ -6329,14 +7042,57 @@
       </p:sp>
       <p:sp>
         <p:nvSpPr>
-          <p:cNvPr id="3" name="TextBox 2"/>
+          <p:cNvPr id="3" name="Rectangle 2"/>
+          <p:cNvSpPr/>
+          <p:nvPr/>
+        </p:nvSpPr>
+        <p:spPr>
+          <a:xfrm>
+            <a:off x="0" y="960120"/>
+            <a:ext cx="12188952" cy="64008"/>
+          </a:xfrm>
+          <a:prstGeom prst="rect">
+            <a:avLst/>
+          </a:prstGeom>
+          <a:solidFill>
+            <a:srgbClr val="FFC000"/>
+          </a:solidFill>
+          <a:ln>
+            <a:noFill/>
+          </a:ln>
+        </p:spPr>
+        <p:style>
+          <a:lnRef idx="1">
+            <a:schemeClr val="accent1"/>
+          </a:lnRef>
+          <a:fillRef idx="3">
+            <a:schemeClr val="accent1"/>
+          </a:fillRef>
+          <a:effectRef idx="2">
+            <a:schemeClr val="accent1"/>
+          </a:effectRef>
+          <a:fontRef idx="minor">
+            <a:schemeClr val="lt1"/>
+          </a:fontRef>
+        </p:style>
+        <p:txBody>
+          <a:bodyPr rtlCol="0" anchor="ctr"/>
+          <a:lstStyle/>
+          <a:p>
+            <a:pPr algn="ctr"/>
+          </a:p>
+        </p:txBody>
+      </p:sp>
+      <p:sp>
+        <p:nvSpPr>
+          <p:cNvPr id="4" name="TextBox 3"/>
           <p:cNvSpPr txBox="1"/>
           <p:nvPr/>
         </p:nvSpPr>
         <p:spPr>
           <a:xfrm>
-            <a:off x="274320" y="73152"/>
-            <a:ext cx="10058400" cy="502920"/>
+            <a:off x="274320" y="54864"/>
+            <a:ext cx="11430000" cy="502920"/>
           </a:xfrm>
           <a:prstGeom prst="rect">
             <a:avLst/>
@@ -6363,14 +7119,14 @@
       </p:sp>
       <p:sp>
         <p:nvSpPr>
-          <p:cNvPr id="4" name="TextBox 3"/>
+          <p:cNvPr id="5" name="TextBox 4"/>
           <p:cNvSpPr txBox="1"/>
           <p:nvPr/>
         </p:nvSpPr>
         <p:spPr>
           <a:xfrm>
-            <a:off x="274320" y="566928"/>
-            <a:ext cx="10058400" cy="365760"/>
+            <a:off x="274320" y="548640"/>
+            <a:ext cx="11430000" cy="365760"/>
           </a:xfrm>
           <a:prstGeom prst="rect">
             <a:avLst/>
@@ -6385,9 +7141,9 @@
           <a:p>
             <a:pPr algn="l"/>
             <a:r>
-              <a:rPr sz="1400" b="0">
+              <a:rPr sz="1300" b="0">
                 <a:solidFill>
-                  <a:srgbClr val="ECF0F1"/>
+                  <a:srgbClr val="F2F2F2"/>
                 </a:solidFill>
               </a:rPr>
               <a:t>Cause-specific Nelson-Aalen smooth · burnout visible in prepayment hazard · 100K sample</a:t>
@@ -6397,7 +7153,7 @@
       </p:sp>
       <p:pic>
         <p:nvPicPr>
-          <p:cNvPr id="5" name="Picture 4" descr="E1_hazard_overall.png"/>
+          <p:cNvPr id="6" name="Picture 5" descr="E1_hazard_overall.png"/>
           <p:cNvPicPr>
             <a:picLocks noChangeAspect="1"/>
           </p:cNvPicPr>
@@ -6446,13 +7202,13 @@
         <p:spPr>
           <a:xfrm>
             <a:off x="0" y="0"/>
-            <a:ext cx="12188952" cy="1005840"/>
+            <a:ext cx="12188952" cy="960120"/>
           </a:xfrm>
           <a:prstGeom prst="rect">
             <a:avLst/>
           </a:prstGeom>
           <a:solidFill>
-            <a:srgbClr val="2C3E50"/>
+            <a:srgbClr val="1F3963"/>
           </a:solidFill>
           <a:ln>
             <a:noFill/>
@@ -6482,14 +7238,57 @@
       </p:sp>
       <p:sp>
         <p:nvSpPr>
-          <p:cNvPr id="3" name="TextBox 2"/>
+          <p:cNvPr id="3" name="Rectangle 2"/>
+          <p:cNvSpPr/>
+          <p:nvPr/>
+        </p:nvSpPr>
+        <p:spPr>
+          <a:xfrm>
+            <a:off x="0" y="960120"/>
+            <a:ext cx="12188952" cy="64008"/>
+          </a:xfrm>
+          <a:prstGeom prst="rect">
+            <a:avLst/>
+          </a:prstGeom>
+          <a:solidFill>
+            <a:srgbClr val="FFC000"/>
+          </a:solidFill>
+          <a:ln>
+            <a:noFill/>
+          </a:ln>
+        </p:spPr>
+        <p:style>
+          <a:lnRef idx="1">
+            <a:schemeClr val="accent1"/>
+          </a:lnRef>
+          <a:fillRef idx="3">
+            <a:schemeClr val="accent1"/>
+          </a:fillRef>
+          <a:effectRef idx="2">
+            <a:schemeClr val="accent1"/>
+          </a:effectRef>
+          <a:fontRef idx="minor">
+            <a:schemeClr val="lt1"/>
+          </a:fontRef>
+        </p:style>
+        <p:txBody>
+          <a:bodyPr rtlCol="0" anchor="ctr"/>
+          <a:lstStyle/>
+          <a:p>
+            <a:pPr algn="ctr"/>
+          </a:p>
+        </p:txBody>
+      </p:sp>
+      <p:sp>
+        <p:nvSpPr>
+          <p:cNvPr id="4" name="TextBox 3"/>
           <p:cNvSpPr txBox="1"/>
           <p:nvPr/>
         </p:nvSpPr>
         <p:spPr>
           <a:xfrm>
-            <a:off x="274320" y="73152"/>
-            <a:ext cx="10058400" cy="502920"/>
+            <a:off x="274320" y="54864"/>
+            <a:ext cx="11430000" cy="502920"/>
           </a:xfrm>
           <a:prstGeom prst="rect">
             <a:avLst/>
@@ -6516,14 +7315,14 @@
       </p:sp>
       <p:sp>
         <p:nvSpPr>
-          <p:cNvPr id="4" name="TextBox 3"/>
+          <p:cNvPr id="5" name="TextBox 4"/>
           <p:cNvSpPr txBox="1"/>
           <p:nvPr/>
         </p:nvSpPr>
         <p:spPr>
           <a:xfrm>
-            <a:off x="274320" y="566928"/>
-            <a:ext cx="10058400" cy="365760"/>
+            <a:off x="274320" y="548640"/>
+            <a:ext cx="11430000" cy="365760"/>
           </a:xfrm>
           <a:prstGeom prst="rect">
             <a:avLst/>
@@ -6538,9 +7337,9 @@
           <a:p>
             <a:pPr algn="l"/>
             <a:r>
-              <a:rPr sz="1400" b="0">
+              <a:rPr sz="1300" b="0">
                 <a:solidFill>
-                  <a:srgbClr val="ECF0F1"/>
+                  <a:srgbClr val="F2F2F2"/>
                 </a:solidFill>
               </a:rPr>
               <a:t>High-FICO refinances fastest · High-LTV defaults persist longer · GFC vintages spike</a:t>
@@ -6550,7 +7349,7 @@
       </p:sp>
       <p:pic>
         <p:nvPicPr>
-          <p:cNvPr id="5" name="Picture 4" descr="E1_hazard_stratified.png"/>
+          <p:cNvPr id="6" name="Picture 5" descr="E1_hazard_stratified.png"/>
           <p:cNvPicPr>
             <a:picLocks noChangeAspect="1"/>
           </p:cNvPicPr>
@@ -6599,13 +7398,13 @@
         <p:spPr>
           <a:xfrm>
             <a:off x="0" y="0"/>
-            <a:ext cx="12188952" cy="1005840"/>
+            <a:ext cx="12188952" cy="960120"/>
           </a:xfrm>
           <a:prstGeom prst="rect">
             <a:avLst/>
           </a:prstGeom>
           <a:solidFill>
-            <a:srgbClr val="2C3E50"/>
+            <a:srgbClr val="1F3963"/>
           </a:solidFill>
           <a:ln>
             <a:noFill/>
@@ -6635,14 +7434,57 @@
       </p:sp>
       <p:sp>
         <p:nvSpPr>
-          <p:cNvPr id="3" name="TextBox 2"/>
+          <p:cNvPr id="3" name="Rectangle 2"/>
+          <p:cNvSpPr/>
+          <p:nvPr/>
+        </p:nvSpPr>
+        <p:spPr>
+          <a:xfrm>
+            <a:off x="0" y="960120"/>
+            <a:ext cx="12188952" cy="64008"/>
+          </a:xfrm>
+          <a:prstGeom prst="rect">
+            <a:avLst/>
+          </a:prstGeom>
+          <a:solidFill>
+            <a:srgbClr val="FFC000"/>
+          </a:solidFill>
+          <a:ln>
+            <a:noFill/>
+          </a:ln>
+        </p:spPr>
+        <p:style>
+          <a:lnRef idx="1">
+            <a:schemeClr val="accent1"/>
+          </a:lnRef>
+          <a:fillRef idx="3">
+            <a:schemeClr val="accent1"/>
+          </a:fillRef>
+          <a:effectRef idx="2">
+            <a:schemeClr val="accent1"/>
+          </a:effectRef>
+          <a:fontRef idx="minor">
+            <a:schemeClr val="lt1"/>
+          </a:fontRef>
+        </p:style>
+        <p:txBody>
+          <a:bodyPr rtlCol="0" anchor="ctr"/>
+          <a:lstStyle/>
+          <a:p>
+            <a:pPr algn="ctr"/>
+          </a:p>
+        </p:txBody>
+      </p:sp>
+      <p:sp>
+        <p:nvSpPr>
+          <p:cNvPr id="4" name="TextBox 3"/>
           <p:cNvSpPr txBox="1"/>
           <p:nvPr/>
         </p:nvSpPr>
         <p:spPr>
           <a:xfrm>
-            <a:off x="274320" y="73152"/>
-            <a:ext cx="10058400" cy="502920"/>
+            <a:off x="274320" y="54864"/>
+            <a:ext cx="11430000" cy="502920"/>
           </a:xfrm>
           <a:prstGeom prst="rect">
             <a:avLst/>
@@ -6662,21 +7504,21 @@
                   <a:srgbClr val="FFFFFF"/>
                 </a:solidFill>
               </a:rPr>
-              <a:t>E(i)(b) — Aalen-Johansen CIF</a:t>
-            </a:r>
-          </a:p>
-        </p:txBody>
-      </p:sp>
-      <p:sp>
-        <p:nvSpPr>
-          <p:cNvPr id="4" name="TextBox 3"/>
+              <a:t>E(i)(b) — Aalen-Johansen CIF: Formula &amp; Contrast</a:t>
+            </a:r>
+          </a:p>
+        </p:txBody>
+      </p:sp>
+      <p:sp>
+        <p:nvSpPr>
+          <p:cNvPr id="5" name="TextBox 4"/>
           <p:cNvSpPr txBox="1"/>
           <p:nvPr/>
         </p:nvSpPr>
         <p:spPr>
           <a:xfrm>
-            <a:off x="274320" y="566928"/>
-            <a:ext cx="10058400" cy="365760"/>
+            <a:off x="274320" y="548640"/>
+            <a:ext cx="11430000" cy="365760"/>
           </a:xfrm>
           <a:prstGeom prst="rect">
             <a:avLst/>
@@ -6691,19 +7533,461 @@
           <a:p>
             <a:pPr algn="l"/>
             <a:r>
-              <a:rPr sz="1400" b="0">
+              <a:rPr sz="1300" b="0">
                 <a:solidFill>
-                  <a:srgbClr val="ECF0F1"/>
+                  <a:srgbClr val="F2F2F2"/>
                 </a:solidFill>
               </a:rPr>
-              <a:t>Correct competing-risks treatment; 10-yr prepay ≈ 45%,  default ≈ 2%</a:t>
+              <a:t>AJ correctly weights each increment by the overall survival probability</a:t>
+            </a:r>
+          </a:p>
+        </p:txBody>
+      </p:sp>
+      <p:sp>
+        <p:nvSpPr>
+          <p:cNvPr id="6" name="Rectangle 5"/>
+          <p:cNvSpPr/>
+          <p:nvPr/>
+        </p:nvSpPr>
+        <p:spPr>
+          <a:xfrm>
+            <a:off x="0" y="1024128"/>
+            <a:ext cx="12188952" cy="5833872"/>
+          </a:xfrm>
+          <a:prstGeom prst="rect">
+            <a:avLst/>
+          </a:prstGeom>
+          <a:solidFill>
+            <a:srgbClr val="F2F2F2"/>
+          </a:solidFill>
+          <a:ln>
+            <a:noFill/>
+          </a:ln>
+        </p:spPr>
+        <p:style>
+          <a:lnRef idx="1">
+            <a:schemeClr val="accent1"/>
+          </a:lnRef>
+          <a:fillRef idx="3">
+            <a:schemeClr val="accent1"/>
+          </a:fillRef>
+          <a:effectRef idx="2">
+            <a:schemeClr val="accent1"/>
+          </a:effectRef>
+          <a:fontRef idx="minor">
+            <a:schemeClr val="lt1"/>
+          </a:fontRef>
+        </p:style>
+        <p:txBody>
+          <a:bodyPr rtlCol="0" anchor="ctr"/>
+          <a:lstStyle/>
+          <a:p>
+            <a:pPr algn="ctr"/>
+          </a:p>
+        </p:txBody>
+      </p:sp>
+      <p:sp>
+        <p:nvSpPr>
+          <p:cNvPr id="7" name="TextBox 6"/>
+          <p:cNvSpPr txBox="1"/>
+          <p:nvPr/>
+        </p:nvSpPr>
+        <p:spPr>
+          <a:xfrm>
+            <a:off x="274320" y="1143000"/>
+            <a:ext cx="11612880" cy="365760"/>
+          </a:xfrm>
+          <a:prstGeom prst="rect">
+            <a:avLst/>
+          </a:prstGeom>
+          <a:noFill/>
+        </p:spPr>
+        <p:txBody>
+          <a:bodyPr wrap="square">
+            <a:spAutoFit/>
+          </a:bodyPr>
+          <a:lstStyle/>
+          <a:p>
+            <a:pPr algn="l"/>
+            <a:r>
+              <a:rPr sz="1300" b="1">
+                <a:solidFill>
+                  <a:srgbClr val="C00000"/>
+                </a:solidFill>
+              </a:rPr>
+              <a:t>Kaplan-Meier  (INCORRECT — treats competing exits as censored)</a:t>
+            </a:r>
+          </a:p>
+        </p:txBody>
+      </p:sp>
+      <p:sp>
+        <p:nvSpPr>
+          <p:cNvPr id="8" name="Rectangle 7"/>
+          <p:cNvSpPr/>
+          <p:nvPr/>
+        </p:nvSpPr>
+        <p:spPr>
+          <a:xfrm>
+            <a:off x="274320" y="1508760"/>
+            <a:ext cx="11612880" cy="822960"/>
+          </a:xfrm>
+          <a:prstGeom prst="rect">
+            <a:avLst/>
+          </a:prstGeom>
+          <a:solidFill>
+            <a:srgbClr val="EEF2F7"/>
+          </a:solidFill>
+          <a:ln>
+            <a:noFill/>
+          </a:ln>
+        </p:spPr>
+        <p:style>
+          <a:lnRef idx="1">
+            <a:schemeClr val="accent1"/>
+          </a:lnRef>
+          <a:fillRef idx="3">
+            <a:schemeClr val="accent1"/>
+          </a:fillRef>
+          <a:effectRef idx="2">
+            <a:schemeClr val="accent1"/>
+          </a:effectRef>
+          <a:fontRef idx="minor">
+            <a:schemeClr val="lt1"/>
+          </a:fontRef>
+        </p:style>
+        <p:txBody>
+          <a:bodyPr rtlCol="0" anchor="ctr"/>
+          <a:lstStyle/>
+          <a:p>
+            <a:pPr algn="ctr"/>
+          </a:p>
+        </p:txBody>
+      </p:sp>
+      <p:sp>
+        <p:nvSpPr>
+          <p:cNvPr id="9" name="TextBox 8"/>
+          <p:cNvSpPr txBox="1"/>
+          <p:nvPr/>
+        </p:nvSpPr>
+        <p:spPr>
+          <a:xfrm>
+            <a:off x="365760" y="1581912"/>
+            <a:ext cx="11430000" cy="731520"/>
+          </a:xfrm>
+          <a:prstGeom prst="rect">
+            <a:avLst/>
+          </a:prstGeom>
+          <a:noFill/>
+        </p:spPr>
+        <p:txBody>
+          <a:bodyPr wrap="square">
+            <a:spAutoFit/>
+          </a:bodyPr>
+          <a:lstStyle/>
+          <a:p>
+            <a:r>
+              <a:rPr sz="1300">
+                <a:solidFill>
+                  <a:srgbClr val="1F3963"/>
+                </a:solidFill>
+                <a:latin typeface="Courier New"/>
+              </a:rPr>
+              <a:t>S_KM(t) = PROD_{t_i &lt;= t} (1 - d_i^(k) / n_i)</a:t>
+            </a:r>
+          </a:p>
+          <a:p>
+            <a:r>
+              <a:rPr sz="1300">
+                <a:solidFill>
+                  <a:srgbClr val="1F3963"/>
+                </a:solidFill>
+                <a:latin typeface="Courier New"/>
+              </a:rPr>
+              <a:t>F_KM^(k)(t) = 1 - S_KM(t)    ← overcounts cause-k hazard</a:t>
+            </a:r>
+          </a:p>
+        </p:txBody>
+      </p:sp>
+      <p:sp>
+        <p:nvSpPr>
+          <p:cNvPr id="10" name="TextBox 9"/>
+          <p:cNvSpPr txBox="1"/>
+          <p:nvPr/>
+        </p:nvSpPr>
+        <p:spPr>
+          <a:xfrm>
+            <a:off x="274320" y="2423160"/>
+            <a:ext cx="11612880" cy="365760"/>
+          </a:xfrm>
+          <a:prstGeom prst="rect">
+            <a:avLst/>
+          </a:prstGeom>
+          <a:noFill/>
+        </p:spPr>
+        <p:txBody>
+          <a:bodyPr wrap="square">
+            <a:spAutoFit/>
+          </a:bodyPr>
+          <a:lstStyle/>
+          <a:p>
+            <a:pPr algn="l"/>
+            <a:r>
+              <a:rPr sz="1300" b="1">
+                <a:solidFill>
+                  <a:srgbClr val="1F3963"/>
+                </a:solidFill>
+              </a:rPr>
+              <a:t>Aalen-Johansen  (CORRECT)</a:t>
+            </a:r>
+          </a:p>
+        </p:txBody>
+      </p:sp>
+      <p:sp>
+        <p:nvSpPr>
+          <p:cNvPr id="11" name="Rectangle 10"/>
+          <p:cNvSpPr/>
+          <p:nvPr/>
+        </p:nvSpPr>
+        <p:spPr>
+          <a:xfrm>
+            <a:off x="274320" y="2788920"/>
+            <a:ext cx="11612880" cy="1417320"/>
+          </a:xfrm>
+          <a:prstGeom prst="rect">
+            <a:avLst/>
+          </a:prstGeom>
+          <a:solidFill>
+            <a:srgbClr val="EEF2F7"/>
+          </a:solidFill>
+          <a:ln>
+            <a:noFill/>
+          </a:ln>
+        </p:spPr>
+        <p:style>
+          <a:lnRef idx="1">
+            <a:schemeClr val="accent1"/>
+          </a:lnRef>
+          <a:fillRef idx="3">
+            <a:schemeClr val="accent1"/>
+          </a:fillRef>
+          <a:effectRef idx="2">
+            <a:schemeClr val="accent1"/>
+          </a:effectRef>
+          <a:fontRef idx="minor">
+            <a:schemeClr val="lt1"/>
+          </a:fontRef>
+        </p:style>
+        <p:txBody>
+          <a:bodyPr rtlCol="0" anchor="ctr"/>
+          <a:lstStyle/>
+          <a:p>
+            <a:pPr algn="ctr"/>
+          </a:p>
+        </p:txBody>
+      </p:sp>
+      <p:sp>
+        <p:nvSpPr>
+          <p:cNvPr id="12" name="TextBox 11"/>
+          <p:cNvSpPr txBox="1"/>
+          <p:nvPr/>
+        </p:nvSpPr>
+        <p:spPr>
+          <a:xfrm>
+            <a:off x="365760" y="2862072"/>
+            <a:ext cx="11430000" cy="1325880"/>
+          </a:xfrm>
+          <a:prstGeom prst="rect">
+            <a:avLst/>
+          </a:prstGeom>
+          <a:noFill/>
+        </p:spPr>
+        <p:txBody>
+          <a:bodyPr wrap="square">
+            <a:spAutoFit/>
+          </a:bodyPr>
+          <a:lstStyle/>
+          <a:p>
+            <a:r>
+              <a:rPr sz="1300">
+                <a:solidFill>
+                  <a:srgbClr val="1F3963"/>
+                </a:solidFill>
+                <a:latin typeface="Courier New"/>
+              </a:rPr>
+              <a:t>F_k(t) = SUM_{t_j &lt;= t}  S(t_j-)  *  d_{kj} / n_j</a:t>
+            </a:r>
+          </a:p>
+          <a:p>
+            <a:r>
+              <a:rPr sz="1300">
+                <a:solidFill>
+                  <a:srgbClr val="1F3963"/>
+                </a:solidFill>
+                <a:latin typeface="Courier New"/>
+              </a:rPr>
+              <a:t/>
+            </a:r>
+          </a:p>
+          <a:p>
+            <a:r>
+              <a:rPr sz="1300">
+                <a:solidFill>
+                  <a:srgbClr val="1F3963"/>
+                </a:solidFill>
+                <a:latin typeface="Courier New"/>
+              </a:rPr>
+              <a:t>  F_k(t) : CIF for cause k at loan age t</a:t>
+            </a:r>
+          </a:p>
+          <a:p>
+            <a:r>
+              <a:rPr sz="1300">
+                <a:solidFill>
+                  <a:srgbClr val="1F3963"/>
+                </a:solidFill>
+                <a:latin typeface="Courier New"/>
+              </a:rPr>
+              <a:t>  d_{kj} : cause-k exits at time t_j</a:t>
+            </a:r>
+          </a:p>
+          <a:p>
+            <a:r>
+              <a:rPr sz="1300">
+                <a:solidFill>
+                  <a:srgbClr val="1F3963"/>
+                </a:solidFill>
+                <a:latin typeface="Courier New"/>
+              </a:rPr>
+              <a:t>  n_j    : loans at risk just before t_j</a:t>
+            </a:r>
+          </a:p>
+          <a:p>
+            <a:r>
+              <a:rPr sz="1300">
+                <a:solidFill>
+                  <a:srgbClr val="1F3963"/>
+                </a:solidFill>
+                <a:latin typeface="Courier New"/>
+              </a:rPr>
+              <a:t>  S(t_j-): overall survival before t_j — uses ALL exits</a:t>
+            </a:r>
+          </a:p>
+        </p:txBody>
+      </p:sp>
+      <p:sp>
+        <p:nvSpPr>
+          <p:cNvPr id="13" name="TextBox 12"/>
+          <p:cNvSpPr txBox="1"/>
+          <p:nvPr/>
+        </p:nvSpPr>
+        <p:spPr>
+          <a:xfrm>
+            <a:off x="274320" y="4279392"/>
+            <a:ext cx="11612880" cy="320040"/>
+          </a:xfrm>
+          <a:prstGeom prst="rect">
+            <a:avLst/>
+          </a:prstGeom>
+          <a:noFill/>
+        </p:spPr>
+        <p:txBody>
+          <a:bodyPr wrap="square">
+            <a:spAutoFit/>
+          </a:bodyPr>
+          <a:lstStyle/>
+          <a:p>
+            <a:pPr algn="l"/>
+            <a:r>
+              <a:rPr sz="1200" b="1">
+                <a:solidFill>
+                  <a:srgbClr val="1F3963"/>
+                </a:solidFill>
+              </a:rPr>
+              <a:t>Partition identity  (impossible under KM):</a:t>
+            </a:r>
+          </a:p>
+        </p:txBody>
+      </p:sp>
+      <p:sp>
+        <p:nvSpPr>
+          <p:cNvPr id="14" name="Rectangle 13"/>
+          <p:cNvSpPr/>
+          <p:nvPr/>
+        </p:nvSpPr>
+        <p:spPr>
+          <a:xfrm>
+            <a:off x="274320" y="4617720"/>
+            <a:ext cx="11612880" cy="457200"/>
+          </a:xfrm>
+          <a:prstGeom prst="rect">
+            <a:avLst/>
+          </a:prstGeom>
+          <a:solidFill>
+            <a:srgbClr val="EEF2F7"/>
+          </a:solidFill>
+          <a:ln>
+            <a:noFill/>
+          </a:ln>
+        </p:spPr>
+        <p:style>
+          <a:lnRef idx="1">
+            <a:schemeClr val="accent1"/>
+          </a:lnRef>
+          <a:fillRef idx="3">
+            <a:schemeClr val="accent1"/>
+          </a:fillRef>
+          <a:effectRef idx="2">
+            <a:schemeClr val="accent1"/>
+          </a:effectRef>
+          <a:fontRef idx="minor">
+            <a:schemeClr val="lt1"/>
+          </a:fontRef>
+        </p:style>
+        <p:txBody>
+          <a:bodyPr rtlCol="0" anchor="ctr"/>
+          <a:lstStyle/>
+          <a:p>
+            <a:pPr algn="ctr"/>
+          </a:p>
+        </p:txBody>
+      </p:sp>
+      <p:sp>
+        <p:nvSpPr>
+          <p:cNvPr id="15" name="TextBox 14"/>
+          <p:cNvSpPr txBox="1"/>
+          <p:nvPr/>
+        </p:nvSpPr>
+        <p:spPr>
+          <a:xfrm>
+            <a:off x="365760" y="4690872"/>
+            <a:ext cx="11430000" cy="365760"/>
+          </a:xfrm>
+          <a:prstGeom prst="rect">
+            <a:avLst/>
+          </a:prstGeom>
+          <a:noFill/>
+        </p:spPr>
+        <p:txBody>
+          <a:bodyPr wrap="square">
+            <a:spAutoFit/>
+          </a:bodyPr>
+          <a:lstStyle/>
+          <a:p>
+            <a:r>
+              <a:rPr sz="1300">
+                <a:solidFill>
+                  <a:srgbClr val="1F3963"/>
+                </a:solidFill>
+                <a:latin typeface="Courier New"/>
+              </a:rPr>
+              <a:t>SUM_k  F_k(t)  +  S(t)  =  1    for all t</a:t>
             </a:r>
           </a:p>
         </p:txBody>
       </p:sp>
       <p:pic>
         <p:nvPicPr>
-          <p:cNvPr id="5" name="Picture 4" descr="E1_competing_risks_cif.png"/>
+          <p:cNvPr id="16" name="Picture 15" descr="E1_competing_risks_cif.png"/>
           <p:cNvPicPr>
             <a:picLocks noChangeAspect="1"/>
           </p:cNvPicPr>
@@ -6717,8 +8001,8 @@
         </p:blipFill>
         <p:spPr>
           <a:xfrm>
-            <a:off x="1371600" y="1097280"/>
-            <a:ext cx="9144000" cy="5034337"/>
+            <a:off x="274320" y="5120640"/>
+            <a:ext cx="9632924" cy="5303520"/>
           </a:xfrm>
           <a:prstGeom prst="rect">
             <a:avLst/>
@@ -6752,13 +8036,13 @@
         <p:spPr>
           <a:xfrm>
             <a:off x="0" y="0"/>
-            <a:ext cx="12188952" cy="1005840"/>
+            <a:ext cx="12188952" cy="960120"/>
           </a:xfrm>
           <a:prstGeom prst="rect">
             <a:avLst/>
           </a:prstGeom>
           <a:solidFill>
-            <a:srgbClr val="2C3E50"/>
+            <a:srgbClr val="1F3963"/>
           </a:solidFill>
           <a:ln>
             <a:noFill/>
@@ -6788,14 +8072,57 @@
       </p:sp>
       <p:sp>
         <p:nvSpPr>
-          <p:cNvPr id="3" name="TextBox 2"/>
+          <p:cNvPr id="3" name="Rectangle 2"/>
+          <p:cNvSpPr/>
+          <p:nvPr/>
+        </p:nvSpPr>
+        <p:spPr>
+          <a:xfrm>
+            <a:off x="0" y="960120"/>
+            <a:ext cx="12188952" cy="64008"/>
+          </a:xfrm>
+          <a:prstGeom prst="rect">
+            <a:avLst/>
+          </a:prstGeom>
+          <a:solidFill>
+            <a:srgbClr val="FFC000"/>
+          </a:solidFill>
+          <a:ln>
+            <a:noFill/>
+          </a:ln>
+        </p:spPr>
+        <p:style>
+          <a:lnRef idx="1">
+            <a:schemeClr val="accent1"/>
+          </a:lnRef>
+          <a:fillRef idx="3">
+            <a:schemeClr val="accent1"/>
+          </a:fillRef>
+          <a:effectRef idx="2">
+            <a:schemeClr val="accent1"/>
+          </a:effectRef>
+          <a:fontRef idx="minor">
+            <a:schemeClr val="lt1"/>
+          </a:fontRef>
+        </p:style>
+        <p:txBody>
+          <a:bodyPr rtlCol="0" anchor="ctr"/>
+          <a:lstStyle/>
+          <a:p>
+            <a:pPr algn="ctr"/>
+          </a:p>
+        </p:txBody>
+      </p:sp>
+      <p:sp>
+        <p:nvSpPr>
+          <p:cNvPr id="4" name="TextBox 3"/>
           <p:cNvSpPr txBox="1"/>
           <p:nvPr/>
         </p:nvSpPr>
         <p:spPr>
           <a:xfrm>
-            <a:off x="274320" y="73152"/>
-            <a:ext cx="10058400" cy="502920"/>
+            <a:off x="274320" y="54864"/>
+            <a:ext cx="11430000" cy="502920"/>
           </a:xfrm>
           <a:prstGeom prst="rect">
             <a:avLst/>
@@ -6815,21 +8142,21 @@
                   <a:srgbClr val="FFFFFF"/>
                 </a:solidFill>
               </a:rPr>
-              <a:t>E(i)(c) — KM vs AJ: Bias from Ignoring Competing Events</a:t>
-            </a:r>
-          </a:p>
-        </p:txBody>
-      </p:sp>
-      <p:sp>
-        <p:nvSpPr>
-          <p:cNvPr id="4" name="TextBox 3"/>
+              <a:t>E(i)(b) — AJ CIF: 10-yr Prepay 83%  ·  Default 2.2%  ·  Active 14.5%</a:t>
+            </a:r>
+          </a:p>
+        </p:txBody>
+      </p:sp>
+      <p:sp>
+        <p:nvSpPr>
+          <p:cNvPr id="5" name="TextBox 4"/>
           <p:cNvSpPr txBox="1"/>
           <p:nvPr/>
         </p:nvSpPr>
         <p:spPr>
           <a:xfrm>
-            <a:off x="274320" y="566928"/>
-            <a:ext cx="10058400" cy="365760"/>
+            <a:off x="274320" y="548640"/>
+            <a:ext cx="11430000" cy="365760"/>
           </a:xfrm>
           <a:prstGeom prst="rect">
             <a:avLst/>
@@ -6844,19 +8171,19 @@
           <a:p>
             <a:pPr algn="l"/>
             <a:r>
-              <a:rPr sz="1400" b="0">
+              <a:rPr sz="1300" b="0">
                 <a:solidFill>
-                  <a:srgbClr val="ECF0F1"/>
+                  <a:srgbClr val="F2F2F2"/>
                 </a:solidFill>
               </a:rPr>
-              <a:t>KM over-estimates prepayment CIF by treating defaults as independent censorings</a:t>
+              <a:t>S_KM over-estimates each cause; AJ partition sums exactly to 1</a:t>
             </a:r>
           </a:p>
         </p:txBody>
       </p:sp>
       <p:pic>
         <p:nvPicPr>
-          <p:cNvPr id="5" name="Picture 4" descr="E1_km_vs_aj_bias.png"/>
+          <p:cNvPr id="6" name="Picture 5" descr="E1_competing_risks_cif.png"/>
           <p:cNvPicPr>
             <a:picLocks noChangeAspect="1"/>
           </p:cNvPicPr>
@@ -6871,69 +8198,13 @@
         <p:spPr>
           <a:xfrm>
             <a:off x="457200" y="1097280"/>
-            <a:ext cx="11247120" cy="3402930"/>
+            <a:ext cx="9632924" cy="5303520"/>
           </a:xfrm>
           <a:prstGeom prst="rect">
             <a:avLst/>
           </a:prstGeom>
         </p:spPr>
       </p:pic>
-      <p:sp>
-        <p:nvSpPr>
-          <p:cNvPr id="6" name="TextBox 5"/>
-          <p:cNvSpPr txBox="1"/>
-          <p:nvPr/>
-        </p:nvSpPr>
-        <p:spPr>
-          <a:xfrm>
-            <a:off x="8686800" y="4754880"/>
-            <a:ext cx="3200400" cy="1371600"/>
-          </a:xfrm>
-          <a:prstGeom prst="rect">
-            <a:avLst/>
-          </a:prstGeom>
-          <a:noFill/>
-        </p:spPr>
-        <p:txBody>
-          <a:bodyPr wrap="square">
-            <a:spAutoFit/>
-          </a:bodyPr>
-          <a:lstStyle/>
-          <a:p>
-            <a:pPr>
-              <a:spcAft>
-                <a:spcPts val="400"/>
-              </a:spcAft>
-              <a:defRPr sz="1300"/>
-            </a:pPr>
-            <a:r>
-              <a:t>• 5 yr: +0.45 pp</a:t>
-            </a:r>
-          </a:p>
-          <a:p>
-            <a:pPr>
-              <a:spcAft>
-                <a:spcPts val="400"/>
-              </a:spcAft>
-              <a:defRPr sz="1300"/>
-            </a:pPr>
-            <a:r>
-              <a:t>• 10 yr: +1.31 pp</a:t>
-            </a:r>
-          </a:p>
-          <a:p>
-            <a:pPr>
-              <a:spcAft>
-                <a:spcPts val="400"/>
-              </a:spcAft>
-              <a:defRPr sz="1300"/>
-            </a:pPr>
-            <a:r>
-              <a:t>• 20 yr: +2.23 pp</a:t>
-            </a:r>
-          </a:p>
-        </p:txBody>
-      </p:sp>
     </p:spTree>
   </p:cSld>
   <p:clrMapOvr>
@@ -6961,13 +8232,13 @@
         <p:spPr>
           <a:xfrm>
             <a:off x="0" y="0"/>
-            <a:ext cx="12188952" cy="1005840"/>
+            <a:ext cx="12188952" cy="960120"/>
           </a:xfrm>
           <a:prstGeom prst="rect">
             <a:avLst/>
           </a:prstGeom>
           <a:solidFill>
-            <a:srgbClr val="2C3E50"/>
+            <a:srgbClr val="1F3963"/>
           </a:solidFill>
           <a:ln>
             <a:noFill/>
@@ -6997,14 +8268,57 @@
       </p:sp>
       <p:sp>
         <p:nvSpPr>
-          <p:cNvPr id="3" name="TextBox 2"/>
+          <p:cNvPr id="3" name="Rectangle 2"/>
+          <p:cNvSpPr/>
+          <p:nvPr/>
+        </p:nvSpPr>
+        <p:spPr>
+          <a:xfrm>
+            <a:off x="0" y="960120"/>
+            <a:ext cx="12188952" cy="64008"/>
+          </a:xfrm>
+          <a:prstGeom prst="rect">
+            <a:avLst/>
+          </a:prstGeom>
+          <a:solidFill>
+            <a:srgbClr val="FFC000"/>
+          </a:solidFill>
+          <a:ln>
+            <a:noFill/>
+          </a:ln>
+        </p:spPr>
+        <p:style>
+          <a:lnRef idx="1">
+            <a:schemeClr val="accent1"/>
+          </a:lnRef>
+          <a:fillRef idx="3">
+            <a:schemeClr val="accent1"/>
+          </a:fillRef>
+          <a:effectRef idx="2">
+            <a:schemeClr val="accent1"/>
+          </a:effectRef>
+          <a:fontRef idx="minor">
+            <a:schemeClr val="lt1"/>
+          </a:fontRef>
+        </p:style>
+        <p:txBody>
+          <a:bodyPr rtlCol="0" anchor="ctr"/>
+          <a:lstStyle/>
+          <a:p>
+            <a:pPr algn="ctr"/>
+          </a:p>
+        </p:txBody>
+      </p:sp>
+      <p:sp>
+        <p:nvSpPr>
+          <p:cNvPr id="4" name="TextBox 3"/>
           <p:cNvSpPr txBox="1"/>
           <p:nvPr/>
         </p:nvSpPr>
         <p:spPr>
           <a:xfrm>
-            <a:off x="274320" y="73152"/>
-            <a:ext cx="10058400" cy="502920"/>
+            <a:off x="274320" y="54864"/>
+            <a:ext cx="11430000" cy="502920"/>
           </a:xfrm>
           <a:prstGeom prst="rect">
             <a:avLst/>
@@ -7024,21 +8338,21 @@
                   <a:srgbClr val="FFFFFF"/>
                 </a:solidFill>
               </a:rPr>
-              <a:t>E(i)(d) — Stratified CIF</a:t>
-            </a:r>
-          </a:p>
-        </p:txBody>
-      </p:sp>
-      <p:sp>
-        <p:nvSpPr>
-          <p:cNvPr id="4" name="TextBox 3"/>
+              <a:t>E(i)(c) — KM vs AJ: Why Defaults Cannot Be Treated as Censorings</a:t>
+            </a:r>
+          </a:p>
+        </p:txBody>
+      </p:sp>
+      <p:sp>
+        <p:nvSpPr>
+          <p:cNvPr id="5" name="TextBox 4"/>
           <p:cNvSpPr txBox="1"/>
           <p:nvPr/>
         </p:nvSpPr>
         <p:spPr>
           <a:xfrm>
-            <a:off x="274320" y="566928"/>
-            <a:ext cx="10058400" cy="365760"/>
+            <a:off x="274320" y="548640"/>
+            <a:ext cx="11430000" cy="365760"/>
           </a:xfrm>
           <a:prstGeom prst="rect">
             <a:avLst/>
@@ -7053,19 +8367,374 @@
           <a:p>
             <a:pPr algn="l"/>
             <a:r>
-              <a:rPr sz="1400" b="0">
+              <a:rPr sz="1300" b="0">
                 <a:solidFill>
-                  <a:srgbClr val="ECF0F1"/>
+                  <a:srgbClr val="F2F2F2"/>
                 </a:solidFill>
               </a:rPr>
-              <a:t>High-FICO → elevated prepayment, near-zero default;  high-LTV → inverted</a:t>
+              <a:t>Every AJ increment ≤ KM increment  →  F_AJ(t) ≤ F_KM(t)  →  growing bias</a:t>
+            </a:r>
+          </a:p>
+        </p:txBody>
+      </p:sp>
+      <p:sp>
+        <p:nvSpPr>
+          <p:cNvPr id="6" name="Rectangle 5"/>
+          <p:cNvSpPr/>
+          <p:nvPr/>
+        </p:nvSpPr>
+        <p:spPr>
+          <a:xfrm>
+            <a:off x="0" y="1024128"/>
+            <a:ext cx="12188952" cy="5833872"/>
+          </a:xfrm>
+          <a:prstGeom prst="rect">
+            <a:avLst/>
+          </a:prstGeom>
+          <a:solidFill>
+            <a:srgbClr val="F2F2F2"/>
+          </a:solidFill>
+          <a:ln>
+            <a:noFill/>
+          </a:ln>
+        </p:spPr>
+        <p:style>
+          <a:lnRef idx="1">
+            <a:schemeClr val="accent1"/>
+          </a:lnRef>
+          <a:fillRef idx="3">
+            <a:schemeClr val="accent1"/>
+          </a:fillRef>
+          <a:effectRef idx="2">
+            <a:schemeClr val="accent1"/>
+          </a:effectRef>
+          <a:fontRef idx="minor">
+            <a:schemeClr val="lt1"/>
+          </a:fontRef>
+        </p:style>
+        <p:txBody>
+          <a:bodyPr rtlCol="0" anchor="ctr"/>
+          <a:lstStyle/>
+          <a:p>
+            <a:pPr algn="ctr"/>
+          </a:p>
+        </p:txBody>
+      </p:sp>
+      <p:sp>
+        <p:nvSpPr>
+          <p:cNvPr id="7" name="TextBox 6"/>
+          <p:cNvSpPr txBox="1"/>
+          <p:nvPr/>
+        </p:nvSpPr>
+        <p:spPr>
+          <a:xfrm>
+            <a:off x="274320" y="1143000"/>
+            <a:ext cx="11612880" cy="365760"/>
+          </a:xfrm>
+          <a:prstGeom prst="rect">
+            <a:avLst/>
+          </a:prstGeom>
+          <a:noFill/>
+        </p:spPr>
+        <p:txBody>
+          <a:bodyPr wrap="square">
+            <a:spAutoFit/>
+          </a:bodyPr>
+          <a:lstStyle/>
+          <a:p>
+            <a:pPr algn="l"/>
+            <a:r>
+              <a:rPr sz="1200" b="1">
+                <a:solidFill>
+                  <a:srgbClr val="C00000"/>
+                </a:solidFill>
+              </a:rPr>
+              <a:t>KM increment at t_j  (defaults excluded from denominator n_j^KM &lt; n_j):</a:t>
+            </a:r>
+          </a:p>
+        </p:txBody>
+      </p:sp>
+      <p:sp>
+        <p:nvSpPr>
+          <p:cNvPr id="8" name="Rectangle 7"/>
+          <p:cNvSpPr/>
+          <p:nvPr/>
+        </p:nvSpPr>
+        <p:spPr>
+          <a:xfrm>
+            <a:off x="274320" y="1508760"/>
+            <a:ext cx="11612880" cy="548640"/>
+          </a:xfrm>
+          <a:prstGeom prst="rect">
+            <a:avLst/>
+          </a:prstGeom>
+          <a:solidFill>
+            <a:srgbClr val="EEF2F7"/>
+          </a:solidFill>
+          <a:ln>
+            <a:noFill/>
+          </a:ln>
+        </p:spPr>
+        <p:style>
+          <a:lnRef idx="1">
+            <a:schemeClr val="accent1"/>
+          </a:lnRef>
+          <a:fillRef idx="3">
+            <a:schemeClr val="accent1"/>
+          </a:fillRef>
+          <a:effectRef idx="2">
+            <a:schemeClr val="accent1"/>
+          </a:effectRef>
+          <a:fontRef idx="minor">
+            <a:schemeClr val="lt1"/>
+          </a:fontRef>
+        </p:style>
+        <p:txBody>
+          <a:bodyPr rtlCol="0" anchor="ctr"/>
+          <a:lstStyle/>
+          <a:p>
+            <a:pPr algn="ctr"/>
+          </a:p>
+        </p:txBody>
+      </p:sp>
+      <p:sp>
+        <p:nvSpPr>
+          <p:cNvPr id="9" name="TextBox 8"/>
+          <p:cNvSpPr txBox="1"/>
+          <p:nvPr/>
+        </p:nvSpPr>
+        <p:spPr>
+          <a:xfrm>
+            <a:off x="365760" y="1581912"/>
+            <a:ext cx="11430000" cy="457200"/>
+          </a:xfrm>
+          <a:prstGeom prst="rect">
+            <a:avLst/>
+          </a:prstGeom>
+          <a:noFill/>
+        </p:spPr>
+        <p:txBody>
+          <a:bodyPr wrap="square">
+            <a:spAutoFit/>
+          </a:bodyPr>
+          <a:lstStyle/>
+          <a:p>
+            <a:r>
+              <a:rPr sz="1300">
+                <a:solidFill>
+                  <a:srgbClr val="1F3963"/>
+                </a:solidFill>
+                <a:latin typeface="Courier New"/>
+              </a:rPr>
+              <a:t>ΔF_KM(t_j)  =  S_KM(t_j-)  *  d_{1j} / n_j^KM    ← n_j^KM underestimates risk set</a:t>
+            </a:r>
+          </a:p>
+        </p:txBody>
+      </p:sp>
+      <p:sp>
+        <p:nvSpPr>
+          <p:cNvPr id="10" name="TextBox 9"/>
+          <p:cNvSpPr txBox="1"/>
+          <p:nvPr/>
+        </p:nvSpPr>
+        <p:spPr>
+          <a:xfrm>
+            <a:off x="274320" y="2148840"/>
+            <a:ext cx="11612880" cy="365760"/>
+          </a:xfrm>
+          <a:prstGeom prst="rect">
+            <a:avLst/>
+          </a:prstGeom>
+          <a:noFill/>
+        </p:spPr>
+        <p:txBody>
+          <a:bodyPr wrap="square">
+            <a:spAutoFit/>
+          </a:bodyPr>
+          <a:lstStyle/>
+          <a:p>
+            <a:pPr algn="l"/>
+            <a:r>
+              <a:rPr sz="1200" b="1">
+                <a:solidFill>
+                  <a:srgbClr val="1F3963"/>
+                </a:solidFill>
+              </a:rPr>
+              <a:t>AJ increment at t_j  (overall survival, full risk set):</a:t>
+            </a:r>
+          </a:p>
+        </p:txBody>
+      </p:sp>
+      <p:sp>
+        <p:nvSpPr>
+          <p:cNvPr id="11" name="Rectangle 10"/>
+          <p:cNvSpPr/>
+          <p:nvPr/>
+        </p:nvSpPr>
+        <p:spPr>
+          <a:xfrm>
+            <a:off x="274320" y="2514600"/>
+            <a:ext cx="11612880" cy="548640"/>
+          </a:xfrm>
+          <a:prstGeom prst="rect">
+            <a:avLst/>
+          </a:prstGeom>
+          <a:solidFill>
+            <a:srgbClr val="EEF2F7"/>
+          </a:solidFill>
+          <a:ln>
+            <a:noFill/>
+          </a:ln>
+        </p:spPr>
+        <p:style>
+          <a:lnRef idx="1">
+            <a:schemeClr val="accent1"/>
+          </a:lnRef>
+          <a:fillRef idx="3">
+            <a:schemeClr val="accent1"/>
+          </a:fillRef>
+          <a:effectRef idx="2">
+            <a:schemeClr val="accent1"/>
+          </a:effectRef>
+          <a:fontRef idx="minor">
+            <a:schemeClr val="lt1"/>
+          </a:fontRef>
+        </p:style>
+        <p:txBody>
+          <a:bodyPr rtlCol="0" anchor="ctr"/>
+          <a:lstStyle/>
+          <a:p>
+            <a:pPr algn="ctr"/>
+          </a:p>
+        </p:txBody>
+      </p:sp>
+      <p:sp>
+        <p:nvSpPr>
+          <p:cNvPr id="12" name="TextBox 11"/>
+          <p:cNvSpPr txBox="1"/>
+          <p:nvPr/>
+        </p:nvSpPr>
+        <p:spPr>
+          <a:xfrm>
+            <a:off x="365760" y="2587752"/>
+            <a:ext cx="11430000" cy="457200"/>
+          </a:xfrm>
+          <a:prstGeom prst="rect">
+            <a:avLst/>
+          </a:prstGeom>
+          <a:noFill/>
+        </p:spPr>
+        <p:txBody>
+          <a:bodyPr wrap="square">
+            <a:spAutoFit/>
+          </a:bodyPr>
+          <a:lstStyle/>
+          <a:p>
+            <a:r>
+              <a:rPr sz="1300">
+                <a:solidFill>
+                  <a:srgbClr val="1F3963"/>
+                </a:solidFill>
+                <a:latin typeface="Courier New"/>
+              </a:rPr>
+              <a:t>ΔF_AJ(t_j)   =  S(t_j-)     *  d_{1j} / n_j      ← S(t_j-) ≤ S_KM(t_j-) always</a:t>
+            </a:r>
+          </a:p>
+        </p:txBody>
+      </p:sp>
+      <p:sp>
+        <p:nvSpPr>
+          <p:cNvPr id="13" name="TextBox 12"/>
+          <p:cNvSpPr txBox="1"/>
+          <p:nvPr/>
+        </p:nvSpPr>
+        <p:spPr>
+          <a:xfrm>
+            <a:off x="274320" y="3154680"/>
+            <a:ext cx="11612880" cy="365760"/>
+          </a:xfrm>
+          <a:prstGeom prst="rect">
+            <a:avLst/>
+          </a:prstGeom>
+          <a:noFill/>
+        </p:spPr>
+        <p:txBody>
+          <a:bodyPr wrap="square">
+            <a:spAutoFit/>
+          </a:bodyPr>
+          <a:lstStyle/>
+          <a:p>
+            <a:pPr algn="l"/>
+            <a:r>
+              <a:rPr sz="1200" b="1">
+                <a:solidFill>
+                  <a:srgbClr val="1F3963"/>
+                </a:solidFill>
+              </a:rPr>
+              <a:t>Consequence — bias compounds over time:</a:t>
+            </a:r>
+          </a:p>
+        </p:txBody>
+      </p:sp>
+      <p:sp>
+        <p:nvSpPr>
+          <p:cNvPr id="14" name="TextBox 13"/>
+          <p:cNvSpPr txBox="1"/>
+          <p:nvPr/>
+        </p:nvSpPr>
+        <p:spPr>
+          <a:xfrm>
+            <a:off x="274320" y="3520440"/>
+            <a:ext cx="11612880" cy="1005840"/>
+          </a:xfrm>
+          <a:prstGeom prst="rect">
+            <a:avLst/>
+          </a:prstGeom>
+          <a:noFill/>
+        </p:spPr>
+        <p:txBody>
+          <a:bodyPr wrap="square">
+            <a:spAutoFit/>
+          </a:bodyPr>
+          <a:lstStyle/>
+          <a:p>
+            <a:pPr>
+              <a:spcAft>
+                <a:spcPts val="400"/>
+              </a:spcAft>
+              <a:defRPr sz="1300"/>
+            </a:pPr>
+            <a:r>
+              <a:t>• 5 yr:  KM over-estimates prepayment CIF by ~+0.45 pp</a:t>
+            </a:r>
+          </a:p>
+          <a:p>
+            <a:pPr>
+              <a:spcAft>
+                <a:spcPts val="400"/>
+              </a:spcAft>
+              <a:defRPr sz="1300"/>
+            </a:pPr>
+            <a:r>
+              <a:t>• 10 yr: bias ≈ +1.31 pp</a:t>
+            </a:r>
+          </a:p>
+          <a:p>
+            <a:pPr>
+              <a:spcAft>
+                <a:spcPts val="400"/>
+              </a:spcAft>
+              <a:defRPr sz="1300"/>
+            </a:pPr>
+            <a:r>
+              <a:t>• 20 yr: bias ≈ +2.23 pp  (gap widens as defaulted loans accumulate)</a:t>
             </a:r>
           </a:p>
         </p:txBody>
       </p:sp>
       <p:pic>
         <p:nvPicPr>
-          <p:cNvPr id="5" name="Picture 4" descr="E1_stratified_cif.png"/>
+          <p:cNvPr id="15" name="Picture 14" descr="E1_km_vs_aj_bias.png"/>
           <p:cNvPicPr>
             <a:picLocks noChangeAspect="1"/>
           </p:cNvPicPr>
@@ -7079,8 +8748,8 @@
         </p:blipFill>
         <p:spPr>
           <a:xfrm>
-            <a:off x="274320" y="1051560"/>
-            <a:ext cx="5186826" cy="5303520"/>
+            <a:off x="274320" y="4572000"/>
+            <a:ext cx="11612880" cy="3513594"/>
           </a:xfrm>
           <a:prstGeom prst="rect">
             <a:avLst/>

</xml_diff>

<commit_message>
Split forest plot into two separate larger charts, sorted ascending
Replace single 1x2 forest plot with two standalone (11x7) figures:
E1_cox_prepay.png and E1_cox_default.png, each sorted by log-HR
ascending. Negative bars shown in grey, positive in cause color.
Value annotations (coef [lo, hi]) added to each bar. Report and
PPTX updated with two dedicated slides.

Co-Authored-By: Claude Sonnet 4.6 <noreply@anthropic.com>
</commit_message>
<xml_diff>
--- a/processed/PartE_Presentation.pptx
+++ b/processed/PartE_Presentation.pptx
@@ -22,6 +22,7 @@
     <p:sldId id="270" r:id="rId21"/>
     <p:sldId id="271" r:id="rId22"/>
     <p:sldId id="272" r:id="rId23"/>
+    <p:sldId id="273" r:id="rId24"/>
   </p:sldIdLst>
   <p:sldSz cx="12188952" cy="6858000" type="screen4x3"/>
   <p:notesSz cx="6858000" cy="9144000"/>
@@ -3741,7 +3742,7 @@
                   <a:srgbClr val="FFFFFF"/>
                 </a:solidFill>
               </a:rPr>
-              <a:t>E(i)(e) — Cause-Specific Cox Regression  (12 features)</a:t>
+              <a:t>E(i)(e) — Cause-Specific Cox: Prepayment  (sorted ascending)</a:t>
             </a:r>
           </a:p>
         </p:txBody>
@@ -3775,14 +3776,14 @@
                   <a:srgbClr val="F2F2F2"/>
                 </a:solidFill>
               </a:rPr>
-              <a:t>Opposite-sign coefficients reveal misrepresentation in naive combined Cox</a:t>
+              <a:t>Rate incentive &amp; Purchase purpose → highest refi hazard  ·  12 features  ·  95% CI</a:t>
             </a:r>
           </a:p>
         </p:txBody>
       </p:sp>
       <p:pic>
         <p:nvPicPr>
-          <p:cNvPr id="6" name="Picture 5" descr="E1_cause_specific_cox.png"/>
+          <p:cNvPr id="6" name="Picture 5" descr="E1_cox_prepay.png"/>
           <p:cNvPicPr>
             <a:picLocks noChangeAspect="1"/>
           </p:cNvPicPr>
@@ -3797,7 +3798,7 @@
         <p:spPr>
           <a:xfrm>
             <a:off x="274320" y="1051560"/>
-            <a:ext cx="11612880" cy="3860561"/>
+            <a:ext cx="8394245" cy="5303520"/>
           </a:xfrm>
           <a:prstGeom prst="rect">
             <a:avLst/>
@@ -3937,7 +3938,7 @@
                   <a:srgbClr val="FFFFFF"/>
                 </a:solidFill>
               </a:rPr>
-              <a:t>E(i)(f) — Fine-Gray Subdistribution Hazard</a:t>
+              <a:t>E(i)(e) — Cause-Specific Cox: Default  (sorted ascending)</a:t>
             </a:r>
           </a:p>
         </p:txBody>
@@ -3971,165 +3972,35 @@
                   <a:srgbClr val="F2F2F2"/>
                 </a:solidFill>
               </a:rPr>
-              <a:t>IPCW-weighted Cox approximation; coefficients directly target the CIF</a:t>
-            </a:r>
-          </a:p>
-        </p:txBody>
-      </p:sp>
-      <p:sp>
-        <p:nvSpPr>
-          <p:cNvPr id="6" name="Rectangle 5"/>
-          <p:cNvSpPr/>
-          <p:nvPr/>
-        </p:nvSpPr>
-        <p:spPr>
-          <a:xfrm>
-            <a:off x="0" y="1005840"/>
-            <a:ext cx="12188952" cy="5852160"/>
-          </a:xfrm>
-          <a:prstGeom prst="rect">
-            <a:avLst/>
-          </a:prstGeom>
-          <a:solidFill>
-            <a:srgbClr val="F2F2F2"/>
-          </a:solidFill>
-          <a:ln>
-            <a:noFill/>
-          </a:ln>
-        </p:spPr>
-        <p:style>
-          <a:lnRef idx="1">
-            <a:schemeClr val="accent1"/>
-          </a:lnRef>
-          <a:fillRef idx="3">
-            <a:schemeClr val="accent1"/>
-          </a:fillRef>
-          <a:effectRef idx="2">
-            <a:schemeClr val="accent1"/>
-          </a:effectRef>
-          <a:fontRef idx="minor">
-            <a:schemeClr val="lt1"/>
-          </a:fontRef>
-        </p:style>
-        <p:txBody>
-          <a:bodyPr rtlCol="0" anchor="ctr"/>
-          <a:lstStyle/>
-          <a:p>
-            <a:pPr algn="ctr"/>
-          </a:p>
-        </p:txBody>
-      </p:sp>
-      <p:sp>
-        <p:nvSpPr>
-          <p:cNvPr id="7" name="TextBox 6"/>
-          <p:cNvSpPr txBox="1"/>
-          <p:nvPr/>
-        </p:nvSpPr>
-        <p:spPr>
-          <a:xfrm>
-            <a:off x="457200" y="1188720"/>
-            <a:ext cx="11247120" cy="5029200"/>
-          </a:xfrm>
-          <a:prstGeom prst="rect">
-            <a:avLst/>
-          </a:prstGeom>
-          <a:noFill/>
-        </p:spPr>
-        <p:txBody>
-          <a:bodyPr wrap="square">
-            <a:spAutoFit/>
-          </a:bodyPr>
-          <a:lstStyle/>
-          <a:p>
-            <a:pPr>
-              <a:spcAft>
-                <a:spcPts val="400"/>
-              </a:spcAft>
-              <a:defRPr sz="1400"/>
-            </a:pPr>
-            <a:r>
-              <a:t>• Subjects who experienced a competing event (default) are KEPT in the risk set with IPCW weights</a:t>
-            </a:r>
-          </a:p>
-          <a:p>
-            <a:pPr>
-              <a:spcAft>
-                <a:spcPts val="400"/>
-              </a:spcAft>
-              <a:defRPr sz="1400"/>
-            </a:pPr>
-            <a:r>
-              <a:t>• The subdistribution hazard integrates to the CIF — covariate effects are CIF effects</a:t>
-            </a:r>
-          </a:p>
-          <a:p>
-            <a:pPr>
-              <a:spcAft>
-                <a:spcPts val="400"/>
-              </a:spcAft>
-              <a:defRPr sz="1400"/>
-            </a:pPr>
-            <a:r>
-              <a:t>• rate_incentive HR is LARGER under Fine-Gray than cause-specific Cox:</a:t>
-            </a:r>
-          </a:p>
-          <a:p>
-            <a:pPr>
-              <a:spcAft>
-                <a:spcPts val="400"/>
-              </a:spcAft>
-              <a:defRPr sz="1400"/>
-            </a:pPr>
-            <a:r>
-              <a:t>•    high-incentive loans are also less likely to default first → amplifies CIF effect</a:t>
-            </a:r>
-          </a:p>
-          <a:p>
-            <a:pPr>
-              <a:spcAft>
-                <a:spcPts val="400"/>
-              </a:spcAft>
-              <a:defRPr sz="1400"/>
-            </a:pPr>
-            <a:r>
-              <a:t>• Low-FICO Fine-Gray HR for prepayment is ATTENUATED: elevated default risk reduces</a:t>
-            </a:r>
-          </a:p>
-          <a:p>
-            <a:pPr>
-              <a:spcAft>
-                <a:spcPts val="400"/>
-              </a:spcAft>
-              <a:defRPr sz="1400"/>
-            </a:pPr>
-            <a:r>
-              <a:t>•    measured prepayment propensity once competing risks are accounted for</a:t>
-            </a:r>
-          </a:p>
-          <a:p>
-            <a:pPr>
-              <a:spcAft>
-                <a:spcPts val="400"/>
-              </a:spcAft>
-              <a:defRPr sz="1400"/>
-            </a:pPr>
-            <a:r>
-              <a:t>• Use Fine-Gray for CIF prediction / loss forecasting</a:t>
-            </a:r>
-          </a:p>
-          <a:p>
-            <a:pPr>
-              <a:spcAft>
-                <a:spcPts val="400"/>
-              </a:spcAft>
-              <a:defRPr sz="1400"/>
-            </a:pPr>
-            <a:r>
-              <a:t>• Use cause-specific Cox for economic mechanism estimation</a:t>
-            </a:r>
-          </a:p>
-        </p:txBody>
-      </p:sp>
+              <a:t>LTV &amp; DTI → highest default hazard  ·  CreditScore opposite sign to prepayment</a:t>
+            </a:r>
+          </a:p>
+        </p:txBody>
+      </p:sp>
+      <p:pic>
+        <p:nvPicPr>
+          <p:cNvPr id="6" name="Picture 5" descr="E1_cox_default.png"/>
+          <p:cNvPicPr>
+            <a:picLocks noChangeAspect="1"/>
+          </p:cNvPicPr>
+          <p:nvPr/>
+        </p:nvPicPr>
+        <p:blipFill>
+          <a:blip r:embed="rId2"/>
+          <a:stretch>
+            <a:fillRect/>
+          </a:stretch>
+        </p:blipFill>
+        <p:spPr>
+          <a:xfrm>
+            <a:off x="274320" y="1051560"/>
+            <a:ext cx="8394245" cy="5303520"/>
+          </a:xfrm>
+          <a:prstGeom prst="rect">
+            <a:avLst/>
+          </a:prstGeom>
+        </p:spPr>
+      </p:pic>
     </p:spTree>
   </p:cSld>
   <p:clrMapOvr>
@@ -4263,7 +4134,7 @@
                   <a:srgbClr val="FFFFFF"/>
                 </a:solidFill>
               </a:rPr>
-              <a:t>E(ii) — Time-Dependent Covariates</a:t>
+              <a:t>E(i)(f) — Fine-Gray Subdistribution Hazard</a:t>
             </a:r>
           </a:p>
         </p:txBody>
@@ -4297,7 +4168,7 @@
                   <a:srgbClr val="F2F2F2"/>
                 </a:solidFill>
               </a:rPr>
-              <a:t>Andersen-Gill counting-process Cox — monthly rate_incentive, unemployment, HPI</a:t>
+              <a:t>IPCW-weighted Cox approximation; coefficients directly target the CIF</a:t>
             </a:r>
           </a:p>
         </p:txBody>
@@ -4371,10 +4242,10 @@
               <a:spcAft>
                 <a:spcPts val="400"/>
               </a:spcAft>
-              <a:defRPr sz="1300"/>
+              <a:defRPr sz="1400"/>
             </a:pPr>
             <a:r>
-              <a:t>• Panel dataset: 93M rows × 2M loans — mortgage_rate, unemployment, HPI YoY, rate_incentive updated monthly</a:t>
+              <a:t>• Subjects who experienced a competing event (default) are KEPT in the risk set with IPCW weights</a:t>
             </a:r>
           </a:p>
           <a:p>
@@ -4382,10 +4253,10 @@
               <a:spcAft>
                 <a:spcPts val="400"/>
               </a:spcAft>
-              <a:defRPr sz="1300"/>
+              <a:defRPr sz="1400"/>
             </a:pPr>
             <a:r>
-              <a:t>• 10,000 loans stratified by vintage → ~500K counting-process rows (tstart, tstop, event)</a:t>
+              <a:t>• The subdistribution hazard integrates to the CIF — covariate effects are CIF effects</a:t>
             </a:r>
           </a:p>
           <a:p>
@@ -4393,10 +4264,10 @@
               <a:spcAft>
                 <a:spcPts val="400"/>
               </a:spcAft>
-              <a:defRPr sz="1300"/>
+              <a:defRPr sz="1400"/>
             </a:pPr>
             <a:r>
-              <a:t>• 11 features: 7 static (FICO, LTV, DTI, UPB + 3 one-hot) + 4 time-varying</a:t>
+              <a:t>• rate_incentive HR is LARGER under Fine-Gray than cause-specific Cox:</a:t>
             </a:r>
           </a:p>
           <a:p>
@@ -4404,10 +4275,10 @@
               <a:spcAft>
                 <a:spcPts val="400"/>
               </a:spcAft>
-              <a:defRPr sz="1300"/>
+              <a:defRPr sz="1400"/>
             </a:pPr>
             <a:r>
-              <a:t>• Key finding: current rate_incentive coefficient LARGER than origination-vintage snapshot</a:t>
+              <a:t>•    high-incentive loans are also less likely to default first → amplifies CIF effect</a:t>
             </a:r>
           </a:p>
           <a:p>
@@ -4415,10 +4286,10 @@
               <a:spcAft>
                 <a:spcPts val="400"/>
               </a:spcAft>
-              <a:defRPr sz="1300"/>
+              <a:defRPr sz="1400"/>
             </a:pPr>
             <a:r>
-              <a:t>•    Static Cox: rate_incentive locked at origination — high-rate era loans always look attractive</a:t>
+              <a:t>• Low-FICO Fine-Gray HR for prepayment is ATTENUATED: elevated default risk reduces</a:t>
             </a:r>
           </a:p>
           <a:p>
@@ -4426,10 +4297,10 @@
               <a:spcAft>
                 <a:spcPts val="400"/>
               </a:spcAft>
-              <a:defRPr sz="1300"/>
+              <a:defRPr sz="1400"/>
             </a:pPr>
             <a:r>
-              <a:t>•    TV Cox: tracks actual monthly refi option value — more responsive to rate cycles</a:t>
+              <a:t>•    measured prepayment propensity once competing risks are accounted for</a:t>
             </a:r>
           </a:p>
           <a:p>
@@ -4437,10 +4308,10 @@
               <a:spcAft>
                 <a:spcPts val="400"/>
               </a:spcAft>
-              <a:defRPr sz="1300"/>
+              <a:defRPr sz="1400"/>
             </a:pPr>
             <a:r>
-              <a:t>• Unemployment: contemporaneous job loss predicts default better than vintage average</a:t>
+              <a:t>• Use Fine-Gray for CIF prediction / loss forecasting</a:t>
             </a:r>
           </a:p>
           <a:p>
@@ -4448,10 +4319,10 @@
               <a:spcAft>
                 <a:spcPts val="400"/>
               </a:spcAft>
-              <a:defRPr sz="1300"/>
+              <a:defRPr sz="1400"/>
             </a:pPr>
             <a:r>
-              <a:t>• Limitation: origination LTV used (not ELTV) — adding current LTV would improve default hazard</a:t>
+              <a:t>• Use cause-specific Cox for economic mechanism estimation</a:t>
             </a:r>
           </a:p>
         </p:txBody>
@@ -4589,59 +4460,199 @@
                   <a:srgbClr val="FFFFFF"/>
                 </a:solidFill>
               </a:rPr>
-              <a:t>E(ii) — TV Cox Results</a:t>
-            </a:r>
-          </a:p>
-        </p:txBody>
-      </p:sp>
-      <p:pic>
-        <p:nvPicPr>
-          <p:cNvPr id="5" name="Picture 4" descr="Eii_tv_cox_forest.png"/>
-          <p:cNvPicPr>
-            <a:picLocks noChangeAspect="1"/>
-          </p:cNvPicPr>
-          <p:nvPr/>
-        </p:nvPicPr>
-        <p:blipFill>
-          <a:blip r:embed="rId2"/>
-          <a:stretch>
-            <a:fillRect/>
-          </a:stretch>
-        </p:blipFill>
-        <p:spPr>
-          <a:xfrm>
-            <a:off x="137160" y="1051560"/>
-            <a:ext cx="7132320" cy="3013704"/>
-          </a:xfrm>
-          <a:prstGeom prst="rect">
-            <a:avLst/>
-          </a:prstGeom>
-        </p:spPr>
-      </p:pic>
-      <p:pic>
-        <p:nvPicPr>
-          <p:cNvPr id="6" name="Picture 5" descr="Eii_static_vs_tv.png"/>
-          <p:cNvPicPr>
-            <a:picLocks noChangeAspect="1"/>
-          </p:cNvPicPr>
-          <p:nvPr/>
-        </p:nvPicPr>
-        <p:blipFill>
-          <a:blip r:embed="rId3"/>
-          <a:stretch>
-            <a:fillRect/>
-          </a:stretch>
-        </p:blipFill>
-        <p:spPr>
-          <a:xfrm>
-            <a:off x="7406640" y="1051560"/>
-            <a:ext cx="4572000" cy="2247385"/>
-          </a:xfrm>
-          <a:prstGeom prst="rect">
-            <a:avLst/>
-          </a:prstGeom>
-        </p:spPr>
-      </p:pic>
+              <a:t>E(ii) — Time-Dependent Covariates</a:t>
+            </a:r>
+          </a:p>
+        </p:txBody>
+      </p:sp>
+      <p:sp>
+        <p:nvSpPr>
+          <p:cNvPr id="5" name="TextBox 4"/>
+          <p:cNvSpPr txBox="1"/>
+          <p:nvPr/>
+        </p:nvSpPr>
+        <p:spPr>
+          <a:xfrm>
+            <a:off x="274320" y="548640"/>
+            <a:ext cx="11430000" cy="365760"/>
+          </a:xfrm>
+          <a:prstGeom prst="rect">
+            <a:avLst/>
+          </a:prstGeom>
+          <a:noFill/>
+        </p:spPr>
+        <p:txBody>
+          <a:bodyPr wrap="square">
+            <a:spAutoFit/>
+          </a:bodyPr>
+          <a:lstStyle/>
+          <a:p>
+            <a:pPr algn="l"/>
+            <a:r>
+              <a:rPr sz="1300" b="0">
+                <a:solidFill>
+                  <a:srgbClr val="F2F2F2"/>
+                </a:solidFill>
+              </a:rPr>
+              <a:t>Andersen-Gill counting-process Cox — monthly rate_incentive, unemployment, HPI</a:t>
+            </a:r>
+          </a:p>
+        </p:txBody>
+      </p:sp>
+      <p:sp>
+        <p:nvSpPr>
+          <p:cNvPr id="6" name="Rectangle 5"/>
+          <p:cNvSpPr/>
+          <p:nvPr/>
+        </p:nvSpPr>
+        <p:spPr>
+          <a:xfrm>
+            <a:off x="0" y="1005840"/>
+            <a:ext cx="12188952" cy="5852160"/>
+          </a:xfrm>
+          <a:prstGeom prst="rect">
+            <a:avLst/>
+          </a:prstGeom>
+          <a:solidFill>
+            <a:srgbClr val="F2F2F2"/>
+          </a:solidFill>
+          <a:ln>
+            <a:noFill/>
+          </a:ln>
+        </p:spPr>
+        <p:style>
+          <a:lnRef idx="1">
+            <a:schemeClr val="accent1"/>
+          </a:lnRef>
+          <a:fillRef idx="3">
+            <a:schemeClr val="accent1"/>
+          </a:fillRef>
+          <a:effectRef idx="2">
+            <a:schemeClr val="accent1"/>
+          </a:effectRef>
+          <a:fontRef idx="minor">
+            <a:schemeClr val="lt1"/>
+          </a:fontRef>
+        </p:style>
+        <p:txBody>
+          <a:bodyPr rtlCol="0" anchor="ctr"/>
+          <a:lstStyle/>
+          <a:p>
+            <a:pPr algn="ctr"/>
+          </a:p>
+        </p:txBody>
+      </p:sp>
+      <p:sp>
+        <p:nvSpPr>
+          <p:cNvPr id="7" name="TextBox 6"/>
+          <p:cNvSpPr txBox="1"/>
+          <p:nvPr/>
+        </p:nvSpPr>
+        <p:spPr>
+          <a:xfrm>
+            <a:off x="457200" y="1188720"/>
+            <a:ext cx="11247120" cy="5029200"/>
+          </a:xfrm>
+          <a:prstGeom prst="rect">
+            <a:avLst/>
+          </a:prstGeom>
+          <a:noFill/>
+        </p:spPr>
+        <p:txBody>
+          <a:bodyPr wrap="square">
+            <a:spAutoFit/>
+          </a:bodyPr>
+          <a:lstStyle/>
+          <a:p>
+            <a:pPr>
+              <a:spcAft>
+                <a:spcPts val="400"/>
+              </a:spcAft>
+              <a:defRPr sz="1300"/>
+            </a:pPr>
+            <a:r>
+              <a:t>• Panel dataset: 93M rows × 2M loans — mortgage_rate, unemployment, HPI YoY, rate_incentive updated monthly</a:t>
+            </a:r>
+          </a:p>
+          <a:p>
+            <a:pPr>
+              <a:spcAft>
+                <a:spcPts val="400"/>
+              </a:spcAft>
+              <a:defRPr sz="1300"/>
+            </a:pPr>
+            <a:r>
+              <a:t>• 10,000 loans stratified by vintage → ~500K counting-process rows (tstart, tstop, event)</a:t>
+            </a:r>
+          </a:p>
+          <a:p>
+            <a:pPr>
+              <a:spcAft>
+                <a:spcPts val="400"/>
+              </a:spcAft>
+              <a:defRPr sz="1300"/>
+            </a:pPr>
+            <a:r>
+              <a:t>• 11 features: 7 static (FICO, LTV, DTI, UPB + 3 one-hot) + 4 time-varying</a:t>
+            </a:r>
+          </a:p>
+          <a:p>
+            <a:pPr>
+              <a:spcAft>
+                <a:spcPts val="400"/>
+              </a:spcAft>
+              <a:defRPr sz="1300"/>
+            </a:pPr>
+            <a:r>
+              <a:t>• Key finding: current rate_incentive coefficient LARGER than origination-vintage snapshot</a:t>
+            </a:r>
+          </a:p>
+          <a:p>
+            <a:pPr>
+              <a:spcAft>
+                <a:spcPts val="400"/>
+              </a:spcAft>
+              <a:defRPr sz="1300"/>
+            </a:pPr>
+            <a:r>
+              <a:t>•    Static Cox: rate_incentive locked at origination — high-rate era loans always look attractive</a:t>
+            </a:r>
+          </a:p>
+          <a:p>
+            <a:pPr>
+              <a:spcAft>
+                <a:spcPts val="400"/>
+              </a:spcAft>
+              <a:defRPr sz="1300"/>
+            </a:pPr>
+            <a:r>
+              <a:t>•    TV Cox: tracks actual monthly refi option value — more responsive to rate cycles</a:t>
+            </a:r>
+          </a:p>
+          <a:p>
+            <a:pPr>
+              <a:spcAft>
+                <a:spcPts val="400"/>
+              </a:spcAft>
+              <a:defRPr sz="1300"/>
+            </a:pPr>
+            <a:r>
+              <a:t>• Unemployment: contemporaneous job loss predicts default better than vintage average</a:t>
+            </a:r>
+          </a:p>
+          <a:p>
+            <a:pPr>
+              <a:spcAft>
+                <a:spcPts val="400"/>
+              </a:spcAft>
+              <a:defRPr sz="1300"/>
+            </a:pPr>
+            <a:r>
+              <a:t>• Limitation: origination LTV used (not ELTV) — adding current LTV would improve default hazard</a:t>
+            </a:r>
+          </a:p>
+        </p:txBody>
+      </p:sp>
     </p:spTree>
   </p:cSld>
   <p:clrMapOvr>
@@ -4775,48 +4786,14 @@
                   <a:srgbClr val="FFFFFF"/>
                 </a:solidFill>
               </a:rPr>
-              <a:t>E(iv) — Scenario Analysis: Interest Rate Shocks</a:t>
-            </a:r>
-          </a:p>
-        </p:txBody>
-      </p:sp>
-      <p:sp>
-        <p:nvSpPr>
-          <p:cNvPr id="5" name="TextBox 4"/>
-          <p:cNvSpPr txBox="1"/>
-          <p:nvPr/>
-        </p:nvSpPr>
-        <p:spPr>
-          <a:xfrm>
-            <a:off x="274320" y="548640"/>
-            <a:ext cx="11430000" cy="365760"/>
-          </a:xfrm>
-          <a:prstGeom prst="rect">
-            <a:avLst/>
-          </a:prstGeom>
-          <a:noFill/>
-        </p:spPr>
-        <p:txBody>
-          <a:bodyPr wrap="square">
-            <a:spAutoFit/>
-          </a:bodyPr>
-          <a:lstStyle/>
-          <a:p>
-            <a:pPr algn="l"/>
-            <a:r>
-              <a:rPr sz="1300" b="0">
-                <a:solidFill>
-                  <a:srgbClr val="F2F2F2"/>
-                </a:solidFill>
-              </a:rPr>
-              <a:t>±100 bp and ±200 bp shocks to mortgage_rate  (rate_incentive updated consistently)</a:t>
+              <a:t>E(ii) — TV Cox Results</a:t>
             </a:r>
           </a:p>
         </p:txBody>
       </p:sp>
       <p:pic>
         <p:nvPicPr>
-          <p:cNvPr id="6" name="Picture 5" descr="E2_scenario_analysis.png"/>
+          <p:cNvPr id="5" name="Picture 4" descr="Eii_tv_cox_forest.png"/>
           <p:cNvPicPr>
             <a:picLocks noChangeAspect="1"/>
           </p:cNvPicPr>
@@ -4830,8 +4807,32 @@
         </p:blipFill>
         <p:spPr>
           <a:xfrm>
-            <a:off x="457200" y="1051560"/>
-            <a:ext cx="11247120" cy="3906695"/>
+            <a:off x="137160" y="1051560"/>
+            <a:ext cx="7132320" cy="3013704"/>
+          </a:xfrm>
+          <a:prstGeom prst="rect">
+            <a:avLst/>
+          </a:prstGeom>
+        </p:spPr>
+      </p:pic>
+      <p:pic>
+        <p:nvPicPr>
+          <p:cNvPr id="6" name="Picture 5" descr="Eii_static_vs_tv.png"/>
+          <p:cNvPicPr>
+            <a:picLocks noChangeAspect="1"/>
+          </p:cNvPicPr>
+          <p:nvPr/>
+        </p:nvPicPr>
+        <p:blipFill>
+          <a:blip r:embed="rId3"/>
+          <a:stretch>
+            <a:fillRect/>
+          </a:stretch>
+        </p:blipFill>
+        <p:spPr>
+          <a:xfrm>
+            <a:off x="7406640" y="1051560"/>
+            <a:ext cx="4572000" cy="2247385"/>
           </a:xfrm>
           <a:prstGeom prst="rect">
             <a:avLst/>
@@ -4971,64 +4972,21 @@
                   <a:srgbClr val="FFFFFF"/>
                 </a:solidFill>
               </a:rPr>
-              <a:t>E(iv) — Scenario Analysis: Interpretation</a:t>
-            </a:r>
-          </a:p>
-        </p:txBody>
-      </p:sp>
-      <p:sp>
-        <p:nvSpPr>
-          <p:cNvPr id="5" name="Rectangle 4"/>
-          <p:cNvSpPr/>
-          <p:nvPr/>
-        </p:nvSpPr>
-        <p:spPr>
-          <a:xfrm>
-            <a:off x="0" y="1005840"/>
-            <a:ext cx="12188952" cy="5852160"/>
-          </a:xfrm>
-          <a:prstGeom prst="rect">
-            <a:avLst/>
-          </a:prstGeom>
-          <a:solidFill>
-            <a:srgbClr val="F2F2F2"/>
-          </a:solidFill>
-          <a:ln>
-            <a:noFill/>
-          </a:ln>
-        </p:spPr>
-        <p:style>
-          <a:lnRef idx="1">
-            <a:schemeClr val="accent1"/>
-          </a:lnRef>
-          <a:fillRef idx="3">
-            <a:schemeClr val="accent1"/>
-          </a:fillRef>
-          <a:effectRef idx="2">
-            <a:schemeClr val="accent1"/>
-          </a:effectRef>
-          <a:fontRef idx="minor">
-            <a:schemeClr val="lt1"/>
-          </a:fontRef>
-        </p:style>
-        <p:txBody>
-          <a:bodyPr rtlCol="0" anchor="ctr"/>
-          <a:lstStyle/>
-          <a:p>
-            <a:pPr algn="ctr"/>
-          </a:p>
-        </p:txBody>
-      </p:sp>
-      <p:sp>
-        <p:nvSpPr>
-          <p:cNvPr id="6" name="TextBox 5"/>
+              <a:t>E(iv) — Scenario Analysis: Interest Rate Shocks</a:t>
+            </a:r>
+          </a:p>
+        </p:txBody>
+      </p:sp>
+      <p:sp>
+        <p:nvSpPr>
+          <p:cNvPr id="5" name="TextBox 4"/>
           <p:cNvSpPr txBox="1"/>
           <p:nvPr/>
         </p:nvSpPr>
         <p:spPr>
           <a:xfrm>
-            <a:off x="457200" y="1188720"/>
-            <a:ext cx="11247120" cy="5029200"/>
+            <a:off x="274320" y="548640"/>
+            <a:ext cx="11430000" cy="365760"/>
           </a:xfrm>
           <a:prstGeom prst="rect">
             <a:avLst/>
@@ -5041,84 +4999,42 @@
           </a:bodyPr>
           <a:lstStyle/>
           <a:p>
-            <a:pPr>
-              <a:spcAft>
-                <a:spcPts val="400"/>
-              </a:spcAft>
-              <a:defRPr sz="1500"/>
-            </a:pPr>
-            <a:r>
-              <a:t>• XGBoost: clear monotone CONVEX response — rate cuts raise prepayment probability more than rate rises suppress it</a:t>
-            </a:r>
-          </a:p>
-          <a:p>
-            <a:pPr>
-              <a:spcAft>
-                <a:spcPts val="400"/>
-              </a:spcAft>
-              <a:defRPr sz="1500"/>
-            </a:pPr>
-            <a:r>
-              <a:t>• Deep Cox: monotone but smoother — log-hazard is a less non-linear function of rate_incentive</a:t>
-            </a:r>
-          </a:p>
-          <a:p>
-            <a:pPr>
-              <a:spcAft>
-                <a:spcPts val="400"/>
-              </a:spcAft>
-              <a:defRPr sz="1500"/>
-            </a:pPr>
-            <a:r>
-              <a:t>• Asymmetry (−200 bp effect &gt; +200 bp effect) reflects the BURNOUT effect:</a:t>
-            </a:r>
-          </a:p>
-          <a:p>
-            <a:pPr>
-              <a:spcAft>
-                <a:spcPts val="400"/>
-              </a:spcAft>
-              <a:defRPr sz="1500"/>
-            </a:pPr>
-            <a:r>
-              <a:t>•    most rate-sensitive borrowers have already prepaid → muted upside response to cuts</a:t>
-            </a:r>
-          </a:p>
-          <a:p>
-            <a:pPr>
-              <a:spcAft>
-                <a:spcPts val="400"/>
-              </a:spcAft>
-              <a:defRPr sz="1500"/>
-            </a:pPr>
-            <a:r>
-              <a:t>• Both models agree on direction → robustness of rate-incentive channel across architectures</a:t>
-            </a:r>
-          </a:p>
-          <a:p>
-            <a:pPr>
-              <a:spcAft>
-                <a:spcPts val="400"/>
-              </a:spcAft>
-              <a:defRPr sz="1500"/>
-            </a:pPr>
-            <a:r>
-              <a:t>• Implication for MBS pricing: prepayment option has POSITIVE CONVEXITY —</a:t>
-            </a:r>
-          </a:p>
-          <a:p>
-            <a:pPr>
-              <a:spcAft>
-                <a:spcPts val="400"/>
-              </a:spcAft>
-              <a:defRPr sz="1500"/>
-            </a:pPr>
-            <a:r>
-              <a:t>•    rate decline creates more prepayment than rate rise suppresses it</a:t>
-            </a:r>
-          </a:p>
-        </p:txBody>
-      </p:sp>
+            <a:pPr algn="l"/>
+            <a:r>
+              <a:rPr sz="1300" b="0">
+                <a:solidFill>
+                  <a:srgbClr val="F2F2F2"/>
+                </a:solidFill>
+              </a:rPr>
+              <a:t>±100 bp and ±200 bp shocks to mortgage_rate  (rate_incentive updated consistently)</a:t>
+            </a:r>
+          </a:p>
+        </p:txBody>
+      </p:sp>
+      <p:pic>
+        <p:nvPicPr>
+          <p:cNvPr id="6" name="Picture 5" descr="E2_scenario_analysis.png"/>
+          <p:cNvPicPr>
+            <a:picLocks noChangeAspect="1"/>
+          </p:cNvPicPr>
+          <p:nvPr/>
+        </p:nvPicPr>
+        <p:blipFill>
+          <a:blip r:embed="rId2"/>
+          <a:stretch>
+            <a:fillRect/>
+          </a:stretch>
+        </p:blipFill>
+        <p:spPr>
+          <a:xfrm>
+            <a:off x="457200" y="1051560"/>
+            <a:ext cx="11247120" cy="3906695"/>
+          </a:xfrm>
+          <a:prstGeom prst="rect">
+            <a:avLst/>
+          </a:prstGeom>
+        </p:spPr>
+      </p:pic>
     </p:spTree>
   </p:cSld>
   <p:clrMapOvr>
@@ -5128,6 +5044,287 @@
 </file>
 
 <file path=ppt/slides/slide17.xml><?xml version="1.0" encoding="utf-8"?>
+<p:sld xmlns:a="http://schemas.openxmlformats.org/drawingml/2006/main" xmlns:p="http://schemas.openxmlformats.org/presentationml/2006/main" xmlns:r="http://schemas.openxmlformats.org/officeDocument/2006/relationships">
+  <p:cSld>
+    <p:spTree>
+      <p:nvGrpSpPr>
+        <p:cNvPr id="1" name=""/>
+        <p:cNvGrpSpPr/>
+        <p:nvPr/>
+      </p:nvGrpSpPr>
+      <p:grpSpPr/>
+      <p:sp>
+        <p:nvSpPr>
+          <p:cNvPr id="2" name="Rectangle 1"/>
+          <p:cNvSpPr/>
+          <p:nvPr/>
+        </p:nvSpPr>
+        <p:spPr>
+          <a:xfrm>
+            <a:off x="0" y="0"/>
+            <a:ext cx="12188952" cy="960120"/>
+          </a:xfrm>
+          <a:prstGeom prst="rect">
+            <a:avLst/>
+          </a:prstGeom>
+          <a:solidFill>
+            <a:srgbClr val="1F3963"/>
+          </a:solidFill>
+          <a:ln>
+            <a:noFill/>
+          </a:ln>
+        </p:spPr>
+        <p:style>
+          <a:lnRef idx="1">
+            <a:schemeClr val="accent1"/>
+          </a:lnRef>
+          <a:fillRef idx="3">
+            <a:schemeClr val="accent1"/>
+          </a:fillRef>
+          <a:effectRef idx="2">
+            <a:schemeClr val="accent1"/>
+          </a:effectRef>
+          <a:fontRef idx="minor">
+            <a:schemeClr val="lt1"/>
+          </a:fontRef>
+        </p:style>
+        <p:txBody>
+          <a:bodyPr rtlCol="0" anchor="ctr"/>
+          <a:lstStyle/>
+          <a:p>
+            <a:pPr algn="ctr"/>
+          </a:p>
+        </p:txBody>
+      </p:sp>
+      <p:sp>
+        <p:nvSpPr>
+          <p:cNvPr id="3" name="Rectangle 2"/>
+          <p:cNvSpPr/>
+          <p:nvPr/>
+        </p:nvSpPr>
+        <p:spPr>
+          <a:xfrm>
+            <a:off x="0" y="960120"/>
+            <a:ext cx="12188952" cy="64008"/>
+          </a:xfrm>
+          <a:prstGeom prst="rect">
+            <a:avLst/>
+          </a:prstGeom>
+          <a:solidFill>
+            <a:srgbClr val="FFC000"/>
+          </a:solidFill>
+          <a:ln>
+            <a:noFill/>
+          </a:ln>
+        </p:spPr>
+        <p:style>
+          <a:lnRef idx="1">
+            <a:schemeClr val="accent1"/>
+          </a:lnRef>
+          <a:fillRef idx="3">
+            <a:schemeClr val="accent1"/>
+          </a:fillRef>
+          <a:effectRef idx="2">
+            <a:schemeClr val="accent1"/>
+          </a:effectRef>
+          <a:fontRef idx="minor">
+            <a:schemeClr val="lt1"/>
+          </a:fontRef>
+        </p:style>
+        <p:txBody>
+          <a:bodyPr rtlCol="0" anchor="ctr"/>
+          <a:lstStyle/>
+          <a:p>
+            <a:pPr algn="ctr"/>
+          </a:p>
+        </p:txBody>
+      </p:sp>
+      <p:sp>
+        <p:nvSpPr>
+          <p:cNvPr id="4" name="TextBox 3"/>
+          <p:cNvSpPr txBox="1"/>
+          <p:nvPr/>
+        </p:nvSpPr>
+        <p:spPr>
+          <a:xfrm>
+            <a:off x="274320" y="54864"/>
+            <a:ext cx="11430000" cy="502920"/>
+          </a:xfrm>
+          <a:prstGeom prst="rect">
+            <a:avLst/>
+          </a:prstGeom>
+          <a:noFill/>
+        </p:spPr>
+        <p:txBody>
+          <a:bodyPr wrap="square">
+            <a:spAutoFit/>
+          </a:bodyPr>
+          <a:lstStyle/>
+          <a:p>
+            <a:pPr algn="l"/>
+            <a:r>
+              <a:rPr sz="2600" b="1">
+                <a:solidFill>
+                  <a:srgbClr val="FFFFFF"/>
+                </a:solidFill>
+              </a:rPr>
+              <a:t>E(iv) — Scenario Analysis: Interpretation</a:t>
+            </a:r>
+          </a:p>
+        </p:txBody>
+      </p:sp>
+      <p:sp>
+        <p:nvSpPr>
+          <p:cNvPr id="5" name="Rectangle 4"/>
+          <p:cNvSpPr/>
+          <p:nvPr/>
+        </p:nvSpPr>
+        <p:spPr>
+          <a:xfrm>
+            <a:off x="0" y="1005840"/>
+            <a:ext cx="12188952" cy="5852160"/>
+          </a:xfrm>
+          <a:prstGeom prst="rect">
+            <a:avLst/>
+          </a:prstGeom>
+          <a:solidFill>
+            <a:srgbClr val="F2F2F2"/>
+          </a:solidFill>
+          <a:ln>
+            <a:noFill/>
+          </a:ln>
+        </p:spPr>
+        <p:style>
+          <a:lnRef idx="1">
+            <a:schemeClr val="accent1"/>
+          </a:lnRef>
+          <a:fillRef idx="3">
+            <a:schemeClr val="accent1"/>
+          </a:fillRef>
+          <a:effectRef idx="2">
+            <a:schemeClr val="accent1"/>
+          </a:effectRef>
+          <a:fontRef idx="minor">
+            <a:schemeClr val="lt1"/>
+          </a:fontRef>
+        </p:style>
+        <p:txBody>
+          <a:bodyPr rtlCol="0" anchor="ctr"/>
+          <a:lstStyle/>
+          <a:p>
+            <a:pPr algn="ctr"/>
+          </a:p>
+        </p:txBody>
+      </p:sp>
+      <p:sp>
+        <p:nvSpPr>
+          <p:cNvPr id="6" name="TextBox 5"/>
+          <p:cNvSpPr txBox="1"/>
+          <p:nvPr/>
+        </p:nvSpPr>
+        <p:spPr>
+          <a:xfrm>
+            <a:off x="457200" y="1188720"/>
+            <a:ext cx="11247120" cy="5029200"/>
+          </a:xfrm>
+          <a:prstGeom prst="rect">
+            <a:avLst/>
+          </a:prstGeom>
+          <a:noFill/>
+        </p:spPr>
+        <p:txBody>
+          <a:bodyPr wrap="square">
+            <a:spAutoFit/>
+          </a:bodyPr>
+          <a:lstStyle/>
+          <a:p>
+            <a:pPr>
+              <a:spcAft>
+                <a:spcPts val="400"/>
+              </a:spcAft>
+              <a:defRPr sz="1500"/>
+            </a:pPr>
+            <a:r>
+              <a:t>• XGBoost: clear monotone CONVEX response — rate cuts raise prepayment probability more than rate rises suppress it</a:t>
+            </a:r>
+          </a:p>
+          <a:p>
+            <a:pPr>
+              <a:spcAft>
+                <a:spcPts val="400"/>
+              </a:spcAft>
+              <a:defRPr sz="1500"/>
+            </a:pPr>
+            <a:r>
+              <a:t>• Deep Cox: monotone but smoother — log-hazard is a less non-linear function of rate_incentive</a:t>
+            </a:r>
+          </a:p>
+          <a:p>
+            <a:pPr>
+              <a:spcAft>
+                <a:spcPts val="400"/>
+              </a:spcAft>
+              <a:defRPr sz="1500"/>
+            </a:pPr>
+            <a:r>
+              <a:t>• Asymmetry (−200 bp effect &gt; +200 bp effect) reflects the BURNOUT effect:</a:t>
+            </a:r>
+          </a:p>
+          <a:p>
+            <a:pPr>
+              <a:spcAft>
+                <a:spcPts val="400"/>
+              </a:spcAft>
+              <a:defRPr sz="1500"/>
+            </a:pPr>
+            <a:r>
+              <a:t>•    most rate-sensitive borrowers have already prepaid → muted upside response to cuts</a:t>
+            </a:r>
+          </a:p>
+          <a:p>
+            <a:pPr>
+              <a:spcAft>
+                <a:spcPts val="400"/>
+              </a:spcAft>
+              <a:defRPr sz="1500"/>
+            </a:pPr>
+            <a:r>
+              <a:t>• Both models agree on direction → robustness of rate-incentive channel across architectures</a:t>
+            </a:r>
+          </a:p>
+          <a:p>
+            <a:pPr>
+              <a:spcAft>
+                <a:spcPts val="400"/>
+              </a:spcAft>
+              <a:defRPr sz="1500"/>
+            </a:pPr>
+            <a:r>
+              <a:t>• Implication for MBS pricing: prepayment option has POSITIVE CONVEXITY —</a:t>
+            </a:r>
+          </a:p>
+          <a:p>
+            <a:pPr>
+              <a:spcAft>
+                <a:spcPts val="400"/>
+              </a:spcAft>
+              <a:defRPr sz="1500"/>
+            </a:pPr>
+            <a:r>
+              <a:t>•    rate decline creates more prepayment than rate rise suppresses it</a:t>
+            </a:r>
+          </a:p>
+        </p:txBody>
+      </p:sp>
+    </p:spTree>
+  </p:cSld>
+  <p:clrMapOvr>
+    <a:masterClrMapping/>
+  </p:clrMapOvr>
+</p:sld>
+</file>
+
+<file path=ppt/slides/slide18.xml><?xml version="1.0" encoding="utf-8"?>
 <p:sld xmlns:a="http://schemas.openxmlformats.org/drawingml/2006/main" xmlns:p="http://schemas.openxmlformats.org/presentationml/2006/main" xmlns:r="http://schemas.openxmlformats.org/officeDocument/2006/relationships">
   <p:cSld>
     <p:spTree>

</xml_diff>

<commit_message>
Add superimposed duration density overlay chart after individual histograms
- New E1_eda_duration_overlay.png: all three event types on one axes,
  normalised to density (proportion per month) so shapes are comparable;
  dashed medians and shaded fills per event type
- Inserted in notebook cell 9 (after plt.show for individual histograms)
- Added to LaTeX report as Fig 2 with caption and \label{fig:eda_duration_overlay}
- Added slide 3b in PPTX between duration histograms and vintage slides
- Rebuilt PDF and PPTX

Co-Authored-By: Claude Sonnet 4.6 <noreply@anthropic.com>
</commit_message>
<xml_diff>
--- a/processed/PartE_Presentation.pptx
+++ b/processed/PartE_Presentation.pptx
@@ -23,6 +23,7 @@
     <p:sldId id="271" r:id="rId22"/>
     <p:sldId id="272" r:id="rId23"/>
     <p:sldId id="273" r:id="rId24"/>
+    <p:sldId id="274" r:id="rId25"/>
   </p:sldIdLst>
   <p:sldSz cx="12188952" cy="6858000" type="screen4x3"/>
   <p:notesSz cx="6858000" cy="9144000"/>
@@ -3546,7 +3547,7 @@
                   <a:srgbClr val="FFFFFF"/>
                 </a:solidFill>
               </a:rPr>
-              <a:t>E(i)(d) — Stratified CIF</a:t>
+              <a:t>E(i)(c) — KM vs AJ: Why Defaults Cannot Be Treated as Censorings</a:t>
             </a:r>
           </a:p>
         </p:txBody>
@@ -3580,14 +3581,369 @@
                   <a:srgbClr val="F2F2F2"/>
                 </a:solidFill>
               </a:rPr>
-              <a:t>High-FICO → elevated prepayment, near-zero default;  high-LTV → inverted</a:t>
+              <a:t>Every AJ increment ≤ KM increment  →  F_AJ(t) ≤ F_KM(t)  →  growing bias</a:t>
+            </a:r>
+          </a:p>
+        </p:txBody>
+      </p:sp>
+      <p:sp>
+        <p:nvSpPr>
+          <p:cNvPr id="6" name="Rectangle 5"/>
+          <p:cNvSpPr/>
+          <p:nvPr/>
+        </p:nvSpPr>
+        <p:spPr>
+          <a:xfrm>
+            <a:off x="0" y="1024128"/>
+            <a:ext cx="12188952" cy="5833872"/>
+          </a:xfrm>
+          <a:prstGeom prst="rect">
+            <a:avLst/>
+          </a:prstGeom>
+          <a:solidFill>
+            <a:srgbClr val="F2F2F2"/>
+          </a:solidFill>
+          <a:ln>
+            <a:noFill/>
+          </a:ln>
+        </p:spPr>
+        <p:style>
+          <a:lnRef idx="1">
+            <a:schemeClr val="accent1"/>
+          </a:lnRef>
+          <a:fillRef idx="3">
+            <a:schemeClr val="accent1"/>
+          </a:fillRef>
+          <a:effectRef idx="2">
+            <a:schemeClr val="accent1"/>
+          </a:effectRef>
+          <a:fontRef idx="minor">
+            <a:schemeClr val="lt1"/>
+          </a:fontRef>
+        </p:style>
+        <p:txBody>
+          <a:bodyPr rtlCol="0" anchor="ctr"/>
+          <a:lstStyle/>
+          <a:p>
+            <a:pPr algn="ctr"/>
+          </a:p>
+        </p:txBody>
+      </p:sp>
+      <p:sp>
+        <p:nvSpPr>
+          <p:cNvPr id="7" name="TextBox 6"/>
+          <p:cNvSpPr txBox="1"/>
+          <p:nvPr/>
+        </p:nvSpPr>
+        <p:spPr>
+          <a:xfrm>
+            <a:off x="274320" y="1143000"/>
+            <a:ext cx="11612880" cy="365760"/>
+          </a:xfrm>
+          <a:prstGeom prst="rect">
+            <a:avLst/>
+          </a:prstGeom>
+          <a:noFill/>
+        </p:spPr>
+        <p:txBody>
+          <a:bodyPr wrap="square">
+            <a:spAutoFit/>
+          </a:bodyPr>
+          <a:lstStyle/>
+          <a:p>
+            <a:pPr algn="l"/>
+            <a:r>
+              <a:rPr sz="1200" b="1">
+                <a:solidFill>
+                  <a:srgbClr val="C00000"/>
+                </a:solidFill>
+              </a:rPr>
+              <a:t>KM increment at t_j  (defaults excluded from denominator n_j^KM &lt; n_j):</a:t>
+            </a:r>
+          </a:p>
+        </p:txBody>
+      </p:sp>
+      <p:sp>
+        <p:nvSpPr>
+          <p:cNvPr id="8" name="Rectangle 7"/>
+          <p:cNvSpPr/>
+          <p:nvPr/>
+        </p:nvSpPr>
+        <p:spPr>
+          <a:xfrm>
+            <a:off x="274320" y="1508760"/>
+            <a:ext cx="11612880" cy="548640"/>
+          </a:xfrm>
+          <a:prstGeom prst="rect">
+            <a:avLst/>
+          </a:prstGeom>
+          <a:solidFill>
+            <a:srgbClr val="EEF2F7"/>
+          </a:solidFill>
+          <a:ln>
+            <a:noFill/>
+          </a:ln>
+        </p:spPr>
+        <p:style>
+          <a:lnRef idx="1">
+            <a:schemeClr val="accent1"/>
+          </a:lnRef>
+          <a:fillRef idx="3">
+            <a:schemeClr val="accent1"/>
+          </a:fillRef>
+          <a:effectRef idx="2">
+            <a:schemeClr val="accent1"/>
+          </a:effectRef>
+          <a:fontRef idx="minor">
+            <a:schemeClr val="lt1"/>
+          </a:fontRef>
+        </p:style>
+        <p:txBody>
+          <a:bodyPr rtlCol="0" anchor="ctr"/>
+          <a:lstStyle/>
+          <a:p>
+            <a:pPr algn="ctr"/>
+          </a:p>
+        </p:txBody>
+      </p:sp>
+      <p:sp>
+        <p:nvSpPr>
+          <p:cNvPr id="9" name="TextBox 8"/>
+          <p:cNvSpPr txBox="1"/>
+          <p:nvPr/>
+        </p:nvSpPr>
+        <p:spPr>
+          <a:xfrm>
+            <a:off x="365760" y="1581912"/>
+            <a:ext cx="11430000" cy="457200"/>
+          </a:xfrm>
+          <a:prstGeom prst="rect">
+            <a:avLst/>
+          </a:prstGeom>
+          <a:noFill/>
+        </p:spPr>
+        <p:txBody>
+          <a:bodyPr wrap="square">
+            <a:spAutoFit/>
+          </a:bodyPr>
+          <a:lstStyle/>
+          <a:p>
+            <a:r>
+              <a:rPr sz="1300">
+                <a:solidFill>
+                  <a:srgbClr val="1F3963"/>
+                </a:solidFill>
+                <a:latin typeface="Courier New"/>
+              </a:rPr>
+              <a:t>ΔF_KM(t_j)  =  S_KM(t_j-)  *  d_{1j} / n_j^KM    ← n_j^KM underestimates risk set</a:t>
+            </a:r>
+          </a:p>
+        </p:txBody>
+      </p:sp>
+      <p:sp>
+        <p:nvSpPr>
+          <p:cNvPr id="10" name="TextBox 9"/>
+          <p:cNvSpPr txBox="1"/>
+          <p:nvPr/>
+        </p:nvSpPr>
+        <p:spPr>
+          <a:xfrm>
+            <a:off x="274320" y="2148840"/>
+            <a:ext cx="11612880" cy="365760"/>
+          </a:xfrm>
+          <a:prstGeom prst="rect">
+            <a:avLst/>
+          </a:prstGeom>
+          <a:noFill/>
+        </p:spPr>
+        <p:txBody>
+          <a:bodyPr wrap="square">
+            <a:spAutoFit/>
+          </a:bodyPr>
+          <a:lstStyle/>
+          <a:p>
+            <a:pPr algn="l"/>
+            <a:r>
+              <a:rPr sz="1200" b="1">
+                <a:solidFill>
+                  <a:srgbClr val="1F3963"/>
+                </a:solidFill>
+              </a:rPr>
+              <a:t>AJ increment at t_j  (overall survival, full risk set):</a:t>
+            </a:r>
+          </a:p>
+        </p:txBody>
+      </p:sp>
+      <p:sp>
+        <p:nvSpPr>
+          <p:cNvPr id="11" name="Rectangle 10"/>
+          <p:cNvSpPr/>
+          <p:nvPr/>
+        </p:nvSpPr>
+        <p:spPr>
+          <a:xfrm>
+            <a:off x="274320" y="2514600"/>
+            <a:ext cx="11612880" cy="548640"/>
+          </a:xfrm>
+          <a:prstGeom prst="rect">
+            <a:avLst/>
+          </a:prstGeom>
+          <a:solidFill>
+            <a:srgbClr val="EEF2F7"/>
+          </a:solidFill>
+          <a:ln>
+            <a:noFill/>
+          </a:ln>
+        </p:spPr>
+        <p:style>
+          <a:lnRef idx="1">
+            <a:schemeClr val="accent1"/>
+          </a:lnRef>
+          <a:fillRef idx="3">
+            <a:schemeClr val="accent1"/>
+          </a:fillRef>
+          <a:effectRef idx="2">
+            <a:schemeClr val="accent1"/>
+          </a:effectRef>
+          <a:fontRef idx="minor">
+            <a:schemeClr val="lt1"/>
+          </a:fontRef>
+        </p:style>
+        <p:txBody>
+          <a:bodyPr rtlCol="0" anchor="ctr"/>
+          <a:lstStyle/>
+          <a:p>
+            <a:pPr algn="ctr"/>
+          </a:p>
+        </p:txBody>
+      </p:sp>
+      <p:sp>
+        <p:nvSpPr>
+          <p:cNvPr id="12" name="TextBox 11"/>
+          <p:cNvSpPr txBox="1"/>
+          <p:nvPr/>
+        </p:nvSpPr>
+        <p:spPr>
+          <a:xfrm>
+            <a:off x="365760" y="2587752"/>
+            <a:ext cx="11430000" cy="457200"/>
+          </a:xfrm>
+          <a:prstGeom prst="rect">
+            <a:avLst/>
+          </a:prstGeom>
+          <a:noFill/>
+        </p:spPr>
+        <p:txBody>
+          <a:bodyPr wrap="square">
+            <a:spAutoFit/>
+          </a:bodyPr>
+          <a:lstStyle/>
+          <a:p>
+            <a:r>
+              <a:rPr sz="1300">
+                <a:solidFill>
+                  <a:srgbClr val="1F3963"/>
+                </a:solidFill>
+                <a:latin typeface="Courier New"/>
+              </a:rPr>
+              <a:t>ΔF_AJ(t_j)   =  S(t_j-)     *  d_{1j} / n_j      ← S(t_j-) ≤ S_KM(t_j-) always</a:t>
+            </a:r>
+          </a:p>
+        </p:txBody>
+      </p:sp>
+      <p:sp>
+        <p:nvSpPr>
+          <p:cNvPr id="13" name="TextBox 12"/>
+          <p:cNvSpPr txBox="1"/>
+          <p:nvPr/>
+        </p:nvSpPr>
+        <p:spPr>
+          <a:xfrm>
+            <a:off x="274320" y="3154680"/>
+            <a:ext cx="11612880" cy="365760"/>
+          </a:xfrm>
+          <a:prstGeom prst="rect">
+            <a:avLst/>
+          </a:prstGeom>
+          <a:noFill/>
+        </p:spPr>
+        <p:txBody>
+          <a:bodyPr wrap="square">
+            <a:spAutoFit/>
+          </a:bodyPr>
+          <a:lstStyle/>
+          <a:p>
+            <a:pPr algn="l"/>
+            <a:r>
+              <a:rPr sz="1200" b="1">
+                <a:solidFill>
+                  <a:srgbClr val="1F3963"/>
+                </a:solidFill>
+              </a:rPr>
+              <a:t>Consequence — bias compounds over time:</a:t>
+            </a:r>
+          </a:p>
+        </p:txBody>
+      </p:sp>
+      <p:sp>
+        <p:nvSpPr>
+          <p:cNvPr id="14" name="TextBox 13"/>
+          <p:cNvSpPr txBox="1"/>
+          <p:nvPr/>
+        </p:nvSpPr>
+        <p:spPr>
+          <a:xfrm>
+            <a:off x="274320" y="3520440"/>
+            <a:ext cx="11612880" cy="1005840"/>
+          </a:xfrm>
+          <a:prstGeom prst="rect">
+            <a:avLst/>
+          </a:prstGeom>
+          <a:noFill/>
+        </p:spPr>
+        <p:txBody>
+          <a:bodyPr wrap="square">
+            <a:spAutoFit/>
+          </a:bodyPr>
+          <a:lstStyle/>
+          <a:p>
+            <a:pPr>
+              <a:spcAft>
+                <a:spcPts val="400"/>
+              </a:spcAft>
+              <a:defRPr sz="1300"/>
+            </a:pPr>
+            <a:r>
+              <a:t>• 5 yr:  KM over-estimates prepayment CIF by ~+0.45 pp</a:t>
+            </a:r>
+          </a:p>
+          <a:p>
+            <a:pPr>
+              <a:spcAft>
+                <a:spcPts val="400"/>
+              </a:spcAft>
+              <a:defRPr sz="1300"/>
+            </a:pPr>
+            <a:r>
+              <a:t>• 10 yr: bias ≈ +1.31 pp</a:t>
+            </a:r>
+          </a:p>
+          <a:p>
+            <a:pPr>
+              <a:spcAft>
+                <a:spcPts val="400"/>
+              </a:spcAft>
+              <a:defRPr sz="1300"/>
+            </a:pPr>
+            <a:r>
+              <a:t>• 20 yr: bias ≈ +2.23 pp  (gap widens as defaulted loans accumulate)</a:t>
             </a:r>
           </a:p>
         </p:txBody>
       </p:sp>
       <p:pic>
         <p:nvPicPr>
-          <p:cNvPr id="6" name="Picture 5" descr="E1_stratified_cif.png"/>
+          <p:cNvPr id="15" name="Picture 14" descr="E1_km_vs_aj_bias.png"/>
           <p:cNvPicPr>
             <a:picLocks noChangeAspect="1"/>
           </p:cNvPicPr>
@@ -3601,8 +3957,8 @@
         </p:blipFill>
         <p:spPr>
           <a:xfrm>
-            <a:off x="274320" y="1051560"/>
-            <a:ext cx="5186826" cy="5303520"/>
+            <a:off x="274320" y="4572000"/>
+            <a:ext cx="11612880" cy="3513594"/>
           </a:xfrm>
           <a:prstGeom prst="rect">
             <a:avLst/>
@@ -3742,7 +4098,7 @@
                   <a:srgbClr val="FFFFFF"/>
                 </a:solidFill>
               </a:rPr>
-              <a:t>E(i)(e) — Cause-Specific Cox: Prepayment  (sorted ascending)</a:t>
+              <a:t>E(i)(d) — Stratified CIF</a:t>
             </a:r>
           </a:p>
         </p:txBody>
@@ -3776,14 +4132,14 @@
                   <a:srgbClr val="F2F2F2"/>
                 </a:solidFill>
               </a:rPr>
-              <a:t>Rate incentive &amp; Purchase purpose → highest refi hazard  ·  12 features  ·  95% CI</a:t>
+              <a:t>High-FICO → elevated prepayment, near-zero default;  high-LTV → inverted</a:t>
             </a:r>
           </a:p>
         </p:txBody>
       </p:sp>
       <p:pic>
         <p:nvPicPr>
-          <p:cNvPr id="6" name="Picture 5" descr="E1_cox_prepay.png"/>
+          <p:cNvPr id="6" name="Picture 5" descr="E1_stratified_cif.png"/>
           <p:cNvPicPr>
             <a:picLocks noChangeAspect="1"/>
           </p:cNvPicPr>
@@ -3798,7 +4154,7 @@
         <p:spPr>
           <a:xfrm>
             <a:off x="274320" y="1051560"/>
-            <a:ext cx="8394245" cy="5303520"/>
+            <a:ext cx="5186826" cy="5303520"/>
           </a:xfrm>
           <a:prstGeom prst="rect">
             <a:avLst/>
@@ -3938,7 +4294,7 @@
                   <a:srgbClr val="FFFFFF"/>
                 </a:solidFill>
               </a:rPr>
-              <a:t>E(i)(e) — Cause-Specific Cox: Default  (sorted ascending)</a:t>
+              <a:t>E(i)(e) — Cause-Specific Cox: Prepayment  (sorted ascending)</a:t>
             </a:r>
           </a:p>
         </p:txBody>
@@ -3972,14 +4328,14 @@
                   <a:srgbClr val="F2F2F2"/>
                 </a:solidFill>
               </a:rPr>
-              <a:t>LTV &amp; DTI → highest default hazard  ·  CreditScore opposite sign to prepayment</a:t>
+              <a:t>Rate incentive &amp; Purchase purpose → highest refi hazard  ·  12 features  ·  95% CI</a:t>
             </a:r>
           </a:p>
         </p:txBody>
       </p:sp>
       <p:pic>
         <p:nvPicPr>
-          <p:cNvPr id="6" name="Picture 5" descr="E1_cox_default.png"/>
+          <p:cNvPr id="6" name="Picture 5" descr="E1_cox_prepay.png"/>
           <p:cNvPicPr>
             <a:picLocks noChangeAspect="1"/>
           </p:cNvPicPr>
@@ -3994,7 +4350,7 @@
         <p:spPr>
           <a:xfrm>
             <a:off x="274320" y="1051560"/>
-            <a:ext cx="8394245" cy="5303520"/>
+            <a:ext cx="8425049" cy="5303520"/>
           </a:xfrm>
           <a:prstGeom prst="rect">
             <a:avLst/>
@@ -4134,7 +4490,7 @@
                   <a:srgbClr val="FFFFFF"/>
                 </a:solidFill>
               </a:rPr>
-              <a:t>E(i)(f) — Fine-Gray Subdistribution Hazard</a:t>
+              <a:t>E(i)(e) — Cause-Specific Cox: Default  (sorted ascending)</a:t>
             </a:r>
           </a:p>
         </p:txBody>
@@ -4168,165 +4524,35 @@
                   <a:srgbClr val="F2F2F2"/>
                 </a:solidFill>
               </a:rPr>
-              <a:t>IPCW-weighted Cox approximation; coefficients directly target the CIF</a:t>
-            </a:r>
-          </a:p>
-        </p:txBody>
-      </p:sp>
-      <p:sp>
-        <p:nvSpPr>
-          <p:cNvPr id="6" name="Rectangle 5"/>
-          <p:cNvSpPr/>
-          <p:nvPr/>
-        </p:nvSpPr>
-        <p:spPr>
-          <a:xfrm>
-            <a:off x="0" y="1005840"/>
-            <a:ext cx="12188952" cy="5852160"/>
-          </a:xfrm>
-          <a:prstGeom prst="rect">
-            <a:avLst/>
-          </a:prstGeom>
-          <a:solidFill>
-            <a:srgbClr val="F2F2F2"/>
-          </a:solidFill>
-          <a:ln>
-            <a:noFill/>
-          </a:ln>
-        </p:spPr>
-        <p:style>
-          <a:lnRef idx="1">
-            <a:schemeClr val="accent1"/>
-          </a:lnRef>
-          <a:fillRef idx="3">
-            <a:schemeClr val="accent1"/>
-          </a:fillRef>
-          <a:effectRef idx="2">
-            <a:schemeClr val="accent1"/>
-          </a:effectRef>
-          <a:fontRef idx="minor">
-            <a:schemeClr val="lt1"/>
-          </a:fontRef>
-        </p:style>
-        <p:txBody>
-          <a:bodyPr rtlCol="0" anchor="ctr"/>
-          <a:lstStyle/>
-          <a:p>
-            <a:pPr algn="ctr"/>
-          </a:p>
-        </p:txBody>
-      </p:sp>
-      <p:sp>
-        <p:nvSpPr>
-          <p:cNvPr id="7" name="TextBox 6"/>
-          <p:cNvSpPr txBox="1"/>
-          <p:nvPr/>
-        </p:nvSpPr>
-        <p:spPr>
-          <a:xfrm>
-            <a:off x="457200" y="1188720"/>
-            <a:ext cx="11247120" cy="5029200"/>
-          </a:xfrm>
-          <a:prstGeom prst="rect">
-            <a:avLst/>
-          </a:prstGeom>
-          <a:noFill/>
-        </p:spPr>
-        <p:txBody>
-          <a:bodyPr wrap="square">
-            <a:spAutoFit/>
-          </a:bodyPr>
-          <a:lstStyle/>
-          <a:p>
-            <a:pPr>
-              <a:spcAft>
-                <a:spcPts val="400"/>
-              </a:spcAft>
-              <a:defRPr sz="1400"/>
-            </a:pPr>
-            <a:r>
-              <a:t>• Subjects who experienced a competing event (default) are KEPT in the risk set with IPCW weights</a:t>
-            </a:r>
-          </a:p>
-          <a:p>
-            <a:pPr>
-              <a:spcAft>
-                <a:spcPts val="400"/>
-              </a:spcAft>
-              <a:defRPr sz="1400"/>
-            </a:pPr>
-            <a:r>
-              <a:t>• The subdistribution hazard integrates to the CIF — covariate effects are CIF effects</a:t>
-            </a:r>
-          </a:p>
-          <a:p>
-            <a:pPr>
-              <a:spcAft>
-                <a:spcPts val="400"/>
-              </a:spcAft>
-              <a:defRPr sz="1400"/>
-            </a:pPr>
-            <a:r>
-              <a:t>• rate_incentive HR is LARGER under Fine-Gray than cause-specific Cox:</a:t>
-            </a:r>
-          </a:p>
-          <a:p>
-            <a:pPr>
-              <a:spcAft>
-                <a:spcPts val="400"/>
-              </a:spcAft>
-              <a:defRPr sz="1400"/>
-            </a:pPr>
-            <a:r>
-              <a:t>•    high-incentive loans are also less likely to default first → amplifies CIF effect</a:t>
-            </a:r>
-          </a:p>
-          <a:p>
-            <a:pPr>
-              <a:spcAft>
-                <a:spcPts val="400"/>
-              </a:spcAft>
-              <a:defRPr sz="1400"/>
-            </a:pPr>
-            <a:r>
-              <a:t>• Low-FICO Fine-Gray HR for prepayment is ATTENUATED: elevated default risk reduces</a:t>
-            </a:r>
-          </a:p>
-          <a:p>
-            <a:pPr>
-              <a:spcAft>
-                <a:spcPts val="400"/>
-              </a:spcAft>
-              <a:defRPr sz="1400"/>
-            </a:pPr>
-            <a:r>
-              <a:t>•    measured prepayment propensity once competing risks are accounted for</a:t>
-            </a:r>
-          </a:p>
-          <a:p>
-            <a:pPr>
-              <a:spcAft>
-                <a:spcPts val="400"/>
-              </a:spcAft>
-              <a:defRPr sz="1400"/>
-            </a:pPr>
-            <a:r>
-              <a:t>• Use Fine-Gray for CIF prediction / loss forecasting</a:t>
-            </a:r>
-          </a:p>
-          <a:p>
-            <a:pPr>
-              <a:spcAft>
-                <a:spcPts val="400"/>
-              </a:spcAft>
-              <a:defRPr sz="1400"/>
-            </a:pPr>
-            <a:r>
-              <a:t>• Use cause-specific Cox for economic mechanism estimation</a:t>
-            </a:r>
-          </a:p>
-        </p:txBody>
-      </p:sp>
+              <a:t>LTV &amp; DTI → highest default hazard  ·  CreditScore opposite sign to prepayment</a:t>
+            </a:r>
+          </a:p>
+        </p:txBody>
+      </p:sp>
+      <p:pic>
+        <p:nvPicPr>
+          <p:cNvPr id="6" name="Picture 5" descr="E1_cox_default.png"/>
+          <p:cNvPicPr>
+            <a:picLocks noChangeAspect="1"/>
+          </p:cNvPicPr>
+          <p:nvPr/>
+        </p:nvPicPr>
+        <p:blipFill>
+          <a:blip r:embed="rId2"/>
+          <a:stretch>
+            <a:fillRect/>
+          </a:stretch>
+        </p:blipFill>
+        <p:spPr>
+          <a:xfrm>
+            <a:off x="274320" y="1051560"/>
+            <a:ext cx="8404513" cy="5303520"/>
+          </a:xfrm>
+          <a:prstGeom prst="rect">
+            <a:avLst/>
+          </a:prstGeom>
+        </p:spPr>
+      </p:pic>
     </p:spTree>
   </p:cSld>
   <p:clrMapOvr>
@@ -4460,7 +4686,7 @@
                   <a:srgbClr val="FFFFFF"/>
                 </a:solidFill>
               </a:rPr>
-              <a:t>E(ii) — Time-Dependent Covariates</a:t>
+              <a:t>E(i)(f) — Fine-Gray Subdistribution Hazard</a:t>
             </a:r>
           </a:p>
         </p:txBody>
@@ -4494,7 +4720,7 @@
                   <a:srgbClr val="F2F2F2"/>
                 </a:solidFill>
               </a:rPr>
-              <a:t>Andersen-Gill counting-process Cox — monthly rate_incentive, unemployment, HPI</a:t>
+              <a:t>IPCW-weighted Cox approximation; coefficients directly target the CIF</a:t>
             </a:r>
           </a:p>
         </p:txBody>
@@ -4568,10 +4794,10 @@
               <a:spcAft>
                 <a:spcPts val="400"/>
               </a:spcAft>
-              <a:defRPr sz="1300"/>
+              <a:defRPr sz="1400"/>
             </a:pPr>
             <a:r>
-              <a:t>• Panel dataset: 93M rows × 2M loans — mortgage_rate, unemployment, HPI YoY, rate_incentive updated monthly</a:t>
+              <a:t>• Subjects who experienced a competing event (default) are KEPT in the risk set with IPCW weights</a:t>
             </a:r>
           </a:p>
           <a:p>
@@ -4579,10 +4805,10 @@
               <a:spcAft>
                 <a:spcPts val="400"/>
               </a:spcAft>
-              <a:defRPr sz="1300"/>
+              <a:defRPr sz="1400"/>
             </a:pPr>
             <a:r>
-              <a:t>• 10,000 loans stratified by vintage → ~500K counting-process rows (tstart, tstop, event)</a:t>
+              <a:t>• The subdistribution hazard integrates to the CIF — covariate effects are CIF effects</a:t>
             </a:r>
           </a:p>
           <a:p>
@@ -4590,10 +4816,10 @@
               <a:spcAft>
                 <a:spcPts val="400"/>
               </a:spcAft>
-              <a:defRPr sz="1300"/>
+              <a:defRPr sz="1400"/>
             </a:pPr>
             <a:r>
-              <a:t>• 11 features: 7 static (FICO, LTV, DTI, UPB + 3 one-hot) + 4 time-varying</a:t>
+              <a:t>• rate_incentive HR is LARGER under Fine-Gray than cause-specific Cox:</a:t>
             </a:r>
           </a:p>
           <a:p>
@@ -4601,10 +4827,10 @@
               <a:spcAft>
                 <a:spcPts val="400"/>
               </a:spcAft>
-              <a:defRPr sz="1300"/>
+              <a:defRPr sz="1400"/>
             </a:pPr>
             <a:r>
-              <a:t>• Key finding: current rate_incentive coefficient LARGER than origination-vintage snapshot</a:t>
+              <a:t>•    high-incentive loans are also less likely to default first → amplifies CIF effect</a:t>
             </a:r>
           </a:p>
           <a:p>
@@ -4612,10 +4838,10 @@
               <a:spcAft>
                 <a:spcPts val="400"/>
               </a:spcAft>
-              <a:defRPr sz="1300"/>
+              <a:defRPr sz="1400"/>
             </a:pPr>
             <a:r>
-              <a:t>•    Static Cox: rate_incentive locked at origination — high-rate era loans always look attractive</a:t>
+              <a:t>• Low-FICO Fine-Gray HR for prepayment is ATTENUATED: elevated default risk reduces</a:t>
             </a:r>
           </a:p>
           <a:p>
@@ -4623,10 +4849,10 @@
               <a:spcAft>
                 <a:spcPts val="400"/>
               </a:spcAft>
-              <a:defRPr sz="1300"/>
+              <a:defRPr sz="1400"/>
             </a:pPr>
             <a:r>
-              <a:t>•    TV Cox: tracks actual monthly refi option value — more responsive to rate cycles</a:t>
+              <a:t>•    measured prepayment propensity once competing risks are accounted for</a:t>
             </a:r>
           </a:p>
           <a:p>
@@ -4634,10 +4860,10 @@
               <a:spcAft>
                 <a:spcPts val="400"/>
               </a:spcAft>
-              <a:defRPr sz="1300"/>
+              <a:defRPr sz="1400"/>
             </a:pPr>
             <a:r>
-              <a:t>• Unemployment: contemporaneous job loss predicts default better than vintage average</a:t>
+              <a:t>• Use Fine-Gray for CIF prediction / loss forecasting</a:t>
             </a:r>
           </a:p>
           <a:p>
@@ -4645,10 +4871,10 @@
               <a:spcAft>
                 <a:spcPts val="400"/>
               </a:spcAft>
-              <a:defRPr sz="1300"/>
+              <a:defRPr sz="1400"/>
             </a:pPr>
             <a:r>
-              <a:t>• Limitation: origination LTV used (not ELTV) — adding current LTV would improve default hazard</a:t>
+              <a:t>• Use cause-specific Cox for economic mechanism estimation</a:t>
             </a:r>
           </a:p>
         </p:txBody>
@@ -4786,59 +5012,199 @@
                   <a:srgbClr val="FFFFFF"/>
                 </a:solidFill>
               </a:rPr>
-              <a:t>E(ii) — TV Cox Results</a:t>
-            </a:r>
-          </a:p>
-        </p:txBody>
-      </p:sp>
-      <p:pic>
-        <p:nvPicPr>
-          <p:cNvPr id="5" name="Picture 4" descr="Eii_tv_cox_forest.png"/>
-          <p:cNvPicPr>
-            <a:picLocks noChangeAspect="1"/>
-          </p:cNvPicPr>
-          <p:nvPr/>
-        </p:nvPicPr>
-        <p:blipFill>
-          <a:blip r:embed="rId2"/>
-          <a:stretch>
-            <a:fillRect/>
-          </a:stretch>
-        </p:blipFill>
-        <p:spPr>
-          <a:xfrm>
-            <a:off x="137160" y="1051560"/>
-            <a:ext cx="7132320" cy="3013704"/>
-          </a:xfrm>
-          <a:prstGeom prst="rect">
-            <a:avLst/>
-          </a:prstGeom>
-        </p:spPr>
-      </p:pic>
-      <p:pic>
-        <p:nvPicPr>
-          <p:cNvPr id="6" name="Picture 5" descr="Eii_static_vs_tv.png"/>
-          <p:cNvPicPr>
-            <a:picLocks noChangeAspect="1"/>
-          </p:cNvPicPr>
-          <p:nvPr/>
-        </p:nvPicPr>
-        <p:blipFill>
-          <a:blip r:embed="rId3"/>
-          <a:stretch>
-            <a:fillRect/>
-          </a:stretch>
-        </p:blipFill>
-        <p:spPr>
-          <a:xfrm>
-            <a:off x="7406640" y="1051560"/>
-            <a:ext cx="4572000" cy="2247385"/>
-          </a:xfrm>
-          <a:prstGeom prst="rect">
-            <a:avLst/>
-          </a:prstGeom>
-        </p:spPr>
-      </p:pic>
+              <a:t>E(ii) — Time-Dependent Covariates</a:t>
+            </a:r>
+          </a:p>
+        </p:txBody>
+      </p:sp>
+      <p:sp>
+        <p:nvSpPr>
+          <p:cNvPr id="5" name="TextBox 4"/>
+          <p:cNvSpPr txBox="1"/>
+          <p:nvPr/>
+        </p:nvSpPr>
+        <p:spPr>
+          <a:xfrm>
+            <a:off x="274320" y="548640"/>
+            <a:ext cx="11430000" cy="365760"/>
+          </a:xfrm>
+          <a:prstGeom prst="rect">
+            <a:avLst/>
+          </a:prstGeom>
+          <a:noFill/>
+        </p:spPr>
+        <p:txBody>
+          <a:bodyPr wrap="square">
+            <a:spAutoFit/>
+          </a:bodyPr>
+          <a:lstStyle/>
+          <a:p>
+            <a:pPr algn="l"/>
+            <a:r>
+              <a:rPr sz="1300" b="0">
+                <a:solidFill>
+                  <a:srgbClr val="F2F2F2"/>
+                </a:solidFill>
+              </a:rPr>
+              <a:t>Andersen-Gill counting-process Cox — monthly rate_incentive, unemployment, HPI</a:t>
+            </a:r>
+          </a:p>
+        </p:txBody>
+      </p:sp>
+      <p:sp>
+        <p:nvSpPr>
+          <p:cNvPr id="6" name="Rectangle 5"/>
+          <p:cNvSpPr/>
+          <p:nvPr/>
+        </p:nvSpPr>
+        <p:spPr>
+          <a:xfrm>
+            <a:off x="0" y="1005840"/>
+            <a:ext cx="12188952" cy="5852160"/>
+          </a:xfrm>
+          <a:prstGeom prst="rect">
+            <a:avLst/>
+          </a:prstGeom>
+          <a:solidFill>
+            <a:srgbClr val="F2F2F2"/>
+          </a:solidFill>
+          <a:ln>
+            <a:noFill/>
+          </a:ln>
+        </p:spPr>
+        <p:style>
+          <a:lnRef idx="1">
+            <a:schemeClr val="accent1"/>
+          </a:lnRef>
+          <a:fillRef idx="3">
+            <a:schemeClr val="accent1"/>
+          </a:fillRef>
+          <a:effectRef idx="2">
+            <a:schemeClr val="accent1"/>
+          </a:effectRef>
+          <a:fontRef idx="minor">
+            <a:schemeClr val="lt1"/>
+          </a:fontRef>
+        </p:style>
+        <p:txBody>
+          <a:bodyPr rtlCol="0" anchor="ctr"/>
+          <a:lstStyle/>
+          <a:p>
+            <a:pPr algn="ctr"/>
+          </a:p>
+        </p:txBody>
+      </p:sp>
+      <p:sp>
+        <p:nvSpPr>
+          <p:cNvPr id="7" name="TextBox 6"/>
+          <p:cNvSpPr txBox="1"/>
+          <p:nvPr/>
+        </p:nvSpPr>
+        <p:spPr>
+          <a:xfrm>
+            <a:off x="457200" y="1188720"/>
+            <a:ext cx="11247120" cy="5029200"/>
+          </a:xfrm>
+          <a:prstGeom prst="rect">
+            <a:avLst/>
+          </a:prstGeom>
+          <a:noFill/>
+        </p:spPr>
+        <p:txBody>
+          <a:bodyPr wrap="square">
+            <a:spAutoFit/>
+          </a:bodyPr>
+          <a:lstStyle/>
+          <a:p>
+            <a:pPr>
+              <a:spcAft>
+                <a:spcPts val="400"/>
+              </a:spcAft>
+              <a:defRPr sz="1300"/>
+            </a:pPr>
+            <a:r>
+              <a:t>• Panel dataset: 93M rows × 2M loans — mortgage_rate, unemployment, HPI YoY, rate_incentive updated monthly</a:t>
+            </a:r>
+          </a:p>
+          <a:p>
+            <a:pPr>
+              <a:spcAft>
+                <a:spcPts val="400"/>
+              </a:spcAft>
+              <a:defRPr sz="1300"/>
+            </a:pPr>
+            <a:r>
+              <a:t>• 10,000 loans stratified by vintage → ~500K counting-process rows (tstart, tstop, event)</a:t>
+            </a:r>
+          </a:p>
+          <a:p>
+            <a:pPr>
+              <a:spcAft>
+                <a:spcPts val="400"/>
+              </a:spcAft>
+              <a:defRPr sz="1300"/>
+            </a:pPr>
+            <a:r>
+              <a:t>• 11 features: 7 static (FICO, LTV, DTI, UPB + 3 one-hot) + 4 time-varying</a:t>
+            </a:r>
+          </a:p>
+          <a:p>
+            <a:pPr>
+              <a:spcAft>
+                <a:spcPts val="400"/>
+              </a:spcAft>
+              <a:defRPr sz="1300"/>
+            </a:pPr>
+            <a:r>
+              <a:t>• Key finding: current rate_incentive coefficient LARGER than origination-vintage snapshot</a:t>
+            </a:r>
+          </a:p>
+          <a:p>
+            <a:pPr>
+              <a:spcAft>
+                <a:spcPts val="400"/>
+              </a:spcAft>
+              <a:defRPr sz="1300"/>
+            </a:pPr>
+            <a:r>
+              <a:t>•    Static Cox: rate_incentive locked at origination — high-rate era loans always look attractive</a:t>
+            </a:r>
+          </a:p>
+          <a:p>
+            <a:pPr>
+              <a:spcAft>
+                <a:spcPts val="400"/>
+              </a:spcAft>
+              <a:defRPr sz="1300"/>
+            </a:pPr>
+            <a:r>
+              <a:t>•    TV Cox: tracks actual monthly refi option value — more responsive to rate cycles</a:t>
+            </a:r>
+          </a:p>
+          <a:p>
+            <a:pPr>
+              <a:spcAft>
+                <a:spcPts val="400"/>
+              </a:spcAft>
+              <a:defRPr sz="1300"/>
+            </a:pPr>
+            <a:r>
+              <a:t>• Unemployment: contemporaneous job loss predicts default better than vintage average</a:t>
+            </a:r>
+          </a:p>
+          <a:p>
+            <a:pPr>
+              <a:spcAft>
+                <a:spcPts val="400"/>
+              </a:spcAft>
+              <a:defRPr sz="1300"/>
+            </a:pPr>
+            <a:r>
+              <a:t>• Limitation: origination LTV used (not ELTV) — adding current LTV would improve default hazard</a:t>
+            </a:r>
+          </a:p>
+        </p:txBody>
+      </p:sp>
     </p:spTree>
   </p:cSld>
   <p:clrMapOvr>
@@ -4972,48 +5338,14 @@
                   <a:srgbClr val="FFFFFF"/>
                 </a:solidFill>
               </a:rPr>
-              <a:t>E(iv) — Scenario Analysis: Interest Rate Shocks</a:t>
-            </a:r>
-          </a:p>
-        </p:txBody>
-      </p:sp>
-      <p:sp>
-        <p:nvSpPr>
-          <p:cNvPr id="5" name="TextBox 4"/>
-          <p:cNvSpPr txBox="1"/>
-          <p:nvPr/>
-        </p:nvSpPr>
-        <p:spPr>
-          <a:xfrm>
-            <a:off x="274320" y="548640"/>
-            <a:ext cx="11430000" cy="365760"/>
-          </a:xfrm>
-          <a:prstGeom prst="rect">
-            <a:avLst/>
-          </a:prstGeom>
-          <a:noFill/>
-        </p:spPr>
-        <p:txBody>
-          <a:bodyPr wrap="square">
-            <a:spAutoFit/>
-          </a:bodyPr>
-          <a:lstStyle/>
-          <a:p>
-            <a:pPr algn="l"/>
-            <a:r>
-              <a:rPr sz="1300" b="0">
-                <a:solidFill>
-                  <a:srgbClr val="F2F2F2"/>
-                </a:solidFill>
-              </a:rPr>
-              <a:t>±100 bp and ±200 bp shocks to mortgage_rate  (rate_incentive updated consistently)</a:t>
+              <a:t>E(ii) — TV Cox Results</a:t>
             </a:r>
           </a:p>
         </p:txBody>
       </p:sp>
       <p:pic>
         <p:nvPicPr>
-          <p:cNvPr id="6" name="Picture 5" descr="E2_scenario_analysis.png"/>
+          <p:cNvPr id="5" name="Picture 4" descr="Eii_tv_cox_forest.png"/>
           <p:cNvPicPr>
             <a:picLocks noChangeAspect="1"/>
           </p:cNvPicPr>
@@ -5027,8 +5359,32 @@
         </p:blipFill>
         <p:spPr>
           <a:xfrm>
-            <a:off x="457200" y="1051560"/>
-            <a:ext cx="11247120" cy="3906695"/>
+            <a:off x="137160" y="1051560"/>
+            <a:ext cx="7132320" cy="3013704"/>
+          </a:xfrm>
+          <a:prstGeom prst="rect">
+            <a:avLst/>
+          </a:prstGeom>
+        </p:spPr>
+      </p:pic>
+      <p:pic>
+        <p:nvPicPr>
+          <p:cNvPr id="6" name="Picture 5" descr="Eii_static_vs_tv.png"/>
+          <p:cNvPicPr>
+            <a:picLocks noChangeAspect="1"/>
+          </p:cNvPicPr>
+          <p:nvPr/>
+        </p:nvPicPr>
+        <p:blipFill>
+          <a:blip r:embed="rId3"/>
+          <a:stretch>
+            <a:fillRect/>
+          </a:stretch>
+        </p:blipFill>
+        <p:spPr>
+          <a:xfrm>
+            <a:off x="7406640" y="1051560"/>
+            <a:ext cx="4572000" cy="2247385"/>
           </a:xfrm>
           <a:prstGeom prst="rect">
             <a:avLst/>
@@ -5168,64 +5524,21 @@
                   <a:srgbClr val="FFFFFF"/>
                 </a:solidFill>
               </a:rPr>
-              <a:t>E(iv) — Scenario Analysis: Interpretation</a:t>
-            </a:r>
-          </a:p>
-        </p:txBody>
-      </p:sp>
-      <p:sp>
-        <p:nvSpPr>
-          <p:cNvPr id="5" name="Rectangle 4"/>
-          <p:cNvSpPr/>
-          <p:nvPr/>
-        </p:nvSpPr>
-        <p:spPr>
-          <a:xfrm>
-            <a:off x="0" y="1005840"/>
-            <a:ext cx="12188952" cy="5852160"/>
-          </a:xfrm>
-          <a:prstGeom prst="rect">
-            <a:avLst/>
-          </a:prstGeom>
-          <a:solidFill>
-            <a:srgbClr val="F2F2F2"/>
-          </a:solidFill>
-          <a:ln>
-            <a:noFill/>
-          </a:ln>
-        </p:spPr>
-        <p:style>
-          <a:lnRef idx="1">
-            <a:schemeClr val="accent1"/>
-          </a:lnRef>
-          <a:fillRef idx="3">
-            <a:schemeClr val="accent1"/>
-          </a:fillRef>
-          <a:effectRef idx="2">
-            <a:schemeClr val="accent1"/>
-          </a:effectRef>
-          <a:fontRef idx="minor">
-            <a:schemeClr val="lt1"/>
-          </a:fontRef>
-        </p:style>
-        <p:txBody>
-          <a:bodyPr rtlCol="0" anchor="ctr"/>
-          <a:lstStyle/>
-          <a:p>
-            <a:pPr algn="ctr"/>
-          </a:p>
-        </p:txBody>
-      </p:sp>
-      <p:sp>
-        <p:nvSpPr>
-          <p:cNvPr id="6" name="TextBox 5"/>
+              <a:t>E(iv) — Scenario Analysis: Interest Rate Shocks</a:t>
+            </a:r>
+          </a:p>
+        </p:txBody>
+      </p:sp>
+      <p:sp>
+        <p:nvSpPr>
+          <p:cNvPr id="5" name="TextBox 4"/>
           <p:cNvSpPr txBox="1"/>
           <p:nvPr/>
         </p:nvSpPr>
         <p:spPr>
           <a:xfrm>
-            <a:off x="457200" y="1188720"/>
-            <a:ext cx="11247120" cy="5029200"/>
+            <a:off x="274320" y="548640"/>
+            <a:ext cx="11430000" cy="365760"/>
           </a:xfrm>
           <a:prstGeom prst="rect">
             <a:avLst/>
@@ -5238,84 +5551,42 @@
           </a:bodyPr>
           <a:lstStyle/>
           <a:p>
-            <a:pPr>
-              <a:spcAft>
-                <a:spcPts val="400"/>
-              </a:spcAft>
-              <a:defRPr sz="1500"/>
-            </a:pPr>
-            <a:r>
-              <a:t>• XGBoost: clear monotone CONVEX response — rate cuts raise prepayment probability more than rate rises suppress it</a:t>
-            </a:r>
-          </a:p>
-          <a:p>
-            <a:pPr>
-              <a:spcAft>
-                <a:spcPts val="400"/>
-              </a:spcAft>
-              <a:defRPr sz="1500"/>
-            </a:pPr>
-            <a:r>
-              <a:t>• Deep Cox: monotone but smoother — log-hazard is a less non-linear function of rate_incentive</a:t>
-            </a:r>
-          </a:p>
-          <a:p>
-            <a:pPr>
-              <a:spcAft>
-                <a:spcPts val="400"/>
-              </a:spcAft>
-              <a:defRPr sz="1500"/>
-            </a:pPr>
-            <a:r>
-              <a:t>• Asymmetry (−200 bp effect &gt; +200 bp effect) reflects the BURNOUT effect:</a:t>
-            </a:r>
-          </a:p>
-          <a:p>
-            <a:pPr>
-              <a:spcAft>
-                <a:spcPts val="400"/>
-              </a:spcAft>
-              <a:defRPr sz="1500"/>
-            </a:pPr>
-            <a:r>
-              <a:t>•    most rate-sensitive borrowers have already prepaid → muted upside response to cuts</a:t>
-            </a:r>
-          </a:p>
-          <a:p>
-            <a:pPr>
-              <a:spcAft>
-                <a:spcPts val="400"/>
-              </a:spcAft>
-              <a:defRPr sz="1500"/>
-            </a:pPr>
-            <a:r>
-              <a:t>• Both models agree on direction → robustness of rate-incentive channel across architectures</a:t>
-            </a:r>
-          </a:p>
-          <a:p>
-            <a:pPr>
-              <a:spcAft>
-                <a:spcPts val="400"/>
-              </a:spcAft>
-              <a:defRPr sz="1500"/>
-            </a:pPr>
-            <a:r>
-              <a:t>• Implication for MBS pricing: prepayment option has POSITIVE CONVEXITY —</a:t>
-            </a:r>
-          </a:p>
-          <a:p>
-            <a:pPr>
-              <a:spcAft>
-                <a:spcPts val="400"/>
-              </a:spcAft>
-              <a:defRPr sz="1500"/>
-            </a:pPr>
-            <a:r>
-              <a:t>•    rate decline creates more prepayment than rate rise suppresses it</a:t>
-            </a:r>
-          </a:p>
-        </p:txBody>
-      </p:sp>
+            <a:pPr algn="l"/>
+            <a:r>
+              <a:rPr sz="1300" b="0">
+                <a:solidFill>
+                  <a:srgbClr val="F2F2F2"/>
+                </a:solidFill>
+              </a:rPr>
+              <a:t>±100 bp and ±200 bp shocks to mortgage_rate  (rate_incentive updated consistently)</a:t>
+            </a:r>
+          </a:p>
+        </p:txBody>
+      </p:sp>
+      <p:pic>
+        <p:nvPicPr>
+          <p:cNvPr id="6" name="Picture 5" descr="E2_scenario_analysis.png"/>
+          <p:cNvPicPr>
+            <a:picLocks noChangeAspect="1"/>
+          </p:cNvPicPr>
+          <p:nvPr/>
+        </p:nvPicPr>
+        <p:blipFill>
+          <a:blip r:embed="rId2"/>
+          <a:stretch>
+            <a:fillRect/>
+          </a:stretch>
+        </p:blipFill>
+        <p:spPr>
+          <a:xfrm>
+            <a:off x="457200" y="1051560"/>
+            <a:ext cx="11247120" cy="3906695"/>
+          </a:xfrm>
+          <a:prstGeom prst="rect">
+            <a:avLst/>
+          </a:prstGeom>
+        </p:spPr>
+      </p:pic>
     </p:spTree>
   </p:cSld>
   <p:clrMapOvr>
@@ -5325,6 +5596,287 @@
 </file>
 
 <file path=ppt/slides/slide18.xml><?xml version="1.0" encoding="utf-8"?>
+<p:sld xmlns:a="http://schemas.openxmlformats.org/drawingml/2006/main" xmlns:p="http://schemas.openxmlformats.org/presentationml/2006/main" xmlns:r="http://schemas.openxmlformats.org/officeDocument/2006/relationships">
+  <p:cSld>
+    <p:spTree>
+      <p:nvGrpSpPr>
+        <p:cNvPr id="1" name=""/>
+        <p:cNvGrpSpPr/>
+        <p:nvPr/>
+      </p:nvGrpSpPr>
+      <p:grpSpPr/>
+      <p:sp>
+        <p:nvSpPr>
+          <p:cNvPr id="2" name="Rectangle 1"/>
+          <p:cNvSpPr/>
+          <p:nvPr/>
+        </p:nvSpPr>
+        <p:spPr>
+          <a:xfrm>
+            <a:off x="0" y="0"/>
+            <a:ext cx="12188952" cy="960120"/>
+          </a:xfrm>
+          <a:prstGeom prst="rect">
+            <a:avLst/>
+          </a:prstGeom>
+          <a:solidFill>
+            <a:srgbClr val="1F3963"/>
+          </a:solidFill>
+          <a:ln>
+            <a:noFill/>
+          </a:ln>
+        </p:spPr>
+        <p:style>
+          <a:lnRef idx="1">
+            <a:schemeClr val="accent1"/>
+          </a:lnRef>
+          <a:fillRef idx="3">
+            <a:schemeClr val="accent1"/>
+          </a:fillRef>
+          <a:effectRef idx="2">
+            <a:schemeClr val="accent1"/>
+          </a:effectRef>
+          <a:fontRef idx="minor">
+            <a:schemeClr val="lt1"/>
+          </a:fontRef>
+        </p:style>
+        <p:txBody>
+          <a:bodyPr rtlCol="0" anchor="ctr"/>
+          <a:lstStyle/>
+          <a:p>
+            <a:pPr algn="ctr"/>
+          </a:p>
+        </p:txBody>
+      </p:sp>
+      <p:sp>
+        <p:nvSpPr>
+          <p:cNvPr id="3" name="Rectangle 2"/>
+          <p:cNvSpPr/>
+          <p:nvPr/>
+        </p:nvSpPr>
+        <p:spPr>
+          <a:xfrm>
+            <a:off x="0" y="960120"/>
+            <a:ext cx="12188952" cy="64008"/>
+          </a:xfrm>
+          <a:prstGeom prst="rect">
+            <a:avLst/>
+          </a:prstGeom>
+          <a:solidFill>
+            <a:srgbClr val="FFC000"/>
+          </a:solidFill>
+          <a:ln>
+            <a:noFill/>
+          </a:ln>
+        </p:spPr>
+        <p:style>
+          <a:lnRef idx="1">
+            <a:schemeClr val="accent1"/>
+          </a:lnRef>
+          <a:fillRef idx="3">
+            <a:schemeClr val="accent1"/>
+          </a:fillRef>
+          <a:effectRef idx="2">
+            <a:schemeClr val="accent1"/>
+          </a:effectRef>
+          <a:fontRef idx="minor">
+            <a:schemeClr val="lt1"/>
+          </a:fontRef>
+        </p:style>
+        <p:txBody>
+          <a:bodyPr rtlCol="0" anchor="ctr"/>
+          <a:lstStyle/>
+          <a:p>
+            <a:pPr algn="ctr"/>
+          </a:p>
+        </p:txBody>
+      </p:sp>
+      <p:sp>
+        <p:nvSpPr>
+          <p:cNvPr id="4" name="TextBox 3"/>
+          <p:cNvSpPr txBox="1"/>
+          <p:nvPr/>
+        </p:nvSpPr>
+        <p:spPr>
+          <a:xfrm>
+            <a:off x="274320" y="54864"/>
+            <a:ext cx="11430000" cy="502920"/>
+          </a:xfrm>
+          <a:prstGeom prst="rect">
+            <a:avLst/>
+          </a:prstGeom>
+          <a:noFill/>
+        </p:spPr>
+        <p:txBody>
+          <a:bodyPr wrap="square">
+            <a:spAutoFit/>
+          </a:bodyPr>
+          <a:lstStyle/>
+          <a:p>
+            <a:pPr algn="l"/>
+            <a:r>
+              <a:rPr sz="2600" b="1">
+                <a:solidFill>
+                  <a:srgbClr val="FFFFFF"/>
+                </a:solidFill>
+              </a:rPr>
+              <a:t>E(iv) — Scenario Analysis: Interpretation</a:t>
+            </a:r>
+          </a:p>
+        </p:txBody>
+      </p:sp>
+      <p:sp>
+        <p:nvSpPr>
+          <p:cNvPr id="5" name="Rectangle 4"/>
+          <p:cNvSpPr/>
+          <p:nvPr/>
+        </p:nvSpPr>
+        <p:spPr>
+          <a:xfrm>
+            <a:off x="0" y="1005840"/>
+            <a:ext cx="12188952" cy="5852160"/>
+          </a:xfrm>
+          <a:prstGeom prst="rect">
+            <a:avLst/>
+          </a:prstGeom>
+          <a:solidFill>
+            <a:srgbClr val="F2F2F2"/>
+          </a:solidFill>
+          <a:ln>
+            <a:noFill/>
+          </a:ln>
+        </p:spPr>
+        <p:style>
+          <a:lnRef idx="1">
+            <a:schemeClr val="accent1"/>
+          </a:lnRef>
+          <a:fillRef idx="3">
+            <a:schemeClr val="accent1"/>
+          </a:fillRef>
+          <a:effectRef idx="2">
+            <a:schemeClr val="accent1"/>
+          </a:effectRef>
+          <a:fontRef idx="minor">
+            <a:schemeClr val="lt1"/>
+          </a:fontRef>
+        </p:style>
+        <p:txBody>
+          <a:bodyPr rtlCol="0" anchor="ctr"/>
+          <a:lstStyle/>
+          <a:p>
+            <a:pPr algn="ctr"/>
+          </a:p>
+        </p:txBody>
+      </p:sp>
+      <p:sp>
+        <p:nvSpPr>
+          <p:cNvPr id="6" name="TextBox 5"/>
+          <p:cNvSpPr txBox="1"/>
+          <p:nvPr/>
+        </p:nvSpPr>
+        <p:spPr>
+          <a:xfrm>
+            <a:off x="457200" y="1188720"/>
+            <a:ext cx="11247120" cy="5029200"/>
+          </a:xfrm>
+          <a:prstGeom prst="rect">
+            <a:avLst/>
+          </a:prstGeom>
+          <a:noFill/>
+        </p:spPr>
+        <p:txBody>
+          <a:bodyPr wrap="square">
+            <a:spAutoFit/>
+          </a:bodyPr>
+          <a:lstStyle/>
+          <a:p>
+            <a:pPr>
+              <a:spcAft>
+                <a:spcPts val="400"/>
+              </a:spcAft>
+              <a:defRPr sz="1500"/>
+            </a:pPr>
+            <a:r>
+              <a:t>• XGBoost: clear monotone CONVEX response — rate cuts raise prepayment probability more than rate rises suppress it</a:t>
+            </a:r>
+          </a:p>
+          <a:p>
+            <a:pPr>
+              <a:spcAft>
+                <a:spcPts val="400"/>
+              </a:spcAft>
+              <a:defRPr sz="1500"/>
+            </a:pPr>
+            <a:r>
+              <a:t>• Deep Cox: monotone but smoother — log-hazard is a less non-linear function of rate_incentive</a:t>
+            </a:r>
+          </a:p>
+          <a:p>
+            <a:pPr>
+              <a:spcAft>
+                <a:spcPts val="400"/>
+              </a:spcAft>
+              <a:defRPr sz="1500"/>
+            </a:pPr>
+            <a:r>
+              <a:t>• Asymmetry (−200 bp effect &gt; +200 bp effect) reflects the BURNOUT effect:</a:t>
+            </a:r>
+          </a:p>
+          <a:p>
+            <a:pPr>
+              <a:spcAft>
+                <a:spcPts val="400"/>
+              </a:spcAft>
+              <a:defRPr sz="1500"/>
+            </a:pPr>
+            <a:r>
+              <a:t>•    most rate-sensitive borrowers have already prepaid → muted upside response to cuts</a:t>
+            </a:r>
+          </a:p>
+          <a:p>
+            <a:pPr>
+              <a:spcAft>
+                <a:spcPts val="400"/>
+              </a:spcAft>
+              <a:defRPr sz="1500"/>
+            </a:pPr>
+            <a:r>
+              <a:t>• Both models agree on direction → robustness of rate-incentive channel across architectures</a:t>
+            </a:r>
+          </a:p>
+          <a:p>
+            <a:pPr>
+              <a:spcAft>
+                <a:spcPts val="400"/>
+              </a:spcAft>
+              <a:defRPr sz="1500"/>
+            </a:pPr>
+            <a:r>
+              <a:t>• Implication for MBS pricing: prepayment option has POSITIVE CONVEXITY —</a:t>
+            </a:r>
+          </a:p>
+          <a:p>
+            <a:pPr>
+              <a:spcAft>
+                <a:spcPts val="400"/>
+              </a:spcAft>
+              <a:defRPr sz="1500"/>
+            </a:pPr>
+            <a:r>
+              <a:t>•    rate decline creates more prepayment than rate rise suppresses it</a:t>
+            </a:r>
+          </a:p>
+        </p:txBody>
+      </p:sp>
+    </p:spTree>
+  </p:cSld>
+  <p:clrMapOvr>
+    <a:masterClrMapping/>
+  </p:clrMapOvr>
+</p:sld>
+</file>
+
+<file path=ppt/slides/slide19.xml><?xml version="1.0" encoding="utf-8"?>
 <p:sld xmlns:a="http://schemas.openxmlformats.org/drawingml/2006/main" xmlns:p="http://schemas.openxmlformats.org/presentationml/2006/main" xmlns:r="http://schemas.openxmlformats.org/officeDocument/2006/relationships">
   <p:cSld>
     <p:spTree>
@@ -7123,14 +7675,48 @@
                   <a:srgbClr val="FFFFFF"/>
                 </a:solidFill>
               </a:rPr>
-              <a:t>E(i)(a) — EDA: Vintage Cohort &amp; Categorical Breakdown</a:t>
+              <a:t>E(i)(a) — EDA: Superimposed Duration Densities</a:t>
+            </a:r>
+          </a:p>
+        </p:txBody>
+      </p:sp>
+      <p:sp>
+        <p:nvSpPr>
+          <p:cNvPr id="5" name="TextBox 4"/>
+          <p:cNvSpPr txBox="1"/>
+          <p:nvPr/>
+        </p:nvSpPr>
+        <p:spPr>
+          <a:xfrm>
+            <a:off x="274320" y="548640"/>
+            <a:ext cx="11430000" cy="365760"/>
+          </a:xfrm>
+          <a:prstGeom prst="rect">
+            <a:avLst/>
+          </a:prstGeom>
+          <a:noFill/>
+        </p:spPr>
+        <p:txBody>
+          <a:bodyPr wrap="square">
+            <a:spAutoFit/>
+          </a:bodyPr>
+          <a:lstStyle/>
+          <a:p>
+            <a:pPr algn="l"/>
+            <a:r>
+              <a:rPr sz="1300" b="0">
+                <a:solidFill>
+                  <a:srgbClr val="F2F2F2"/>
+                </a:solidFill>
+              </a:rPr>
+              <a:t>Normalised within each event type · dashed lines = median · full 34M-loan dataset</a:t>
             </a:r>
           </a:p>
         </p:txBody>
       </p:sp>
       <p:pic>
         <p:nvPicPr>
-          <p:cNvPr id="5" name="Picture 4" descr="E1_eda_vintage.png"/>
+          <p:cNvPr id="6" name="Picture 5" descr="E1_eda_duration_overlay.png"/>
           <p:cNvPicPr>
             <a:picLocks noChangeAspect="1"/>
           </p:cNvPicPr>
@@ -7144,32 +7730,8 @@
         </p:blipFill>
         <p:spPr>
           <a:xfrm>
-            <a:off x="137160" y="1051560"/>
-            <a:ext cx="7315200" cy="2499743"/>
-          </a:xfrm>
-          <a:prstGeom prst="rect">
-            <a:avLst/>
-          </a:prstGeom>
-        </p:spPr>
-      </p:pic>
-      <p:pic>
-        <p:nvPicPr>
-          <p:cNvPr id="6" name="Picture 5" descr="E1_eda_categorical.png"/>
-          <p:cNvPicPr>
-            <a:picLocks noChangeAspect="1"/>
-          </p:cNvPicPr>
-          <p:nvPr/>
-        </p:nvPicPr>
-        <p:blipFill>
-          <a:blip r:embed="rId3"/>
-          <a:stretch>
-            <a:fillRect/>
-          </a:stretch>
-        </p:blipFill>
-        <p:spPr>
-          <a:xfrm>
-            <a:off x="7589520" y="1051560"/>
-            <a:ext cx="4389120" cy="1600506"/>
+            <a:off x="457200" y="1097280"/>
+            <a:ext cx="11247120" cy="4607406"/>
           </a:xfrm>
           <a:prstGeom prst="rect">
             <a:avLst/>
@@ -7309,48 +7871,14 @@
                   <a:srgbClr val="FFFFFF"/>
                 </a:solidFill>
               </a:rPr>
-              <a:t>E(i)(a) — Hazard Intensity: Prepayment Peaks Early, Default Rises Slowly</a:t>
-            </a:r>
-          </a:p>
-        </p:txBody>
-      </p:sp>
-      <p:sp>
-        <p:nvSpPr>
-          <p:cNvPr id="5" name="TextBox 4"/>
-          <p:cNvSpPr txBox="1"/>
-          <p:nvPr/>
-        </p:nvSpPr>
-        <p:spPr>
-          <a:xfrm>
-            <a:off x="274320" y="548640"/>
-            <a:ext cx="11430000" cy="365760"/>
-          </a:xfrm>
-          <a:prstGeom prst="rect">
-            <a:avLst/>
-          </a:prstGeom>
-          <a:noFill/>
-        </p:spPr>
-        <p:txBody>
-          <a:bodyPr wrap="square">
-            <a:spAutoFit/>
-          </a:bodyPr>
-          <a:lstStyle/>
-          <a:p>
-            <a:pPr algn="l"/>
-            <a:r>
-              <a:rPr sz="1300" b="0">
-                <a:solidFill>
-                  <a:srgbClr val="F2F2F2"/>
-                </a:solidFill>
-              </a:rPr>
-              <a:t>Cause-specific Nelson-Aalen smooth · burnout visible in prepayment hazard · 100K sample</a:t>
+              <a:t>E(i)(a) — EDA: Vintage Cohort &amp; Categorical Breakdown</a:t>
             </a:r>
           </a:p>
         </p:txBody>
       </p:sp>
       <p:pic>
         <p:nvPicPr>
-          <p:cNvPr id="6" name="Picture 5" descr="E1_hazard_overall.png"/>
+          <p:cNvPr id="5" name="Picture 4" descr="E1_eda_vintage.png"/>
           <p:cNvPicPr>
             <a:picLocks noChangeAspect="1"/>
           </p:cNvPicPr>
@@ -7364,8 +7892,32 @@
         </p:blipFill>
         <p:spPr>
           <a:xfrm>
-            <a:off x="457200" y="1097280"/>
-            <a:ext cx="11247120" cy="3629792"/>
+            <a:off x="137160" y="1051560"/>
+            <a:ext cx="7315200" cy="2499743"/>
+          </a:xfrm>
+          <a:prstGeom prst="rect">
+            <a:avLst/>
+          </a:prstGeom>
+        </p:spPr>
+      </p:pic>
+      <p:pic>
+        <p:nvPicPr>
+          <p:cNvPr id="6" name="Picture 5" descr="E1_eda_categorical.png"/>
+          <p:cNvPicPr>
+            <a:picLocks noChangeAspect="1"/>
+          </p:cNvPicPr>
+          <p:nvPr/>
+        </p:nvPicPr>
+        <p:blipFill>
+          <a:blip r:embed="rId3"/>
+          <a:stretch>
+            <a:fillRect/>
+          </a:stretch>
+        </p:blipFill>
+        <p:spPr>
+          <a:xfrm>
+            <a:off x="7589520" y="1051560"/>
+            <a:ext cx="4389120" cy="1600506"/>
           </a:xfrm>
           <a:prstGeom prst="rect">
             <a:avLst/>
@@ -7505,7 +8057,7 @@
                   <a:srgbClr val="FFFFFF"/>
                 </a:solidFill>
               </a:rPr>
-              <a:t>E(i)(a) — Stratified Hazard Intensity by FICO · LTV · Rate · Vintage</a:t>
+              <a:t>E(i)(a) — Hazard Intensity: Prepayment Peaks Early, Default Rises Slowly</a:t>
             </a:r>
           </a:p>
         </p:txBody>
@@ -7539,14 +8091,14 @@
                   <a:srgbClr val="F2F2F2"/>
                 </a:solidFill>
               </a:rPr>
-              <a:t>High-FICO refinances fastest · High-LTV defaults persist longer · GFC vintages spike</a:t>
+              <a:t>Cause-specific Nelson-Aalen smooth · burnout visible in prepayment hazard · 100K sample</a:t>
             </a:r>
           </a:p>
         </p:txBody>
       </p:sp>
       <p:pic>
         <p:nvPicPr>
-          <p:cNvPr id="6" name="Picture 5" descr="E1_hazard_stratified.png"/>
+          <p:cNvPr id="6" name="Picture 5" descr="E1_hazard_overall.png"/>
           <p:cNvPicPr>
             <a:picLocks noChangeAspect="1"/>
           </p:cNvPicPr>
@@ -7560,8 +8112,8 @@
         </p:blipFill>
         <p:spPr>
           <a:xfrm>
-            <a:off x="457200" y="1005840"/>
-            <a:ext cx="4063204" cy="5303520"/>
+            <a:off x="457200" y="1097280"/>
+            <a:ext cx="11247120" cy="3629792"/>
           </a:xfrm>
           <a:prstGeom prst="rect">
             <a:avLst/>
@@ -7701,7 +8253,7 @@
                   <a:srgbClr val="FFFFFF"/>
                 </a:solidFill>
               </a:rPr>
-              <a:t>E(i)(b) — Aalen-Johansen CIF: Formula &amp; Contrast</a:t>
+              <a:t>E(i)(a) — Stratified Hazard Intensity by FICO · LTV · Rate · Vintage</a:t>
             </a:r>
           </a:p>
         </p:txBody>
@@ -7735,456 +8287,14 @@
                   <a:srgbClr val="F2F2F2"/>
                 </a:solidFill>
               </a:rPr>
-              <a:t>AJ correctly weights each increment by the overall survival probability</a:t>
-            </a:r>
-          </a:p>
-        </p:txBody>
-      </p:sp>
-      <p:sp>
-        <p:nvSpPr>
-          <p:cNvPr id="6" name="Rectangle 5"/>
-          <p:cNvSpPr/>
-          <p:nvPr/>
-        </p:nvSpPr>
-        <p:spPr>
-          <a:xfrm>
-            <a:off x="0" y="1024128"/>
-            <a:ext cx="12188952" cy="5833872"/>
-          </a:xfrm>
-          <a:prstGeom prst="rect">
-            <a:avLst/>
-          </a:prstGeom>
-          <a:solidFill>
-            <a:srgbClr val="F2F2F2"/>
-          </a:solidFill>
-          <a:ln>
-            <a:noFill/>
-          </a:ln>
-        </p:spPr>
-        <p:style>
-          <a:lnRef idx="1">
-            <a:schemeClr val="accent1"/>
-          </a:lnRef>
-          <a:fillRef idx="3">
-            <a:schemeClr val="accent1"/>
-          </a:fillRef>
-          <a:effectRef idx="2">
-            <a:schemeClr val="accent1"/>
-          </a:effectRef>
-          <a:fontRef idx="minor">
-            <a:schemeClr val="lt1"/>
-          </a:fontRef>
-        </p:style>
-        <p:txBody>
-          <a:bodyPr rtlCol="0" anchor="ctr"/>
-          <a:lstStyle/>
-          <a:p>
-            <a:pPr algn="ctr"/>
-          </a:p>
-        </p:txBody>
-      </p:sp>
-      <p:sp>
-        <p:nvSpPr>
-          <p:cNvPr id="7" name="TextBox 6"/>
-          <p:cNvSpPr txBox="1"/>
-          <p:nvPr/>
-        </p:nvSpPr>
-        <p:spPr>
-          <a:xfrm>
-            <a:off x="274320" y="1143000"/>
-            <a:ext cx="11612880" cy="365760"/>
-          </a:xfrm>
-          <a:prstGeom prst="rect">
-            <a:avLst/>
-          </a:prstGeom>
-          <a:noFill/>
-        </p:spPr>
-        <p:txBody>
-          <a:bodyPr wrap="square">
-            <a:spAutoFit/>
-          </a:bodyPr>
-          <a:lstStyle/>
-          <a:p>
-            <a:pPr algn="l"/>
-            <a:r>
-              <a:rPr sz="1300" b="1">
-                <a:solidFill>
-                  <a:srgbClr val="C00000"/>
-                </a:solidFill>
-              </a:rPr>
-              <a:t>Kaplan-Meier  (INCORRECT — treats competing exits as censored)</a:t>
-            </a:r>
-          </a:p>
-        </p:txBody>
-      </p:sp>
-      <p:sp>
-        <p:nvSpPr>
-          <p:cNvPr id="8" name="Rectangle 7"/>
-          <p:cNvSpPr/>
-          <p:nvPr/>
-        </p:nvSpPr>
-        <p:spPr>
-          <a:xfrm>
-            <a:off x="274320" y="1508760"/>
-            <a:ext cx="11612880" cy="822960"/>
-          </a:xfrm>
-          <a:prstGeom prst="rect">
-            <a:avLst/>
-          </a:prstGeom>
-          <a:solidFill>
-            <a:srgbClr val="EEF2F7"/>
-          </a:solidFill>
-          <a:ln>
-            <a:noFill/>
-          </a:ln>
-        </p:spPr>
-        <p:style>
-          <a:lnRef idx="1">
-            <a:schemeClr val="accent1"/>
-          </a:lnRef>
-          <a:fillRef idx="3">
-            <a:schemeClr val="accent1"/>
-          </a:fillRef>
-          <a:effectRef idx="2">
-            <a:schemeClr val="accent1"/>
-          </a:effectRef>
-          <a:fontRef idx="minor">
-            <a:schemeClr val="lt1"/>
-          </a:fontRef>
-        </p:style>
-        <p:txBody>
-          <a:bodyPr rtlCol="0" anchor="ctr"/>
-          <a:lstStyle/>
-          <a:p>
-            <a:pPr algn="ctr"/>
-          </a:p>
-        </p:txBody>
-      </p:sp>
-      <p:sp>
-        <p:nvSpPr>
-          <p:cNvPr id="9" name="TextBox 8"/>
-          <p:cNvSpPr txBox="1"/>
-          <p:nvPr/>
-        </p:nvSpPr>
-        <p:spPr>
-          <a:xfrm>
-            <a:off x="365760" y="1581912"/>
-            <a:ext cx="11430000" cy="731520"/>
-          </a:xfrm>
-          <a:prstGeom prst="rect">
-            <a:avLst/>
-          </a:prstGeom>
-          <a:noFill/>
-        </p:spPr>
-        <p:txBody>
-          <a:bodyPr wrap="square">
-            <a:spAutoFit/>
-          </a:bodyPr>
-          <a:lstStyle/>
-          <a:p>
-            <a:r>
-              <a:rPr sz="1300">
-                <a:solidFill>
-                  <a:srgbClr val="1F3963"/>
-                </a:solidFill>
-                <a:latin typeface="Courier New"/>
-              </a:rPr>
-              <a:t>S_KM(t) = PROD_{t_i &lt;= t} (1 - d_i^(k) / n_i)</a:t>
-            </a:r>
-          </a:p>
-          <a:p>
-            <a:r>
-              <a:rPr sz="1300">
-                <a:solidFill>
-                  <a:srgbClr val="1F3963"/>
-                </a:solidFill>
-                <a:latin typeface="Courier New"/>
-              </a:rPr>
-              <a:t>F_KM^(k)(t) = 1 - S_KM(t)    ← overcounts cause-k hazard</a:t>
-            </a:r>
-          </a:p>
-        </p:txBody>
-      </p:sp>
-      <p:sp>
-        <p:nvSpPr>
-          <p:cNvPr id="10" name="TextBox 9"/>
-          <p:cNvSpPr txBox="1"/>
-          <p:nvPr/>
-        </p:nvSpPr>
-        <p:spPr>
-          <a:xfrm>
-            <a:off x="274320" y="2423160"/>
-            <a:ext cx="11612880" cy="365760"/>
-          </a:xfrm>
-          <a:prstGeom prst="rect">
-            <a:avLst/>
-          </a:prstGeom>
-          <a:noFill/>
-        </p:spPr>
-        <p:txBody>
-          <a:bodyPr wrap="square">
-            <a:spAutoFit/>
-          </a:bodyPr>
-          <a:lstStyle/>
-          <a:p>
-            <a:pPr algn="l"/>
-            <a:r>
-              <a:rPr sz="1300" b="1">
-                <a:solidFill>
-                  <a:srgbClr val="1F3963"/>
-                </a:solidFill>
-              </a:rPr>
-              <a:t>Aalen-Johansen  (CORRECT)</a:t>
-            </a:r>
-          </a:p>
-        </p:txBody>
-      </p:sp>
-      <p:sp>
-        <p:nvSpPr>
-          <p:cNvPr id="11" name="Rectangle 10"/>
-          <p:cNvSpPr/>
-          <p:nvPr/>
-        </p:nvSpPr>
-        <p:spPr>
-          <a:xfrm>
-            <a:off x="274320" y="2788920"/>
-            <a:ext cx="11612880" cy="1417320"/>
-          </a:xfrm>
-          <a:prstGeom prst="rect">
-            <a:avLst/>
-          </a:prstGeom>
-          <a:solidFill>
-            <a:srgbClr val="EEF2F7"/>
-          </a:solidFill>
-          <a:ln>
-            <a:noFill/>
-          </a:ln>
-        </p:spPr>
-        <p:style>
-          <a:lnRef idx="1">
-            <a:schemeClr val="accent1"/>
-          </a:lnRef>
-          <a:fillRef idx="3">
-            <a:schemeClr val="accent1"/>
-          </a:fillRef>
-          <a:effectRef idx="2">
-            <a:schemeClr val="accent1"/>
-          </a:effectRef>
-          <a:fontRef idx="minor">
-            <a:schemeClr val="lt1"/>
-          </a:fontRef>
-        </p:style>
-        <p:txBody>
-          <a:bodyPr rtlCol="0" anchor="ctr"/>
-          <a:lstStyle/>
-          <a:p>
-            <a:pPr algn="ctr"/>
-          </a:p>
-        </p:txBody>
-      </p:sp>
-      <p:sp>
-        <p:nvSpPr>
-          <p:cNvPr id="12" name="TextBox 11"/>
-          <p:cNvSpPr txBox="1"/>
-          <p:nvPr/>
-        </p:nvSpPr>
-        <p:spPr>
-          <a:xfrm>
-            <a:off x="365760" y="2862072"/>
-            <a:ext cx="11430000" cy="1325880"/>
-          </a:xfrm>
-          <a:prstGeom prst="rect">
-            <a:avLst/>
-          </a:prstGeom>
-          <a:noFill/>
-        </p:spPr>
-        <p:txBody>
-          <a:bodyPr wrap="square">
-            <a:spAutoFit/>
-          </a:bodyPr>
-          <a:lstStyle/>
-          <a:p>
-            <a:r>
-              <a:rPr sz="1300">
-                <a:solidFill>
-                  <a:srgbClr val="1F3963"/>
-                </a:solidFill>
-                <a:latin typeface="Courier New"/>
-              </a:rPr>
-              <a:t>F_k(t) = SUM_{t_j &lt;= t}  S(t_j-)  *  d_{kj} / n_j</a:t>
-            </a:r>
-          </a:p>
-          <a:p>
-            <a:r>
-              <a:rPr sz="1300">
-                <a:solidFill>
-                  <a:srgbClr val="1F3963"/>
-                </a:solidFill>
-                <a:latin typeface="Courier New"/>
-              </a:rPr>
-              <a:t/>
-            </a:r>
-          </a:p>
-          <a:p>
-            <a:r>
-              <a:rPr sz="1300">
-                <a:solidFill>
-                  <a:srgbClr val="1F3963"/>
-                </a:solidFill>
-                <a:latin typeface="Courier New"/>
-              </a:rPr>
-              <a:t>  F_k(t) : CIF for cause k at loan age t</a:t>
-            </a:r>
-          </a:p>
-          <a:p>
-            <a:r>
-              <a:rPr sz="1300">
-                <a:solidFill>
-                  <a:srgbClr val="1F3963"/>
-                </a:solidFill>
-                <a:latin typeface="Courier New"/>
-              </a:rPr>
-              <a:t>  d_{kj} : cause-k exits at time t_j</a:t>
-            </a:r>
-          </a:p>
-          <a:p>
-            <a:r>
-              <a:rPr sz="1300">
-                <a:solidFill>
-                  <a:srgbClr val="1F3963"/>
-                </a:solidFill>
-                <a:latin typeface="Courier New"/>
-              </a:rPr>
-              <a:t>  n_j    : loans at risk just before t_j</a:t>
-            </a:r>
-          </a:p>
-          <a:p>
-            <a:r>
-              <a:rPr sz="1300">
-                <a:solidFill>
-                  <a:srgbClr val="1F3963"/>
-                </a:solidFill>
-                <a:latin typeface="Courier New"/>
-              </a:rPr>
-              <a:t>  S(t_j-): overall survival before t_j — uses ALL exits</a:t>
-            </a:r>
-          </a:p>
-        </p:txBody>
-      </p:sp>
-      <p:sp>
-        <p:nvSpPr>
-          <p:cNvPr id="13" name="TextBox 12"/>
-          <p:cNvSpPr txBox="1"/>
-          <p:nvPr/>
-        </p:nvSpPr>
-        <p:spPr>
-          <a:xfrm>
-            <a:off x="274320" y="4279392"/>
-            <a:ext cx="11612880" cy="320040"/>
-          </a:xfrm>
-          <a:prstGeom prst="rect">
-            <a:avLst/>
-          </a:prstGeom>
-          <a:noFill/>
-        </p:spPr>
-        <p:txBody>
-          <a:bodyPr wrap="square">
-            <a:spAutoFit/>
-          </a:bodyPr>
-          <a:lstStyle/>
-          <a:p>
-            <a:pPr algn="l"/>
-            <a:r>
-              <a:rPr sz="1200" b="1">
-                <a:solidFill>
-                  <a:srgbClr val="1F3963"/>
-                </a:solidFill>
-              </a:rPr>
-              <a:t>Partition identity  (impossible under KM):</a:t>
-            </a:r>
-          </a:p>
-        </p:txBody>
-      </p:sp>
-      <p:sp>
-        <p:nvSpPr>
-          <p:cNvPr id="14" name="Rectangle 13"/>
-          <p:cNvSpPr/>
-          <p:nvPr/>
-        </p:nvSpPr>
-        <p:spPr>
-          <a:xfrm>
-            <a:off x="274320" y="4617720"/>
-            <a:ext cx="11612880" cy="457200"/>
-          </a:xfrm>
-          <a:prstGeom prst="rect">
-            <a:avLst/>
-          </a:prstGeom>
-          <a:solidFill>
-            <a:srgbClr val="EEF2F7"/>
-          </a:solidFill>
-          <a:ln>
-            <a:noFill/>
-          </a:ln>
-        </p:spPr>
-        <p:style>
-          <a:lnRef idx="1">
-            <a:schemeClr val="accent1"/>
-          </a:lnRef>
-          <a:fillRef idx="3">
-            <a:schemeClr val="accent1"/>
-          </a:fillRef>
-          <a:effectRef idx="2">
-            <a:schemeClr val="accent1"/>
-          </a:effectRef>
-          <a:fontRef idx="minor">
-            <a:schemeClr val="lt1"/>
-          </a:fontRef>
-        </p:style>
-        <p:txBody>
-          <a:bodyPr rtlCol="0" anchor="ctr"/>
-          <a:lstStyle/>
-          <a:p>
-            <a:pPr algn="ctr"/>
-          </a:p>
-        </p:txBody>
-      </p:sp>
-      <p:sp>
-        <p:nvSpPr>
-          <p:cNvPr id="15" name="TextBox 14"/>
-          <p:cNvSpPr txBox="1"/>
-          <p:nvPr/>
-        </p:nvSpPr>
-        <p:spPr>
-          <a:xfrm>
-            <a:off x="365760" y="4690872"/>
-            <a:ext cx="11430000" cy="365760"/>
-          </a:xfrm>
-          <a:prstGeom prst="rect">
-            <a:avLst/>
-          </a:prstGeom>
-          <a:noFill/>
-        </p:spPr>
-        <p:txBody>
-          <a:bodyPr wrap="square">
-            <a:spAutoFit/>
-          </a:bodyPr>
-          <a:lstStyle/>
-          <a:p>
-            <a:r>
-              <a:rPr sz="1300">
-                <a:solidFill>
-                  <a:srgbClr val="1F3963"/>
-                </a:solidFill>
-                <a:latin typeface="Courier New"/>
-              </a:rPr>
-              <a:t>SUM_k  F_k(t)  +  S(t)  =  1    for all t</a:t>
+              <a:t>High-FICO refinances fastest · High-LTV defaults persist longer · GFC vintages spike</a:t>
             </a:r>
           </a:p>
         </p:txBody>
       </p:sp>
       <p:pic>
         <p:nvPicPr>
-          <p:cNvPr id="16" name="Picture 15" descr="E1_competing_risks_cif.png"/>
+          <p:cNvPr id="6" name="Picture 5" descr="E1_hazard_stratified.png"/>
           <p:cNvPicPr>
             <a:picLocks noChangeAspect="1"/>
           </p:cNvPicPr>
@@ -8198,8 +8308,8 @@
         </p:blipFill>
         <p:spPr>
           <a:xfrm>
-            <a:off x="274320" y="5120640"/>
-            <a:ext cx="9632924" cy="5303520"/>
+            <a:off x="457200" y="1005840"/>
+            <a:ext cx="4063204" cy="5303520"/>
           </a:xfrm>
           <a:prstGeom prst="rect">
             <a:avLst/>
@@ -8339,7 +8449,7 @@
                   <a:srgbClr val="FFFFFF"/>
                 </a:solidFill>
               </a:rPr>
-              <a:t>E(i)(b) — AJ CIF: 10-yr Prepay 83%  ·  Default 2.2%  ·  Active 14.5%</a:t>
+              <a:t>E(i)(b) — Aalen-Johansen CIF: Formula &amp; Contrast</a:t>
             </a:r>
           </a:p>
         </p:txBody>
@@ -8373,14 +8483,456 @@
                   <a:srgbClr val="F2F2F2"/>
                 </a:solidFill>
               </a:rPr>
-              <a:t>S_KM over-estimates each cause; AJ partition sums exactly to 1</a:t>
+              <a:t>AJ correctly weights each increment by the overall survival probability</a:t>
+            </a:r>
+          </a:p>
+        </p:txBody>
+      </p:sp>
+      <p:sp>
+        <p:nvSpPr>
+          <p:cNvPr id="6" name="Rectangle 5"/>
+          <p:cNvSpPr/>
+          <p:nvPr/>
+        </p:nvSpPr>
+        <p:spPr>
+          <a:xfrm>
+            <a:off x="0" y="1024128"/>
+            <a:ext cx="12188952" cy="5833872"/>
+          </a:xfrm>
+          <a:prstGeom prst="rect">
+            <a:avLst/>
+          </a:prstGeom>
+          <a:solidFill>
+            <a:srgbClr val="F2F2F2"/>
+          </a:solidFill>
+          <a:ln>
+            <a:noFill/>
+          </a:ln>
+        </p:spPr>
+        <p:style>
+          <a:lnRef idx="1">
+            <a:schemeClr val="accent1"/>
+          </a:lnRef>
+          <a:fillRef idx="3">
+            <a:schemeClr val="accent1"/>
+          </a:fillRef>
+          <a:effectRef idx="2">
+            <a:schemeClr val="accent1"/>
+          </a:effectRef>
+          <a:fontRef idx="minor">
+            <a:schemeClr val="lt1"/>
+          </a:fontRef>
+        </p:style>
+        <p:txBody>
+          <a:bodyPr rtlCol="0" anchor="ctr"/>
+          <a:lstStyle/>
+          <a:p>
+            <a:pPr algn="ctr"/>
+          </a:p>
+        </p:txBody>
+      </p:sp>
+      <p:sp>
+        <p:nvSpPr>
+          <p:cNvPr id="7" name="TextBox 6"/>
+          <p:cNvSpPr txBox="1"/>
+          <p:nvPr/>
+        </p:nvSpPr>
+        <p:spPr>
+          <a:xfrm>
+            <a:off x="274320" y="1143000"/>
+            <a:ext cx="11612880" cy="365760"/>
+          </a:xfrm>
+          <a:prstGeom prst="rect">
+            <a:avLst/>
+          </a:prstGeom>
+          <a:noFill/>
+        </p:spPr>
+        <p:txBody>
+          <a:bodyPr wrap="square">
+            <a:spAutoFit/>
+          </a:bodyPr>
+          <a:lstStyle/>
+          <a:p>
+            <a:pPr algn="l"/>
+            <a:r>
+              <a:rPr sz="1300" b="1">
+                <a:solidFill>
+                  <a:srgbClr val="C00000"/>
+                </a:solidFill>
+              </a:rPr>
+              <a:t>Kaplan-Meier  (INCORRECT — treats competing exits as censored)</a:t>
+            </a:r>
+          </a:p>
+        </p:txBody>
+      </p:sp>
+      <p:sp>
+        <p:nvSpPr>
+          <p:cNvPr id="8" name="Rectangle 7"/>
+          <p:cNvSpPr/>
+          <p:nvPr/>
+        </p:nvSpPr>
+        <p:spPr>
+          <a:xfrm>
+            <a:off x="274320" y="1508760"/>
+            <a:ext cx="11612880" cy="822960"/>
+          </a:xfrm>
+          <a:prstGeom prst="rect">
+            <a:avLst/>
+          </a:prstGeom>
+          <a:solidFill>
+            <a:srgbClr val="EEF2F7"/>
+          </a:solidFill>
+          <a:ln>
+            <a:noFill/>
+          </a:ln>
+        </p:spPr>
+        <p:style>
+          <a:lnRef idx="1">
+            <a:schemeClr val="accent1"/>
+          </a:lnRef>
+          <a:fillRef idx="3">
+            <a:schemeClr val="accent1"/>
+          </a:fillRef>
+          <a:effectRef idx="2">
+            <a:schemeClr val="accent1"/>
+          </a:effectRef>
+          <a:fontRef idx="minor">
+            <a:schemeClr val="lt1"/>
+          </a:fontRef>
+        </p:style>
+        <p:txBody>
+          <a:bodyPr rtlCol="0" anchor="ctr"/>
+          <a:lstStyle/>
+          <a:p>
+            <a:pPr algn="ctr"/>
+          </a:p>
+        </p:txBody>
+      </p:sp>
+      <p:sp>
+        <p:nvSpPr>
+          <p:cNvPr id="9" name="TextBox 8"/>
+          <p:cNvSpPr txBox="1"/>
+          <p:nvPr/>
+        </p:nvSpPr>
+        <p:spPr>
+          <a:xfrm>
+            <a:off x="365760" y="1581912"/>
+            <a:ext cx="11430000" cy="731520"/>
+          </a:xfrm>
+          <a:prstGeom prst="rect">
+            <a:avLst/>
+          </a:prstGeom>
+          <a:noFill/>
+        </p:spPr>
+        <p:txBody>
+          <a:bodyPr wrap="square">
+            <a:spAutoFit/>
+          </a:bodyPr>
+          <a:lstStyle/>
+          <a:p>
+            <a:r>
+              <a:rPr sz="1300">
+                <a:solidFill>
+                  <a:srgbClr val="1F3963"/>
+                </a:solidFill>
+                <a:latin typeface="Courier New"/>
+              </a:rPr>
+              <a:t>S_KM(t) = PROD_{t_i &lt;= t} (1 - d_i^(k) / n_i)</a:t>
+            </a:r>
+          </a:p>
+          <a:p>
+            <a:r>
+              <a:rPr sz="1300">
+                <a:solidFill>
+                  <a:srgbClr val="1F3963"/>
+                </a:solidFill>
+                <a:latin typeface="Courier New"/>
+              </a:rPr>
+              <a:t>F_KM^(k)(t) = 1 - S_KM(t)    ← overcounts cause-k hazard</a:t>
+            </a:r>
+          </a:p>
+        </p:txBody>
+      </p:sp>
+      <p:sp>
+        <p:nvSpPr>
+          <p:cNvPr id="10" name="TextBox 9"/>
+          <p:cNvSpPr txBox="1"/>
+          <p:nvPr/>
+        </p:nvSpPr>
+        <p:spPr>
+          <a:xfrm>
+            <a:off x="274320" y="2423160"/>
+            <a:ext cx="11612880" cy="365760"/>
+          </a:xfrm>
+          <a:prstGeom prst="rect">
+            <a:avLst/>
+          </a:prstGeom>
+          <a:noFill/>
+        </p:spPr>
+        <p:txBody>
+          <a:bodyPr wrap="square">
+            <a:spAutoFit/>
+          </a:bodyPr>
+          <a:lstStyle/>
+          <a:p>
+            <a:pPr algn="l"/>
+            <a:r>
+              <a:rPr sz="1300" b="1">
+                <a:solidFill>
+                  <a:srgbClr val="1F3963"/>
+                </a:solidFill>
+              </a:rPr>
+              <a:t>Aalen-Johansen  (CORRECT)</a:t>
+            </a:r>
+          </a:p>
+        </p:txBody>
+      </p:sp>
+      <p:sp>
+        <p:nvSpPr>
+          <p:cNvPr id="11" name="Rectangle 10"/>
+          <p:cNvSpPr/>
+          <p:nvPr/>
+        </p:nvSpPr>
+        <p:spPr>
+          <a:xfrm>
+            <a:off x="274320" y="2788920"/>
+            <a:ext cx="11612880" cy="1417320"/>
+          </a:xfrm>
+          <a:prstGeom prst="rect">
+            <a:avLst/>
+          </a:prstGeom>
+          <a:solidFill>
+            <a:srgbClr val="EEF2F7"/>
+          </a:solidFill>
+          <a:ln>
+            <a:noFill/>
+          </a:ln>
+        </p:spPr>
+        <p:style>
+          <a:lnRef idx="1">
+            <a:schemeClr val="accent1"/>
+          </a:lnRef>
+          <a:fillRef idx="3">
+            <a:schemeClr val="accent1"/>
+          </a:fillRef>
+          <a:effectRef idx="2">
+            <a:schemeClr val="accent1"/>
+          </a:effectRef>
+          <a:fontRef idx="minor">
+            <a:schemeClr val="lt1"/>
+          </a:fontRef>
+        </p:style>
+        <p:txBody>
+          <a:bodyPr rtlCol="0" anchor="ctr"/>
+          <a:lstStyle/>
+          <a:p>
+            <a:pPr algn="ctr"/>
+          </a:p>
+        </p:txBody>
+      </p:sp>
+      <p:sp>
+        <p:nvSpPr>
+          <p:cNvPr id="12" name="TextBox 11"/>
+          <p:cNvSpPr txBox="1"/>
+          <p:nvPr/>
+        </p:nvSpPr>
+        <p:spPr>
+          <a:xfrm>
+            <a:off x="365760" y="2862072"/>
+            <a:ext cx="11430000" cy="1325880"/>
+          </a:xfrm>
+          <a:prstGeom prst="rect">
+            <a:avLst/>
+          </a:prstGeom>
+          <a:noFill/>
+        </p:spPr>
+        <p:txBody>
+          <a:bodyPr wrap="square">
+            <a:spAutoFit/>
+          </a:bodyPr>
+          <a:lstStyle/>
+          <a:p>
+            <a:r>
+              <a:rPr sz="1300">
+                <a:solidFill>
+                  <a:srgbClr val="1F3963"/>
+                </a:solidFill>
+                <a:latin typeface="Courier New"/>
+              </a:rPr>
+              <a:t>F_k(t) = SUM_{t_j &lt;= t}  S(t_j-)  *  d_{kj} / n_j</a:t>
+            </a:r>
+          </a:p>
+          <a:p>
+            <a:r>
+              <a:rPr sz="1300">
+                <a:solidFill>
+                  <a:srgbClr val="1F3963"/>
+                </a:solidFill>
+                <a:latin typeface="Courier New"/>
+              </a:rPr>
+              <a:t/>
+            </a:r>
+          </a:p>
+          <a:p>
+            <a:r>
+              <a:rPr sz="1300">
+                <a:solidFill>
+                  <a:srgbClr val="1F3963"/>
+                </a:solidFill>
+                <a:latin typeface="Courier New"/>
+              </a:rPr>
+              <a:t>  F_k(t) : CIF for cause k at loan age t</a:t>
+            </a:r>
+          </a:p>
+          <a:p>
+            <a:r>
+              <a:rPr sz="1300">
+                <a:solidFill>
+                  <a:srgbClr val="1F3963"/>
+                </a:solidFill>
+                <a:latin typeface="Courier New"/>
+              </a:rPr>
+              <a:t>  d_{kj} : cause-k exits at time t_j</a:t>
+            </a:r>
+          </a:p>
+          <a:p>
+            <a:r>
+              <a:rPr sz="1300">
+                <a:solidFill>
+                  <a:srgbClr val="1F3963"/>
+                </a:solidFill>
+                <a:latin typeface="Courier New"/>
+              </a:rPr>
+              <a:t>  n_j    : loans at risk just before t_j</a:t>
+            </a:r>
+          </a:p>
+          <a:p>
+            <a:r>
+              <a:rPr sz="1300">
+                <a:solidFill>
+                  <a:srgbClr val="1F3963"/>
+                </a:solidFill>
+                <a:latin typeface="Courier New"/>
+              </a:rPr>
+              <a:t>  S(t_j-): overall survival before t_j — uses ALL exits</a:t>
+            </a:r>
+          </a:p>
+        </p:txBody>
+      </p:sp>
+      <p:sp>
+        <p:nvSpPr>
+          <p:cNvPr id="13" name="TextBox 12"/>
+          <p:cNvSpPr txBox="1"/>
+          <p:nvPr/>
+        </p:nvSpPr>
+        <p:spPr>
+          <a:xfrm>
+            <a:off x="274320" y="4279392"/>
+            <a:ext cx="11612880" cy="320040"/>
+          </a:xfrm>
+          <a:prstGeom prst="rect">
+            <a:avLst/>
+          </a:prstGeom>
+          <a:noFill/>
+        </p:spPr>
+        <p:txBody>
+          <a:bodyPr wrap="square">
+            <a:spAutoFit/>
+          </a:bodyPr>
+          <a:lstStyle/>
+          <a:p>
+            <a:pPr algn="l"/>
+            <a:r>
+              <a:rPr sz="1200" b="1">
+                <a:solidFill>
+                  <a:srgbClr val="1F3963"/>
+                </a:solidFill>
+              </a:rPr>
+              <a:t>Partition identity  (impossible under KM):</a:t>
+            </a:r>
+          </a:p>
+        </p:txBody>
+      </p:sp>
+      <p:sp>
+        <p:nvSpPr>
+          <p:cNvPr id="14" name="Rectangle 13"/>
+          <p:cNvSpPr/>
+          <p:nvPr/>
+        </p:nvSpPr>
+        <p:spPr>
+          <a:xfrm>
+            <a:off x="274320" y="4617720"/>
+            <a:ext cx="11612880" cy="457200"/>
+          </a:xfrm>
+          <a:prstGeom prst="rect">
+            <a:avLst/>
+          </a:prstGeom>
+          <a:solidFill>
+            <a:srgbClr val="EEF2F7"/>
+          </a:solidFill>
+          <a:ln>
+            <a:noFill/>
+          </a:ln>
+        </p:spPr>
+        <p:style>
+          <a:lnRef idx="1">
+            <a:schemeClr val="accent1"/>
+          </a:lnRef>
+          <a:fillRef idx="3">
+            <a:schemeClr val="accent1"/>
+          </a:fillRef>
+          <a:effectRef idx="2">
+            <a:schemeClr val="accent1"/>
+          </a:effectRef>
+          <a:fontRef idx="minor">
+            <a:schemeClr val="lt1"/>
+          </a:fontRef>
+        </p:style>
+        <p:txBody>
+          <a:bodyPr rtlCol="0" anchor="ctr"/>
+          <a:lstStyle/>
+          <a:p>
+            <a:pPr algn="ctr"/>
+          </a:p>
+        </p:txBody>
+      </p:sp>
+      <p:sp>
+        <p:nvSpPr>
+          <p:cNvPr id="15" name="TextBox 14"/>
+          <p:cNvSpPr txBox="1"/>
+          <p:nvPr/>
+        </p:nvSpPr>
+        <p:spPr>
+          <a:xfrm>
+            <a:off x="365760" y="4690872"/>
+            <a:ext cx="11430000" cy="365760"/>
+          </a:xfrm>
+          <a:prstGeom prst="rect">
+            <a:avLst/>
+          </a:prstGeom>
+          <a:noFill/>
+        </p:spPr>
+        <p:txBody>
+          <a:bodyPr wrap="square">
+            <a:spAutoFit/>
+          </a:bodyPr>
+          <a:lstStyle/>
+          <a:p>
+            <a:r>
+              <a:rPr sz="1300">
+                <a:solidFill>
+                  <a:srgbClr val="1F3963"/>
+                </a:solidFill>
+                <a:latin typeface="Courier New"/>
+              </a:rPr>
+              <a:t>SUM_k  F_k(t)  +  S(t)  =  1    for all t</a:t>
             </a:r>
           </a:p>
         </p:txBody>
       </p:sp>
       <p:pic>
         <p:nvPicPr>
-          <p:cNvPr id="6" name="Picture 5" descr="E1_competing_risks_cif.png"/>
+          <p:cNvPr id="16" name="Picture 15" descr="E1_competing_risks_cif.png"/>
           <p:cNvPicPr>
             <a:picLocks noChangeAspect="1"/>
           </p:cNvPicPr>
@@ -8394,7 +8946,7 @@
         </p:blipFill>
         <p:spPr>
           <a:xfrm>
-            <a:off x="457200" y="1097280"/>
+            <a:off x="274320" y="5120640"/>
             <a:ext cx="9632924" cy="5303520"/>
           </a:xfrm>
           <a:prstGeom prst="rect">
@@ -8535,7 +9087,7 @@
                   <a:srgbClr val="FFFFFF"/>
                 </a:solidFill>
               </a:rPr>
-              <a:t>E(i)(c) — KM vs AJ: Why Defaults Cannot Be Treated as Censorings</a:t>
+              <a:t>E(i)(b) — AJ CIF: 10-yr Prepay 83%  ·  Default 2.2%  ·  Active 14.5%</a:t>
             </a:r>
           </a:p>
         </p:txBody>
@@ -8569,369 +9121,14 @@
                   <a:srgbClr val="F2F2F2"/>
                 </a:solidFill>
               </a:rPr>
-              <a:t>Every AJ increment ≤ KM increment  →  F_AJ(t) ≤ F_KM(t)  →  growing bias</a:t>
-            </a:r>
-          </a:p>
-        </p:txBody>
-      </p:sp>
-      <p:sp>
-        <p:nvSpPr>
-          <p:cNvPr id="6" name="Rectangle 5"/>
-          <p:cNvSpPr/>
-          <p:nvPr/>
-        </p:nvSpPr>
-        <p:spPr>
-          <a:xfrm>
-            <a:off x="0" y="1024128"/>
-            <a:ext cx="12188952" cy="5833872"/>
-          </a:xfrm>
-          <a:prstGeom prst="rect">
-            <a:avLst/>
-          </a:prstGeom>
-          <a:solidFill>
-            <a:srgbClr val="F2F2F2"/>
-          </a:solidFill>
-          <a:ln>
-            <a:noFill/>
-          </a:ln>
-        </p:spPr>
-        <p:style>
-          <a:lnRef idx="1">
-            <a:schemeClr val="accent1"/>
-          </a:lnRef>
-          <a:fillRef idx="3">
-            <a:schemeClr val="accent1"/>
-          </a:fillRef>
-          <a:effectRef idx="2">
-            <a:schemeClr val="accent1"/>
-          </a:effectRef>
-          <a:fontRef idx="minor">
-            <a:schemeClr val="lt1"/>
-          </a:fontRef>
-        </p:style>
-        <p:txBody>
-          <a:bodyPr rtlCol="0" anchor="ctr"/>
-          <a:lstStyle/>
-          <a:p>
-            <a:pPr algn="ctr"/>
-          </a:p>
-        </p:txBody>
-      </p:sp>
-      <p:sp>
-        <p:nvSpPr>
-          <p:cNvPr id="7" name="TextBox 6"/>
-          <p:cNvSpPr txBox="1"/>
-          <p:nvPr/>
-        </p:nvSpPr>
-        <p:spPr>
-          <a:xfrm>
-            <a:off x="274320" y="1143000"/>
-            <a:ext cx="11612880" cy="365760"/>
-          </a:xfrm>
-          <a:prstGeom prst="rect">
-            <a:avLst/>
-          </a:prstGeom>
-          <a:noFill/>
-        </p:spPr>
-        <p:txBody>
-          <a:bodyPr wrap="square">
-            <a:spAutoFit/>
-          </a:bodyPr>
-          <a:lstStyle/>
-          <a:p>
-            <a:pPr algn="l"/>
-            <a:r>
-              <a:rPr sz="1200" b="1">
-                <a:solidFill>
-                  <a:srgbClr val="C00000"/>
-                </a:solidFill>
-              </a:rPr>
-              <a:t>KM increment at t_j  (defaults excluded from denominator n_j^KM &lt; n_j):</a:t>
-            </a:r>
-          </a:p>
-        </p:txBody>
-      </p:sp>
-      <p:sp>
-        <p:nvSpPr>
-          <p:cNvPr id="8" name="Rectangle 7"/>
-          <p:cNvSpPr/>
-          <p:nvPr/>
-        </p:nvSpPr>
-        <p:spPr>
-          <a:xfrm>
-            <a:off x="274320" y="1508760"/>
-            <a:ext cx="11612880" cy="548640"/>
-          </a:xfrm>
-          <a:prstGeom prst="rect">
-            <a:avLst/>
-          </a:prstGeom>
-          <a:solidFill>
-            <a:srgbClr val="EEF2F7"/>
-          </a:solidFill>
-          <a:ln>
-            <a:noFill/>
-          </a:ln>
-        </p:spPr>
-        <p:style>
-          <a:lnRef idx="1">
-            <a:schemeClr val="accent1"/>
-          </a:lnRef>
-          <a:fillRef idx="3">
-            <a:schemeClr val="accent1"/>
-          </a:fillRef>
-          <a:effectRef idx="2">
-            <a:schemeClr val="accent1"/>
-          </a:effectRef>
-          <a:fontRef idx="minor">
-            <a:schemeClr val="lt1"/>
-          </a:fontRef>
-        </p:style>
-        <p:txBody>
-          <a:bodyPr rtlCol="0" anchor="ctr"/>
-          <a:lstStyle/>
-          <a:p>
-            <a:pPr algn="ctr"/>
-          </a:p>
-        </p:txBody>
-      </p:sp>
-      <p:sp>
-        <p:nvSpPr>
-          <p:cNvPr id="9" name="TextBox 8"/>
-          <p:cNvSpPr txBox="1"/>
-          <p:nvPr/>
-        </p:nvSpPr>
-        <p:spPr>
-          <a:xfrm>
-            <a:off x="365760" y="1581912"/>
-            <a:ext cx="11430000" cy="457200"/>
-          </a:xfrm>
-          <a:prstGeom prst="rect">
-            <a:avLst/>
-          </a:prstGeom>
-          <a:noFill/>
-        </p:spPr>
-        <p:txBody>
-          <a:bodyPr wrap="square">
-            <a:spAutoFit/>
-          </a:bodyPr>
-          <a:lstStyle/>
-          <a:p>
-            <a:r>
-              <a:rPr sz="1300">
-                <a:solidFill>
-                  <a:srgbClr val="1F3963"/>
-                </a:solidFill>
-                <a:latin typeface="Courier New"/>
-              </a:rPr>
-              <a:t>ΔF_KM(t_j)  =  S_KM(t_j-)  *  d_{1j} / n_j^KM    ← n_j^KM underestimates risk set</a:t>
-            </a:r>
-          </a:p>
-        </p:txBody>
-      </p:sp>
-      <p:sp>
-        <p:nvSpPr>
-          <p:cNvPr id="10" name="TextBox 9"/>
-          <p:cNvSpPr txBox="1"/>
-          <p:nvPr/>
-        </p:nvSpPr>
-        <p:spPr>
-          <a:xfrm>
-            <a:off x="274320" y="2148840"/>
-            <a:ext cx="11612880" cy="365760"/>
-          </a:xfrm>
-          <a:prstGeom prst="rect">
-            <a:avLst/>
-          </a:prstGeom>
-          <a:noFill/>
-        </p:spPr>
-        <p:txBody>
-          <a:bodyPr wrap="square">
-            <a:spAutoFit/>
-          </a:bodyPr>
-          <a:lstStyle/>
-          <a:p>
-            <a:pPr algn="l"/>
-            <a:r>
-              <a:rPr sz="1200" b="1">
-                <a:solidFill>
-                  <a:srgbClr val="1F3963"/>
-                </a:solidFill>
-              </a:rPr>
-              <a:t>AJ increment at t_j  (overall survival, full risk set):</a:t>
-            </a:r>
-          </a:p>
-        </p:txBody>
-      </p:sp>
-      <p:sp>
-        <p:nvSpPr>
-          <p:cNvPr id="11" name="Rectangle 10"/>
-          <p:cNvSpPr/>
-          <p:nvPr/>
-        </p:nvSpPr>
-        <p:spPr>
-          <a:xfrm>
-            <a:off x="274320" y="2514600"/>
-            <a:ext cx="11612880" cy="548640"/>
-          </a:xfrm>
-          <a:prstGeom prst="rect">
-            <a:avLst/>
-          </a:prstGeom>
-          <a:solidFill>
-            <a:srgbClr val="EEF2F7"/>
-          </a:solidFill>
-          <a:ln>
-            <a:noFill/>
-          </a:ln>
-        </p:spPr>
-        <p:style>
-          <a:lnRef idx="1">
-            <a:schemeClr val="accent1"/>
-          </a:lnRef>
-          <a:fillRef idx="3">
-            <a:schemeClr val="accent1"/>
-          </a:fillRef>
-          <a:effectRef idx="2">
-            <a:schemeClr val="accent1"/>
-          </a:effectRef>
-          <a:fontRef idx="minor">
-            <a:schemeClr val="lt1"/>
-          </a:fontRef>
-        </p:style>
-        <p:txBody>
-          <a:bodyPr rtlCol="0" anchor="ctr"/>
-          <a:lstStyle/>
-          <a:p>
-            <a:pPr algn="ctr"/>
-          </a:p>
-        </p:txBody>
-      </p:sp>
-      <p:sp>
-        <p:nvSpPr>
-          <p:cNvPr id="12" name="TextBox 11"/>
-          <p:cNvSpPr txBox="1"/>
-          <p:nvPr/>
-        </p:nvSpPr>
-        <p:spPr>
-          <a:xfrm>
-            <a:off x="365760" y="2587752"/>
-            <a:ext cx="11430000" cy="457200"/>
-          </a:xfrm>
-          <a:prstGeom prst="rect">
-            <a:avLst/>
-          </a:prstGeom>
-          <a:noFill/>
-        </p:spPr>
-        <p:txBody>
-          <a:bodyPr wrap="square">
-            <a:spAutoFit/>
-          </a:bodyPr>
-          <a:lstStyle/>
-          <a:p>
-            <a:r>
-              <a:rPr sz="1300">
-                <a:solidFill>
-                  <a:srgbClr val="1F3963"/>
-                </a:solidFill>
-                <a:latin typeface="Courier New"/>
-              </a:rPr>
-              <a:t>ΔF_AJ(t_j)   =  S(t_j-)     *  d_{1j} / n_j      ← S(t_j-) ≤ S_KM(t_j-) always</a:t>
-            </a:r>
-          </a:p>
-        </p:txBody>
-      </p:sp>
-      <p:sp>
-        <p:nvSpPr>
-          <p:cNvPr id="13" name="TextBox 12"/>
-          <p:cNvSpPr txBox="1"/>
-          <p:nvPr/>
-        </p:nvSpPr>
-        <p:spPr>
-          <a:xfrm>
-            <a:off x="274320" y="3154680"/>
-            <a:ext cx="11612880" cy="365760"/>
-          </a:xfrm>
-          <a:prstGeom prst="rect">
-            <a:avLst/>
-          </a:prstGeom>
-          <a:noFill/>
-        </p:spPr>
-        <p:txBody>
-          <a:bodyPr wrap="square">
-            <a:spAutoFit/>
-          </a:bodyPr>
-          <a:lstStyle/>
-          <a:p>
-            <a:pPr algn="l"/>
-            <a:r>
-              <a:rPr sz="1200" b="1">
-                <a:solidFill>
-                  <a:srgbClr val="1F3963"/>
-                </a:solidFill>
-              </a:rPr>
-              <a:t>Consequence — bias compounds over time:</a:t>
-            </a:r>
-          </a:p>
-        </p:txBody>
-      </p:sp>
-      <p:sp>
-        <p:nvSpPr>
-          <p:cNvPr id="14" name="TextBox 13"/>
-          <p:cNvSpPr txBox="1"/>
-          <p:nvPr/>
-        </p:nvSpPr>
-        <p:spPr>
-          <a:xfrm>
-            <a:off x="274320" y="3520440"/>
-            <a:ext cx="11612880" cy="1005840"/>
-          </a:xfrm>
-          <a:prstGeom prst="rect">
-            <a:avLst/>
-          </a:prstGeom>
-          <a:noFill/>
-        </p:spPr>
-        <p:txBody>
-          <a:bodyPr wrap="square">
-            <a:spAutoFit/>
-          </a:bodyPr>
-          <a:lstStyle/>
-          <a:p>
-            <a:pPr>
-              <a:spcAft>
-                <a:spcPts val="400"/>
-              </a:spcAft>
-              <a:defRPr sz="1300"/>
-            </a:pPr>
-            <a:r>
-              <a:t>• 5 yr:  KM over-estimates prepayment CIF by ~+0.45 pp</a:t>
-            </a:r>
-          </a:p>
-          <a:p>
-            <a:pPr>
-              <a:spcAft>
-                <a:spcPts val="400"/>
-              </a:spcAft>
-              <a:defRPr sz="1300"/>
-            </a:pPr>
-            <a:r>
-              <a:t>• 10 yr: bias ≈ +1.31 pp</a:t>
-            </a:r>
-          </a:p>
-          <a:p>
-            <a:pPr>
-              <a:spcAft>
-                <a:spcPts val="400"/>
-              </a:spcAft>
-              <a:defRPr sz="1300"/>
-            </a:pPr>
-            <a:r>
-              <a:t>• 20 yr: bias ≈ +2.23 pp  (gap widens as defaulted loans accumulate)</a:t>
+              <a:t>S_KM over-estimates each cause; AJ partition sums exactly to 1</a:t>
             </a:r>
           </a:p>
         </p:txBody>
       </p:sp>
       <p:pic>
         <p:nvPicPr>
-          <p:cNvPr id="15" name="Picture 14" descr="E1_km_vs_aj_bias.png"/>
+          <p:cNvPr id="6" name="Picture 5" descr="E1_competing_risks_cif.png"/>
           <p:cNvPicPr>
             <a:picLocks noChangeAspect="1"/>
           </p:cNvPicPr>
@@ -8945,8 +9142,8 @@
         </p:blipFill>
         <p:spPr>
           <a:xfrm>
-            <a:off x="274320" y="4572000"/>
-            <a:ext cx="11612880" cy="3513594"/>
+            <a:off x="457200" y="1097280"/>
+            <a:ext cx="9632924" cy="5303520"/>
           </a:xfrm>
           <a:prstGeom prst="rect">
             <a:avLst/>

</xml_diff>

<commit_message>
Remove superimposed overlay and covariate box plot charts from E(i)
- Deleted sections 2b (density overlay) and 3 (6-feature box plots) from notebook cell 9
- Removed corresponding figures from LaTeX report and PDF report
- Removed overlay slide from PPTX deck
- Rebuilt PDF and PPTX

Co-Authored-By: Claude Sonnet 4.6 <noreply@anthropic.com>
</commit_message>
<xml_diff>
--- a/processed/PartE_Presentation.pptx
+++ b/processed/PartE_Presentation.pptx
@@ -23,7 +23,6 @@
     <p:sldId id="271" r:id="rId22"/>
     <p:sldId id="272" r:id="rId23"/>
     <p:sldId id="273" r:id="rId24"/>
-    <p:sldId id="274" r:id="rId25"/>
   </p:sldIdLst>
   <p:sldSz cx="12188952" cy="6858000" type="screen4x3"/>
   <p:notesSz cx="6858000" cy="9144000"/>
@@ -3547,7 +3546,7 @@
                   <a:srgbClr val="FFFFFF"/>
                 </a:solidFill>
               </a:rPr>
-              <a:t>E(i)(c) — KM vs AJ: Why Defaults Cannot Be Treated as Censorings</a:t>
+              <a:t>E(i)(d) — Stratified CIF</a:t>
             </a:r>
           </a:p>
         </p:txBody>
@@ -3581,369 +3580,14 @@
                   <a:srgbClr val="F2F2F2"/>
                 </a:solidFill>
               </a:rPr>
-              <a:t>Every AJ increment ≤ KM increment  →  F_AJ(t) ≤ F_KM(t)  →  growing bias</a:t>
-            </a:r>
-          </a:p>
-        </p:txBody>
-      </p:sp>
-      <p:sp>
-        <p:nvSpPr>
-          <p:cNvPr id="6" name="Rectangle 5"/>
-          <p:cNvSpPr/>
-          <p:nvPr/>
-        </p:nvSpPr>
-        <p:spPr>
-          <a:xfrm>
-            <a:off x="0" y="1024128"/>
-            <a:ext cx="12188952" cy="5833872"/>
-          </a:xfrm>
-          <a:prstGeom prst="rect">
-            <a:avLst/>
-          </a:prstGeom>
-          <a:solidFill>
-            <a:srgbClr val="F2F2F2"/>
-          </a:solidFill>
-          <a:ln>
-            <a:noFill/>
-          </a:ln>
-        </p:spPr>
-        <p:style>
-          <a:lnRef idx="1">
-            <a:schemeClr val="accent1"/>
-          </a:lnRef>
-          <a:fillRef idx="3">
-            <a:schemeClr val="accent1"/>
-          </a:fillRef>
-          <a:effectRef idx="2">
-            <a:schemeClr val="accent1"/>
-          </a:effectRef>
-          <a:fontRef idx="minor">
-            <a:schemeClr val="lt1"/>
-          </a:fontRef>
-        </p:style>
-        <p:txBody>
-          <a:bodyPr rtlCol="0" anchor="ctr"/>
-          <a:lstStyle/>
-          <a:p>
-            <a:pPr algn="ctr"/>
-          </a:p>
-        </p:txBody>
-      </p:sp>
-      <p:sp>
-        <p:nvSpPr>
-          <p:cNvPr id="7" name="TextBox 6"/>
-          <p:cNvSpPr txBox="1"/>
-          <p:nvPr/>
-        </p:nvSpPr>
-        <p:spPr>
-          <a:xfrm>
-            <a:off x="274320" y="1143000"/>
-            <a:ext cx="11612880" cy="365760"/>
-          </a:xfrm>
-          <a:prstGeom prst="rect">
-            <a:avLst/>
-          </a:prstGeom>
-          <a:noFill/>
-        </p:spPr>
-        <p:txBody>
-          <a:bodyPr wrap="square">
-            <a:spAutoFit/>
-          </a:bodyPr>
-          <a:lstStyle/>
-          <a:p>
-            <a:pPr algn="l"/>
-            <a:r>
-              <a:rPr sz="1200" b="1">
-                <a:solidFill>
-                  <a:srgbClr val="C00000"/>
-                </a:solidFill>
-              </a:rPr>
-              <a:t>KM increment at t_j  (defaults excluded from denominator n_j^KM &lt; n_j):</a:t>
-            </a:r>
-          </a:p>
-        </p:txBody>
-      </p:sp>
-      <p:sp>
-        <p:nvSpPr>
-          <p:cNvPr id="8" name="Rectangle 7"/>
-          <p:cNvSpPr/>
-          <p:nvPr/>
-        </p:nvSpPr>
-        <p:spPr>
-          <a:xfrm>
-            <a:off x="274320" y="1508760"/>
-            <a:ext cx="11612880" cy="548640"/>
-          </a:xfrm>
-          <a:prstGeom prst="rect">
-            <a:avLst/>
-          </a:prstGeom>
-          <a:solidFill>
-            <a:srgbClr val="EEF2F7"/>
-          </a:solidFill>
-          <a:ln>
-            <a:noFill/>
-          </a:ln>
-        </p:spPr>
-        <p:style>
-          <a:lnRef idx="1">
-            <a:schemeClr val="accent1"/>
-          </a:lnRef>
-          <a:fillRef idx="3">
-            <a:schemeClr val="accent1"/>
-          </a:fillRef>
-          <a:effectRef idx="2">
-            <a:schemeClr val="accent1"/>
-          </a:effectRef>
-          <a:fontRef idx="minor">
-            <a:schemeClr val="lt1"/>
-          </a:fontRef>
-        </p:style>
-        <p:txBody>
-          <a:bodyPr rtlCol="0" anchor="ctr"/>
-          <a:lstStyle/>
-          <a:p>
-            <a:pPr algn="ctr"/>
-          </a:p>
-        </p:txBody>
-      </p:sp>
-      <p:sp>
-        <p:nvSpPr>
-          <p:cNvPr id="9" name="TextBox 8"/>
-          <p:cNvSpPr txBox="1"/>
-          <p:nvPr/>
-        </p:nvSpPr>
-        <p:spPr>
-          <a:xfrm>
-            <a:off x="365760" y="1581912"/>
-            <a:ext cx="11430000" cy="457200"/>
-          </a:xfrm>
-          <a:prstGeom prst="rect">
-            <a:avLst/>
-          </a:prstGeom>
-          <a:noFill/>
-        </p:spPr>
-        <p:txBody>
-          <a:bodyPr wrap="square">
-            <a:spAutoFit/>
-          </a:bodyPr>
-          <a:lstStyle/>
-          <a:p>
-            <a:r>
-              <a:rPr sz="1300">
-                <a:solidFill>
-                  <a:srgbClr val="1F3963"/>
-                </a:solidFill>
-                <a:latin typeface="Courier New"/>
-              </a:rPr>
-              <a:t>ΔF_KM(t_j)  =  S_KM(t_j-)  *  d_{1j} / n_j^KM    ← n_j^KM underestimates risk set</a:t>
-            </a:r>
-          </a:p>
-        </p:txBody>
-      </p:sp>
-      <p:sp>
-        <p:nvSpPr>
-          <p:cNvPr id="10" name="TextBox 9"/>
-          <p:cNvSpPr txBox="1"/>
-          <p:nvPr/>
-        </p:nvSpPr>
-        <p:spPr>
-          <a:xfrm>
-            <a:off x="274320" y="2148840"/>
-            <a:ext cx="11612880" cy="365760"/>
-          </a:xfrm>
-          <a:prstGeom prst="rect">
-            <a:avLst/>
-          </a:prstGeom>
-          <a:noFill/>
-        </p:spPr>
-        <p:txBody>
-          <a:bodyPr wrap="square">
-            <a:spAutoFit/>
-          </a:bodyPr>
-          <a:lstStyle/>
-          <a:p>
-            <a:pPr algn="l"/>
-            <a:r>
-              <a:rPr sz="1200" b="1">
-                <a:solidFill>
-                  <a:srgbClr val="1F3963"/>
-                </a:solidFill>
-              </a:rPr>
-              <a:t>AJ increment at t_j  (overall survival, full risk set):</a:t>
-            </a:r>
-          </a:p>
-        </p:txBody>
-      </p:sp>
-      <p:sp>
-        <p:nvSpPr>
-          <p:cNvPr id="11" name="Rectangle 10"/>
-          <p:cNvSpPr/>
-          <p:nvPr/>
-        </p:nvSpPr>
-        <p:spPr>
-          <a:xfrm>
-            <a:off x="274320" y="2514600"/>
-            <a:ext cx="11612880" cy="548640"/>
-          </a:xfrm>
-          <a:prstGeom prst="rect">
-            <a:avLst/>
-          </a:prstGeom>
-          <a:solidFill>
-            <a:srgbClr val="EEF2F7"/>
-          </a:solidFill>
-          <a:ln>
-            <a:noFill/>
-          </a:ln>
-        </p:spPr>
-        <p:style>
-          <a:lnRef idx="1">
-            <a:schemeClr val="accent1"/>
-          </a:lnRef>
-          <a:fillRef idx="3">
-            <a:schemeClr val="accent1"/>
-          </a:fillRef>
-          <a:effectRef idx="2">
-            <a:schemeClr val="accent1"/>
-          </a:effectRef>
-          <a:fontRef idx="minor">
-            <a:schemeClr val="lt1"/>
-          </a:fontRef>
-        </p:style>
-        <p:txBody>
-          <a:bodyPr rtlCol="0" anchor="ctr"/>
-          <a:lstStyle/>
-          <a:p>
-            <a:pPr algn="ctr"/>
-          </a:p>
-        </p:txBody>
-      </p:sp>
-      <p:sp>
-        <p:nvSpPr>
-          <p:cNvPr id="12" name="TextBox 11"/>
-          <p:cNvSpPr txBox="1"/>
-          <p:nvPr/>
-        </p:nvSpPr>
-        <p:spPr>
-          <a:xfrm>
-            <a:off x="365760" y="2587752"/>
-            <a:ext cx="11430000" cy="457200"/>
-          </a:xfrm>
-          <a:prstGeom prst="rect">
-            <a:avLst/>
-          </a:prstGeom>
-          <a:noFill/>
-        </p:spPr>
-        <p:txBody>
-          <a:bodyPr wrap="square">
-            <a:spAutoFit/>
-          </a:bodyPr>
-          <a:lstStyle/>
-          <a:p>
-            <a:r>
-              <a:rPr sz="1300">
-                <a:solidFill>
-                  <a:srgbClr val="1F3963"/>
-                </a:solidFill>
-                <a:latin typeface="Courier New"/>
-              </a:rPr>
-              <a:t>ΔF_AJ(t_j)   =  S(t_j-)     *  d_{1j} / n_j      ← S(t_j-) ≤ S_KM(t_j-) always</a:t>
-            </a:r>
-          </a:p>
-        </p:txBody>
-      </p:sp>
-      <p:sp>
-        <p:nvSpPr>
-          <p:cNvPr id="13" name="TextBox 12"/>
-          <p:cNvSpPr txBox="1"/>
-          <p:nvPr/>
-        </p:nvSpPr>
-        <p:spPr>
-          <a:xfrm>
-            <a:off x="274320" y="3154680"/>
-            <a:ext cx="11612880" cy="365760"/>
-          </a:xfrm>
-          <a:prstGeom prst="rect">
-            <a:avLst/>
-          </a:prstGeom>
-          <a:noFill/>
-        </p:spPr>
-        <p:txBody>
-          <a:bodyPr wrap="square">
-            <a:spAutoFit/>
-          </a:bodyPr>
-          <a:lstStyle/>
-          <a:p>
-            <a:pPr algn="l"/>
-            <a:r>
-              <a:rPr sz="1200" b="1">
-                <a:solidFill>
-                  <a:srgbClr val="1F3963"/>
-                </a:solidFill>
-              </a:rPr>
-              <a:t>Consequence — bias compounds over time:</a:t>
-            </a:r>
-          </a:p>
-        </p:txBody>
-      </p:sp>
-      <p:sp>
-        <p:nvSpPr>
-          <p:cNvPr id="14" name="TextBox 13"/>
-          <p:cNvSpPr txBox="1"/>
-          <p:nvPr/>
-        </p:nvSpPr>
-        <p:spPr>
-          <a:xfrm>
-            <a:off x="274320" y="3520440"/>
-            <a:ext cx="11612880" cy="1005840"/>
-          </a:xfrm>
-          <a:prstGeom prst="rect">
-            <a:avLst/>
-          </a:prstGeom>
-          <a:noFill/>
-        </p:spPr>
-        <p:txBody>
-          <a:bodyPr wrap="square">
-            <a:spAutoFit/>
-          </a:bodyPr>
-          <a:lstStyle/>
-          <a:p>
-            <a:pPr>
-              <a:spcAft>
-                <a:spcPts val="400"/>
-              </a:spcAft>
-              <a:defRPr sz="1300"/>
-            </a:pPr>
-            <a:r>
-              <a:t>• 5 yr:  KM over-estimates prepayment CIF by ~+0.45 pp</a:t>
-            </a:r>
-          </a:p>
-          <a:p>
-            <a:pPr>
-              <a:spcAft>
-                <a:spcPts val="400"/>
-              </a:spcAft>
-              <a:defRPr sz="1300"/>
-            </a:pPr>
-            <a:r>
-              <a:t>• 10 yr: bias ≈ +1.31 pp</a:t>
-            </a:r>
-          </a:p>
-          <a:p>
-            <a:pPr>
-              <a:spcAft>
-                <a:spcPts val="400"/>
-              </a:spcAft>
-              <a:defRPr sz="1300"/>
-            </a:pPr>
-            <a:r>
-              <a:t>• 20 yr: bias ≈ +2.23 pp  (gap widens as defaulted loans accumulate)</a:t>
+              <a:t>High-FICO → elevated prepayment, near-zero default;  high-LTV → inverted</a:t>
             </a:r>
           </a:p>
         </p:txBody>
       </p:sp>
       <p:pic>
         <p:nvPicPr>
-          <p:cNvPr id="15" name="Picture 14" descr="E1_km_vs_aj_bias.png"/>
+          <p:cNvPr id="6" name="Picture 5" descr="E1_stratified_cif.png"/>
           <p:cNvPicPr>
             <a:picLocks noChangeAspect="1"/>
           </p:cNvPicPr>
@@ -3957,8 +3601,8 @@
         </p:blipFill>
         <p:spPr>
           <a:xfrm>
-            <a:off x="274320" y="4572000"/>
-            <a:ext cx="11612880" cy="3513594"/>
+            <a:off x="274320" y="1051560"/>
+            <a:ext cx="5186826" cy="5303520"/>
           </a:xfrm>
           <a:prstGeom prst="rect">
             <a:avLst/>
@@ -4098,7 +3742,7 @@
                   <a:srgbClr val="FFFFFF"/>
                 </a:solidFill>
               </a:rPr>
-              <a:t>E(i)(d) — Stratified CIF</a:t>
+              <a:t>E(i)(e) — Cause-Specific Cox: Prepayment  (sorted ascending)</a:t>
             </a:r>
           </a:p>
         </p:txBody>
@@ -4132,14 +3776,14 @@
                   <a:srgbClr val="F2F2F2"/>
                 </a:solidFill>
               </a:rPr>
-              <a:t>High-FICO → elevated prepayment, near-zero default;  high-LTV → inverted</a:t>
+              <a:t>Rate incentive &amp; Purchase purpose → highest refi hazard  ·  12 features  ·  95% CI</a:t>
             </a:r>
           </a:p>
         </p:txBody>
       </p:sp>
       <p:pic>
         <p:nvPicPr>
-          <p:cNvPr id="6" name="Picture 5" descr="E1_stratified_cif.png"/>
+          <p:cNvPr id="6" name="Picture 5" descr="E1_cox_prepay.png"/>
           <p:cNvPicPr>
             <a:picLocks noChangeAspect="1"/>
           </p:cNvPicPr>
@@ -4154,7 +3798,7 @@
         <p:spPr>
           <a:xfrm>
             <a:off x="274320" y="1051560"/>
-            <a:ext cx="5186826" cy="5303520"/>
+            <a:ext cx="8425049" cy="5303520"/>
           </a:xfrm>
           <a:prstGeom prst="rect">
             <a:avLst/>
@@ -4294,7 +3938,7 @@
                   <a:srgbClr val="FFFFFF"/>
                 </a:solidFill>
               </a:rPr>
-              <a:t>E(i)(e) — Cause-Specific Cox: Prepayment  (sorted ascending)</a:t>
+              <a:t>E(i)(e) — Cause-Specific Cox: Default  (sorted ascending)</a:t>
             </a:r>
           </a:p>
         </p:txBody>
@@ -4328,14 +3972,14 @@
                   <a:srgbClr val="F2F2F2"/>
                 </a:solidFill>
               </a:rPr>
-              <a:t>Rate incentive &amp; Purchase purpose → highest refi hazard  ·  12 features  ·  95% CI</a:t>
+              <a:t>LTV &amp; DTI → highest default hazard  ·  CreditScore opposite sign to prepayment</a:t>
             </a:r>
           </a:p>
         </p:txBody>
       </p:sp>
       <p:pic>
         <p:nvPicPr>
-          <p:cNvPr id="6" name="Picture 5" descr="E1_cox_prepay.png"/>
+          <p:cNvPr id="6" name="Picture 5" descr="E1_cox_default.png"/>
           <p:cNvPicPr>
             <a:picLocks noChangeAspect="1"/>
           </p:cNvPicPr>
@@ -4350,7 +3994,7 @@
         <p:spPr>
           <a:xfrm>
             <a:off x="274320" y="1051560"/>
-            <a:ext cx="8425049" cy="5303520"/>
+            <a:ext cx="8404513" cy="5303520"/>
           </a:xfrm>
           <a:prstGeom prst="rect">
             <a:avLst/>
@@ -4490,7 +4134,7 @@
                   <a:srgbClr val="FFFFFF"/>
                 </a:solidFill>
               </a:rPr>
-              <a:t>E(i)(e) — Cause-Specific Cox: Default  (sorted ascending)</a:t>
+              <a:t>E(i)(f) — Fine-Gray Subdistribution Hazard</a:t>
             </a:r>
           </a:p>
         </p:txBody>
@@ -4524,35 +4168,165 @@
                   <a:srgbClr val="F2F2F2"/>
                 </a:solidFill>
               </a:rPr>
-              <a:t>LTV &amp; DTI → highest default hazard  ·  CreditScore opposite sign to prepayment</a:t>
-            </a:r>
-          </a:p>
-        </p:txBody>
-      </p:sp>
-      <p:pic>
-        <p:nvPicPr>
-          <p:cNvPr id="6" name="Picture 5" descr="E1_cox_default.png"/>
-          <p:cNvPicPr>
-            <a:picLocks noChangeAspect="1"/>
-          </p:cNvPicPr>
-          <p:nvPr/>
-        </p:nvPicPr>
-        <p:blipFill>
-          <a:blip r:embed="rId2"/>
-          <a:stretch>
-            <a:fillRect/>
-          </a:stretch>
-        </p:blipFill>
-        <p:spPr>
-          <a:xfrm>
-            <a:off x="274320" y="1051560"/>
-            <a:ext cx="8404513" cy="5303520"/>
-          </a:xfrm>
-          <a:prstGeom prst="rect">
-            <a:avLst/>
-          </a:prstGeom>
-        </p:spPr>
-      </p:pic>
+              <a:t>IPCW-weighted Cox approximation; coefficients directly target the CIF</a:t>
+            </a:r>
+          </a:p>
+        </p:txBody>
+      </p:sp>
+      <p:sp>
+        <p:nvSpPr>
+          <p:cNvPr id="6" name="Rectangle 5"/>
+          <p:cNvSpPr/>
+          <p:nvPr/>
+        </p:nvSpPr>
+        <p:spPr>
+          <a:xfrm>
+            <a:off x="0" y="1005840"/>
+            <a:ext cx="12188952" cy="5852160"/>
+          </a:xfrm>
+          <a:prstGeom prst="rect">
+            <a:avLst/>
+          </a:prstGeom>
+          <a:solidFill>
+            <a:srgbClr val="F2F2F2"/>
+          </a:solidFill>
+          <a:ln>
+            <a:noFill/>
+          </a:ln>
+        </p:spPr>
+        <p:style>
+          <a:lnRef idx="1">
+            <a:schemeClr val="accent1"/>
+          </a:lnRef>
+          <a:fillRef idx="3">
+            <a:schemeClr val="accent1"/>
+          </a:fillRef>
+          <a:effectRef idx="2">
+            <a:schemeClr val="accent1"/>
+          </a:effectRef>
+          <a:fontRef idx="minor">
+            <a:schemeClr val="lt1"/>
+          </a:fontRef>
+        </p:style>
+        <p:txBody>
+          <a:bodyPr rtlCol="0" anchor="ctr"/>
+          <a:lstStyle/>
+          <a:p>
+            <a:pPr algn="ctr"/>
+          </a:p>
+        </p:txBody>
+      </p:sp>
+      <p:sp>
+        <p:nvSpPr>
+          <p:cNvPr id="7" name="TextBox 6"/>
+          <p:cNvSpPr txBox="1"/>
+          <p:nvPr/>
+        </p:nvSpPr>
+        <p:spPr>
+          <a:xfrm>
+            <a:off x="457200" y="1188720"/>
+            <a:ext cx="11247120" cy="5029200"/>
+          </a:xfrm>
+          <a:prstGeom prst="rect">
+            <a:avLst/>
+          </a:prstGeom>
+          <a:noFill/>
+        </p:spPr>
+        <p:txBody>
+          <a:bodyPr wrap="square">
+            <a:spAutoFit/>
+          </a:bodyPr>
+          <a:lstStyle/>
+          <a:p>
+            <a:pPr>
+              <a:spcAft>
+                <a:spcPts val="400"/>
+              </a:spcAft>
+              <a:defRPr sz="1400"/>
+            </a:pPr>
+            <a:r>
+              <a:t>• Subjects who experienced a competing event (default) are KEPT in the risk set with IPCW weights</a:t>
+            </a:r>
+          </a:p>
+          <a:p>
+            <a:pPr>
+              <a:spcAft>
+                <a:spcPts val="400"/>
+              </a:spcAft>
+              <a:defRPr sz="1400"/>
+            </a:pPr>
+            <a:r>
+              <a:t>• The subdistribution hazard integrates to the CIF — covariate effects are CIF effects</a:t>
+            </a:r>
+          </a:p>
+          <a:p>
+            <a:pPr>
+              <a:spcAft>
+                <a:spcPts val="400"/>
+              </a:spcAft>
+              <a:defRPr sz="1400"/>
+            </a:pPr>
+            <a:r>
+              <a:t>• rate_incentive HR is LARGER under Fine-Gray than cause-specific Cox:</a:t>
+            </a:r>
+          </a:p>
+          <a:p>
+            <a:pPr>
+              <a:spcAft>
+                <a:spcPts val="400"/>
+              </a:spcAft>
+              <a:defRPr sz="1400"/>
+            </a:pPr>
+            <a:r>
+              <a:t>•    high-incentive loans are also less likely to default first → amplifies CIF effect</a:t>
+            </a:r>
+          </a:p>
+          <a:p>
+            <a:pPr>
+              <a:spcAft>
+                <a:spcPts val="400"/>
+              </a:spcAft>
+              <a:defRPr sz="1400"/>
+            </a:pPr>
+            <a:r>
+              <a:t>• Low-FICO Fine-Gray HR for prepayment is ATTENUATED: elevated default risk reduces</a:t>
+            </a:r>
+          </a:p>
+          <a:p>
+            <a:pPr>
+              <a:spcAft>
+                <a:spcPts val="400"/>
+              </a:spcAft>
+              <a:defRPr sz="1400"/>
+            </a:pPr>
+            <a:r>
+              <a:t>•    measured prepayment propensity once competing risks are accounted for</a:t>
+            </a:r>
+          </a:p>
+          <a:p>
+            <a:pPr>
+              <a:spcAft>
+                <a:spcPts val="400"/>
+              </a:spcAft>
+              <a:defRPr sz="1400"/>
+            </a:pPr>
+            <a:r>
+              <a:t>• Use Fine-Gray for CIF prediction / loss forecasting</a:t>
+            </a:r>
+          </a:p>
+          <a:p>
+            <a:pPr>
+              <a:spcAft>
+                <a:spcPts val="400"/>
+              </a:spcAft>
+              <a:defRPr sz="1400"/>
+            </a:pPr>
+            <a:r>
+              <a:t>• Use cause-specific Cox for economic mechanism estimation</a:t>
+            </a:r>
+          </a:p>
+        </p:txBody>
+      </p:sp>
     </p:spTree>
   </p:cSld>
   <p:clrMapOvr>
@@ -4686,7 +4460,7 @@
                   <a:srgbClr val="FFFFFF"/>
                 </a:solidFill>
               </a:rPr>
-              <a:t>E(i)(f) — Fine-Gray Subdistribution Hazard</a:t>
+              <a:t>E(ii) — Time-Dependent Covariates</a:t>
             </a:r>
           </a:p>
         </p:txBody>
@@ -4720,7 +4494,7 @@
                   <a:srgbClr val="F2F2F2"/>
                 </a:solidFill>
               </a:rPr>
-              <a:t>IPCW-weighted Cox approximation; coefficients directly target the CIF</a:t>
+              <a:t>Andersen-Gill counting-process Cox — monthly rate_incentive, unemployment, HPI</a:t>
             </a:r>
           </a:p>
         </p:txBody>
@@ -4794,10 +4568,10 @@
               <a:spcAft>
                 <a:spcPts val="400"/>
               </a:spcAft>
-              <a:defRPr sz="1400"/>
+              <a:defRPr sz="1300"/>
             </a:pPr>
             <a:r>
-              <a:t>• Subjects who experienced a competing event (default) are KEPT in the risk set with IPCW weights</a:t>
+              <a:t>• Panel dataset: 93M rows × 2M loans — mortgage_rate, unemployment, HPI YoY, rate_incentive updated monthly</a:t>
             </a:r>
           </a:p>
           <a:p>
@@ -4805,10 +4579,10 @@
               <a:spcAft>
                 <a:spcPts val="400"/>
               </a:spcAft>
-              <a:defRPr sz="1400"/>
+              <a:defRPr sz="1300"/>
             </a:pPr>
             <a:r>
-              <a:t>• The subdistribution hazard integrates to the CIF — covariate effects are CIF effects</a:t>
+              <a:t>• 10,000 loans stratified by vintage → ~500K counting-process rows (tstart, tstop, event)</a:t>
             </a:r>
           </a:p>
           <a:p>
@@ -4816,10 +4590,10 @@
               <a:spcAft>
                 <a:spcPts val="400"/>
               </a:spcAft>
-              <a:defRPr sz="1400"/>
+              <a:defRPr sz="1300"/>
             </a:pPr>
             <a:r>
-              <a:t>• rate_incentive HR is LARGER under Fine-Gray than cause-specific Cox:</a:t>
+              <a:t>• 11 features: 7 static (FICO, LTV, DTI, UPB + 3 one-hot) + 4 time-varying</a:t>
             </a:r>
           </a:p>
           <a:p>
@@ -4827,10 +4601,10 @@
               <a:spcAft>
                 <a:spcPts val="400"/>
               </a:spcAft>
-              <a:defRPr sz="1400"/>
+              <a:defRPr sz="1300"/>
             </a:pPr>
             <a:r>
-              <a:t>•    high-incentive loans are also less likely to default first → amplifies CIF effect</a:t>
+              <a:t>• Key finding: current rate_incentive coefficient LARGER than origination-vintage snapshot</a:t>
             </a:r>
           </a:p>
           <a:p>
@@ -4838,10 +4612,10 @@
               <a:spcAft>
                 <a:spcPts val="400"/>
               </a:spcAft>
-              <a:defRPr sz="1400"/>
+              <a:defRPr sz="1300"/>
             </a:pPr>
             <a:r>
-              <a:t>• Low-FICO Fine-Gray HR for prepayment is ATTENUATED: elevated default risk reduces</a:t>
+              <a:t>•    Static Cox: rate_incentive locked at origination — high-rate era loans always look attractive</a:t>
             </a:r>
           </a:p>
           <a:p>
@@ -4849,10 +4623,10 @@
               <a:spcAft>
                 <a:spcPts val="400"/>
               </a:spcAft>
-              <a:defRPr sz="1400"/>
+              <a:defRPr sz="1300"/>
             </a:pPr>
             <a:r>
-              <a:t>•    measured prepayment propensity once competing risks are accounted for</a:t>
+              <a:t>•    TV Cox: tracks actual monthly refi option value — more responsive to rate cycles</a:t>
             </a:r>
           </a:p>
           <a:p>
@@ -4860,10 +4634,10 @@
               <a:spcAft>
                 <a:spcPts val="400"/>
               </a:spcAft>
-              <a:defRPr sz="1400"/>
+              <a:defRPr sz="1300"/>
             </a:pPr>
             <a:r>
-              <a:t>• Use Fine-Gray for CIF prediction / loss forecasting</a:t>
+              <a:t>• Unemployment: contemporaneous job loss predicts default better than vintage average</a:t>
             </a:r>
           </a:p>
           <a:p>
@@ -4871,10 +4645,10 @@
               <a:spcAft>
                 <a:spcPts val="400"/>
               </a:spcAft>
-              <a:defRPr sz="1400"/>
+              <a:defRPr sz="1300"/>
             </a:pPr>
             <a:r>
-              <a:t>• Use cause-specific Cox for economic mechanism estimation</a:t>
+              <a:t>• Limitation: origination LTV used (not ELTV) — adding current LTV would improve default hazard</a:t>
             </a:r>
           </a:p>
         </p:txBody>
@@ -5012,199 +4786,59 @@
                   <a:srgbClr val="FFFFFF"/>
                 </a:solidFill>
               </a:rPr>
-              <a:t>E(ii) — Time-Dependent Covariates</a:t>
-            </a:r>
-          </a:p>
-        </p:txBody>
-      </p:sp>
-      <p:sp>
-        <p:nvSpPr>
-          <p:cNvPr id="5" name="TextBox 4"/>
-          <p:cNvSpPr txBox="1"/>
-          <p:nvPr/>
-        </p:nvSpPr>
-        <p:spPr>
-          <a:xfrm>
-            <a:off x="274320" y="548640"/>
-            <a:ext cx="11430000" cy="365760"/>
-          </a:xfrm>
-          <a:prstGeom prst="rect">
-            <a:avLst/>
-          </a:prstGeom>
-          <a:noFill/>
-        </p:spPr>
-        <p:txBody>
-          <a:bodyPr wrap="square">
-            <a:spAutoFit/>
-          </a:bodyPr>
-          <a:lstStyle/>
-          <a:p>
-            <a:pPr algn="l"/>
-            <a:r>
-              <a:rPr sz="1300" b="0">
-                <a:solidFill>
-                  <a:srgbClr val="F2F2F2"/>
-                </a:solidFill>
-              </a:rPr>
-              <a:t>Andersen-Gill counting-process Cox — monthly rate_incentive, unemployment, HPI</a:t>
-            </a:r>
-          </a:p>
-        </p:txBody>
-      </p:sp>
-      <p:sp>
-        <p:nvSpPr>
-          <p:cNvPr id="6" name="Rectangle 5"/>
-          <p:cNvSpPr/>
-          <p:nvPr/>
-        </p:nvSpPr>
-        <p:spPr>
-          <a:xfrm>
-            <a:off x="0" y="1005840"/>
-            <a:ext cx="12188952" cy="5852160"/>
-          </a:xfrm>
-          <a:prstGeom prst="rect">
-            <a:avLst/>
-          </a:prstGeom>
-          <a:solidFill>
-            <a:srgbClr val="F2F2F2"/>
-          </a:solidFill>
-          <a:ln>
-            <a:noFill/>
-          </a:ln>
-        </p:spPr>
-        <p:style>
-          <a:lnRef idx="1">
-            <a:schemeClr val="accent1"/>
-          </a:lnRef>
-          <a:fillRef idx="3">
-            <a:schemeClr val="accent1"/>
-          </a:fillRef>
-          <a:effectRef idx="2">
-            <a:schemeClr val="accent1"/>
-          </a:effectRef>
-          <a:fontRef idx="minor">
-            <a:schemeClr val="lt1"/>
-          </a:fontRef>
-        </p:style>
-        <p:txBody>
-          <a:bodyPr rtlCol="0" anchor="ctr"/>
-          <a:lstStyle/>
-          <a:p>
-            <a:pPr algn="ctr"/>
-          </a:p>
-        </p:txBody>
-      </p:sp>
-      <p:sp>
-        <p:nvSpPr>
-          <p:cNvPr id="7" name="TextBox 6"/>
-          <p:cNvSpPr txBox="1"/>
-          <p:nvPr/>
-        </p:nvSpPr>
-        <p:spPr>
-          <a:xfrm>
-            <a:off x="457200" y="1188720"/>
-            <a:ext cx="11247120" cy="5029200"/>
-          </a:xfrm>
-          <a:prstGeom prst="rect">
-            <a:avLst/>
-          </a:prstGeom>
-          <a:noFill/>
-        </p:spPr>
-        <p:txBody>
-          <a:bodyPr wrap="square">
-            <a:spAutoFit/>
-          </a:bodyPr>
-          <a:lstStyle/>
-          <a:p>
-            <a:pPr>
-              <a:spcAft>
-                <a:spcPts val="400"/>
-              </a:spcAft>
-              <a:defRPr sz="1300"/>
-            </a:pPr>
-            <a:r>
-              <a:t>• Panel dataset: 93M rows × 2M loans — mortgage_rate, unemployment, HPI YoY, rate_incentive updated monthly</a:t>
-            </a:r>
-          </a:p>
-          <a:p>
-            <a:pPr>
-              <a:spcAft>
-                <a:spcPts val="400"/>
-              </a:spcAft>
-              <a:defRPr sz="1300"/>
-            </a:pPr>
-            <a:r>
-              <a:t>• 10,000 loans stratified by vintage → ~500K counting-process rows (tstart, tstop, event)</a:t>
-            </a:r>
-          </a:p>
-          <a:p>
-            <a:pPr>
-              <a:spcAft>
-                <a:spcPts val="400"/>
-              </a:spcAft>
-              <a:defRPr sz="1300"/>
-            </a:pPr>
-            <a:r>
-              <a:t>• 11 features: 7 static (FICO, LTV, DTI, UPB + 3 one-hot) + 4 time-varying</a:t>
-            </a:r>
-          </a:p>
-          <a:p>
-            <a:pPr>
-              <a:spcAft>
-                <a:spcPts val="400"/>
-              </a:spcAft>
-              <a:defRPr sz="1300"/>
-            </a:pPr>
-            <a:r>
-              <a:t>• Key finding: current rate_incentive coefficient LARGER than origination-vintage snapshot</a:t>
-            </a:r>
-          </a:p>
-          <a:p>
-            <a:pPr>
-              <a:spcAft>
-                <a:spcPts val="400"/>
-              </a:spcAft>
-              <a:defRPr sz="1300"/>
-            </a:pPr>
-            <a:r>
-              <a:t>•    Static Cox: rate_incentive locked at origination — high-rate era loans always look attractive</a:t>
-            </a:r>
-          </a:p>
-          <a:p>
-            <a:pPr>
-              <a:spcAft>
-                <a:spcPts val="400"/>
-              </a:spcAft>
-              <a:defRPr sz="1300"/>
-            </a:pPr>
-            <a:r>
-              <a:t>•    TV Cox: tracks actual monthly refi option value — more responsive to rate cycles</a:t>
-            </a:r>
-          </a:p>
-          <a:p>
-            <a:pPr>
-              <a:spcAft>
-                <a:spcPts val="400"/>
-              </a:spcAft>
-              <a:defRPr sz="1300"/>
-            </a:pPr>
-            <a:r>
-              <a:t>• Unemployment: contemporaneous job loss predicts default better than vintage average</a:t>
-            </a:r>
-          </a:p>
-          <a:p>
-            <a:pPr>
-              <a:spcAft>
-                <a:spcPts val="400"/>
-              </a:spcAft>
-              <a:defRPr sz="1300"/>
-            </a:pPr>
-            <a:r>
-              <a:t>• Limitation: origination LTV used (not ELTV) — adding current LTV would improve default hazard</a:t>
-            </a:r>
-          </a:p>
-        </p:txBody>
-      </p:sp>
+              <a:t>E(ii) — TV Cox Results</a:t>
+            </a:r>
+          </a:p>
+        </p:txBody>
+      </p:sp>
+      <p:pic>
+        <p:nvPicPr>
+          <p:cNvPr id="5" name="Picture 4" descr="Eii_tv_cox_forest.png"/>
+          <p:cNvPicPr>
+            <a:picLocks noChangeAspect="1"/>
+          </p:cNvPicPr>
+          <p:nvPr/>
+        </p:nvPicPr>
+        <p:blipFill>
+          <a:blip r:embed="rId2"/>
+          <a:stretch>
+            <a:fillRect/>
+          </a:stretch>
+        </p:blipFill>
+        <p:spPr>
+          <a:xfrm>
+            <a:off x="137160" y="1051560"/>
+            <a:ext cx="7132320" cy="3013704"/>
+          </a:xfrm>
+          <a:prstGeom prst="rect">
+            <a:avLst/>
+          </a:prstGeom>
+        </p:spPr>
+      </p:pic>
+      <p:pic>
+        <p:nvPicPr>
+          <p:cNvPr id="6" name="Picture 5" descr="Eii_static_vs_tv.png"/>
+          <p:cNvPicPr>
+            <a:picLocks noChangeAspect="1"/>
+          </p:cNvPicPr>
+          <p:nvPr/>
+        </p:nvPicPr>
+        <p:blipFill>
+          <a:blip r:embed="rId3"/>
+          <a:stretch>
+            <a:fillRect/>
+          </a:stretch>
+        </p:blipFill>
+        <p:spPr>
+          <a:xfrm>
+            <a:off x="7406640" y="1051560"/>
+            <a:ext cx="4572000" cy="2247385"/>
+          </a:xfrm>
+          <a:prstGeom prst="rect">
+            <a:avLst/>
+          </a:prstGeom>
+        </p:spPr>
+      </p:pic>
     </p:spTree>
   </p:cSld>
   <p:clrMapOvr>
@@ -5338,14 +4972,48 @@
                   <a:srgbClr val="FFFFFF"/>
                 </a:solidFill>
               </a:rPr>
-              <a:t>E(ii) — TV Cox Results</a:t>
+              <a:t>E(iv) — Scenario Analysis: Interest Rate Shocks</a:t>
+            </a:r>
+          </a:p>
+        </p:txBody>
+      </p:sp>
+      <p:sp>
+        <p:nvSpPr>
+          <p:cNvPr id="5" name="TextBox 4"/>
+          <p:cNvSpPr txBox="1"/>
+          <p:nvPr/>
+        </p:nvSpPr>
+        <p:spPr>
+          <a:xfrm>
+            <a:off x="274320" y="548640"/>
+            <a:ext cx="11430000" cy="365760"/>
+          </a:xfrm>
+          <a:prstGeom prst="rect">
+            <a:avLst/>
+          </a:prstGeom>
+          <a:noFill/>
+        </p:spPr>
+        <p:txBody>
+          <a:bodyPr wrap="square">
+            <a:spAutoFit/>
+          </a:bodyPr>
+          <a:lstStyle/>
+          <a:p>
+            <a:pPr algn="l"/>
+            <a:r>
+              <a:rPr sz="1300" b="0">
+                <a:solidFill>
+                  <a:srgbClr val="F2F2F2"/>
+                </a:solidFill>
+              </a:rPr>
+              <a:t>±100 bp and ±200 bp shocks to mortgage_rate  (rate_incentive updated consistently)</a:t>
             </a:r>
           </a:p>
         </p:txBody>
       </p:sp>
       <p:pic>
         <p:nvPicPr>
-          <p:cNvPr id="5" name="Picture 4" descr="Eii_tv_cox_forest.png"/>
+          <p:cNvPr id="6" name="Picture 5" descr="E2_scenario_analysis.png"/>
           <p:cNvPicPr>
             <a:picLocks noChangeAspect="1"/>
           </p:cNvPicPr>
@@ -5359,32 +5027,8 @@
         </p:blipFill>
         <p:spPr>
           <a:xfrm>
-            <a:off x="137160" y="1051560"/>
-            <a:ext cx="7132320" cy="3013704"/>
-          </a:xfrm>
-          <a:prstGeom prst="rect">
-            <a:avLst/>
-          </a:prstGeom>
-        </p:spPr>
-      </p:pic>
-      <p:pic>
-        <p:nvPicPr>
-          <p:cNvPr id="6" name="Picture 5" descr="Eii_static_vs_tv.png"/>
-          <p:cNvPicPr>
-            <a:picLocks noChangeAspect="1"/>
-          </p:cNvPicPr>
-          <p:nvPr/>
-        </p:nvPicPr>
-        <p:blipFill>
-          <a:blip r:embed="rId3"/>
-          <a:stretch>
-            <a:fillRect/>
-          </a:stretch>
-        </p:blipFill>
-        <p:spPr>
-          <a:xfrm>
-            <a:off x="7406640" y="1051560"/>
-            <a:ext cx="4572000" cy="2247385"/>
+            <a:off x="457200" y="1051560"/>
+            <a:ext cx="11247120" cy="3906695"/>
           </a:xfrm>
           <a:prstGeom prst="rect">
             <a:avLst/>
@@ -5524,21 +5168,64 @@
                   <a:srgbClr val="FFFFFF"/>
                 </a:solidFill>
               </a:rPr>
-              <a:t>E(iv) — Scenario Analysis: Interest Rate Shocks</a:t>
-            </a:r>
-          </a:p>
-        </p:txBody>
-      </p:sp>
-      <p:sp>
-        <p:nvSpPr>
-          <p:cNvPr id="5" name="TextBox 4"/>
+              <a:t>E(iv) — Scenario Analysis: Interpretation</a:t>
+            </a:r>
+          </a:p>
+        </p:txBody>
+      </p:sp>
+      <p:sp>
+        <p:nvSpPr>
+          <p:cNvPr id="5" name="Rectangle 4"/>
+          <p:cNvSpPr/>
+          <p:nvPr/>
+        </p:nvSpPr>
+        <p:spPr>
+          <a:xfrm>
+            <a:off x="0" y="1005840"/>
+            <a:ext cx="12188952" cy="5852160"/>
+          </a:xfrm>
+          <a:prstGeom prst="rect">
+            <a:avLst/>
+          </a:prstGeom>
+          <a:solidFill>
+            <a:srgbClr val="F2F2F2"/>
+          </a:solidFill>
+          <a:ln>
+            <a:noFill/>
+          </a:ln>
+        </p:spPr>
+        <p:style>
+          <a:lnRef idx="1">
+            <a:schemeClr val="accent1"/>
+          </a:lnRef>
+          <a:fillRef idx="3">
+            <a:schemeClr val="accent1"/>
+          </a:fillRef>
+          <a:effectRef idx="2">
+            <a:schemeClr val="accent1"/>
+          </a:effectRef>
+          <a:fontRef idx="minor">
+            <a:schemeClr val="lt1"/>
+          </a:fontRef>
+        </p:style>
+        <p:txBody>
+          <a:bodyPr rtlCol="0" anchor="ctr"/>
+          <a:lstStyle/>
+          <a:p>
+            <a:pPr algn="ctr"/>
+          </a:p>
+        </p:txBody>
+      </p:sp>
+      <p:sp>
+        <p:nvSpPr>
+          <p:cNvPr id="6" name="TextBox 5"/>
           <p:cNvSpPr txBox="1"/>
           <p:nvPr/>
         </p:nvSpPr>
         <p:spPr>
           <a:xfrm>
-            <a:off x="274320" y="548640"/>
-            <a:ext cx="11430000" cy="365760"/>
+            <a:off x="457200" y="1188720"/>
+            <a:ext cx="11247120" cy="5029200"/>
           </a:xfrm>
           <a:prstGeom prst="rect">
             <a:avLst/>
@@ -5551,42 +5238,84 @@
           </a:bodyPr>
           <a:lstStyle/>
           <a:p>
-            <a:pPr algn="l"/>
-            <a:r>
-              <a:rPr sz="1300" b="0">
-                <a:solidFill>
-                  <a:srgbClr val="F2F2F2"/>
-                </a:solidFill>
-              </a:rPr>
-              <a:t>±100 bp and ±200 bp shocks to mortgage_rate  (rate_incentive updated consistently)</a:t>
-            </a:r>
-          </a:p>
-        </p:txBody>
-      </p:sp>
-      <p:pic>
-        <p:nvPicPr>
-          <p:cNvPr id="6" name="Picture 5" descr="E2_scenario_analysis.png"/>
-          <p:cNvPicPr>
-            <a:picLocks noChangeAspect="1"/>
-          </p:cNvPicPr>
-          <p:nvPr/>
-        </p:nvPicPr>
-        <p:blipFill>
-          <a:blip r:embed="rId2"/>
-          <a:stretch>
-            <a:fillRect/>
-          </a:stretch>
-        </p:blipFill>
-        <p:spPr>
-          <a:xfrm>
-            <a:off x="457200" y="1051560"/>
-            <a:ext cx="11247120" cy="3906695"/>
-          </a:xfrm>
-          <a:prstGeom prst="rect">
-            <a:avLst/>
-          </a:prstGeom>
-        </p:spPr>
-      </p:pic>
+            <a:pPr>
+              <a:spcAft>
+                <a:spcPts val="400"/>
+              </a:spcAft>
+              <a:defRPr sz="1500"/>
+            </a:pPr>
+            <a:r>
+              <a:t>• XGBoost: clear monotone CONVEX response — rate cuts raise prepayment probability more than rate rises suppress it</a:t>
+            </a:r>
+          </a:p>
+          <a:p>
+            <a:pPr>
+              <a:spcAft>
+                <a:spcPts val="400"/>
+              </a:spcAft>
+              <a:defRPr sz="1500"/>
+            </a:pPr>
+            <a:r>
+              <a:t>• Deep Cox: monotone but smoother — log-hazard is a less non-linear function of rate_incentive</a:t>
+            </a:r>
+          </a:p>
+          <a:p>
+            <a:pPr>
+              <a:spcAft>
+                <a:spcPts val="400"/>
+              </a:spcAft>
+              <a:defRPr sz="1500"/>
+            </a:pPr>
+            <a:r>
+              <a:t>• Asymmetry (−200 bp effect &gt; +200 bp effect) reflects the BURNOUT effect:</a:t>
+            </a:r>
+          </a:p>
+          <a:p>
+            <a:pPr>
+              <a:spcAft>
+                <a:spcPts val="400"/>
+              </a:spcAft>
+              <a:defRPr sz="1500"/>
+            </a:pPr>
+            <a:r>
+              <a:t>•    most rate-sensitive borrowers have already prepaid → muted upside response to cuts</a:t>
+            </a:r>
+          </a:p>
+          <a:p>
+            <a:pPr>
+              <a:spcAft>
+                <a:spcPts val="400"/>
+              </a:spcAft>
+              <a:defRPr sz="1500"/>
+            </a:pPr>
+            <a:r>
+              <a:t>• Both models agree on direction → robustness of rate-incentive channel across architectures</a:t>
+            </a:r>
+          </a:p>
+          <a:p>
+            <a:pPr>
+              <a:spcAft>
+                <a:spcPts val="400"/>
+              </a:spcAft>
+              <a:defRPr sz="1500"/>
+            </a:pPr>
+            <a:r>
+              <a:t>• Implication for MBS pricing: prepayment option has POSITIVE CONVEXITY —</a:t>
+            </a:r>
+          </a:p>
+          <a:p>
+            <a:pPr>
+              <a:spcAft>
+                <a:spcPts val="400"/>
+              </a:spcAft>
+              <a:defRPr sz="1500"/>
+            </a:pPr>
+            <a:r>
+              <a:t>•    rate decline creates more prepayment than rate rise suppresses it</a:t>
+            </a:r>
+          </a:p>
+        </p:txBody>
+      </p:sp>
     </p:spTree>
   </p:cSld>
   <p:clrMapOvr>
@@ -5596,287 +5325,6 @@
 </file>
 
 <file path=ppt/slides/slide18.xml><?xml version="1.0" encoding="utf-8"?>
-<p:sld xmlns:a="http://schemas.openxmlformats.org/drawingml/2006/main" xmlns:p="http://schemas.openxmlformats.org/presentationml/2006/main" xmlns:r="http://schemas.openxmlformats.org/officeDocument/2006/relationships">
-  <p:cSld>
-    <p:spTree>
-      <p:nvGrpSpPr>
-        <p:cNvPr id="1" name=""/>
-        <p:cNvGrpSpPr/>
-        <p:nvPr/>
-      </p:nvGrpSpPr>
-      <p:grpSpPr/>
-      <p:sp>
-        <p:nvSpPr>
-          <p:cNvPr id="2" name="Rectangle 1"/>
-          <p:cNvSpPr/>
-          <p:nvPr/>
-        </p:nvSpPr>
-        <p:spPr>
-          <a:xfrm>
-            <a:off x="0" y="0"/>
-            <a:ext cx="12188952" cy="960120"/>
-          </a:xfrm>
-          <a:prstGeom prst="rect">
-            <a:avLst/>
-          </a:prstGeom>
-          <a:solidFill>
-            <a:srgbClr val="1F3963"/>
-          </a:solidFill>
-          <a:ln>
-            <a:noFill/>
-          </a:ln>
-        </p:spPr>
-        <p:style>
-          <a:lnRef idx="1">
-            <a:schemeClr val="accent1"/>
-          </a:lnRef>
-          <a:fillRef idx="3">
-            <a:schemeClr val="accent1"/>
-          </a:fillRef>
-          <a:effectRef idx="2">
-            <a:schemeClr val="accent1"/>
-          </a:effectRef>
-          <a:fontRef idx="minor">
-            <a:schemeClr val="lt1"/>
-          </a:fontRef>
-        </p:style>
-        <p:txBody>
-          <a:bodyPr rtlCol="0" anchor="ctr"/>
-          <a:lstStyle/>
-          <a:p>
-            <a:pPr algn="ctr"/>
-          </a:p>
-        </p:txBody>
-      </p:sp>
-      <p:sp>
-        <p:nvSpPr>
-          <p:cNvPr id="3" name="Rectangle 2"/>
-          <p:cNvSpPr/>
-          <p:nvPr/>
-        </p:nvSpPr>
-        <p:spPr>
-          <a:xfrm>
-            <a:off x="0" y="960120"/>
-            <a:ext cx="12188952" cy="64008"/>
-          </a:xfrm>
-          <a:prstGeom prst="rect">
-            <a:avLst/>
-          </a:prstGeom>
-          <a:solidFill>
-            <a:srgbClr val="FFC000"/>
-          </a:solidFill>
-          <a:ln>
-            <a:noFill/>
-          </a:ln>
-        </p:spPr>
-        <p:style>
-          <a:lnRef idx="1">
-            <a:schemeClr val="accent1"/>
-          </a:lnRef>
-          <a:fillRef idx="3">
-            <a:schemeClr val="accent1"/>
-          </a:fillRef>
-          <a:effectRef idx="2">
-            <a:schemeClr val="accent1"/>
-          </a:effectRef>
-          <a:fontRef idx="minor">
-            <a:schemeClr val="lt1"/>
-          </a:fontRef>
-        </p:style>
-        <p:txBody>
-          <a:bodyPr rtlCol="0" anchor="ctr"/>
-          <a:lstStyle/>
-          <a:p>
-            <a:pPr algn="ctr"/>
-          </a:p>
-        </p:txBody>
-      </p:sp>
-      <p:sp>
-        <p:nvSpPr>
-          <p:cNvPr id="4" name="TextBox 3"/>
-          <p:cNvSpPr txBox="1"/>
-          <p:nvPr/>
-        </p:nvSpPr>
-        <p:spPr>
-          <a:xfrm>
-            <a:off x="274320" y="54864"/>
-            <a:ext cx="11430000" cy="502920"/>
-          </a:xfrm>
-          <a:prstGeom prst="rect">
-            <a:avLst/>
-          </a:prstGeom>
-          <a:noFill/>
-        </p:spPr>
-        <p:txBody>
-          <a:bodyPr wrap="square">
-            <a:spAutoFit/>
-          </a:bodyPr>
-          <a:lstStyle/>
-          <a:p>
-            <a:pPr algn="l"/>
-            <a:r>
-              <a:rPr sz="2600" b="1">
-                <a:solidFill>
-                  <a:srgbClr val="FFFFFF"/>
-                </a:solidFill>
-              </a:rPr>
-              <a:t>E(iv) — Scenario Analysis: Interpretation</a:t>
-            </a:r>
-          </a:p>
-        </p:txBody>
-      </p:sp>
-      <p:sp>
-        <p:nvSpPr>
-          <p:cNvPr id="5" name="Rectangle 4"/>
-          <p:cNvSpPr/>
-          <p:nvPr/>
-        </p:nvSpPr>
-        <p:spPr>
-          <a:xfrm>
-            <a:off x="0" y="1005840"/>
-            <a:ext cx="12188952" cy="5852160"/>
-          </a:xfrm>
-          <a:prstGeom prst="rect">
-            <a:avLst/>
-          </a:prstGeom>
-          <a:solidFill>
-            <a:srgbClr val="F2F2F2"/>
-          </a:solidFill>
-          <a:ln>
-            <a:noFill/>
-          </a:ln>
-        </p:spPr>
-        <p:style>
-          <a:lnRef idx="1">
-            <a:schemeClr val="accent1"/>
-          </a:lnRef>
-          <a:fillRef idx="3">
-            <a:schemeClr val="accent1"/>
-          </a:fillRef>
-          <a:effectRef idx="2">
-            <a:schemeClr val="accent1"/>
-          </a:effectRef>
-          <a:fontRef idx="minor">
-            <a:schemeClr val="lt1"/>
-          </a:fontRef>
-        </p:style>
-        <p:txBody>
-          <a:bodyPr rtlCol="0" anchor="ctr"/>
-          <a:lstStyle/>
-          <a:p>
-            <a:pPr algn="ctr"/>
-          </a:p>
-        </p:txBody>
-      </p:sp>
-      <p:sp>
-        <p:nvSpPr>
-          <p:cNvPr id="6" name="TextBox 5"/>
-          <p:cNvSpPr txBox="1"/>
-          <p:nvPr/>
-        </p:nvSpPr>
-        <p:spPr>
-          <a:xfrm>
-            <a:off x="457200" y="1188720"/>
-            <a:ext cx="11247120" cy="5029200"/>
-          </a:xfrm>
-          <a:prstGeom prst="rect">
-            <a:avLst/>
-          </a:prstGeom>
-          <a:noFill/>
-        </p:spPr>
-        <p:txBody>
-          <a:bodyPr wrap="square">
-            <a:spAutoFit/>
-          </a:bodyPr>
-          <a:lstStyle/>
-          <a:p>
-            <a:pPr>
-              <a:spcAft>
-                <a:spcPts val="400"/>
-              </a:spcAft>
-              <a:defRPr sz="1500"/>
-            </a:pPr>
-            <a:r>
-              <a:t>• XGBoost: clear monotone CONVEX response — rate cuts raise prepayment probability more than rate rises suppress it</a:t>
-            </a:r>
-          </a:p>
-          <a:p>
-            <a:pPr>
-              <a:spcAft>
-                <a:spcPts val="400"/>
-              </a:spcAft>
-              <a:defRPr sz="1500"/>
-            </a:pPr>
-            <a:r>
-              <a:t>• Deep Cox: monotone but smoother — log-hazard is a less non-linear function of rate_incentive</a:t>
-            </a:r>
-          </a:p>
-          <a:p>
-            <a:pPr>
-              <a:spcAft>
-                <a:spcPts val="400"/>
-              </a:spcAft>
-              <a:defRPr sz="1500"/>
-            </a:pPr>
-            <a:r>
-              <a:t>• Asymmetry (−200 bp effect &gt; +200 bp effect) reflects the BURNOUT effect:</a:t>
-            </a:r>
-          </a:p>
-          <a:p>
-            <a:pPr>
-              <a:spcAft>
-                <a:spcPts val="400"/>
-              </a:spcAft>
-              <a:defRPr sz="1500"/>
-            </a:pPr>
-            <a:r>
-              <a:t>•    most rate-sensitive borrowers have already prepaid → muted upside response to cuts</a:t>
-            </a:r>
-          </a:p>
-          <a:p>
-            <a:pPr>
-              <a:spcAft>
-                <a:spcPts val="400"/>
-              </a:spcAft>
-              <a:defRPr sz="1500"/>
-            </a:pPr>
-            <a:r>
-              <a:t>• Both models agree on direction → robustness of rate-incentive channel across architectures</a:t>
-            </a:r>
-          </a:p>
-          <a:p>
-            <a:pPr>
-              <a:spcAft>
-                <a:spcPts val="400"/>
-              </a:spcAft>
-              <a:defRPr sz="1500"/>
-            </a:pPr>
-            <a:r>
-              <a:t>• Implication for MBS pricing: prepayment option has POSITIVE CONVEXITY —</a:t>
-            </a:r>
-          </a:p>
-          <a:p>
-            <a:pPr>
-              <a:spcAft>
-                <a:spcPts val="400"/>
-              </a:spcAft>
-              <a:defRPr sz="1500"/>
-            </a:pPr>
-            <a:r>
-              <a:t>•    rate decline creates more prepayment than rate rise suppresses it</a:t>
-            </a:r>
-          </a:p>
-        </p:txBody>
-      </p:sp>
-    </p:spTree>
-  </p:cSld>
-  <p:clrMapOvr>
-    <a:masterClrMapping/>
-  </p:clrMapOvr>
-</p:sld>
-</file>
-
-<file path=ppt/slides/slide19.xml><?xml version="1.0" encoding="utf-8"?>
 <p:sld xmlns:a="http://schemas.openxmlformats.org/drawingml/2006/main" xmlns:p="http://schemas.openxmlformats.org/presentationml/2006/main" xmlns:r="http://schemas.openxmlformats.org/officeDocument/2006/relationships">
   <p:cSld>
     <p:spTree>
@@ -7675,48 +7123,14 @@
                   <a:srgbClr val="FFFFFF"/>
                 </a:solidFill>
               </a:rPr>
-              <a:t>E(i)(a) — EDA: Superimposed Duration Densities</a:t>
-            </a:r>
-          </a:p>
-        </p:txBody>
-      </p:sp>
-      <p:sp>
-        <p:nvSpPr>
-          <p:cNvPr id="5" name="TextBox 4"/>
-          <p:cNvSpPr txBox="1"/>
-          <p:nvPr/>
-        </p:nvSpPr>
-        <p:spPr>
-          <a:xfrm>
-            <a:off x="274320" y="548640"/>
-            <a:ext cx="11430000" cy="365760"/>
-          </a:xfrm>
-          <a:prstGeom prst="rect">
-            <a:avLst/>
-          </a:prstGeom>
-          <a:noFill/>
-        </p:spPr>
-        <p:txBody>
-          <a:bodyPr wrap="square">
-            <a:spAutoFit/>
-          </a:bodyPr>
-          <a:lstStyle/>
-          <a:p>
-            <a:pPr algn="l"/>
-            <a:r>
-              <a:rPr sz="1300" b="0">
-                <a:solidFill>
-                  <a:srgbClr val="F2F2F2"/>
-                </a:solidFill>
-              </a:rPr>
-              <a:t>Normalised within each event type · dashed lines = median · full 34M-loan dataset</a:t>
+              <a:t>E(i)(a) — EDA: Vintage Cohort &amp; Categorical Breakdown</a:t>
             </a:r>
           </a:p>
         </p:txBody>
       </p:sp>
       <p:pic>
         <p:nvPicPr>
-          <p:cNvPr id="6" name="Picture 5" descr="E1_eda_duration_overlay.png"/>
+          <p:cNvPr id="5" name="Picture 4" descr="E1_eda_vintage.png"/>
           <p:cNvPicPr>
             <a:picLocks noChangeAspect="1"/>
           </p:cNvPicPr>
@@ -7730,8 +7144,32 @@
         </p:blipFill>
         <p:spPr>
           <a:xfrm>
-            <a:off x="457200" y="1097280"/>
-            <a:ext cx="11247120" cy="4607406"/>
+            <a:off x="137160" y="1051560"/>
+            <a:ext cx="7315200" cy="3054615"/>
+          </a:xfrm>
+          <a:prstGeom prst="rect">
+            <a:avLst/>
+          </a:prstGeom>
+        </p:spPr>
+      </p:pic>
+      <p:pic>
+        <p:nvPicPr>
+          <p:cNvPr id="6" name="Picture 5" descr="E1_eda_categorical.png"/>
+          <p:cNvPicPr>
+            <a:picLocks noChangeAspect="1"/>
+          </p:cNvPicPr>
+          <p:nvPr/>
+        </p:nvPicPr>
+        <p:blipFill>
+          <a:blip r:embed="rId3"/>
+          <a:stretch>
+            <a:fillRect/>
+          </a:stretch>
+        </p:blipFill>
+        <p:spPr>
+          <a:xfrm>
+            <a:off x="7589520" y="1051560"/>
+            <a:ext cx="4389120" cy="1600506"/>
           </a:xfrm>
           <a:prstGeom prst="rect">
             <a:avLst/>
@@ -7871,14 +7309,48 @@
                   <a:srgbClr val="FFFFFF"/>
                 </a:solidFill>
               </a:rPr>
-              <a:t>E(i)(a) — EDA: Vintage Cohort &amp; Categorical Breakdown</a:t>
+              <a:t>E(i)(a) — Hazard Intensity: Prepayment Peaks Early, Default Rises Slowly</a:t>
+            </a:r>
+          </a:p>
+        </p:txBody>
+      </p:sp>
+      <p:sp>
+        <p:nvSpPr>
+          <p:cNvPr id="5" name="TextBox 4"/>
+          <p:cNvSpPr txBox="1"/>
+          <p:nvPr/>
+        </p:nvSpPr>
+        <p:spPr>
+          <a:xfrm>
+            <a:off x="274320" y="548640"/>
+            <a:ext cx="11430000" cy="365760"/>
+          </a:xfrm>
+          <a:prstGeom prst="rect">
+            <a:avLst/>
+          </a:prstGeom>
+          <a:noFill/>
+        </p:spPr>
+        <p:txBody>
+          <a:bodyPr wrap="square">
+            <a:spAutoFit/>
+          </a:bodyPr>
+          <a:lstStyle/>
+          <a:p>
+            <a:pPr algn="l"/>
+            <a:r>
+              <a:rPr sz="1300" b="0">
+                <a:solidFill>
+                  <a:srgbClr val="F2F2F2"/>
+                </a:solidFill>
+              </a:rPr>
+              <a:t>Cause-specific Nelson-Aalen smooth · burnout visible in prepayment hazard · 100K sample</a:t>
             </a:r>
           </a:p>
         </p:txBody>
       </p:sp>
       <p:pic>
         <p:nvPicPr>
-          <p:cNvPr id="5" name="Picture 4" descr="E1_eda_vintage.png"/>
+          <p:cNvPr id="6" name="Picture 5" descr="E1_hazard_overall.png"/>
           <p:cNvPicPr>
             <a:picLocks noChangeAspect="1"/>
           </p:cNvPicPr>
@@ -7892,32 +7364,8 @@
         </p:blipFill>
         <p:spPr>
           <a:xfrm>
-            <a:off x="137160" y="1051560"/>
-            <a:ext cx="7315200" cy="3054615"/>
-          </a:xfrm>
-          <a:prstGeom prst="rect">
-            <a:avLst/>
-          </a:prstGeom>
-        </p:spPr>
-      </p:pic>
-      <p:pic>
-        <p:nvPicPr>
-          <p:cNvPr id="6" name="Picture 5" descr="E1_eda_categorical.png"/>
-          <p:cNvPicPr>
-            <a:picLocks noChangeAspect="1"/>
-          </p:cNvPicPr>
-          <p:nvPr/>
-        </p:nvPicPr>
-        <p:blipFill>
-          <a:blip r:embed="rId3"/>
-          <a:stretch>
-            <a:fillRect/>
-          </a:stretch>
-        </p:blipFill>
-        <p:spPr>
-          <a:xfrm>
-            <a:off x="7589520" y="1051560"/>
-            <a:ext cx="4389120" cy="1600506"/>
+            <a:off x="457200" y="1097280"/>
+            <a:ext cx="11247120" cy="3629792"/>
           </a:xfrm>
           <a:prstGeom prst="rect">
             <a:avLst/>
@@ -8057,7 +7505,7 @@
                   <a:srgbClr val="FFFFFF"/>
                 </a:solidFill>
               </a:rPr>
-              <a:t>E(i)(a) — Hazard Intensity: Prepayment Peaks Early, Default Rises Slowly</a:t>
+              <a:t>E(i)(a) — Stratified Hazard Intensity by FICO · LTV · Rate · Vintage</a:t>
             </a:r>
           </a:p>
         </p:txBody>
@@ -8091,14 +7539,14 @@
                   <a:srgbClr val="F2F2F2"/>
                 </a:solidFill>
               </a:rPr>
-              <a:t>Cause-specific Nelson-Aalen smooth · burnout visible in prepayment hazard · 100K sample</a:t>
+              <a:t>High-FICO refinances fastest · High-LTV defaults persist longer · GFC vintages spike</a:t>
             </a:r>
           </a:p>
         </p:txBody>
       </p:sp>
       <p:pic>
         <p:nvPicPr>
-          <p:cNvPr id="6" name="Picture 5" descr="E1_hazard_overall.png"/>
+          <p:cNvPr id="6" name="Picture 5" descr="E1_hazard_stratified.png"/>
           <p:cNvPicPr>
             <a:picLocks noChangeAspect="1"/>
           </p:cNvPicPr>
@@ -8112,8 +7560,8 @@
         </p:blipFill>
         <p:spPr>
           <a:xfrm>
-            <a:off x="457200" y="1097280"/>
-            <a:ext cx="11247120" cy="3629792"/>
+            <a:off x="457200" y="1005840"/>
+            <a:ext cx="4063204" cy="5303520"/>
           </a:xfrm>
           <a:prstGeom prst="rect">
             <a:avLst/>
@@ -8253,7 +7701,7 @@
                   <a:srgbClr val="FFFFFF"/>
                 </a:solidFill>
               </a:rPr>
-              <a:t>E(i)(a) — Stratified Hazard Intensity by FICO · LTV · Rate · Vintage</a:t>
+              <a:t>E(i)(b) — Aalen-Johansen CIF: Formula &amp; Contrast</a:t>
             </a:r>
           </a:p>
         </p:txBody>
@@ -8287,14 +7735,456 @@
                   <a:srgbClr val="F2F2F2"/>
                 </a:solidFill>
               </a:rPr>
-              <a:t>High-FICO refinances fastest · High-LTV defaults persist longer · GFC vintages spike</a:t>
+              <a:t>AJ correctly weights each increment by the overall survival probability</a:t>
+            </a:r>
+          </a:p>
+        </p:txBody>
+      </p:sp>
+      <p:sp>
+        <p:nvSpPr>
+          <p:cNvPr id="6" name="Rectangle 5"/>
+          <p:cNvSpPr/>
+          <p:nvPr/>
+        </p:nvSpPr>
+        <p:spPr>
+          <a:xfrm>
+            <a:off x="0" y="1024128"/>
+            <a:ext cx="12188952" cy="5833872"/>
+          </a:xfrm>
+          <a:prstGeom prst="rect">
+            <a:avLst/>
+          </a:prstGeom>
+          <a:solidFill>
+            <a:srgbClr val="F2F2F2"/>
+          </a:solidFill>
+          <a:ln>
+            <a:noFill/>
+          </a:ln>
+        </p:spPr>
+        <p:style>
+          <a:lnRef idx="1">
+            <a:schemeClr val="accent1"/>
+          </a:lnRef>
+          <a:fillRef idx="3">
+            <a:schemeClr val="accent1"/>
+          </a:fillRef>
+          <a:effectRef idx="2">
+            <a:schemeClr val="accent1"/>
+          </a:effectRef>
+          <a:fontRef idx="minor">
+            <a:schemeClr val="lt1"/>
+          </a:fontRef>
+        </p:style>
+        <p:txBody>
+          <a:bodyPr rtlCol="0" anchor="ctr"/>
+          <a:lstStyle/>
+          <a:p>
+            <a:pPr algn="ctr"/>
+          </a:p>
+        </p:txBody>
+      </p:sp>
+      <p:sp>
+        <p:nvSpPr>
+          <p:cNvPr id="7" name="TextBox 6"/>
+          <p:cNvSpPr txBox="1"/>
+          <p:nvPr/>
+        </p:nvSpPr>
+        <p:spPr>
+          <a:xfrm>
+            <a:off x="274320" y="1143000"/>
+            <a:ext cx="11612880" cy="365760"/>
+          </a:xfrm>
+          <a:prstGeom prst="rect">
+            <a:avLst/>
+          </a:prstGeom>
+          <a:noFill/>
+        </p:spPr>
+        <p:txBody>
+          <a:bodyPr wrap="square">
+            <a:spAutoFit/>
+          </a:bodyPr>
+          <a:lstStyle/>
+          <a:p>
+            <a:pPr algn="l"/>
+            <a:r>
+              <a:rPr sz="1300" b="1">
+                <a:solidFill>
+                  <a:srgbClr val="C00000"/>
+                </a:solidFill>
+              </a:rPr>
+              <a:t>Kaplan-Meier  (INCORRECT — treats competing exits as censored)</a:t>
+            </a:r>
+          </a:p>
+        </p:txBody>
+      </p:sp>
+      <p:sp>
+        <p:nvSpPr>
+          <p:cNvPr id="8" name="Rectangle 7"/>
+          <p:cNvSpPr/>
+          <p:nvPr/>
+        </p:nvSpPr>
+        <p:spPr>
+          <a:xfrm>
+            <a:off x="274320" y="1508760"/>
+            <a:ext cx="11612880" cy="822960"/>
+          </a:xfrm>
+          <a:prstGeom prst="rect">
+            <a:avLst/>
+          </a:prstGeom>
+          <a:solidFill>
+            <a:srgbClr val="EEF2F7"/>
+          </a:solidFill>
+          <a:ln>
+            <a:noFill/>
+          </a:ln>
+        </p:spPr>
+        <p:style>
+          <a:lnRef idx="1">
+            <a:schemeClr val="accent1"/>
+          </a:lnRef>
+          <a:fillRef idx="3">
+            <a:schemeClr val="accent1"/>
+          </a:fillRef>
+          <a:effectRef idx="2">
+            <a:schemeClr val="accent1"/>
+          </a:effectRef>
+          <a:fontRef idx="minor">
+            <a:schemeClr val="lt1"/>
+          </a:fontRef>
+        </p:style>
+        <p:txBody>
+          <a:bodyPr rtlCol="0" anchor="ctr"/>
+          <a:lstStyle/>
+          <a:p>
+            <a:pPr algn="ctr"/>
+          </a:p>
+        </p:txBody>
+      </p:sp>
+      <p:sp>
+        <p:nvSpPr>
+          <p:cNvPr id="9" name="TextBox 8"/>
+          <p:cNvSpPr txBox="1"/>
+          <p:nvPr/>
+        </p:nvSpPr>
+        <p:spPr>
+          <a:xfrm>
+            <a:off x="365760" y="1581912"/>
+            <a:ext cx="11430000" cy="731520"/>
+          </a:xfrm>
+          <a:prstGeom prst="rect">
+            <a:avLst/>
+          </a:prstGeom>
+          <a:noFill/>
+        </p:spPr>
+        <p:txBody>
+          <a:bodyPr wrap="square">
+            <a:spAutoFit/>
+          </a:bodyPr>
+          <a:lstStyle/>
+          <a:p>
+            <a:r>
+              <a:rPr sz="1300">
+                <a:solidFill>
+                  <a:srgbClr val="1F3963"/>
+                </a:solidFill>
+                <a:latin typeface="Courier New"/>
+              </a:rPr>
+              <a:t>S_KM(t) = PROD_{t_i &lt;= t} (1 - d_i^(k) / n_i)</a:t>
+            </a:r>
+          </a:p>
+          <a:p>
+            <a:r>
+              <a:rPr sz="1300">
+                <a:solidFill>
+                  <a:srgbClr val="1F3963"/>
+                </a:solidFill>
+                <a:latin typeface="Courier New"/>
+              </a:rPr>
+              <a:t>F_KM^(k)(t) = 1 - S_KM(t)    ← overcounts cause-k hazard</a:t>
+            </a:r>
+          </a:p>
+        </p:txBody>
+      </p:sp>
+      <p:sp>
+        <p:nvSpPr>
+          <p:cNvPr id="10" name="TextBox 9"/>
+          <p:cNvSpPr txBox="1"/>
+          <p:nvPr/>
+        </p:nvSpPr>
+        <p:spPr>
+          <a:xfrm>
+            <a:off x="274320" y="2423160"/>
+            <a:ext cx="11612880" cy="365760"/>
+          </a:xfrm>
+          <a:prstGeom prst="rect">
+            <a:avLst/>
+          </a:prstGeom>
+          <a:noFill/>
+        </p:spPr>
+        <p:txBody>
+          <a:bodyPr wrap="square">
+            <a:spAutoFit/>
+          </a:bodyPr>
+          <a:lstStyle/>
+          <a:p>
+            <a:pPr algn="l"/>
+            <a:r>
+              <a:rPr sz="1300" b="1">
+                <a:solidFill>
+                  <a:srgbClr val="1F3963"/>
+                </a:solidFill>
+              </a:rPr>
+              <a:t>Aalen-Johansen  (CORRECT)</a:t>
+            </a:r>
+          </a:p>
+        </p:txBody>
+      </p:sp>
+      <p:sp>
+        <p:nvSpPr>
+          <p:cNvPr id="11" name="Rectangle 10"/>
+          <p:cNvSpPr/>
+          <p:nvPr/>
+        </p:nvSpPr>
+        <p:spPr>
+          <a:xfrm>
+            <a:off x="274320" y="2788920"/>
+            <a:ext cx="11612880" cy="1417320"/>
+          </a:xfrm>
+          <a:prstGeom prst="rect">
+            <a:avLst/>
+          </a:prstGeom>
+          <a:solidFill>
+            <a:srgbClr val="EEF2F7"/>
+          </a:solidFill>
+          <a:ln>
+            <a:noFill/>
+          </a:ln>
+        </p:spPr>
+        <p:style>
+          <a:lnRef idx="1">
+            <a:schemeClr val="accent1"/>
+          </a:lnRef>
+          <a:fillRef idx="3">
+            <a:schemeClr val="accent1"/>
+          </a:fillRef>
+          <a:effectRef idx="2">
+            <a:schemeClr val="accent1"/>
+          </a:effectRef>
+          <a:fontRef idx="minor">
+            <a:schemeClr val="lt1"/>
+          </a:fontRef>
+        </p:style>
+        <p:txBody>
+          <a:bodyPr rtlCol="0" anchor="ctr"/>
+          <a:lstStyle/>
+          <a:p>
+            <a:pPr algn="ctr"/>
+          </a:p>
+        </p:txBody>
+      </p:sp>
+      <p:sp>
+        <p:nvSpPr>
+          <p:cNvPr id="12" name="TextBox 11"/>
+          <p:cNvSpPr txBox="1"/>
+          <p:nvPr/>
+        </p:nvSpPr>
+        <p:spPr>
+          <a:xfrm>
+            <a:off x="365760" y="2862072"/>
+            <a:ext cx="11430000" cy="1325880"/>
+          </a:xfrm>
+          <a:prstGeom prst="rect">
+            <a:avLst/>
+          </a:prstGeom>
+          <a:noFill/>
+        </p:spPr>
+        <p:txBody>
+          <a:bodyPr wrap="square">
+            <a:spAutoFit/>
+          </a:bodyPr>
+          <a:lstStyle/>
+          <a:p>
+            <a:r>
+              <a:rPr sz="1300">
+                <a:solidFill>
+                  <a:srgbClr val="1F3963"/>
+                </a:solidFill>
+                <a:latin typeface="Courier New"/>
+              </a:rPr>
+              <a:t>F_k(t) = SUM_{t_j &lt;= t}  S(t_j-)  *  d_{kj} / n_j</a:t>
+            </a:r>
+          </a:p>
+          <a:p>
+            <a:r>
+              <a:rPr sz="1300">
+                <a:solidFill>
+                  <a:srgbClr val="1F3963"/>
+                </a:solidFill>
+                <a:latin typeface="Courier New"/>
+              </a:rPr>
+              <a:t/>
+            </a:r>
+          </a:p>
+          <a:p>
+            <a:r>
+              <a:rPr sz="1300">
+                <a:solidFill>
+                  <a:srgbClr val="1F3963"/>
+                </a:solidFill>
+                <a:latin typeface="Courier New"/>
+              </a:rPr>
+              <a:t>  F_k(t) : CIF for cause k at loan age t</a:t>
+            </a:r>
+          </a:p>
+          <a:p>
+            <a:r>
+              <a:rPr sz="1300">
+                <a:solidFill>
+                  <a:srgbClr val="1F3963"/>
+                </a:solidFill>
+                <a:latin typeface="Courier New"/>
+              </a:rPr>
+              <a:t>  d_{kj} : cause-k exits at time t_j</a:t>
+            </a:r>
+          </a:p>
+          <a:p>
+            <a:r>
+              <a:rPr sz="1300">
+                <a:solidFill>
+                  <a:srgbClr val="1F3963"/>
+                </a:solidFill>
+                <a:latin typeface="Courier New"/>
+              </a:rPr>
+              <a:t>  n_j    : loans at risk just before t_j</a:t>
+            </a:r>
+          </a:p>
+          <a:p>
+            <a:r>
+              <a:rPr sz="1300">
+                <a:solidFill>
+                  <a:srgbClr val="1F3963"/>
+                </a:solidFill>
+                <a:latin typeface="Courier New"/>
+              </a:rPr>
+              <a:t>  S(t_j-): overall survival before t_j — uses ALL exits</a:t>
+            </a:r>
+          </a:p>
+        </p:txBody>
+      </p:sp>
+      <p:sp>
+        <p:nvSpPr>
+          <p:cNvPr id="13" name="TextBox 12"/>
+          <p:cNvSpPr txBox="1"/>
+          <p:nvPr/>
+        </p:nvSpPr>
+        <p:spPr>
+          <a:xfrm>
+            <a:off x="274320" y="4279392"/>
+            <a:ext cx="11612880" cy="320040"/>
+          </a:xfrm>
+          <a:prstGeom prst="rect">
+            <a:avLst/>
+          </a:prstGeom>
+          <a:noFill/>
+        </p:spPr>
+        <p:txBody>
+          <a:bodyPr wrap="square">
+            <a:spAutoFit/>
+          </a:bodyPr>
+          <a:lstStyle/>
+          <a:p>
+            <a:pPr algn="l"/>
+            <a:r>
+              <a:rPr sz="1200" b="1">
+                <a:solidFill>
+                  <a:srgbClr val="1F3963"/>
+                </a:solidFill>
+              </a:rPr>
+              <a:t>Partition identity  (impossible under KM):</a:t>
+            </a:r>
+          </a:p>
+        </p:txBody>
+      </p:sp>
+      <p:sp>
+        <p:nvSpPr>
+          <p:cNvPr id="14" name="Rectangle 13"/>
+          <p:cNvSpPr/>
+          <p:nvPr/>
+        </p:nvSpPr>
+        <p:spPr>
+          <a:xfrm>
+            <a:off x="274320" y="4617720"/>
+            <a:ext cx="11612880" cy="457200"/>
+          </a:xfrm>
+          <a:prstGeom prst="rect">
+            <a:avLst/>
+          </a:prstGeom>
+          <a:solidFill>
+            <a:srgbClr val="EEF2F7"/>
+          </a:solidFill>
+          <a:ln>
+            <a:noFill/>
+          </a:ln>
+        </p:spPr>
+        <p:style>
+          <a:lnRef idx="1">
+            <a:schemeClr val="accent1"/>
+          </a:lnRef>
+          <a:fillRef idx="3">
+            <a:schemeClr val="accent1"/>
+          </a:fillRef>
+          <a:effectRef idx="2">
+            <a:schemeClr val="accent1"/>
+          </a:effectRef>
+          <a:fontRef idx="minor">
+            <a:schemeClr val="lt1"/>
+          </a:fontRef>
+        </p:style>
+        <p:txBody>
+          <a:bodyPr rtlCol="0" anchor="ctr"/>
+          <a:lstStyle/>
+          <a:p>
+            <a:pPr algn="ctr"/>
+          </a:p>
+        </p:txBody>
+      </p:sp>
+      <p:sp>
+        <p:nvSpPr>
+          <p:cNvPr id="15" name="TextBox 14"/>
+          <p:cNvSpPr txBox="1"/>
+          <p:nvPr/>
+        </p:nvSpPr>
+        <p:spPr>
+          <a:xfrm>
+            <a:off x="365760" y="4690872"/>
+            <a:ext cx="11430000" cy="365760"/>
+          </a:xfrm>
+          <a:prstGeom prst="rect">
+            <a:avLst/>
+          </a:prstGeom>
+          <a:noFill/>
+        </p:spPr>
+        <p:txBody>
+          <a:bodyPr wrap="square">
+            <a:spAutoFit/>
+          </a:bodyPr>
+          <a:lstStyle/>
+          <a:p>
+            <a:r>
+              <a:rPr sz="1300">
+                <a:solidFill>
+                  <a:srgbClr val="1F3963"/>
+                </a:solidFill>
+                <a:latin typeface="Courier New"/>
+              </a:rPr>
+              <a:t>SUM_k  F_k(t)  +  S(t)  =  1    for all t</a:t>
             </a:r>
           </a:p>
         </p:txBody>
       </p:sp>
       <p:pic>
         <p:nvPicPr>
-          <p:cNvPr id="6" name="Picture 5" descr="E1_hazard_stratified.png"/>
+          <p:cNvPr id="16" name="Picture 15" descr="E1_competing_risks_cif.png"/>
           <p:cNvPicPr>
             <a:picLocks noChangeAspect="1"/>
           </p:cNvPicPr>
@@ -8308,8 +8198,8 @@
         </p:blipFill>
         <p:spPr>
           <a:xfrm>
-            <a:off x="457200" y="1005840"/>
-            <a:ext cx="4063204" cy="5303520"/>
+            <a:off x="274320" y="5120640"/>
+            <a:ext cx="9632924" cy="5303520"/>
           </a:xfrm>
           <a:prstGeom prst="rect">
             <a:avLst/>
@@ -8449,7 +8339,7 @@
                   <a:srgbClr val="FFFFFF"/>
                 </a:solidFill>
               </a:rPr>
-              <a:t>E(i)(b) — Aalen-Johansen CIF: Formula &amp; Contrast</a:t>
+              <a:t>E(i)(b) — AJ CIF: 10-yr Prepay 83%  ·  Default 2.2%  ·  Active 14.5%</a:t>
             </a:r>
           </a:p>
         </p:txBody>
@@ -8483,456 +8373,14 @@
                   <a:srgbClr val="F2F2F2"/>
                 </a:solidFill>
               </a:rPr>
-              <a:t>AJ correctly weights each increment by the overall survival probability</a:t>
-            </a:r>
-          </a:p>
-        </p:txBody>
-      </p:sp>
-      <p:sp>
-        <p:nvSpPr>
-          <p:cNvPr id="6" name="Rectangle 5"/>
-          <p:cNvSpPr/>
-          <p:nvPr/>
-        </p:nvSpPr>
-        <p:spPr>
-          <a:xfrm>
-            <a:off x="0" y="1024128"/>
-            <a:ext cx="12188952" cy="5833872"/>
-          </a:xfrm>
-          <a:prstGeom prst="rect">
-            <a:avLst/>
-          </a:prstGeom>
-          <a:solidFill>
-            <a:srgbClr val="F2F2F2"/>
-          </a:solidFill>
-          <a:ln>
-            <a:noFill/>
-          </a:ln>
-        </p:spPr>
-        <p:style>
-          <a:lnRef idx="1">
-            <a:schemeClr val="accent1"/>
-          </a:lnRef>
-          <a:fillRef idx="3">
-            <a:schemeClr val="accent1"/>
-          </a:fillRef>
-          <a:effectRef idx="2">
-            <a:schemeClr val="accent1"/>
-          </a:effectRef>
-          <a:fontRef idx="minor">
-            <a:schemeClr val="lt1"/>
-          </a:fontRef>
-        </p:style>
-        <p:txBody>
-          <a:bodyPr rtlCol="0" anchor="ctr"/>
-          <a:lstStyle/>
-          <a:p>
-            <a:pPr algn="ctr"/>
-          </a:p>
-        </p:txBody>
-      </p:sp>
-      <p:sp>
-        <p:nvSpPr>
-          <p:cNvPr id="7" name="TextBox 6"/>
-          <p:cNvSpPr txBox="1"/>
-          <p:nvPr/>
-        </p:nvSpPr>
-        <p:spPr>
-          <a:xfrm>
-            <a:off x="274320" y="1143000"/>
-            <a:ext cx="11612880" cy="365760"/>
-          </a:xfrm>
-          <a:prstGeom prst="rect">
-            <a:avLst/>
-          </a:prstGeom>
-          <a:noFill/>
-        </p:spPr>
-        <p:txBody>
-          <a:bodyPr wrap="square">
-            <a:spAutoFit/>
-          </a:bodyPr>
-          <a:lstStyle/>
-          <a:p>
-            <a:pPr algn="l"/>
-            <a:r>
-              <a:rPr sz="1300" b="1">
-                <a:solidFill>
-                  <a:srgbClr val="C00000"/>
-                </a:solidFill>
-              </a:rPr>
-              <a:t>Kaplan-Meier  (INCORRECT — treats competing exits as censored)</a:t>
-            </a:r>
-          </a:p>
-        </p:txBody>
-      </p:sp>
-      <p:sp>
-        <p:nvSpPr>
-          <p:cNvPr id="8" name="Rectangle 7"/>
-          <p:cNvSpPr/>
-          <p:nvPr/>
-        </p:nvSpPr>
-        <p:spPr>
-          <a:xfrm>
-            <a:off x="274320" y="1508760"/>
-            <a:ext cx="11612880" cy="822960"/>
-          </a:xfrm>
-          <a:prstGeom prst="rect">
-            <a:avLst/>
-          </a:prstGeom>
-          <a:solidFill>
-            <a:srgbClr val="EEF2F7"/>
-          </a:solidFill>
-          <a:ln>
-            <a:noFill/>
-          </a:ln>
-        </p:spPr>
-        <p:style>
-          <a:lnRef idx="1">
-            <a:schemeClr val="accent1"/>
-          </a:lnRef>
-          <a:fillRef idx="3">
-            <a:schemeClr val="accent1"/>
-          </a:fillRef>
-          <a:effectRef idx="2">
-            <a:schemeClr val="accent1"/>
-          </a:effectRef>
-          <a:fontRef idx="minor">
-            <a:schemeClr val="lt1"/>
-          </a:fontRef>
-        </p:style>
-        <p:txBody>
-          <a:bodyPr rtlCol="0" anchor="ctr"/>
-          <a:lstStyle/>
-          <a:p>
-            <a:pPr algn="ctr"/>
-          </a:p>
-        </p:txBody>
-      </p:sp>
-      <p:sp>
-        <p:nvSpPr>
-          <p:cNvPr id="9" name="TextBox 8"/>
-          <p:cNvSpPr txBox="1"/>
-          <p:nvPr/>
-        </p:nvSpPr>
-        <p:spPr>
-          <a:xfrm>
-            <a:off x="365760" y="1581912"/>
-            <a:ext cx="11430000" cy="731520"/>
-          </a:xfrm>
-          <a:prstGeom prst="rect">
-            <a:avLst/>
-          </a:prstGeom>
-          <a:noFill/>
-        </p:spPr>
-        <p:txBody>
-          <a:bodyPr wrap="square">
-            <a:spAutoFit/>
-          </a:bodyPr>
-          <a:lstStyle/>
-          <a:p>
-            <a:r>
-              <a:rPr sz="1300">
-                <a:solidFill>
-                  <a:srgbClr val="1F3963"/>
-                </a:solidFill>
-                <a:latin typeface="Courier New"/>
-              </a:rPr>
-              <a:t>S_KM(t) = PROD_{t_i &lt;= t} (1 - d_i^(k) / n_i)</a:t>
-            </a:r>
-          </a:p>
-          <a:p>
-            <a:r>
-              <a:rPr sz="1300">
-                <a:solidFill>
-                  <a:srgbClr val="1F3963"/>
-                </a:solidFill>
-                <a:latin typeface="Courier New"/>
-              </a:rPr>
-              <a:t>F_KM^(k)(t) = 1 - S_KM(t)    ← overcounts cause-k hazard</a:t>
-            </a:r>
-          </a:p>
-        </p:txBody>
-      </p:sp>
-      <p:sp>
-        <p:nvSpPr>
-          <p:cNvPr id="10" name="TextBox 9"/>
-          <p:cNvSpPr txBox="1"/>
-          <p:nvPr/>
-        </p:nvSpPr>
-        <p:spPr>
-          <a:xfrm>
-            <a:off x="274320" y="2423160"/>
-            <a:ext cx="11612880" cy="365760"/>
-          </a:xfrm>
-          <a:prstGeom prst="rect">
-            <a:avLst/>
-          </a:prstGeom>
-          <a:noFill/>
-        </p:spPr>
-        <p:txBody>
-          <a:bodyPr wrap="square">
-            <a:spAutoFit/>
-          </a:bodyPr>
-          <a:lstStyle/>
-          <a:p>
-            <a:pPr algn="l"/>
-            <a:r>
-              <a:rPr sz="1300" b="1">
-                <a:solidFill>
-                  <a:srgbClr val="1F3963"/>
-                </a:solidFill>
-              </a:rPr>
-              <a:t>Aalen-Johansen  (CORRECT)</a:t>
-            </a:r>
-          </a:p>
-        </p:txBody>
-      </p:sp>
-      <p:sp>
-        <p:nvSpPr>
-          <p:cNvPr id="11" name="Rectangle 10"/>
-          <p:cNvSpPr/>
-          <p:nvPr/>
-        </p:nvSpPr>
-        <p:spPr>
-          <a:xfrm>
-            <a:off x="274320" y="2788920"/>
-            <a:ext cx="11612880" cy="1417320"/>
-          </a:xfrm>
-          <a:prstGeom prst="rect">
-            <a:avLst/>
-          </a:prstGeom>
-          <a:solidFill>
-            <a:srgbClr val="EEF2F7"/>
-          </a:solidFill>
-          <a:ln>
-            <a:noFill/>
-          </a:ln>
-        </p:spPr>
-        <p:style>
-          <a:lnRef idx="1">
-            <a:schemeClr val="accent1"/>
-          </a:lnRef>
-          <a:fillRef idx="3">
-            <a:schemeClr val="accent1"/>
-          </a:fillRef>
-          <a:effectRef idx="2">
-            <a:schemeClr val="accent1"/>
-          </a:effectRef>
-          <a:fontRef idx="minor">
-            <a:schemeClr val="lt1"/>
-          </a:fontRef>
-        </p:style>
-        <p:txBody>
-          <a:bodyPr rtlCol="0" anchor="ctr"/>
-          <a:lstStyle/>
-          <a:p>
-            <a:pPr algn="ctr"/>
-          </a:p>
-        </p:txBody>
-      </p:sp>
-      <p:sp>
-        <p:nvSpPr>
-          <p:cNvPr id="12" name="TextBox 11"/>
-          <p:cNvSpPr txBox="1"/>
-          <p:nvPr/>
-        </p:nvSpPr>
-        <p:spPr>
-          <a:xfrm>
-            <a:off x="365760" y="2862072"/>
-            <a:ext cx="11430000" cy="1325880"/>
-          </a:xfrm>
-          <a:prstGeom prst="rect">
-            <a:avLst/>
-          </a:prstGeom>
-          <a:noFill/>
-        </p:spPr>
-        <p:txBody>
-          <a:bodyPr wrap="square">
-            <a:spAutoFit/>
-          </a:bodyPr>
-          <a:lstStyle/>
-          <a:p>
-            <a:r>
-              <a:rPr sz="1300">
-                <a:solidFill>
-                  <a:srgbClr val="1F3963"/>
-                </a:solidFill>
-                <a:latin typeface="Courier New"/>
-              </a:rPr>
-              <a:t>F_k(t) = SUM_{t_j &lt;= t}  S(t_j-)  *  d_{kj} / n_j</a:t>
-            </a:r>
-          </a:p>
-          <a:p>
-            <a:r>
-              <a:rPr sz="1300">
-                <a:solidFill>
-                  <a:srgbClr val="1F3963"/>
-                </a:solidFill>
-                <a:latin typeface="Courier New"/>
-              </a:rPr>
-              <a:t/>
-            </a:r>
-          </a:p>
-          <a:p>
-            <a:r>
-              <a:rPr sz="1300">
-                <a:solidFill>
-                  <a:srgbClr val="1F3963"/>
-                </a:solidFill>
-                <a:latin typeface="Courier New"/>
-              </a:rPr>
-              <a:t>  F_k(t) : CIF for cause k at loan age t</a:t>
-            </a:r>
-          </a:p>
-          <a:p>
-            <a:r>
-              <a:rPr sz="1300">
-                <a:solidFill>
-                  <a:srgbClr val="1F3963"/>
-                </a:solidFill>
-                <a:latin typeface="Courier New"/>
-              </a:rPr>
-              <a:t>  d_{kj} : cause-k exits at time t_j</a:t>
-            </a:r>
-          </a:p>
-          <a:p>
-            <a:r>
-              <a:rPr sz="1300">
-                <a:solidFill>
-                  <a:srgbClr val="1F3963"/>
-                </a:solidFill>
-                <a:latin typeface="Courier New"/>
-              </a:rPr>
-              <a:t>  n_j    : loans at risk just before t_j</a:t>
-            </a:r>
-          </a:p>
-          <a:p>
-            <a:r>
-              <a:rPr sz="1300">
-                <a:solidFill>
-                  <a:srgbClr val="1F3963"/>
-                </a:solidFill>
-                <a:latin typeface="Courier New"/>
-              </a:rPr>
-              <a:t>  S(t_j-): overall survival before t_j — uses ALL exits</a:t>
-            </a:r>
-          </a:p>
-        </p:txBody>
-      </p:sp>
-      <p:sp>
-        <p:nvSpPr>
-          <p:cNvPr id="13" name="TextBox 12"/>
-          <p:cNvSpPr txBox="1"/>
-          <p:nvPr/>
-        </p:nvSpPr>
-        <p:spPr>
-          <a:xfrm>
-            <a:off x="274320" y="4279392"/>
-            <a:ext cx="11612880" cy="320040"/>
-          </a:xfrm>
-          <a:prstGeom prst="rect">
-            <a:avLst/>
-          </a:prstGeom>
-          <a:noFill/>
-        </p:spPr>
-        <p:txBody>
-          <a:bodyPr wrap="square">
-            <a:spAutoFit/>
-          </a:bodyPr>
-          <a:lstStyle/>
-          <a:p>
-            <a:pPr algn="l"/>
-            <a:r>
-              <a:rPr sz="1200" b="1">
-                <a:solidFill>
-                  <a:srgbClr val="1F3963"/>
-                </a:solidFill>
-              </a:rPr>
-              <a:t>Partition identity  (impossible under KM):</a:t>
-            </a:r>
-          </a:p>
-        </p:txBody>
-      </p:sp>
-      <p:sp>
-        <p:nvSpPr>
-          <p:cNvPr id="14" name="Rectangle 13"/>
-          <p:cNvSpPr/>
-          <p:nvPr/>
-        </p:nvSpPr>
-        <p:spPr>
-          <a:xfrm>
-            <a:off x="274320" y="4617720"/>
-            <a:ext cx="11612880" cy="457200"/>
-          </a:xfrm>
-          <a:prstGeom prst="rect">
-            <a:avLst/>
-          </a:prstGeom>
-          <a:solidFill>
-            <a:srgbClr val="EEF2F7"/>
-          </a:solidFill>
-          <a:ln>
-            <a:noFill/>
-          </a:ln>
-        </p:spPr>
-        <p:style>
-          <a:lnRef idx="1">
-            <a:schemeClr val="accent1"/>
-          </a:lnRef>
-          <a:fillRef idx="3">
-            <a:schemeClr val="accent1"/>
-          </a:fillRef>
-          <a:effectRef idx="2">
-            <a:schemeClr val="accent1"/>
-          </a:effectRef>
-          <a:fontRef idx="minor">
-            <a:schemeClr val="lt1"/>
-          </a:fontRef>
-        </p:style>
-        <p:txBody>
-          <a:bodyPr rtlCol="0" anchor="ctr"/>
-          <a:lstStyle/>
-          <a:p>
-            <a:pPr algn="ctr"/>
-          </a:p>
-        </p:txBody>
-      </p:sp>
-      <p:sp>
-        <p:nvSpPr>
-          <p:cNvPr id="15" name="TextBox 14"/>
-          <p:cNvSpPr txBox="1"/>
-          <p:nvPr/>
-        </p:nvSpPr>
-        <p:spPr>
-          <a:xfrm>
-            <a:off x="365760" y="4690872"/>
-            <a:ext cx="11430000" cy="365760"/>
-          </a:xfrm>
-          <a:prstGeom prst="rect">
-            <a:avLst/>
-          </a:prstGeom>
-          <a:noFill/>
-        </p:spPr>
-        <p:txBody>
-          <a:bodyPr wrap="square">
-            <a:spAutoFit/>
-          </a:bodyPr>
-          <a:lstStyle/>
-          <a:p>
-            <a:r>
-              <a:rPr sz="1300">
-                <a:solidFill>
-                  <a:srgbClr val="1F3963"/>
-                </a:solidFill>
-                <a:latin typeface="Courier New"/>
-              </a:rPr>
-              <a:t>SUM_k  F_k(t)  +  S(t)  =  1    for all t</a:t>
+              <a:t>S_KM over-estimates each cause; AJ partition sums exactly to 1</a:t>
             </a:r>
           </a:p>
         </p:txBody>
       </p:sp>
       <p:pic>
         <p:nvPicPr>
-          <p:cNvPr id="16" name="Picture 15" descr="E1_competing_risks_cif.png"/>
+          <p:cNvPr id="6" name="Picture 5" descr="E1_competing_risks_cif.png"/>
           <p:cNvPicPr>
             <a:picLocks noChangeAspect="1"/>
           </p:cNvPicPr>
@@ -8946,7 +8394,7 @@
         </p:blipFill>
         <p:spPr>
           <a:xfrm>
-            <a:off x="274320" y="5120640"/>
+            <a:off x="457200" y="1097280"/>
             <a:ext cx="9632924" cy="5303520"/>
           </a:xfrm>
           <a:prstGeom prst="rect">
@@ -9087,7 +8535,7 @@
                   <a:srgbClr val="FFFFFF"/>
                 </a:solidFill>
               </a:rPr>
-              <a:t>E(i)(b) — AJ CIF: 10-yr Prepay 83%  ·  Default 2.2%  ·  Active 14.5%</a:t>
+              <a:t>E(i)(c) — KM vs AJ: Why Defaults Cannot Be Treated as Censorings</a:t>
             </a:r>
           </a:p>
         </p:txBody>
@@ -9121,14 +8569,369 @@
                   <a:srgbClr val="F2F2F2"/>
                 </a:solidFill>
               </a:rPr>
-              <a:t>S_KM over-estimates each cause; AJ partition sums exactly to 1</a:t>
+              <a:t>Every AJ increment ≤ KM increment  →  F_AJ(t) ≤ F_KM(t)  →  growing bias</a:t>
+            </a:r>
+          </a:p>
+        </p:txBody>
+      </p:sp>
+      <p:sp>
+        <p:nvSpPr>
+          <p:cNvPr id="6" name="Rectangle 5"/>
+          <p:cNvSpPr/>
+          <p:nvPr/>
+        </p:nvSpPr>
+        <p:spPr>
+          <a:xfrm>
+            <a:off x="0" y="1024128"/>
+            <a:ext cx="12188952" cy="5833872"/>
+          </a:xfrm>
+          <a:prstGeom prst="rect">
+            <a:avLst/>
+          </a:prstGeom>
+          <a:solidFill>
+            <a:srgbClr val="F2F2F2"/>
+          </a:solidFill>
+          <a:ln>
+            <a:noFill/>
+          </a:ln>
+        </p:spPr>
+        <p:style>
+          <a:lnRef idx="1">
+            <a:schemeClr val="accent1"/>
+          </a:lnRef>
+          <a:fillRef idx="3">
+            <a:schemeClr val="accent1"/>
+          </a:fillRef>
+          <a:effectRef idx="2">
+            <a:schemeClr val="accent1"/>
+          </a:effectRef>
+          <a:fontRef idx="minor">
+            <a:schemeClr val="lt1"/>
+          </a:fontRef>
+        </p:style>
+        <p:txBody>
+          <a:bodyPr rtlCol="0" anchor="ctr"/>
+          <a:lstStyle/>
+          <a:p>
+            <a:pPr algn="ctr"/>
+          </a:p>
+        </p:txBody>
+      </p:sp>
+      <p:sp>
+        <p:nvSpPr>
+          <p:cNvPr id="7" name="TextBox 6"/>
+          <p:cNvSpPr txBox="1"/>
+          <p:nvPr/>
+        </p:nvSpPr>
+        <p:spPr>
+          <a:xfrm>
+            <a:off x="274320" y="1143000"/>
+            <a:ext cx="11612880" cy="365760"/>
+          </a:xfrm>
+          <a:prstGeom prst="rect">
+            <a:avLst/>
+          </a:prstGeom>
+          <a:noFill/>
+        </p:spPr>
+        <p:txBody>
+          <a:bodyPr wrap="square">
+            <a:spAutoFit/>
+          </a:bodyPr>
+          <a:lstStyle/>
+          <a:p>
+            <a:pPr algn="l"/>
+            <a:r>
+              <a:rPr sz="1200" b="1">
+                <a:solidFill>
+                  <a:srgbClr val="C00000"/>
+                </a:solidFill>
+              </a:rPr>
+              <a:t>KM increment at t_j  (defaults excluded from denominator n_j^KM &lt; n_j):</a:t>
+            </a:r>
+          </a:p>
+        </p:txBody>
+      </p:sp>
+      <p:sp>
+        <p:nvSpPr>
+          <p:cNvPr id="8" name="Rectangle 7"/>
+          <p:cNvSpPr/>
+          <p:nvPr/>
+        </p:nvSpPr>
+        <p:spPr>
+          <a:xfrm>
+            <a:off x="274320" y="1508760"/>
+            <a:ext cx="11612880" cy="548640"/>
+          </a:xfrm>
+          <a:prstGeom prst="rect">
+            <a:avLst/>
+          </a:prstGeom>
+          <a:solidFill>
+            <a:srgbClr val="EEF2F7"/>
+          </a:solidFill>
+          <a:ln>
+            <a:noFill/>
+          </a:ln>
+        </p:spPr>
+        <p:style>
+          <a:lnRef idx="1">
+            <a:schemeClr val="accent1"/>
+          </a:lnRef>
+          <a:fillRef idx="3">
+            <a:schemeClr val="accent1"/>
+          </a:fillRef>
+          <a:effectRef idx="2">
+            <a:schemeClr val="accent1"/>
+          </a:effectRef>
+          <a:fontRef idx="minor">
+            <a:schemeClr val="lt1"/>
+          </a:fontRef>
+        </p:style>
+        <p:txBody>
+          <a:bodyPr rtlCol="0" anchor="ctr"/>
+          <a:lstStyle/>
+          <a:p>
+            <a:pPr algn="ctr"/>
+          </a:p>
+        </p:txBody>
+      </p:sp>
+      <p:sp>
+        <p:nvSpPr>
+          <p:cNvPr id="9" name="TextBox 8"/>
+          <p:cNvSpPr txBox="1"/>
+          <p:nvPr/>
+        </p:nvSpPr>
+        <p:spPr>
+          <a:xfrm>
+            <a:off x="365760" y="1581912"/>
+            <a:ext cx="11430000" cy="457200"/>
+          </a:xfrm>
+          <a:prstGeom prst="rect">
+            <a:avLst/>
+          </a:prstGeom>
+          <a:noFill/>
+        </p:spPr>
+        <p:txBody>
+          <a:bodyPr wrap="square">
+            <a:spAutoFit/>
+          </a:bodyPr>
+          <a:lstStyle/>
+          <a:p>
+            <a:r>
+              <a:rPr sz="1300">
+                <a:solidFill>
+                  <a:srgbClr val="1F3963"/>
+                </a:solidFill>
+                <a:latin typeface="Courier New"/>
+              </a:rPr>
+              <a:t>ΔF_KM(t_j)  =  S_KM(t_j-)  *  d_{1j} / n_j^KM    ← n_j^KM underestimates risk set</a:t>
+            </a:r>
+          </a:p>
+        </p:txBody>
+      </p:sp>
+      <p:sp>
+        <p:nvSpPr>
+          <p:cNvPr id="10" name="TextBox 9"/>
+          <p:cNvSpPr txBox="1"/>
+          <p:nvPr/>
+        </p:nvSpPr>
+        <p:spPr>
+          <a:xfrm>
+            <a:off x="274320" y="2148840"/>
+            <a:ext cx="11612880" cy="365760"/>
+          </a:xfrm>
+          <a:prstGeom prst="rect">
+            <a:avLst/>
+          </a:prstGeom>
+          <a:noFill/>
+        </p:spPr>
+        <p:txBody>
+          <a:bodyPr wrap="square">
+            <a:spAutoFit/>
+          </a:bodyPr>
+          <a:lstStyle/>
+          <a:p>
+            <a:pPr algn="l"/>
+            <a:r>
+              <a:rPr sz="1200" b="1">
+                <a:solidFill>
+                  <a:srgbClr val="1F3963"/>
+                </a:solidFill>
+              </a:rPr>
+              <a:t>AJ increment at t_j  (overall survival, full risk set):</a:t>
+            </a:r>
+          </a:p>
+        </p:txBody>
+      </p:sp>
+      <p:sp>
+        <p:nvSpPr>
+          <p:cNvPr id="11" name="Rectangle 10"/>
+          <p:cNvSpPr/>
+          <p:nvPr/>
+        </p:nvSpPr>
+        <p:spPr>
+          <a:xfrm>
+            <a:off x="274320" y="2514600"/>
+            <a:ext cx="11612880" cy="548640"/>
+          </a:xfrm>
+          <a:prstGeom prst="rect">
+            <a:avLst/>
+          </a:prstGeom>
+          <a:solidFill>
+            <a:srgbClr val="EEF2F7"/>
+          </a:solidFill>
+          <a:ln>
+            <a:noFill/>
+          </a:ln>
+        </p:spPr>
+        <p:style>
+          <a:lnRef idx="1">
+            <a:schemeClr val="accent1"/>
+          </a:lnRef>
+          <a:fillRef idx="3">
+            <a:schemeClr val="accent1"/>
+          </a:fillRef>
+          <a:effectRef idx="2">
+            <a:schemeClr val="accent1"/>
+          </a:effectRef>
+          <a:fontRef idx="minor">
+            <a:schemeClr val="lt1"/>
+          </a:fontRef>
+        </p:style>
+        <p:txBody>
+          <a:bodyPr rtlCol="0" anchor="ctr"/>
+          <a:lstStyle/>
+          <a:p>
+            <a:pPr algn="ctr"/>
+          </a:p>
+        </p:txBody>
+      </p:sp>
+      <p:sp>
+        <p:nvSpPr>
+          <p:cNvPr id="12" name="TextBox 11"/>
+          <p:cNvSpPr txBox="1"/>
+          <p:nvPr/>
+        </p:nvSpPr>
+        <p:spPr>
+          <a:xfrm>
+            <a:off x="365760" y="2587752"/>
+            <a:ext cx="11430000" cy="457200"/>
+          </a:xfrm>
+          <a:prstGeom prst="rect">
+            <a:avLst/>
+          </a:prstGeom>
+          <a:noFill/>
+        </p:spPr>
+        <p:txBody>
+          <a:bodyPr wrap="square">
+            <a:spAutoFit/>
+          </a:bodyPr>
+          <a:lstStyle/>
+          <a:p>
+            <a:r>
+              <a:rPr sz="1300">
+                <a:solidFill>
+                  <a:srgbClr val="1F3963"/>
+                </a:solidFill>
+                <a:latin typeface="Courier New"/>
+              </a:rPr>
+              <a:t>ΔF_AJ(t_j)   =  S(t_j-)     *  d_{1j} / n_j      ← S(t_j-) ≤ S_KM(t_j-) always</a:t>
+            </a:r>
+          </a:p>
+        </p:txBody>
+      </p:sp>
+      <p:sp>
+        <p:nvSpPr>
+          <p:cNvPr id="13" name="TextBox 12"/>
+          <p:cNvSpPr txBox="1"/>
+          <p:nvPr/>
+        </p:nvSpPr>
+        <p:spPr>
+          <a:xfrm>
+            <a:off x="274320" y="3154680"/>
+            <a:ext cx="11612880" cy="365760"/>
+          </a:xfrm>
+          <a:prstGeom prst="rect">
+            <a:avLst/>
+          </a:prstGeom>
+          <a:noFill/>
+        </p:spPr>
+        <p:txBody>
+          <a:bodyPr wrap="square">
+            <a:spAutoFit/>
+          </a:bodyPr>
+          <a:lstStyle/>
+          <a:p>
+            <a:pPr algn="l"/>
+            <a:r>
+              <a:rPr sz="1200" b="1">
+                <a:solidFill>
+                  <a:srgbClr val="1F3963"/>
+                </a:solidFill>
+              </a:rPr>
+              <a:t>Consequence — bias compounds over time:</a:t>
+            </a:r>
+          </a:p>
+        </p:txBody>
+      </p:sp>
+      <p:sp>
+        <p:nvSpPr>
+          <p:cNvPr id="14" name="TextBox 13"/>
+          <p:cNvSpPr txBox="1"/>
+          <p:nvPr/>
+        </p:nvSpPr>
+        <p:spPr>
+          <a:xfrm>
+            <a:off x="274320" y="3520440"/>
+            <a:ext cx="11612880" cy="1005840"/>
+          </a:xfrm>
+          <a:prstGeom prst="rect">
+            <a:avLst/>
+          </a:prstGeom>
+          <a:noFill/>
+        </p:spPr>
+        <p:txBody>
+          <a:bodyPr wrap="square">
+            <a:spAutoFit/>
+          </a:bodyPr>
+          <a:lstStyle/>
+          <a:p>
+            <a:pPr>
+              <a:spcAft>
+                <a:spcPts val="400"/>
+              </a:spcAft>
+              <a:defRPr sz="1300"/>
+            </a:pPr>
+            <a:r>
+              <a:t>• 5 yr:  KM over-estimates prepayment CIF by ~+0.45 pp</a:t>
+            </a:r>
+          </a:p>
+          <a:p>
+            <a:pPr>
+              <a:spcAft>
+                <a:spcPts val="400"/>
+              </a:spcAft>
+              <a:defRPr sz="1300"/>
+            </a:pPr>
+            <a:r>
+              <a:t>• 10 yr: bias ≈ +1.31 pp</a:t>
+            </a:r>
+          </a:p>
+          <a:p>
+            <a:pPr>
+              <a:spcAft>
+                <a:spcPts val="400"/>
+              </a:spcAft>
+              <a:defRPr sz="1300"/>
+            </a:pPr>
+            <a:r>
+              <a:t>• 20 yr: bias ≈ +2.23 pp  (gap widens as defaulted loans accumulate)</a:t>
             </a:r>
           </a:p>
         </p:txBody>
       </p:sp>
       <p:pic>
         <p:nvPicPr>
-          <p:cNvPr id="6" name="Picture 5" descr="E1_competing_risks_cif.png"/>
+          <p:cNvPr id="15" name="Picture 14" descr="E1_km_vs_aj_bias.png"/>
           <p:cNvPicPr>
             <a:picLocks noChangeAspect="1"/>
           </p:cNvPicPr>
@@ -9142,8 +8945,8 @@
         </p:blipFill>
         <p:spPr>
           <a:xfrm>
-            <a:off x="457200" y="1097280"/>
-            <a:ext cx="9632924" cy="5303520"/>
+            <a:off x="274320" y="4572000"/>
+            <a:ext cx="11612880" cy="3513594"/>
           </a:xfrm>
           <a:prstGeom prst="rect">
             <a:avLst/>

</xml_diff>

<commit_message>
Tidy E(i) notebook: 5% sample, unified style, new Fine-Gray chart
- Sample: 100K → 5% (~1.7M loans) for AJ/KM/stratified CIF/prepayment Cox;
  200K subsample for default Cox and Fine-Gray (speed cap)
- Remove unused Deep Cox and XGBoost setup cells from E(i) notebook
- Unified colour palette: C_PRE=#2171b5, C_DEF=#cb181d, consistent rcParams
- New E1_fg_comparison.png: CS-Cox vs Fine-Gray dot+line comparison plot
- Regenerated: E1_eda_duration, E1_eda_vintage, E1_eda_categorical,
  E1_competing_risks_cif, E1_km_vs_aj_bias, E1_stratified_cif,
  E1_cox_prepay, E1_cox_default, E1_fg_comparison
- Updated report and PPTX: added Fine-Gray comparison figure and slide

Co-Authored-By: Claude Sonnet 4.6 <noreply@anthropic.com>
</commit_message>
<xml_diff>
--- a/processed/PartE_Presentation.pptx
+++ b/processed/PartE_Presentation.pptx
@@ -3602,7 +3602,7 @@
         <p:spPr>
           <a:xfrm>
             <a:off x="274320" y="1051560"/>
-            <a:ext cx="5186826" cy="5303520"/>
+            <a:ext cx="5188167" cy="5303520"/>
           </a:xfrm>
           <a:prstGeom prst="rect">
             <a:avLst/>
@@ -3798,7 +3798,7 @@
         <p:spPr>
           <a:xfrm>
             <a:off x="274320" y="1051560"/>
-            <a:ext cx="8425049" cy="5303520"/>
+            <a:ext cx="8378024" cy="5303520"/>
           </a:xfrm>
           <a:prstGeom prst="rect">
             <a:avLst/>
@@ -3994,7 +3994,7 @@
         <p:spPr>
           <a:xfrm>
             <a:off x="274320" y="1051560"/>
-            <a:ext cx="8404513" cy="5303520"/>
+            <a:ext cx="8378024" cy="5303520"/>
           </a:xfrm>
           <a:prstGeom prst="rect">
             <a:avLst/>
@@ -4168,54 +4168,35 @@
                   <a:srgbClr val="F2F2F2"/>
                 </a:solidFill>
               </a:rPr>
-              <a:t>IPCW-weighted Cox approximation; coefficients directly target the CIF</a:t>
-            </a:r>
-          </a:p>
-        </p:txBody>
-      </p:sp>
-      <p:sp>
-        <p:nvSpPr>
-          <p:cNvPr id="6" name="Rectangle 5"/>
-          <p:cNvSpPr/>
-          <p:nvPr/>
-        </p:nvSpPr>
-        <p:spPr>
-          <a:xfrm>
-            <a:off x="0" y="1005840"/>
-            <a:ext cx="12188952" cy="5852160"/>
-          </a:xfrm>
-          <a:prstGeom prst="rect">
-            <a:avLst/>
-          </a:prstGeom>
-          <a:solidFill>
-            <a:srgbClr val="F2F2F2"/>
-          </a:solidFill>
-          <a:ln>
-            <a:noFill/>
-          </a:ln>
-        </p:spPr>
-        <p:style>
-          <a:lnRef idx="1">
-            <a:schemeClr val="accent1"/>
-          </a:lnRef>
-          <a:fillRef idx="3">
-            <a:schemeClr val="accent1"/>
-          </a:fillRef>
-          <a:effectRef idx="2">
-            <a:schemeClr val="accent1"/>
-          </a:effectRef>
-          <a:fontRef idx="minor">
-            <a:schemeClr val="lt1"/>
-          </a:fontRef>
-        </p:style>
-        <p:txBody>
-          <a:bodyPr rtlCol="0" anchor="ctr"/>
-          <a:lstStyle/>
-          <a:p>
-            <a:pPr algn="ctr"/>
-          </a:p>
-        </p:txBody>
-      </p:sp>
+              <a:t>IPCW-weighted Cox · coefficients directly target the CIF</a:t>
+            </a:r>
+          </a:p>
+        </p:txBody>
+      </p:sp>
+      <p:pic>
+        <p:nvPicPr>
+          <p:cNvPr id="6" name="Picture 5" descr="E1_fg_comparison.png"/>
+          <p:cNvPicPr>
+            <a:picLocks noChangeAspect="1"/>
+          </p:cNvPicPr>
+          <p:nvPr/>
+        </p:nvPicPr>
+        <p:blipFill>
+          <a:blip r:embed="rId2"/>
+          <a:stretch>
+            <a:fillRect/>
+          </a:stretch>
+        </p:blipFill>
+        <p:spPr>
+          <a:xfrm>
+            <a:off x="274320" y="1051560"/>
+            <a:ext cx="6858000" cy="4779818"/>
+          </a:xfrm>
+          <a:prstGeom prst="rect">
+            <a:avLst/>
+          </a:prstGeom>
+        </p:spPr>
+      </p:pic>
       <p:sp>
         <p:nvSpPr>
           <p:cNvPr id="7" name="TextBox 6"/>
@@ -4224,8 +4205,8 @@
         </p:nvSpPr>
         <p:spPr>
           <a:xfrm>
-            <a:off x="457200" y="1188720"/>
-            <a:ext cx="11247120" cy="5029200"/>
+            <a:off x="7315200" y="1188720"/>
+            <a:ext cx="4663440" cy="5029200"/>
           </a:xfrm>
           <a:prstGeom prst="rect">
             <a:avLst/>
@@ -4242,10 +4223,10 @@
               <a:spcAft>
                 <a:spcPts val="400"/>
               </a:spcAft>
-              <a:defRPr sz="1400"/>
+              <a:defRPr sz="1300"/>
             </a:pPr>
             <a:r>
-              <a:t>• Subjects who experienced a competing event (default) are KEPT in the risk set with IPCW weights</a:t>
+              <a:t>• Defaulted loans KEPT in prepayment risk set (IPCW-weighted)</a:t>
             </a:r>
           </a:p>
           <a:p>
@@ -4253,10 +4234,10 @@
               <a:spcAft>
                 <a:spcPts val="400"/>
               </a:spcAft>
-              <a:defRPr sz="1400"/>
+              <a:defRPr sz="1300"/>
             </a:pPr>
             <a:r>
-              <a:t>• The subdistribution hazard integrates to the CIF — covariate effects are CIF effects</a:t>
+              <a:t>• rate_incentive: LARGER under Fine-Gray — high-incentive loans also less likely to default first</a:t>
             </a:r>
           </a:p>
           <a:p>
@@ -4264,10 +4245,10 @@
               <a:spcAft>
                 <a:spcPts val="400"/>
               </a:spcAft>
-              <a:defRPr sz="1400"/>
+              <a:defRPr sz="1300"/>
             </a:pPr>
             <a:r>
-              <a:t>• rate_incentive HR is LARGER under Fine-Gray than cause-specific Cox:</a:t>
+              <a:t>• FICO: ATTENUATED under Fine-Gray — elevated default risk for low-FICO reduces measured prepayment propensity</a:t>
             </a:r>
           </a:p>
           <a:p>
@@ -4275,10 +4256,10 @@
               <a:spcAft>
                 <a:spcPts val="400"/>
               </a:spcAft>
-              <a:defRPr sz="1400"/>
+              <a:defRPr sz="1300"/>
             </a:pPr>
             <a:r>
-              <a:t>•    high-incentive loans are also less likely to default first → amplifies CIF effect</a:t>
+              <a:t>• Use Fine-Gray for CIF prediction / loss forecasting</a:t>
             </a:r>
           </a:p>
           <a:p>
@@ -4286,40 +4267,7 @@
               <a:spcAft>
                 <a:spcPts val="400"/>
               </a:spcAft>
-              <a:defRPr sz="1400"/>
-            </a:pPr>
-            <a:r>
-              <a:t>• Low-FICO Fine-Gray HR for prepayment is ATTENUATED: elevated default risk reduces</a:t>
-            </a:r>
-          </a:p>
-          <a:p>
-            <a:pPr>
-              <a:spcAft>
-                <a:spcPts val="400"/>
-              </a:spcAft>
-              <a:defRPr sz="1400"/>
-            </a:pPr>
-            <a:r>
-              <a:t>•    measured prepayment propensity once competing risks are accounted for</a:t>
-            </a:r>
-          </a:p>
-          <a:p>
-            <a:pPr>
-              <a:spcAft>
-                <a:spcPts val="400"/>
-              </a:spcAft>
-              <a:defRPr sz="1400"/>
-            </a:pPr>
-            <a:r>
-              <a:t>• Use Fine-Gray for CIF prediction / loss forecasting</a:t>
-            </a:r>
-          </a:p>
-          <a:p>
-            <a:pPr>
-              <a:spcAft>
-                <a:spcPts val="400"/>
-              </a:spcAft>
-              <a:defRPr sz="1400"/>
+              <a:defRPr sz="1300"/>
             </a:pPr>
             <a:r>
               <a:t>• Use cause-specific Cox for economic mechanism estimation</a:t>
@@ -6983,7 +6931,7 @@
         <p:spPr>
           <a:xfrm>
             <a:off x="137160" y="1051560"/>
-            <a:ext cx="11887200" cy="4938579"/>
+            <a:ext cx="11887200" cy="4941345"/>
           </a:xfrm>
           <a:prstGeom prst="rect">
             <a:avLst/>
@@ -7145,7 +7093,7 @@
         <p:spPr>
           <a:xfrm>
             <a:off x="137160" y="1051560"/>
-            <a:ext cx="7315200" cy="3054615"/>
+            <a:ext cx="7315200" cy="3062176"/>
           </a:xfrm>
           <a:prstGeom prst="rect">
             <a:avLst/>
@@ -7169,7 +7117,7 @@
         <p:spPr>
           <a:xfrm>
             <a:off x="7589520" y="1051560"/>
-            <a:ext cx="4389120" cy="1600506"/>
+            <a:ext cx="4389120" cy="1683933"/>
           </a:xfrm>
           <a:prstGeom prst="rect">
             <a:avLst/>
@@ -8199,7 +8147,7 @@
         <p:spPr>
           <a:xfrm>
             <a:off x="274320" y="5120640"/>
-            <a:ext cx="9632924" cy="5303520"/>
+            <a:ext cx="10715275" cy="5303520"/>
           </a:xfrm>
           <a:prstGeom prst="rect">
             <a:avLst/>
@@ -8395,7 +8343,7 @@
         <p:spPr>
           <a:xfrm>
             <a:off x="457200" y="1097280"/>
-            <a:ext cx="9632924" cy="5303520"/>
+            <a:ext cx="10715275" cy="5303520"/>
           </a:xfrm>
           <a:prstGeom prst="rect">
             <a:avLst/>
@@ -8946,7 +8894,7 @@
         <p:spPr>
           <a:xfrm>
             <a:off x="274320" y="4572000"/>
-            <a:ext cx="11612880" cy="3513594"/>
+            <a:ext cx="11612880" cy="4177035"/>
           </a:xfrm>
           <a:prstGeom prst="rect">
             <a:avLst/>

</xml_diff>